<commit_message>
fix(slides): clarify ACT 2 progression and evidence boundaries
Separate two research explanations and close both recorded task answers.
Retain prior slide budgets while adding three slides and eleven minutes.
Align the 93-slide deck, Notes, source mapping and static fallback links.
Preserve Trial boundaries and keep external delivery gates open.
</commit_message>
<xml_diff>
--- a/production/ACT_5.pptx
+++ b/production/ACT_5.pptx
@@ -2,20 +2,20 @@
 <file path=ppt/presentation.xml><?xml version="1.0" encoding="utf-8"?>
 <p:presentation xmlns:p="http://schemas.openxmlformats.org/presentationml/2006/main">
   <p:sldMasterIdLst>
-    <p:sldMasterId xmlns:r="http://schemas.openxmlformats.org/officeDocument/2006/relationships" id="2147483648" r:id="R08688b9691ff47cc"/>
+    <p:sldMasterId xmlns:r="http://schemas.openxmlformats.org/officeDocument/2006/relationships" id="2147483648" r:id="R2f3eed3237e04616"/>
   </p:sldMasterIdLst>
   <p:notesMasterIdLst>
-    <p:notesMasterId xmlns:r="http://schemas.openxmlformats.org/officeDocument/2006/relationships" r:id="Rdaa3ff4db9c24670"/>
+    <p:notesMasterId xmlns:r="http://schemas.openxmlformats.org/officeDocument/2006/relationships" r:id="Rc3b2fa444d3242f4"/>
   </p:notesMasterIdLst>
   <p:sldIdLst>
-    <p:sldId xmlns:r="http://schemas.openxmlformats.org/officeDocument/2006/relationships" id="256" r:id="R96c2151d6fd248de"/>
-    <p:sldId xmlns:r="http://schemas.openxmlformats.org/officeDocument/2006/relationships" id="257" r:id="Ra438ff973b5c47e4"/>
-    <p:sldId xmlns:r="http://schemas.openxmlformats.org/officeDocument/2006/relationships" id="258" r:id="R7a5d4587535b4654"/>
-    <p:sldId xmlns:r="http://schemas.openxmlformats.org/officeDocument/2006/relationships" id="259" r:id="R12c2aa9a80a4433f"/>
-    <p:sldId xmlns:r="http://schemas.openxmlformats.org/officeDocument/2006/relationships" id="260" r:id="Rd08b8c6880d54e53"/>
-    <p:sldId xmlns:r="http://schemas.openxmlformats.org/officeDocument/2006/relationships" id="261" r:id="R4b0f37d66cb44a9d"/>
-    <p:sldId xmlns:r="http://schemas.openxmlformats.org/officeDocument/2006/relationships" id="262" r:id="R209173db9d6e4f11"/>
-    <p:sldId xmlns:r="http://schemas.openxmlformats.org/officeDocument/2006/relationships" id="263" r:id="R97e8fdb8c95b49da"/>
+    <p:sldId xmlns:r="http://schemas.openxmlformats.org/officeDocument/2006/relationships" id="256" r:id="Rd84fd0cd90674e06"/>
+    <p:sldId xmlns:r="http://schemas.openxmlformats.org/officeDocument/2006/relationships" id="257" r:id="R252aa8b4184d4519"/>
+    <p:sldId xmlns:r="http://schemas.openxmlformats.org/officeDocument/2006/relationships" id="258" r:id="R94f04604618d40be"/>
+    <p:sldId xmlns:r="http://schemas.openxmlformats.org/officeDocument/2006/relationships" id="259" r:id="R2fb35ff2835349a0"/>
+    <p:sldId xmlns:r="http://schemas.openxmlformats.org/officeDocument/2006/relationships" id="260" r:id="Rae8708408f6c4e7b"/>
+    <p:sldId xmlns:r="http://schemas.openxmlformats.org/officeDocument/2006/relationships" id="261" r:id="R4b99ca486b5545cb"/>
+    <p:sldId xmlns:r="http://schemas.openxmlformats.org/officeDocument/2006/relationships" id="262" r:id="R4458f7043b8a41bf"/>
+    <p:sldId xmlns:r="http://schemas.openxmlformats.org/officeDocument/2006/relationships" id="263" r:id="Rfe2089ea759f4c97"/>
   </p:sldIdLst>
   <p:sldSz cx="12192000" cy="6858000"/>
   <p:notesSz cx="6858000" cy="9144000"/>
@@ -449,7 +449,7 @@
           <a:lstStyle xmlns:a="http://schemas.openxmlformats.org/drawingml/2006/main"/>
           <a:p xmlns:a="http://schemas.openxmlformats.org/drawingml/2006/main">
             <a:r>
-              <a:t>## S83 — 여섯 시간의 Story를 한 장으로</a:t>
+              <a:t>## S86 — 전체 Story를 한 장으로</a:t>
             </a:r>
           </a:p>
           <a:p xmlns:a="http://schemas.openxmlformats.org/drawingml/2006/main">
@@ -464,7 +464,7 @@
           </a:p>
           <a:p xmlns:a="http://schemas.openxmlformats.org/drawingml/2006/main">
             <a:r>
-              <a:t>S83</a:t>
+              <a:t>S86</a:t>
             </a:r>
           </a:p>
           <a:p xmlns:a="http://schemas.openxmlformats.org/drawingml/2006/main">
@@ -479,7 +479,7 @@
           </a:p>
           <a:p xmlns:a="http://schemas.openxmlformats.org/drawingml/2006/main">
             <a:r>
-              <a:t>여섯 시간의 Story를 한 장으로</a:t>
+              <a:t>전체 Story를 한 장으로</a:t>
             </a:r>
           </a:p>
           <a:p xmlns:a="http://schemas.openxmlformats.org/drawingml/2006/main">
@@ -579,7 +579,7 @@
           </a:p>
           <a:p xmlns:a="http://schemas.openxmlformats.org/drawingml/2006/main">
             <a:r>
-              <a:t>3. (2:45–4:00 / Lecture) 앞의 방식이 사라지지 않고 문제에 맞는 대응이 더해졌다고 정리한다. S84 실제 Repository 이력→S85 선택 기준→S86 책임을 거쳐 S87에서 AI-Native 운영 모델을 회수한다.</a:t>
+              <a:t>3. (2:45–4:00 / Lecture) 앞의 방식이 사라지지 않고 문제에 맞는 대응이 더해졌다고 정리한다. S87 실제 Repository 이력→S88 선택 기준→S89 책임을 거쳐 S90에서 AI-Native 운영 모델을 회수한다.</a:t>
             </a:r>
           </a:p>
           <a:p xmlns:a="http://schemas.openxmlformats.org/drawingml/2006/main">
@@ -589,7 +589,7 @@
           </a:p>
           <a:p xmlns:a="http://schemas.openxmlformats.org/drawingml/2006/main">
             <a:r>
-              <a:t>화면 진행: 이 장은 다섯 방식이 어떤 문제에 대응했는지 여정을 회수한다. 실제 State 이름이나 책임 목록을 여기서 모두 설명하지 않고 S84와 S86에 남긴다.</a:t>
+              <a:t>화면 진행: 이 장은 다섯 방식이 어떤 문제에 대응했는지 여정을 회수한다. 실제 State 이름이나 책임 목록을 여기서 모두 설명하지 않고 S87와 S89에 남긴다.</a:t>
             </a:r>
           </a:p>
           <a:p xmlns:a="http://schemas.openxmlformats.org/drawingml/2006/main">
@@ -679,7 +679,7 @@
           </a:p>
           <a:p xmlns:a="http://schemas.openxmlformats.org/drawingml/2006/main">
             <a:r>
-              <a:t>다섯 개 행동 행을 차례로 가리킨다. 새로운 실행이나 상태를 추가하지 않는다. S87의 정의를 바로 다음 장에서 설명한다고 예고하지 않는다.</a:t>
+              <a:t>다섯 개 행동 행을 차례로 가리킨다. 새로운 실행이나 상태를 추가하지 않는다. S90의 정의를 바로 다음 장에서 설명한다고 예고하지 않는다.</a:t>
             </a:r>
           </a:p>
           <a:p xmlns:a="http://schemas.openxmlformats.org/drawingml/2006/main">
@@ -709,7 +709,7 @@
           </a:p>
           <a:p xmlns:a="http://schemas.openxmlformats.org/drawingml/2006/main">
             <a:r>
-              <a:t>“전체 교육 모델 가운데, 하나의 Repository에서 실제로 확인한 변화만 다시 보겠습니다.” S84로 넘긴다.</a:t>
+              <a:t>“전체 교육 모델 가운데, 하나의 Repository에서 실제로 확인한 변화만 다시 보겠습니다.” S87로 넘긴다.</a:t>
             </a:r>
           </a:p>
           <a:p xmlns:a="http://schemas.openxmlformats.org/drawingml/2006/main">
@@ -739,7 +739,7 @@
           </a:p>
           <a:p xmlns:a="http://schemas.openxmlformats.org/drawingml/2006/main">
             <a:r>
-              <a:t>LOCAL STATIC ARTIFACT — production/ACT_5.pptx의 S83와 production/preview/act5/S83.png를 사용한다. 원본 실행 캡처 또는 새로운 Trial 결과로 표현하지 않는다. 로컬 렌더링 검토 결과는 통합 평가 문서에 기록한다.</a:t>
+              <a:t>LOCAL STATIC ARTIFACT — production/ACT_5.pptx의 S86와 production/preview/act5/S86.png를 사용한다. 원본 실행 캡처 또는 새로운 Trial 결과로 표현하지 않는다. 로컬 렌더링 검토 결과는 통합 평가 문서에 기록한다.</a:t>
             </a:r>
           </a:p>
           <a:p xmlns:a="http://schemas.openxmlformats.org/drawingml/2006/main">
@@ -824,7 +824,7 @@
           <a:lstStyle xmlns:a="http://schemas.openxmlformats.org/drawingml/2006/main"/>
           <a:p xmlns:a="http://schemas.openxmlformats.org/drawingml/2006/main">
             <a:r>
-              <a:t>## S84 — 하나의 Repository가 문제에 대응해 진화했다</a:t>
+              <a:t>## S87 — 하나의 Repository가 문제에 대응해 진화했다</a:t>
             </a:r>
           </a:p>
           <a:p xmlns:a="http://schemas.openxmlformats.org/drawingml/2006/main">
@@ -834,7 +834,7 @@
           </a:p>
           <a:p xmlns:a="http://schemas.openxmlformats.org/drawingml/2006/main">
             <a:r>
-              <a:t>Slide ID: S84</a:t>
+              <a:t>Slide ID: S87</a:t>
             </a:r>
           </a:p>
           <a:p xmlns:a="http://schemas.openxmlformats.org/drawingml/2006/main">
@@ -919,7 +919,7 @@
           </a:p>
           <a:p xmlns:a="http://schemas.openxmlformats.org/drawingml/2006/main">
             <a:r>
-              <a:t>2. (1:00–2:30 / VISUAL Demo) 아래 세 발췌(S18 crop 수정, S42 상세 문서 분리, S55 같은 조건의 성능 비교)를 가리키며 위의 일곱 State 변화와 연결한다. 작은 그림은 기억을 회수하는 용도이며 코드·경로·수치를 다시 읽는 시간이 아니다.</a:t>
+              <a:t>2. (1:00–2:30 / VISUAL Demo) 아래 세 발췌(S18 crop 수정, S43 상세 문서 분리, S58 같은 조건의 성능 비교)를 가리키며 위의 일곱 State 변화와 연결한다. 작은 그림은 기억을 회수하는 용도이며 코드·경로·수치를 다시 읽는 시간이 아니다.</a:t>
             </a:r>
           </a:p>
           <a:p xmlns:a="http://schemas.openxmlformats.org/drawingml/2006/main">
@@ -944,7 +944,7 @@
           </a:p>
           <a:p xmlns:a="http://schemas.openxmlformats.org/drawingml/2006/main">
             <a:r>
-              <a:t>Evidence / Source: OBSERVED_PRODUCT · `ai-dev-training-demo`의 named Git State/tag 기록과 DEMO-12. State 순서는 STATE-00 → STATE-00-FIXED → STATE-01 → STATE-02 → STATE-03 → STATE-04 → STATE-04-PERF다. 발췌 원본: assets/slide-illustrations/recap/S16-source.png, S32-source.png, S45-source.png. 파일명은 최초80장판 캡처 시점의 번호이며 현재 대응은 S18/S42/S55다. 실제 Trial 원본 화면이 아닌 당시 production PNG 발췌다. S18은 TRIAL-002 diff 재구성, S42는 STATE-02→03 문구 발췌, S55는 STATE-04→04-PERF 단일 코드·입력·환경 비교다. SHA-256과 native crop 범위: assets/slide-illustrations/ASSET_MANIFEST.json.</a:t>
+              <a:t>Evidence / Source: OBSERVED_PRODUCT · `ai-dev-training-demo`의 named Git State/tag 기록과 DEMO-12. State 순서는 STATE-00 → STATE-00-FIXED → STATE-01 → STATE-02 → STATE-03 → STATE-04 → STATE-04-PERF다. 발췌 원본: assets/slide-illustrations/recap/S16-source.png, S32-source.png, S47-source.png. 파일명은 최초80장판 캡처 시점의 번호이며 현재 대응은 S18/S43/S58다. 실제 Trial 원본 화면이 아닌 당시 production PNG 발췌다. S18은 TRIAL-002 diff 재구성, S43는 STATE-02→03 문구 발췌, S58는 STATE-04→04-PERF 단일 코드·입력·환경 비교다. SHA-256과 native crop 범위: assets/slide-illustrations/ASSET_MANIFEST.json.</a:t>
             </a:r>
           </a:p>
           <a:p xmlns:a="http://schemas.openxmlformats.org/drawingml/2006/main">
@@ -954,7 +954,7 @@
           </a:p>
           <a:p xmlns:a="http://schemas.openxmlformats.org/drawingml/2006/main">
             <a:r>
-              <a:t>Claim Boundary: 기록된 State와 Demo evidence 범위에 한정한다. Benchmark preparation commits는 supporting history이며 별도 State가 아니다. Subagent, Memory, stale Harness 또는 Loop를 Product State로 표시하지 않는다. 세 그림은 기존 발표자료 발췌이며 원본 실행 캡처가 아니다. S42로 Routing 우월성·토큰 절감을 주장하지 않고, S55는 tracemalloc 피크와 이 환경의 코드 변경 결과로 한정하며 RSS·Harness 단독 인과성으로 확대하지 않는다.</a:t>
+              <a:t>Claim Boundary: 기록된 State와 Demo evidence 범위에 한정한다. Benchmark preparation commits는 supporting history이며 별도 State가 아니다. Subagent, Memory, stale Harness 또는 Loop를 Product State로 표시하지 않는다. 세 그림은 기존 발표자료 발췌이며 원본 실행 캡처가 아니다. S43로 Routing 우월성·토큰 절감을 주장하지 않고, S58는 tracemalloc 피크와 이 환경의 코드 변경 결과로 한정하며 RSS·Harness 단독 인과성으로 확대하지 않는다.</a:t>
             </a:r>
           </a:p>
           <a:p xmlns:a="http://schemas.openxmlformats.org/drawingml/2006/main">
@@ -1014,7 +1014,7 @@
           </a:p>
           <a:p xmlns:a="http://schemas.openxmlformats.org/drawingml/2006/main">
             <a:r>
-              <a:t>Transition: “그러면 이 작업에서 Subagent와 Memory는 왜 없었을까요?” S85로 전환한다.</a:t>
+              <a:t>Transition: “그러면 이 작업에서 Subagent와 Memory는 왜 없었을까요?” S88로 전환한다.</a:t>
             </a:r>
           </a:p>
           <a:p xmlns:a="http://schemas.openxmlformats.org/drawingml/2006/main">
@@ -1034,7 +1034,7 @@
           </a:p>
           <a:p xmlns:a="http://schemas.openxmlformats.org/drawingml/2006/main">
             <a:r>
-              <a:t>Fallback: LOCAL STATIC ARTIFACT — production/ACT_5.pptx의 S84와 production/preview/act5/S84.png를 사용한다. 원본 실행 캡처 또는 새로운 Trial 결과로 표현하지 않는다. 로컬 렌더링 검토 결과는 통합 평가 문서에 기록한다.</a:t>
+              <a:t>Fallback: LOCAL STATIC ARTIFACT — production/ACT_5.pptx의 S87와 production/preview/act5/S87.png를 사용한다. 원본 실행 캡처 또는 새로운 Trial 결과로 표현하지 않는다. 로컬 렌더링 검토 결과는 통합 평가 문서에 기록한다.</a:t>
             </a:r>
           </a:p>
           <a:p xmlns:a="http://schemas.openxmlformats.org/drawingml/2006/main">
@@ -1114,7 +1114,7 @@
           <a:lstStyle xmlns:a="http://schemas.openxmlformats.org/drawingml/2006/main"/>
           <a:p xmlns:a="http://schemas.openxmlformats.org/drawingml/2006/main">
             <a:r>
-              <a:t>## S85 — 필요성이 입증되지 않은 것은 보류했다</a:t>
+              <a:t>## S88 — 필요성이 입증되지 않은 것은 보류했다</a:t>
             </a:r>
           </a:p>
           <a:p xmlns:a="http://schemas.openxmlformats.org/drawingml/2006/main">
@@ -1129,7 +1129,7 @@
           </a:p>
           <a:p xmlns:a="http://schemas.openxmlformats.org/drawingml/2006/main">
             <a:r>
-              <a:t>S85</a:t>
+              <a:t>S88</a:t>
             </a:r>
           </a:p>
           <a:p xmlns:a="http://schemas.openxmlformats.org/drawingml/2006/main">
@@ -1374,7 +1374,7 @@
           </a:p>
           <a:p xmlns:a="http://schemas.openxmlformats.org/drawingml/2006/main">
             <a:r>
-              <a:t>“필요한 구성요소를 선택한 뒤에도, 그 결과가 충분한지 판단하는 책임은 남습니다. 무엇을 확인하고 완료를 수용해야 할까요?” S86으로 이동한다.</a:t>
+              <a:t>“필요한 구성요소를 선택한 뒤에도, 그 결과가 충분한지 판단하는 책임은 남습니다. 무엇을 확인하고 완료를 수용해야 할까요?” S89으로 이동한다.</a:t>
             </a:r>
           </a:p>
           <a:p xmlns:a="http://schemas.openxmlformats.org/drawingml/2006/main">
@@ -1404,7 +1404,7 @@
           </a:p>
           <a:p xmlns:a="http://schemas.openxmlformats.org/drawingml/2006/main">
             <a:r>
-              <a:t>LOCAL STATIC ARTIFACT — production/ACT_5.pptx의 S85와 production/preview/act5/S85.png를 사용한다. 원본 실행 캡처 또는 새로운 Trial 결과로 표현하지 않는다. 로컬 렌더링 검토 결과는 통합 평가 문서에 기록한다.</a:t>
+              <a:t>LOCAL STATIC ARTIFACT — production/ACT_5.pptx의 S88와 production/preview/act5/S88.png를 사용한다. 원본 실행 캡처 또는 새로운 Trial 결과로 표현하지 않는다. 로컬 렌더링 검토 결과는 통합 평가 문서에 기록한다.</a:t>
             </a:r>
           </a:p>
           <a:p xmlns:a="http://schemas.openxmlformats.org/drawingml/2006/main">
@@ -1489,7 +1489,7 @@
           <a:lstStyle xmlns:a="http://schemas.openxmlformats.org/drawingml/2006/main"/>
           <a:p xmlns:a="http://schemas.openxmlformats.org/drawingml/2006/main">
             <a:r>
-              <a:t>## S86 — 위임이 늘어도 개발자 책임은 남는다</a:t>
+              <a:t>## S89 — 위임이 늘어도 개발자 책임은 남는다</a:t>
             </a:r>
           </a:p>
           <a:p xmlns:a="http://schemas.openxmlformats.org/drawingml/2006/main">
@@ -1504,7 +1504,7 @@
           </a:p>
           <a:p xmlns:a="http://schemas.openxmlformats.org/drawingml/2006/main">
             <a:r>
-              <a:t>S86</a:t>
+              <a:t>S89</a:t>
             </a:r>
           </a:p>
           <a:p xmlns:a="http://schemas.openxmlformats.org/drawingml/2006/main">
@@ -1609,7 +1609,7 @@
           </a:p>
           <a:p xmlns:a="http://schemas.openxmlformats.org/drawingml/2006/main">
             <a:r>
-              <a:t>1. (0:00–0:40 / Lecture) S85의 구성요소 선택에서 결과를 수용하는 판단으로 이어 간다. AI가 도울 수 있는 행동은 상단 한 문장으로만 읽는다.</a:t>
+              <a:t>1. (0:00–0:40 / Lecture) S88의 구성요소 선택에서 결과를 수용하는 판단으로 이어 간다. AI가 도울 수 있는 행동은 상단 한 문장으로만 읽는다.</a:t>
             </a:r>
           </a:p>
           <a:p xmlns:a="http://schemas.openxmlformats.org/drawingml/2006/main">
@@ -1619,7 +1619,7 @@
           </a:p>
           <a:p xmlns:a="http://schemas.openxmlformats.org/drawingml/2006/main">
             <a:r>
-              <a:t>3. (2:20–3:00 / Lecture) 역할의 절대적 분업이 아니라 개발자의 판단과 책임을 강조하고 S87의 운영 모델로 연결한다.</a:t>
+              <a:t>3. (2:20–3:00 / Lecture) 역할의 절대적 분업이 아니라 개발자의 판단과 책임을 강조하고 S90의 운영 모델로 연결한다.</a:t>
             </a:r>
           </a:p>
           <a:p xmlns:a="http://schemas.openxmlformats.org/drawingml/2006/main">
@@ -1749,7 +1749,7 @@
           </a:p>
           <a:p xmlns:a="http://schemas.openxmlformats.org/drawingml/2006/main">
             <a:r>
-              <a:t>“이 역할 변화를 이 교육에서는 어떤 모델로 부를까요?” S87로 이동한다.</a:t>
+              <a:t>“이 역할 변화를 이 교육에서는 어떤 모델로 부를까요?” S90로 이동한다.</a:t>
             </a:r>
           </a:p>
           <a:p xmlns:a="http://schemas.openxmlformats.org/drawingml/2006/main">
@@ -1779,7 +1779,7 @@
           </a:p>
           <a:p xmlns:a="http://schemas.openxmlformats.org/drawingml/2006/main">
             <a:r>
-              <a:t>LOCAL STATIC ARTIFACT — production/ACT_5.pptx의 S86와 production/preview/act5/S86.png를 사용한다. 원본 실행 캡처 또는 새로운 Trial 결과로 표현하지 않는다. 로컬 렌더링 검토 결과는 통합 평가 문서에 기록한다.</a:t>
+              <a:t>LOCAL STATIC ARTIFACT — production/ACT_5.pptx의 S89와 production/preview/act5/S89.png를 사용한다. 원본 실행 캡처 또는 새로운 Trial 결과로 표현하지 않는다. 로컬 렌더링 검토 결과는 통합 평가 문서에 기록한다.</a:t>
             </a:r>
           </a:p>
           <a:p xmlns:a="http://schemas.openxmlformats.org/drawingml/2006/main">
@@ -1864,7 +1864,7 @@
           <a:lstStyle xmlns:a="http://schemas.openxmlformats.org/drawingml/2006/main"/>
           <a:p xmlns:a="http://schemas.openxmlformats.org/drawingml/2006/main">
             <a:r>
-              <a:t>## S87 — AI-Native Development는 이 교육의 운영 모델</a:t>
+              <a:t>## S90 — AI-Native Development는 이 교육의 운영 모델</a:t>
             </a:r>
           </a:p>
           <a:p xmlns:a="http://schemas.openxmlformats.org/drawingml/2006/main">
@@ -1879,7 +1879,7 @@
           </a:p>
           <a:p xmlns:a="http://schemas.openxmlformats.org/drawingml/2006/main">
             <a:r>
-              <a:t>S87</a:t>
+              <a:t>S90</a:t>
             </a:r>
           </a:p>
           <a:p xmlns:a="http://schemas.openxmlformats.org/drawingml/2006/main">
@@ -1994,7 +1994,7 @@
           </a:p>
           <a:p xmlns:a="http://schemas.openxmlformats.org/drawingml/2006/main">
             <a:r>
-              <a:t>3. (2:20–3:00 / Lecture) 모든 Task에 모든 요소를 의무적으로 넣으라는 보편 정의가 아님을 한정하고 자신의 반복 마찰을 찾는 S88로 이동한다.</a:t>
+              <a:t>3. (2:20–3:00 / Lecture) 모든 Task에 모든 요소를 의무적으로 넣으라는 보편 정의가 아님을 한정하고 자신의 반복 마찰을 찾는 S91로 이동한다.</a:t>
             </a:r>
           </a:p>
           <a:p xmlns:a="http://schemas.openxmlformats.org/drawingml/2006/main">
@@ -2079,7 +2079,7 @@
           </a:p>
           <a:p xmlns:a="http://schemas.openxmlformats.org/drawingml/2006/main">
             <a:r>
-              <a:t>다음 S88에서 C++ Vision 업무와 자신의 Repository로 transfer한다.</a:t>
+              <a:t>다음 S91에서 C++ Vision 업무와 자신의 Repository로 transfer한다.</a:t>
             </a:r>
           </a:p>
           <a:p xmlns:a="http://schemas.openxmlformats.org/drawingml/2006/main">
@@ -2124,7 +2124,7 @@
           </a:p>
           <a:p xmlns:a="http://schemas.openxmlformats.org/drawingml/2006/main">
             <a:r>
-              <a:t>“내 Repository에서는 어떤 Layer에서 마찰이 반복될까요?” S88로 넘긴다.</a:t>
+              <a:t>“내 Repository에서는 어떤 Layer에서 마찰이 반복될까요?” S91로 넘긴다.</a:t>
             </a:r>
           </a:p>
           <a:p xmlns:a="http://schemas.openxmlformats.org/drawingml/2006/main">
@@ -2154,7 +2154,7 @@
           </a:p>
           <a:p xmlns:a="http://schemas.openxmlformats.org/drawingml/2006/main">
             <a:r>
-              <a:t>LOCAL STATIC ARTIFACT — production/ACT_5.pptx의 S87와 production/preview/act5/S87.png를 사용한다. 원본 실행 캡처 또는 새로운 Trial 결과로 표현하지 않는다. 로컬 렌더링 검토 결과는 통합 평가 문서에 기록한다.</a:t>
+              <a:t>LOCAL STATIC ARTIFACT — production/ACT_5.pptx의 S90와 production/preview/act5/S90.png를 사용한다. 원본 실행 캡처 또는 새로운 Trial 결과로 표현하지 않는다. 로컬 렌더링 검토 결과는 통합 평가 문서에 기록한다.</a:t>
             </a:r>
           </a:p>
           <a:p xmlns:a="http://schemas.openxmlformats.org/drawingml/2006/main">
@@ -2239,7 +2239,7 @@
           <a:lstStyle xmlns:a="http://schemas.openxmlformats.org/drawingml/2006/main"/>
           <a:p xmlns:a="http://schemas.openxmlformats.org/drawingml/2006/main">
             <a:r>
-              <a:t>## S88 — 어느 Layer에서 마찰이 반복되는가?</a:t>
+              <a:t>## S91 — 어느 Layer에서 마찰이 반복되는가?</a:t>
             </a:r>
           </a:p>
           <a:p xmlns:a="http://schemas.openxmlformats.org/drawingml/2006/main">
@@ -2254,7 +2254,7 @@
           </a:p>
           <a:p xmlns:a="http://schemas.openxmlformats.org/drawingml/2006/main">
             <a:r>
-              <a:t>S88</a:t>
+              <a:t>S91</a:t>
             </a:r>
           </a:p>
           <a:p xmlns:a="http://schemas.openxmlformats.org/drawingml/2006/main">
@@ -2369,7 +2369,7 @@
           </a:p>
           <a:p xmlns:a="http://schemas.openxmlformats.org/drawingml/2006/main">
             <a:r>
-              <a:t>3. (3:00–5:00 / Transition) 떠올린 마찰 한 곳을 다음 작업의 작은 행동 하나로 좁히겠다고 안내하고 S89의 세 질문으로 연결한다. Task/Context/Workflow/Verification/Feedback의 새 개념 설명은 하지 않는다.</a:t>
+              <a:t>3. (3:00–5:00 / Transition) 떠올린 마찰 한 곳을 다음 작업의 작은 행동 하나로 좁히겠다고 안내하고 S92의 세 질문으로 연결한다. Task/Context/Workflow/Verification/Feedback의 새 개념 설명은 하지 않는다.</a:t>
             </a:r>
           </a:p>
           <a:p xmlns:a="http://schemas.openxmlformats.org/drawingml/2006/main">
@@ -2499,7 +2499,7 @@
           </a:p>
           <a:p xmlns:a="http://schemas.openxmlformats.org/drawingml/2006/main">
             <a:r>
-              <a:t>“방금 떠올린 한 곳에서, 다음 작업 때 다르게 해 볼 작은 행동 하나를 마음속으로 골라 봅시다.” S89로 이동한다.</a:t>
+              <a:t>“방금 떠올린 한 곳에서, 다음 작업 때 다르게 해 볼 작은 행동 하나를 마음속으로 골라 봅시다.” S92로 이동한다.</a:t>
             </a:r>
           </a:p>
           <a:p xmlns:a="http://schemas.openxmlformats.org/drawingml/2006/main">
@@ -2529,7 +2529,7 @@
           </a:p>
           <a:p xmlns:a="http://schemas.openxmlformats.org/drawingml/2006/main">
             <a:r>
-              <a:t>LOCAL STATIC ARTIFACT — production/ACT_5.pptx의 S88와 production/preview/act5/S88.png를 사용한다. 원본 실행 캡처 또는 새로운 Trial 결과로 표현하지 않는다. 로컬 렌더링 검토 결과는 통합 평가 문서에 기록한다.</a:t>
+              <a:t>LOCAL STATIC ARTIFACT — production/ACT_5.pptx의 S91와 production/preview/act5/S91.png를 사용한다. 원본 실행 캡처 또는 새로운 Trial 결과로 표현하지 않는다. 로컬 렌더링 검토 결과는 통합 평가 문서에 기록한다.</a:t>
             </a:r>
           </a:p>
           <a:p xmlns:a="http://schemas.openxmlformats.org/drawingml/2006/main">
@@ -2614,7 +2614,7 @@
           <a:lstStyle xmlns:a="http://schemas.openxmlformats.org/drawingml/2006/main"/>
           <a:p xmlns:a="http://schemas.openxmlformats.org/drawingml/2006/main">
             <a:r>
-              <a:t>## S89 — 다음 작은 행동을 개인적으로 고른다</a:t>
+              <a:t>## S92 — 다음 작은 행동을 개인적으로 고른다</a:t>
             </a:r>
           </a:p>
           <a:p xmlns:a="http://schemas.openxmlformats.org/drawingml/2006/main">
@@ -2629,7 +2629,7 @@
           </a:p>
           <a:p xmlns:a="http://schemas.openxmlformats.org/drawingml/2006/main">
             <a:r>
-              <a:t>S89</a:t>
+              <a:t>S92</a:t>
             </a:r>
           </a:p>
           <a:p xmlns:a="http://schemas.openxmlformats.org/drawingml/2006/main">
@@ -2734,7 +2734,7 @@
           </a:p>
           <a:p xmlns:a="http://schemas.openxmlformats.org/drawingml/2006/main">
             <a:r>
-              <a:t>1. (0:00–1:00 / Lecture) S88에서 떠올린 반복 마찰 한 곳을 이어 받아, 다음 작업에서 다르게 해 볼 작은 행동 하나를 고르는 시간이라고 안내한다.</a:t>
+              <a:t>1. (0:00–1:00 / Lecture) S91에서 떠올린 반복 마찰 한 곳을 이어 받아, 다음 작업에서 다르게 해 볼 작은 행동 하나를 고르는 시간이라고 안내한다.</a:t>
             </a:r>
           </a:p>
           <a:p xmlns:a="http://schemas.openxmlformats.org/drawingml/2006/main">
@@ -2744,7 +2744,7 @@
           </a:p>
           <a:p xmlns:a="http://schemas.openxmlformats.org/drawingml/2006/main">
             <a:r>
-              <a:t>3. (2:00–4:00 / Reflection) 두 분 동안 다음 행동 하나를 조용히 개인적으로 고를 시간을 둔다. 답변·기록·발표·제출을 요구하지 않는다. 시간 뒤 S90 질문 시간으로 넘어간다.</a:t>
+              <a:t>3. (2:00–4:00 / Reflection) 두 분 동안 다음 행동 하나를 조용히 개인적으로 고를 시간을 둔다. 답변·기록·발표·제출을 요구하지 않는다. 시간 뒤 S93 질문 시간으로 넘어간다.</a:t>
             </a:r>
           </a:p>
           <a:p xmlns:a="http://schemas.openxmlformats.org/drawingml/2006/main">
@@ -2859,7 +2859,7 @@
           </a:p>
           <a:p xmlns:a="http://schemas.openxmlformats.org/drawingml/2006/main">
             <a:r>
-              <a:t>떠올린 마찰에 맞는 다음 행동 하나를 마음속으로 고르는 개인 성찰로 진행한다. 공유나 실천 약속을 요구하지 않고 응답을 받기 위해 기다리지 않는다. 2분 뒤 바로 S90으로 이동한다.</a:t>
+              <a:t>떠올린 마찰에 맞는 다음 행동 하나를 마음속으로 고르는 개인 성찰로 진행한다. 공유나 실천 약속을 요구하지 않고 응답을 받기 위해 기다리지 않는다. 2분 뒤 바로 S93으로 이동한다.</a:t>
             </a:r>
           </a:p>
           <a:p xmlns:a="http://schemas.openxmlformats.org/drawingml/2006/main">
@@ -2874,7 +2874,7 @@
           </a:p>
           <a:p xmlns:a="http://schemas.openxmlformats.org/drawingml/2006/main">
             <a:r>
-              <a:t>“이제 질문을 받고, 마지막 공통 모델로 마무리하겠습니다.” S90으로 넘긴다.</a:t>
+              <a:t>“이제 질문을 받고, 마지막 공통 모델로 마무리하겠습니다.” S93으로 넘긴다.</a:t>
             </a:r>
           </a:p>
           <a:p xmlns:a="http://schemas.openxmlformats.org/drawingml/2006/main">
@@ -2904,7 +2904,7 @@
           </a:p>
           <a:p xmlns:a="http://schemas.openxmlformats.org/drawingml/2006/main">
             <a:r>
-              <a:t>LOCAL STATIC ARTIFACT — production/ACT_5.pptx의 S89와 production/preview/act5/S89.png를 사용한다. 원본 실행 캡처 또는 새로운 Trial 결과로 표현하지 않는다. 로컬 렌더링 검토 결과는 통합 평가 문서에 기록한다.</a:t>
+              <a:t>LOCAL STATIC ARTIFACT — production/ACT_5.pptx의 S92와 production/preview/act5/S92.png를 사용한다. 원본 실행 캡처 또는 새로운 Trial 결과로 표현하지 않는다. 로컬 렌더링 검토 결과는 통합 평가 문서에 기록한다.</a:t>
             </a:r>
           </a:p>
           <a:p xmlns:a="http://schemas.openxmlformats.org/drawingml/2006/main">
@@ -2989,7 +2989,7 @@
           <a:lstStyle xmlns:a="http://schemas.openxmlformats.org/drawingml/2006/main"/>
           <a:p xmlns:a="http://schemas.openxmlformats.org/drawingml/2006/main">
             <a:r>
-              <a:t>## S90 — Q&amp;A와 교육 마무리</a:t>
+              <a:t>## S93 — Q&amp;A와 교육 마무리</a:t>
             </a:r>
           </a:p>
           <a:p xmlns:a="http://schemas.openxmlformats.org/drawingml/2006/main">
@@ -3004,7 +3004,7 @@
           </a:p>
           <a:p xmlns:a="http://schemas.openxmlformats.org/drawingml/2006/main">
             <a:r>
-              <a:t>S90</a:t>
+              <a:t>S93</a:t>
             </a:r>
           </a:p>
           <a:p xmlns:a="http://schemas.openxmlformats.org/drawingml/2006/main">
@@ -3269,7 +3269,7 @@
           </a:p>
           <a:p xmlns:a="http://schemas.openxmlformats.org/drawingml/2006/main">
             <a:r>
-              <a:t>LOCAL STATIC ARTIFACT — production/ACT_5.pptx의 S90와 production/preview/act5/S90.png를 사용한다. 원본 실행 캡처 또는 새로운 Trial 결과로 표현하지 않는다. 로컬 렌더링 검토 결과는 통합 평가 문서에 기록한다.</a:t>
+              <a:t>LOCAL STATIC ARTIFACT — production/ACT_5.pptx의 S93와 production/preview/act5/S93.png를 사용한다. 원본 실행 캡처 또는 새로운 Trial 결과로 표현하지 않는다. 로컬 렌더링 검토 결과는 통합 평가 문서에 기록한다.</a:t>
             </a:r>
           </a:p>
           <a:p xmlns:a="http://schemas.openxmlformats.org/drawingml/2006/main">
@@ -3331,7 +3331,7 @@
           <p:cNvPr id="3" name="Title">
             <a:extLst xmlns:a="http://schemas.openxmlformats.org/drawingml/2006/main">
               <a:ext uri="{FF2B5EF4-FFF2-40B4-BE49-F238E27FC236}">
-                <a16:creationId xmlns:a16="http://schemas.microsoft.com/office/drawing/2014/main" id="{06BDFA19-9364-482F-9F1B-334BE1A17EDB}"/>
+                <a16:creationId xmlns:a16="http://schemas.microsoft.com/office/drawing/2014/main" id="{43E14815-E28E-4553-A2D7-82F055FC3F05}"/>
               </a:ext>
             </a:extLst>
           </p:cNvPr>
@@ -3560,7 +3560,7 @@
           <p:cNvPr id="2" name="Subtitle">
             <a:extLst xmlns:a="http://schemas.openxmlformats.org/drawingml/2006/main">
               <a:ext uri="{FF2B5EF4-FFF2-40B4-BE49-F238E27FC236}">
-                <a16:creationId xmlns:a16="http://schemas.microsoft.com/office/drawing/2014/main" id="{B87576FC-F4C8-4406-A063-E6EB68C0AD5A}"/>
+                <a16:creationId xmlns:a16="http://schemas.microsoft.com/office/drawing/2014/main" id="{22D164D3-3FE1-44BA-BE05-1F11046C374D}"/>
               </a:ext>
             </a:extLst>
           </p:cNvPr>
@@ -3806,7 +3806,7 @@
           <p:cNvPr id="2" name="Section title">
             <a:extLst xmlns:a="http://schemas.openxmlformats.org/drawingml/2006/main">
               <a:ext uri="{FF2B5EF4-FFF2-40B4-BE49-F238E27FC236}">
-                <a16:creationId xmlns:a16="http://schemas.microsoft.com/office/drawing/2014/main" id="{F7765621-1597-4DCC-9096-67A6904DBF0F}"/>
+                <a16:creationId xmlns:a16="http://schemas.microsoft.com/office/drawing/2014/main" id="{E35886E5-8ED4-4186-A5CF-831B2070238B}"/>
               </a:ext>
             </a:extLst>
           </p:cNvPr>
@@ -4052,7 +4052,7 @@
           <p:cNvPr id="3" name="Title">
             <a:extLst xmlns:a="http://schemas.openxmlformats.org/drawingml/2006/main">
               <a:ext uri="{FF2B5EF4-FFF2-40B4-BE49-F238E27FC236}">
-                <a16:creationId xmlns:a16="http://schemas.microsoft.com/office/drawing/2014/main" id="{88A6023D-3DD3-4395-A838-C5989FAB8F73}"/>
+                <a16:creationId xmlns:a16="http://schemas.microsoft.com/office/drawing/2014/main" id="{3E546242-DBFA-486D-830F-610045531A92}"/>
               </a:ext>
             </a:extLst>
           </p:cNvPr>
@@ -4281,7 +4281,7 @@
           <p:cNvPr id="2" name="Body">
             <a:extLst xmlns:a="http://schemas.openxmlformats.org/drawingml/2006/main">
               <a:ext uri="{FF2B5EF4-FFF2-40B4-BE49-F238E27FC236}">
-                <a16:creationId xmlns:a16="http://schemas.microsoft.com/office/drawing/2014/main" id="{550FF485-9316-4BEC-A18B-6F9108FD067F}"/>
+                <a16:creationId xmlns:a16="http://schemas.microsoft.com/office/drawing/2014/main" id="{3DDDA005-BB55-4B81-A346-1D72B6E15F88}"/>
               </a:ext>
             </a:extLst>
           </p:cNvPr>
@@ -4527,7 +4527,7 @@
           <p:cNvPr id="4" name="Title">
             <a:extLst xmlns:a="http://schemas.openxmlformats.org/drawingml/2006/main">
               <a:ext uri="{FF2B5EF4-FFF2-40B4-BE49-F238E27FC236}">
-                <a16:creationId xmlns:a16="http://schemas.microsoft.com/office/drawing/2014/main" id="{9550B743-BB0F-4302-92B6-9FD7A7605D97}"/>
+                <a16:creationId xmlns:a16="http://schemas.microsoft.com/office/drawing/2014/main" id="{215B3C42-ED77-40C3-B19C-3FE7E5B59355}"/>
               </a:ext>
             </a:extLst>
           </p:cNvPr>
@@ -4756,7 +4756,7 @@
           <p:cNvPr id="2" name="Left column">
             <a:extLst xmlns:a="http://schemas.openxmlformats.org/drawingml/2006/main">
               <a:ext uri="{FF2B5EF4-FFF2-40B4-BE49-F238E27FC236}">
-                <a16:creationId xmlns:a16="http://schemas.microsoft.com/office/drawing/2014/main" id="{DBB01B30-590C-4AA4-AC36-A7C70FFF1323}"/>
+                <a16:creationId xmlns:a16="http://schemas.microsoft.com/office/drawing/2014/main" id="{421FC662-27C7-44C7-9368-DD9CF4C18F5F}"/>
               </a:ext>
             </a:extLst>
           </p:cNvPr>
@@ -4985,7 +4985,7 @@
           <p:cNvPr id="3" name="Right column">
             <a:extLst xmlns:a="http://schemas.openxmlformats.org/drawingml/2006/main">
               <a:ext uri="{FF2B5EF4-FFF2-40B4-BE49-F238E27FC236}">
-                <a16:creationId xmlns:a16="http://schemas.microsoft.com/office/drawing/2014/main" id="{101CB071-5AF0-4511-B1A7-DA1774FF4A4C}"/>
+                <a16:creationId xmlns:a16="http://schemas.microsoft.com/office/drawing/2014/main" id="{1DAD0DB2-3900-4075-8B66-86BB52DBD296}"/>
               </a:ext>
             </a:extLst>
           </p:cNvPr>
@@ -5231,7 +5231,7 @@
           <p:cNvPr id="3" name="Title">
             <a:extLst xmlns:a="http://schemas.openxmlformats.org/drawingml/2006/main">
               <a:ext uri="{FF2B5EF4-FFF2-40B4-BE49-F238E27FC236}">
-                <a16:creationId xmlns:a16="http://schemas.microsoft.com/office/drawing/2014/main" id="{28C71329-57D9-4A82-963E-EE3EAB8E8052}"/>
+                <a16:creationId xmlns:a16="http://schemas.microsoft.com/office/drawing/2014/main" id="{17C04CFF-F858-4844-990B-026CDCBD7ABB}"/>
               </a:ext>
             </a:extLst>
           </p:cNvPr>
@@ -5460,7 +5460,7 @@
           <p:cNvPr id="2" name="Left column">
             <a:extLst xmlns:a="http://schemas.openxmlformats.org/drawingml/2006/main">
               <a:ext uri="{FF2B5EF4-FFF2-40B4-BE49-F238E27FC236}">
-                <a16:creationId xmlns:a16="http://schemas.microsoft.com/office/drawing/2014/main" id="{D4CB99F2-2ED8-485C-A243-ECF2833688D0}"/>
+                <a16:creationId xmlns:a16="http://schemas.microsoft.com/office/drawing/2014/main" id="{36A2C2D2-E378-4B12-BD6F-133582EE9647}"/>
               </a:ext>
             </a:extLst>
           </p:cNvPr>
@@ -5727,12 +5727,12 @@
   </p:cSld>
   <p:clrMap bg1="lt1" tx1="dk1" bg2="lt2" tx2="dk2" accent1="accent1" accent2="accent2" accent3="accent3" accent4="accent4" accent5="accent5" accent6="accent6" hlink="hlink" folHlink="folHlink"/>
   <p:sldLayoutIdLst>
-    <p:sldLayoutId xmlns:r="http://schemas.openxmlformats.org/officeDocument/2006/relationships" id="2147483649" r:id="Rf6dd621553e14551"/>
-    <p:sldLayoutId xmlns:r="http://schemas.openxmlformats.org/officeDocument/2006/relationships" id="2147483650" r:id="Rc0c0cca1a5d2457a"/>
-    <p:sldLayoutId xmlns:r="http://schemas.openxmlformats.org/officeDocument/2006/relationships" id="2147483651" r:id="Rc4fa3edd0bff4116"/>
-    <p:sldLayoutId xmlns:r="http://schemas.openxmlformats.org/officeDocument/2006/relationships" id="2147483652" r:id="R5b33173aef914146"/>
-    <p:sldLayoutId xmlns:r="http://schemas.openxmlformats.org/officeDocument/2006/relationships" id="2147483653" r:id="R3ca7e079b15045fb"/>
-    <p:sldLayoutId xmlns:r="http://schemas.openxmlformats.org/officeDocument/2006/relationships" id="2147483654" r:id="R4a32a6e70d04423f"/>
+    <p:sldLayoutId xmlns:r="http://schemas.openxmlformats.org/officeDocument/2006/relationships" id="2147483649" r:id="Rc5909f4139f04645"/>
+    <p:sldLayoutId xmlns:r="http://schemas.openxmlformats.org/officeDocument/2006/relationships" id="2147483650" r:id="R01a4dbfcccc64537"/>
+    <p:sldLayoutId xmlns:r="http://schemas.openxmlformats.org/officeDocument/2006/relationships" id="2147483651" r:id="Rc537e5971cd54824"/>
+    <p:sldLayoutId xmlns:r="http://schemas.openxmlformats.org/officeDocument/2006/relationships" id="2147483652" r:id="R4c399ed5cb4d4663"/>
+    <p:sldLayoutId xmlns:r="http://schemas.openxmlformats.org/officeDocument/2006/relationships" id="2147483653" r:id="R5d4fb76cd84543de"/>
+    <p:sldLayoutId xmlns:r="http://schemas.openxmlformats.org/officeDocument/2006/relationships" id="2147483654" r:id="R70988268d5884106"/>
   </p:sldLayoutIdLst>
   <p:txStyles>
     <p:titleStyle>
@@ -6283,7 +6283,7 @@
           <p:cNvPr id="34" name="ACT 5 · 전체 여정 회수">
             <a:extLst xmlns:a="http://schemas.openxmlformats.org/drawingml/2006/main">
               <a:ext uri="{FF2B5EF4-FFF2-40B4-BE49-F238E27FC236}">
-                <a16:creationId xmlns:a16="http://schemas.microsoft.com/office/drawing/2014/main" id="{D96B2794-E4A5-4F76-8422-ADCE746A7D3D}"/>
+                <a16:creationId xmlns:a16="http://schemas.microsoft.com/office/drawing/2014/main" id="{504492BB-EB27-4CCA-BC33-E4686F940358}"/>
               </a:ext>
             </a:extLst>
           </p:cNvPr>
@@ -6438,10 +6438,10 @@
       </p:sp>
       <p:sp>
         <p:nvSpPr>
-          <p:cNvPr id="2" name="S83">
+          <p:cNvPr id="2" name="S86">
             <a:extLst xmlns:a="http://schemas.openxmlformats.org/drawingml/2006/main">
               <a:ext uri="{FF2B5EF4-FFF2-40B4-BE49-F238E27FC236}">
-                <a16:creationId xmlns:a16="http://schemas.microsoft.com/office/drawing/2014/main" id="{352E97D1-D5B3-4A34-842D-364E29E70DFE}"/>
+                <a16:creationId xmlns:a16="http://schemas.microsoft.com/office/drawing/2014/main" id="{72D4BC1A-918A-4C2E-A026-C6C74751651E}"/>
               </a:ext>
             </a:extLst>
           </p:cNvPr>
@@ -6589,17 +6589,17 @@
                 <a:ea typeface="Malgun Gothic"/>
                 <a:cs typeface="Malgun Gothic"/>
               </a:rPr>
-              <a:t>S83</a:t>
+              <a:t>S86</a:t>
             </a:r>
           </a:p>
         </p:txBody>
       </p:sp>
       <p:sp>
         <p:nvSpPr>
-          <p:cNvPr id="3" name="여섯 시간의 Story를 한 장으로">
+          <p:cNvPr id="3" name="전체 Story를 한 장으로">
             <a:extLst xmlns:a="http://schemas.openxmlformats.org/drawingml/2006/main">
               <a:ext uri="{FF2B5EF4-FFF2-40B4-BE49-F238E27FC236}">
-                <a16:creationId xmlns:a16="http://schemas.microsoft.com/office/drawing/2014/main" id="{50AD4981-C6B6-4A73-B373-4E25EE0D8C37}"/>
+                <a16:creationId xmlns:a16="http://schemas.microsoft.com/office/drawing/2014/main" id="{4F40E9FA-AE12-47DE-AC2E-755071E3D299}"/>
               </a:ext>
             </a:extLst>
           </p:cNvPr>
@@ -6747,7 +6747,7 @@
                 <a:ea typeface="Malgun Gothic"/>
                 <a:cs typeface="Malgun Gothic"/>
               </a:rPr>
-              <a:t>여섯 시간의 Story를 한 장으로</a:t>
+              <a:t>전체 Story를 한 장으로</a:t>
             </a:r>
           </a:p>
         </p:txBody>
@@ -6757,7 +6757,7 @@
           <p:cNvPr id="4" name="">
             <a:extLst xmlns:a="http://schemas.openxmlformats.org/drawingml/2006/main">
               <a:ext uri="{FF2B5EF4-FFF2-40B4-BE49-F238E27FC236}">
-                <a16:creationId xmlns:a16="http://schemas.microsoft.com/office/drawing/2014/main" id="{313F77F5-7627-44FA-923D-806C51618620}"/>
+                <a16:creationId xmlns:a16="http://schemas.microsoft.com/office/drawing/2014/main" id="{3DB8FAE6-0B52-4BC9-9A44-DE77B9B8F5FB}"/>
               </a:ext>
             </a:extLst>
           </p:cNvPr>
@@ -6788,7 +6788,7 @@
           <p:cNvPr id="5" name="BEAT-060 · 이 교육의 문제 중심 진화 모델">
             <a:extLst xmlns:a="http://schemas.openxmlformats.org/drawingml/2006/main">
               <a:ext uri="{FF2B5EF4-FFF2-40B4-BE49-F238E27FC236}">
-                <a16:creationId xmlns:a16="http://schemas.microsoft.com/office/drawing/2014/main" id="{89EA282F-421D-4890-BBC7-11FACFEC0EA7}"/>
+                <a16:creationId xmlns:a16="http://schemas.microsoft.com/office/drawing/2014/main" id="{39907017-478C-4F85-8C66-F0A1B8A411A5}"/>
               </a:ext>
             </a:extLst>
           </p:cNvPr>
@@ -6946,7 +6946,7 @@
           <p:cNvPr id="6" name="앞의 방식을 버리거나, 모든 프로젝트가 같은 순서로 발전해야 한다는 뜻은 아니다.">
             <a:extLst xmlns:a="http://schemas.openxmlformats.org/drawingml/2006/main">
               <a:ext uri="{FF2B5EF4-FFF2-40B4-BE49-F238E27FC236}">
-                <a16:creationId xmlns:a16="http://schemas.microsoft.com/office/drawing/2014/main" id="{B47B5972-87E2-4FB1-A78E-E80A8492D627}"/>
+                <a16:creationId xmlns:a16="http://schemas.microsoft.com/office/drawing/2014/main" id="{3E9CDA57-823E-4C6A-82CC-68675F1CCD56}"/>
               </a:ext>
             </a:extLst>
           </p:cNvPr>
@@ -7104,7 +7104,7 @@
           <p:cNvPr id="7" name="문제가 넓어질수록, 필요한 대응이 더해졌다.">
             <a:extLst xmlns:a="http://schemas.openxmlformats.org/drawingml/2006/main">
               <a:ext uri="{FF2B5EF4-FFF2-40B4-BE49-F238E27FC236}">
-                <a16:creationId xmlns:a16="http://schemas.microsoft.com/office/drawing/2014/main" id="{565D4194-1D2B-441F-B7A2-A04D0B7992D2}"/>
+                <a16:creationId xmlns:a16="http://schemas.microsoft.com/office/drawing/2014/main" id="{DFF61F7B-B662-4DD4-A462-B3726679343E}"/>
               </a:ext>
             </a:extLst>
           </p:cNvPr>
@@ -7262,7 +7262,7 @@
           <p:cNvPr id="8" name="01">
             <a:extLst xmlns:a="http://schemas.openxmlformats.org/drawingml/2006/main">
               <a:ext uri="{FF2B5EF4-FFF2-40B4-BE49-F238E27FC236}">
-                <a16:creationId xmlns:a16="http://schemas.microsoft.com/office/drawing/2014/main" id="{6D9E7530-2CED-4A81-B210-B19D744F4CA8}"/>
+                <a16:creationId xmlns:a16="http://schemas.microsoft.com/office/drawing/2014/main" id="{B7654A38-E389-455E-99B3-0B1D0585ED22}"/>
               </a:ext>
             </a:extLst>
           </p:cNvPr>
@@ -7420,7 +7420,7 @@
           <p:cNvPr id="9" name="">
             <a:extLst xmlns:a="http://schemas.openxmlformats.org/drawingml/2006/main">
               <a:ext uri="{FF2B5EF4-FFF2-40B4-BE49-F238E27FC236}">
-                <a16:creationId xmlns:a16="http://schemas.microsoft.com/office/drawing/2014/main" id="{78088DC3-6654-401D-BC56-D824BD23F3B3}"/>
+                <a16:creationId xmlns:a16="http://schemas.microsoft.com/office/drawing/2014/main" id="{50D59EC9-3397-41B9-8936-A3823528A227}"/>
               </a:ext>
             </a:extLst>
           </p:cNvPr>
@@ -7451,7 +7451,7 @@
           <p:cNvPr id="10" name="Chatbot">
             <a:extLst xmlns:a="http://schemas.openxmlformats.org/drawingml/2006/main">
               <a:ext uri="{FF2B5EF4-FFF2-40B4-BE49-F238E27FC236}">
-                <a16:creationId xmlns:a16="http://schemas.microsoft.com/office/drawing/2014/main" id="{662C8359-DBD9-4CB2-9414-A002220FFF78}"/>
+                <a16:creationId xmlns:a16="http://schemas.microsoft.com/office/drawing/2014/main" id="{B386AEA8-EA65-4448-93DF-95034F6C54DE}"/>
               </a:ext>
             </a:extLst>
           </p:cNvPr>
@@ -7609,7 +7609,7 @@
           <p:cNvPr id="11" name="답을 구한다">
             <a:extLst xmlns:a="http://schemas.openxmlformats.org/drawingml/2006/main">
               <a:ext uri="{FF2B5EF4-FFF2-40B4-BE49-F238E27FC236}">
-                <a16:creationId xmlns:a16="http://schemas.microsoft.com/office/drawing/2014/main" id="{4B3B7F8D-D8A6-47E4-9D8E-59F6E4BAF166}"/>
+                <a16:creationId xmlns:a16="http://schemas.microsoft.com/office/drawing/2014/main" id="{818F43AD-17F6-41AD-B84F-57DC7015398F}"/>
               </a:ext>
             </a:extLst>
           </p:cNvPr>
@@ -7767,7 +7767,7 @@
           <p:cNvPr id="12" name="">
             <a:extLst xmlns:a="http://schemas.openxmlformats.org/drawingml/2006/main">
               <a:ext uri="{FF2B5EF4-FFF2-40B4-BE49-F238E27FC236}">
-                <a16:creationId xmlns:a16="http://schemas.microsoft.com/office/drawing/2014/main" id="{1F28F0B7-FBAB-4816-A0C1-151E0E1A612B}"/>
+                <a16:creationId xmlns:a16="http://schemas.microsoft.com/office/drawing/2014/main" id="{D467AB32-75BA-4577-9F58-13C26E1B8DCD}"/>
               </a:ext>
             </a:extLst>
           </p:cNvPr>
@@ -7797,7 +7797,7 @@
           <p:cNvPr id="13" name="02">
             <a:extLst xmlns:a="http://schemas.openxmlformats.org/drawingml/2006/main">
               <a:ext uri="{FF2B5EF4-FFF2-40B4-BE49-F238E27FC236}">
-                <a16:creationId xmlns:a16="http://schemas.microsoft.com/office/drawing/2014/main" id="{341B590A-3F66-4997-A110-3D6F3FE8FF9B}"/>
+                <a16:creationId xmlns:a16="http://schemas.microsoft.com/office/drawing/2014/main" id="{EEAB0D7E-BE9D-4382-8DAD-0A013F2A434D}"/>
               </a:ext>
             </a:extLst>
           </p:cNvPr>
@@ -7955,7 +7955,7 @@
           <p:cNvPr id="14" name="">
             <a:extLst xmlns:a="http://schemas.openxmlformats.org/drawingml/2006/main">
               <a:ext uri="{FF2B5EF4-FFF2-40B4-BE49-F238E27FC236}">
-                <a16:creationId xmlns:a16="http://schemas.microsoft.com/office/drawing/2014/main" id="{2D6BAA09-49B5-49B0-8B89-DAB5DB653C29}"/>
+                <a16:creationId xmlns:a16="http://schemas.microsoft.com/office/drawing/2014/main" id="{0C410B15-DD4D-42E0-B602-BBC1E13D3831}"/>
               </a:ext>
             </a:extLst>
           </p:cNvPr>
@@ -7986,7 +7986,7 @@
           <p:cNvPr id="15" name="Prompt">
             <a:extLst xmlns:a="http://schemas.openxmlformats.org/drawingml/2006/main">
               <a:ext uri="{FF2B5EF4-FFF2-40B4-BE49-F238E27FC236}">
-                <a16:creationId xmlns:a16="http://schemas.microsoft.com/office/drawing/2014/main" id="{E9D912D9-2423-453D-B00F-13AA3124BF5B}"/>
+                <a16:creationId xmlns:a16="http://schemas.microsoft.com/office/drawing/2014/main" id="{D540793C-7266-4796-B0D4-711F32BBD6A2}"/>
               </a:ext>
             </a:extLst>
           </p:cNvPr>
@@ -8144,7 +8144,7 @@
           <p:cNvPr id="16" name="이번 작업을&#10;구체화한다">
             <a:extLst xmlns:a="http://schemas.openxmlformats.org/drawingml/2006/main">
               <a:ext uri="{FF2B5EF4-FFF2-40B4-BE49-F238E27FC236}">
-                <a16:creationId xmlns:a16="http://schemas.microsoft.com/office/drawing/2014/main" id="{6CE30F67-AEC4-4589-AEF2-01995006F014}"/>
+                <a16:creationId xmlns:a16="http://schemas.microsoft.com/office/drawing/2014/main" id="{1C3901B8-21C5-43BE-8933-DCD8A0A510A9}"/>
               </a:ext>
             </a:extLst>
           </p:cNvPr>
@@ -8325,7 +8325,7 @@
           <p:cNvPr id="17" name="">
             <a:extLst xmlns:a="http://schemas.openxmlformats.org/drawingml/2006/main">
               <a:ext uri="{FF2B5EF4-FFF2-40B4-BE49-F238E27FC236}">
-                <a16:creationId xmlns:a16="http://schemas.microsoft.com/office/drawing/2014/main" id="{13651712-EBAD-486D-A097-0A71C88B867B}"/>
+                <a16:creationId xmlns:a16="http://schemas.microsoft.com/office/drawing/2014/main" id="{4CEECBAE-95B8-4BC8-9760-F8CB06172AD5}"/>
               </a:ext>
             </a:extLst>
           </p:cNvPr>
@@ -8355,7 +8355,7 @@
           <p:cNvPr id="18" name="03">
             <a:extLst xmlns:a="http://schemas.openxmlformats.org/drawingml/2006/main">
               <a:ext uri="{FF2B5EF4-FFF2-40B4-BE49-F238E27FC236}">
-                <a16:creationId xmlns:a16="http://schemas.microsoft.com/office/drawing/2014/main" id="{3F5FEF59-E15B-406F-9701-64A7262B2DEE}"/>
+                <a16:creationId xmlns:a16="http://schemas.microsoft.com/office/drawing/2014/main" id="{EC651C2B-B7F5-429C-9836-77C75E7C7FEE}"/>
               </a:ext>
             </a:extLst>
           </p:cNvPr>
@@ -8513,7 +8513,7 @@
           <p:cNvPr id="19" name="">
             <a:extLst xmlns:a="http://schemas.openxmlformats.org/drawingml/2006/main">
               <a:ext uri="{FF2B5EF4-FFF2-40B4-BE49-F238E27FC236}">
-                <a16:creationId xmlns:a16="http://schemas.microsoft.com/office/drawing/2014/main" id="{5B4A2C43-1625-442A-879C-5AE0628CC3A1}"/>
+                <a16:creationId xmlns:a16="http://schemas.microsoft.com/office/drawing/2014/main" id="{7F568289-6826-4262-AB8A-4E4276102B1F}"/>
               </a:ext>
             </a:extLst>
           </p:cNvPr>
@@ -8544,7 +8544,7 @@
           <p:cNvPr id="20" name="Context">
             <a:extLst xmlns:a="http://schemas.openxmlformats.org/drawingml/2006/main">
               <a:ext uri="{FF2B5EF4-FFF2-40B4-BE49-F238E27FC236}">
-                <a16:creationId xmlns:a16="http://schemas.microsoft.com/office/drawing/2014/main" id="{BF6C41CF-C2A0-423B-8432-267C40FEC921}"/>
+                <a16:creationId xmlns:a16="http://schemas.microsoft.com/office/drawing/2014/main" id="{2EC23996-18A9-47DB-8B1D-81F08C8C681B}"/>
               </a:ext>
             </a:extLst>
           </p:cNvPr>
@@ -8702,7 +8702,7 @@
           <p:cNvPr id="21" name="프로젝트 지식을&#10;제공한다">
             <a:extLst xmlns:a="http://schemas.openxmlformats.org/drawingml/2006/main">
               <a:ext uri="{FF2B5EF4-FFF2-40B4-BE49-F238E27FC236}">
-                <a16:creationId xmlns:a16="http://schemas.microsoft.com/office/drawing/2014/main" id="{95DDEE49-26BC-429D-8A0C-79EE59898219}"/>
+                <a16:creationId xmlns:a16="http://schemas.microsoft.com/office/drawing/2014/main" id="{AD70FC03-F7D1-412D-9060-57FBBFF0443A}"/>
               </a:ext>
             </a:extLst>
           </p:cNvPr>
@@ -8883,7 +8883,7 @@
           <p:cNvPr id="22" name="">
             <a:extLst xmlns:a="http://schemas.openxmlformats.org/drawingml/2006/main">
               <a:ext uri="{FF2B5EF4-FFF2-40B4-BE49-F238E27FC236}">
-                <a16:creationId xmlns:a16="http://schemas.microsoft.com/office/drawing/2014/main" id="{C2415EC8-8C7D-41E3-8ACF-E772D6220ACE}"/>
+                <a16:creationId xmlns:a16="http://schemas.microsoft.com/office/drawing/2014/main" id="{8FA1D4A5-D03A-4982-BDC0-6AE2096FF991}"/>
               </a:ext>
             </a:extLst>
           </p:cNvPr>
@@ -8913,7 +8913,7 @@
           <p:cNvPr id="23" name="04">
             <a:extLst xmlns:a="http://schemas.openxmlformats.org/drawingml/2006/main">
               <a:ext uri="{FF2B5EF4-FFF2-40B4-BE49-F238E27FC236}">
-                <a16:creationId xmlns:a16="http://schemas.microsoft.com/office/drawing/2014/main" id="{D0C28045-088D-42B0-AB5A-AFAA18FB6639}"/>
+                <a16:creationId xmlns:a16="http://schemas.microsoft.com/office/drawing/2014/main" id="{89C53316-941E-491B-877D-64839EDCFAC5}"/>
               </a:ext>
             </a:extLst>
           </p:cNvPr>
@@ -9071,7 +9071,7 @@
           <p:cNvPr id="24" name="">
             <a:extLst xmlns:a="http://schemas.openxmlformats.org/drawingml/2006/main">
               <a:ext uri="{FF2B5EF4-FFF2-40B4-BE49-F238E27FC236}">
-                <a16:creationId xmlns:a16="http://schemas.microsoft.com/office/drawing/2014/main" id="{BE31B2CC-9198-477A-89F7-26415A724D70}"/>
+                <a16:creationId xmlns:a16="http://schemas.microsoft.com/office/drawing/2014/main" id="{49E34DCE-E093-471B-BF10-E0E2F28EE028}"/>
               </a:ext>
             </a:extLst>
           </p:cNvPr>
@@ -9102,7 +9102,7 @@
           <p:cNvPr id="25" name="Harness">
             <a:extLst xmlns:a="http://schemas.openxmlformats.org/drawingml/2006/main">
               <a:ext uri="{FF2B5EF4-FFF2-40B4-BE49-F238E27FC236}">
-                <a16:creationId xmlns:a16="http://schemas.microsoft.com/office/drawing/2014/main" id="{6CA35EC3-F3D2-4019-9D57-EC8FE9346FE6}"/>
+                <a16:creationId xmlns:a16="http://schemas.microsoft.com/office/drawing/2014/main" id="{60905D54-0E39-4E75-8565-EDC72D6B481B}"/>
               </a:ext>
             </a:extLst>
           </p:cNvPr>
@@ -9260,7 +9260,7 @@
           <p:cNvPr id="26" name="일하는 환경을&#10;설계한다">
             <a:extLst xmlns:a="http://schemas.openxmlformats.org/drawingml/2006/main">
               <a:ext uri="{FF2B5EF4-FFF2-40B4-BE49-F238E27FC236}">
-                <a16:creationId xmlns:a16="http://schemas.microsoft.com/office/drawing/2014/main" id="{C590DA66-772B-46F9-90F2-DC1FA8FD22CE}"/>
+                <a16:creationId xmlns:a16="http://schemas.microsoft.com/office/drawing/2014/main" id="{3FE12F39-50CC-4198-B578-E447C6C78454}"/>
               </a:ext>
             </a:extLst>
           </p:cNvPr>
@@ -9441,7 +9441,7 @@
           <p:cNvPr id="27" name="">
             <a:extLst xmlns:a="http://schemas.openxmlformats.org/drawingml/2006/main">
               <a:ext uri="{FF2B5EF4-FFF2-40B4-BE49-F238E27FC236}">
-                <a16:creationId xmlns:a16="http://schemas.microsoft.com/office/drawing/2014/main" id="{278EDA88-611C-48BE-8FB6-27C278147909}"/>
+                <a16:creationId xmlns:a16="http://schemas.microsoft.com/office/drawing/2014/main" id="{BD81C7A9-4312-4D73-B0C0-E29063E04E6A}"/>
               </a:ext>
             </a:extLst>
           </p:cNvPr>
@@ -9471,7 +9471,7 @@
           <p:cNvPr id="28" name="05">
             <a:extLst xmlns:a="http://schemas.openxmlformats.org/drawingml/2006/main">
               <a:ext uri="{FF2B5EF4-FFF2-40B4-BE49-F238E27FC236}">
-                <a16:creationId xmlns:a16="http://schemas.microsoft.com/office/drawing/2014/main" id="{17D399A1-E720-41C5-AFA2-2DA6D12BADC4}"/>
+                <a16:creationId xmlns:a16="http://schemas.microsoft.com/office/drawing/2014/main" id="{4B4DE943-05F5-4818-A380-2FDB7B4DD5C7}"/>
               </a:ext>
             </a:extLst>
           </p:cNvPr>
@@ -9629,7 +9629,7 @@
           <p:cNvPr id="29" name="">
             <a:extLst xmlns:a="http://schemas.openxmlformats.org/drawingml/2006/main">
               <a:ext uri="{FF2B5EF4-FFF2-40B4-BE49-F238E27FC236}">
-                <a16:creationId xmlns:a16="http://schemas.microsoft.com/office/drawing/2014/main" id="{EB5A8FDB-AB94-494C-8A40-C1CBFDC62F35}"/>
+                <a16:creationId xmlns:a16="http://schemas.microsoft.com/office/drawing/2014/main" id="{2C49FE80-FA6D-4298-BACC-7E4665FA56EA}"/>
               </a:ext>
             </a:extLst>
           </p:cNvPr>
@@ -9660,7 +9660,7 @@
           <p:cNvPr id="30" name="Loop">
             <a:extLst xmlns:a="http://schemas.openxmlformats.org/drawingml/2006/main">
               <a:ext uri="{FF2B5EF4-FFF2-40B4-BE49-F238E27FC236}">
-                <a16:creationId xmlns:a16="http://schemas.microsoft.com/office/drawing/2014/main" id="{37435F33-A708-4DFF-8573-486F9A4FFB21}"/>
+                <a16:creationId xmlns:a16="http://schemas.microsoft.com/office/drawing/2014/main" id="{B982D052-32B4-4AE8-8719-676DBDD2DDD3}"/>
               </a:ext>
             </a:extLst>
           </p:cNvPr>
@@ -9818,7 +9818,7 @@
           <p:cNvPr id="31" name="피드백으로&#10;시스템을 고친다">
             <a:extLst xmlns:a="http://schemas.openxmlformats.org/drawingml/2006/main">
               <a:ext uri="{FF2B5EF4-FFF2-40B4-BE49-F238E27FC236}">
-                <a16:creationId xmlns:a16="http://schemas.microsoft.com/office/drawing/2014/main" id="{2AB81FC9-2C80-42FE-A5A5-14E12184BCF0}"/>
+                <a16:creationId xmlns:a16="http://schemas.microsoft.com/office/drawing/2014/main" id="{ABC0A4D9-4823-4D83-8977-2F1C0FC8F658}"/>
               </a:ext>
             </a:extLst>
           </p:cNvPr>
@@ -9999,7 +9999,7 @@
           <p:cNvPr id="32" name="지금 나는 AI를 어떤 방식으로 사용하고 있을까?">
             <a:extLst xmlns:a="http://schemas.openxmlformats.org/drawingml/2006/main">
               <a:ext uri="{FF2B5EF4-FFF2-40B4-BE49-F238E27FC236}">
-                <a16:creationId xmlns:a16="http://schemas.microsoft.com/office/drawing/2014/main" id="{C3CF4256-13A3-44A6-AC25-5BA71BD4D40F}"/>
+                <a16:creationId xmlns:a16="http://schemas.microsoft.com/office/drawing/2014/main" id="{7D3BAE17-18E6-4E0D-9CCB-DD6FFC6BE684}"/>
               </a:ext>
             </a:extLst>
           </p:cNvPr>
@@ -10157,7 +10157,7 @@
           <p:cNvPr id="33" name="Legacy module connection">
             <a:extLst xmlns:a="http://schemas.openxmlformats.org/drawingml/2006/main">
               <a:ext uri="{FF2B5EF4-FFF2-40B4-BE49-F238E27FC236}">
-                <a16:creationId xmlns:a16="http://schemas.microsoft.com/office/drawing/2014/main" id="{C0574E31-1CB3-44E8-ABEF-6E62685A354F}"/>
+                <a16:creationId xmlns:a16="http://schemas.microsoft.com/office/drawing/2014/main" id="{72AC86D4-C0F3-4725-B4FF-61E22904900F}"/>
               </a:ext>
             </a:extLst>
           </p:cNvPr>
@@ -10313,7 +10313,7 @@
     </p:spTree>
     <p:extLst>
       <p:ext uri="{BB962C8B-B14F-4D97-AF65-F5344CB8AC3E}">
-        <p14:creationId xmlns:p14="http://schemas.microsoft.com/office/powerpoint/2010/main" val="2102295465"/>
+        <p14:creationId xmlns:p14="http://schemas.microsoft.com/office/powerpoint/2010/main" val="64537024"/>
       </p:ext>
     </p:extLst>
   </p:cSld>
@@ -10344,7 +10344,7 @@
           <p:cNvPr id="54" name="ACT 5 · 확인된 제품 변화">
             <a:extLst xmlns:a="http://schemas.openxmlformats.org/drawingml/2006/main">
               <a:ext uri="{FF2B5EF4-FFF2-40B4-BE49-F238E27FC236}">
-                <a16:creationId xmlns:a16="http://schemas.microsoft.com/office/drawing/2014/main" id="{217E1920-DBD5-451D-B2BE-C748AF828056}"/>
+                <a16:creationId xmlns:a16="http://schemas.microsoft.com/office/drawing/2014/main" id="{1A2C96E3-E49C-4B12-89E3-8C2142D8FCD0}"/>
               </a:ext>
             </a:extLst>
           </p:cNvPr>
@@ -10499,10 +10499,10 @@
       </p:sp>
       <p:sp>
         <p:nvSpPr>
-          <p:cNvPr id="2" name="S84">
+          <p:cNvPr id="2" name="S87">
             <a:extLst xmlns:a="http://schemas.openxmlformats.org/drawingml/2006/main">
               <a:ext uri="{FF2B5EF4-FFF2-40B4-BE49-F238E27FC236}">
-                <a16:creationId xmlns:a16="http://schemas.microsoft.com/office/drawing/2014/main" id="{19C1A9E0-480C-4C01-A41A-A684AFDC1CCC}"/>
+                <a16:creationId xmlns:a16="http://schemas.microsoft.com/office/drawing/2014/main" id="{CBB7E805-1886-4F15-AAD6-F92A7BFA5467}"/>
               </a:ext>
             </a:extLst>
           </p:cNvPr>
@@ -10650,7 +10650,7 @@
                 <a:ea typeface="Malgun Gothic"/>
                 <a:cs typeface="Malgun Gothic"/>
               </a:rPr>
-              <a:t>S84</a:t>
+              <a:t>S87</a:t>
             </a:r>
           </a:p>
         </p:txBody>
@@ -10660,7 +10660,7 @@
           <p:cNvPr id="3" name="하나의 Repository가 문제에 대응해 진화했다">
             <a:extLst xmlns:a="http://schemas.openxmlformats.org/drawingml/2006/main">
               <a:ext uri="{FF2B5EF4-FFF2-40B4-BE49-F238E27FC236}">
-                <a16:creationId xmlns:a16="http://schemas.microsoft.com/office/drawing/2014/main" id="{CACCE858-F541-4440-AD47-A71A40CF510D}"/>
+                <a16:creationId xmlns:a16="http://schemas.microsoft.com/office/drawing/2014/main" id="{7C33B6C3-2346-4E50-98E5-214FFCE6FF71}"/>
               </a:ext>
             </a:extLst>
           </p:cNvPr>
@@ -10818,7 +10818,7 @@
           <p:cNvPr id="4" name="">
             <a:extLst xmlns:a="http://schemas.openxmlformats.org/drawingml/2006/main">
               <a:ext uri="{FF2B5EF4-FFF2-40B4-BE49-F238E27FC236}">
-                <a16:creationId xmlns:a16="http://schemas.microsoft.com/office/drawing/2014/main" id="{7DB9D08B-FD99-4E13-B0A3-76A10454BE60}"/>
+                <a16:creationId xmlns:a16="http://schemas.microsoft.com/office/drawing/2014/main" id="{91E3B395-251A-4EEB-86EB-E5AE1C3394AC}"/>
               </a:ext>
             </a:extLst>
           </p:cNvPr>
@@ -10846,10 +10846,10 @@
       </p:sp>
       <p:sp>
         <p:nvSpPr>
-          <p:cNvPr id="5" name="DEMO-12 · 실제 Git State 이력 · S18 / S42 / S55 발표자료 발췌">
+          <p:cNvPr id="5" name="DEMO-12 · 실제 Git State 이력 · S18 / S43 / S58 발표자료 발췌">
             <a:extLst xmlns:a="http://schemas.openxmlformats.org/drawingml/2006/main">
               <a:ext uri="{FF2B5EF4-FFF2-40B4-BE49-F238E27FC236}">
-                <a16:creationId xmlns:a16="http://schemas.microsoft.com/office/drawing/2014/main" id="{D839B420-2EAC-44F3-B54C-B430038BF2AF}"/>
+                <a16:creationId xmlns:a16="http://schemas.microsoft.com/office/drawing/2014/main" id="{C4674DF6-71FA-41A3-B8E5-53CF30DCE3EE}"/>
               </a:ext>
             </a:extLst>
           </p:cNvPr>
@@ -10997,7 +10997,7 @@
                 <a:ea typeface="Malgun Gothic"/>
                 <a:cs typeface="Malgun Gothic"/>
               </a:rPr>
-              <a:t>DEMO-12 · 실제 Git State 이력 · S18 / S42 / S55 발표자료 발췌</a:t>
+              <a:t>DEMO-12 · 실제 Git State 이력 · S18 / S43 / S58 발표자료 발췌</a:t>
             </a:r>
           </a:p>
         </p:txBody>
@@ -11007,7 +11007,7 @@
           <p:cNvPr id="6" name="원본 실행 화면 아님 · 성능은 해당 코드·입력·환경 범위 · State는 성숙도 등급이나 Product L">
             <a:extLst xmlns:a="http://schemas.openxmlformats.org/drawingml/2006/main">
               <a:ext uri="{FF2B5EF4-FFF2-40B4-BE49-F238E27FC236}">
-                <a16:creationId xmlns:a16="http://schemas.microsoft.com/office/drawing/2014/main" id="{163954F6-909C-4F49-AB8A-0F05CDF0AA21}"/>
+                <a16:creationId xmlns:a16="http://schemas.microsoft.com/office/drawing/2014/main" id="{DEA0255B-BF7E-4DB4-B6A5-A1BA6B27BEA9}"/>
               </a:ext>
             </a:extLst>
           </p:cNvPr>
@@ -11165,7 +11165,7 @@
           <p:cNvPr id="7" name="">
             <a:extLst xmlns:a="http://schemas.openxmlformats.org/drawingml/2006/main">
               <a:ext uri="{FF2B5EF4-FFF2-40B4-BE49-F238E27FC236}">
-                <a16:creationId xmlns:a16="http://schemas.microsoft.com/office/drawing/2014/main" id="{EC28C19E-ED47-41DF-9C1D-891785ACD8B9}"/>
+                <a16:creationId xmlns:a16="http://schemas.microsoft.com/office/drawing/2014/main" id="{66413B04-DD9C-4531-ABEF-9CDCCEBA2938}"/>
               </a:ext>
             </a:extLst>
           </p:cNvPr>
@@ -11196,7 +11196,7 @@
           <p:cNvPr id="8" name="01">
             <a:extLst xmlns:a="http://schemas.openxmlformats.org/drawingml/2006/main">
               <a:ext uri="{FF2B5EF4-FFF2-40B4-BE49-F238E27FC236}">
-                <a16:creationId xmlns:a16="http://schemas.microsoft.com/office/drawing/2014/main" id="{AACCA936-B292-42B0-A6D9-180BBF53033F}"/>
+                <a16:creationId xmlns:a16="http://schemas.microsoft.com/office/drawing/2014/main" id="{4F354BB1-4F62-4A49-B2F7-4B6BA0DDA28C}"/>
               </a:ext>
             </a:extLst>
           </p:cNvPr>
@@ -11354,7 +11354,7 @@
           <p:cNvPr id="9" name="STATE-00">
             <a:extLst xmlns:a="http://schemas.openxmlformats.org/drawingml/2006/main">
               <a:ext uri="{FF2B5EF4-FFF2-40B4-BE49-F238E27FC236}">
-                <a16:creationId xmlns:a16="http://schemas.microsoft.com/office/drawing/2014/main" id="{09CAB909-DAA4-4E33-9B6C-D1B31513A88E}"/>
+                <a16:creationId xmlns:a16="http://schemas.microsoft.com/office/drawing/2014/main" id="{DC44B91C-A39A-40EB-9FD4-945A32285F99}"/>
               </a:ext>
             </a:extLst>
           </p:cNvPr>
@@ -11512,7 +11512,7 @@
           <p:cNvPr id="10" name="crop 경계 문제">
             <a:extLst xmlns:a="http://schemas.openxmlformats.org/drawingml/2006/main">
               <a:ext uri="{FF2B5EF4-FFF2-40B4-BE49-F238E27FC236}">
-                <a16:creationId xmlns:a16="http://schemas.microsoft.com/office/drawing/2014/main" id="{4F41913F-3D6F-472E-8CC4-89CC61A1D935}"/>
+                <a16:creationId xmlns:a16="http://schemas.microsoft.com/office/drawing/2014/main" id="{352BE0B9-7FFC-4462-8ADC-A860D22C4E3E}"/>
               </a:ext>
             </a:extLst>
           </p:cNvPr>
@@ -11670,7 +11670,7 @@
           <p:cNvPr id="11" name="">
             <a:extLst xmlns:a="http://schemas.openxmlformats.org/drawingml/2006/main">
               <a:ext uri="{FF2B5EF4-FFF2-40B4-BE49-F238E27FC236}">
-                <a16:creationId xmlns:a16="http://schemas.microsoft.com/office/drawing/2014/main" id="{87DF21AA-00FA-46CA-8C05-40048459F974}"/>
+                <a16:creationId xmlns:a16="http://schemas.microsoft.com/office/drawing/2014/main" id="{90137305-BB2B-4C84-9A6B-774C9FC44538}"/>
               </a:ext>
             </a:extLst>
           </p:cNvPr>
@@ -11700,7 +11700,7 @@
           <p:cNvPr id="12" name="">
             <a:extLst xmlns:a="http://schemas.openxmlformats.org/drawingml/2006/main">
               <a:ext uri="{FF2B5EF4-FFF2-40B4-BE49-F238E27FC236}">
-                <a16:creationId xmlns:a16="http://schemas.microsoft.com/office/drawing/2014/main" id="{B72124B6-1FDA-41AC-A9F3-4BEE1605EDB7}"/>
+                <a16:creationId xmlns:a16="http://schemas.microsoft.com/office/drawing/2014/main" id="{56DB9743-3977-4B97-AC57-32504CF77E68}"/>
               </a:ext>
             </a:extLst>
           </p:cNvPr>
@@ -11731,7 +11731,7 @@
           <p:cNvPr id="13" name="02">
             <a:extLst xmlns:a="http://schemas.openxmlformats.org/drawingml/2006/main">
               <a:ext uri="{FF2B5EF4-FFF2-40B4-BE49-F238E27FC236}">
-                <a16:creationId xmlns:a16="http://schemas.microsoft.com/office/drawing/2014/main" id="{649B7E83-D0E2-470E-9C1C-B95DD2987D35}"/>
+                <a16:creationId xmlns:a16="http://schemas.microsoft.com/office/drawing/2014/main" id="{2BA5AED0-F323-4196-83DE-6C00FB40D39F}"/>
               </a:ext>
             </a:extLst>
           </p:cNvPr>
@@ -11889,7 +11889,7 @@
           <p:cNvPr id="14" name="STATE-00-FIXED">
             <a:extLst xmlns:a="http://schemas.openxmlformats.org/drawingml/2006/main">
               <a:ext uri="{FF2B5EF4-FFF2-40B4-BE49-F238E27FC236}">
-                <a16:creationId xmlns:a16="http://schemas.microsoft.com/office/drawing/2014/main" id="{BF6DD9C7-EC38-4275-B144-5CF2D36B5E64}"/>
+                <a16:creationId xmlns:a16="http://schemas.microsoft.com/office/drawing/2014/main" id="{EB8D5004-6810-445A-A855-4A578957BE8E}"/>
               </a:ext>
             </a:extLst>
           </p:cNvPr>
@@ -12047,7 +12047,7 @@
           <p:cNvPr id="15" name="계약에 맞게 수정">
             <a:extLst xmlns:a="http://schemas.openxmlformats.org/drawingml/2006/main">
               <a:ext uri="{FF2B5EF4-FFF2-40B4-BE49-F238E27FC236}">
-                <a16:creationId xmlns:a16="http://schemas.microsoft.com/office/drawing/2014/main" id="{854A33CD-2EAD-4BEB-A3F3-9667EB436ADB}"/>
+                <a16:creationId xmlns:a16="http://schemas.microsoft.com/office/drawing/2014/main" id="{99839A61-657F-47F9-B101-203E2AA6350A}"/>
               </a:ext>
             </a:extLst>
           </p:cNvPr>
@@ -12205,7 +12205,7 @@
           <p:cNvPr id="16" name="">
             <a:extLst xmlns:a="http://schemas.openxmlformats.org/drawingml/2006/main">
               <a:ext uri="{FF2B5EF4-FFF2-40B4-BE49-F238E27FC236}">
-                <a16:creationId xmlns:a16="http://schemas.microsoft.com/office/drawing/2014/main" id="{801EB076-DDD7-4C67-BC39-AB91BC7B1457}"/>
+                <a16:creationId xmlns:a16="http://schemas.microsoft.com/office/drawing/2014/main" id="{B9E49F65-7C92-4FF3-944C-8E3D94D0344A}"/>
               </a:ext>
             </a:extLst>
           </p:cNvPr>
@@ -12235,7 +12235,7 @@
           <p:cNvPr id="17" name="">
             <a:extLst xmlns:a="http://schemas.openxmlformats.org/drawingml/2006/main">
               <a:ext uri="{FF2B5EF4-FFF2-40B4-BE49-F238E27FC236}">
-                <a16:creationId xmlns:a16="http://schemas.microsoft.com/office/drawing/2014/main" id="{608AC83F-8ACD-49EE-BB6D-B796C20953C9}"/>
+                <a16:creationId xmlns:a16="http://schemas.microsoft.com/office/drawing/2014/main" id="{0C6C54B1-DB26-4C10-B5FC-EE671B772422}"/>
               </a:ext>
             </a:extLst>
           </p:cNvPr>
@@ -12266,7 +12266,7 @@
           <p:cNvPr id="18" name="03">
             <a:extLst xmlns:a="http://schemas.openxmlformats.org/drawingml/2006/main">
               <a:ext uri="{FF2B5EF4-FFF2-40B4-BE49-F238E27FC236}">
-                <a16:creationId xmlns:a16="http://schemas.microsoft.com/office/drawing/2014/main" id="{F4D3CACB-F323-4014-B738-DEA7402185AF}"/>
+                <a16:creationId xmlns:a16="http://schemas.microsoft.com/office/drawing/2014/main" id="{2C418548-4EF2-4DCC-9594-12D08A140408}"/>
               </a:ext>
             </a:extLst>
           </p:cNvPr>
@@ -12424,7 +12424,7 @@
           <p:cNvPr id="19" name="STATE-01">
             <a:extLst xmlns:a="http://schemas.openxmlformats.org/drawingml/2006/main">
               <a:ext uri="{FF2B5EF4-FFF2-40B4-BE49-F238E27FC236}">
-                <a16:creationId xmlns:a16="http://schemas.microsoft.com/office/drawing/2014/main" id="{FADB7A62-7FB2-4931-B1A5-58B521BEDB1C}"/>
+                <a16:creationId xmlns:a16="http://schemas.microsoft.com/office/drawing/2014/main" id="{06B9E38D-5387-4E5A-AB2C-E462EE3CE356}"/>
               </a:ext>
             </a:extLst>
           </p:cNvPr>
@@ -12582,7 +12582,7 @@
           <p:cNvPr id="20" name="프로젝트 지침">
             <a:extLst xmlns:a="http://schemas.openxmlformats.org/drawingml/2006/main">
               <a:ext uri="{FF2B5EF4-FFF2-40B4-BE49-F238E27FC236}">
-                <a16:creationId xmlns:a16="http://schemas.microsoft.com/office/drawing/2014/main" id="{CA08E7A4-E878-47A1-B4A5-F2AC47E5660D}"/>
+                <a16:creationId xmlns:a16="http://schemas.microsoft.com/office/drawing/2014/main" id="{B110CBE6-579A-4CD4-8093-E86661D04627}"/>
               </a:ext>
             </a:extLst>
           </p:cNvPr>
@@ -12740,7 +12740,7 @@
           <p:cNvPr id="21" name="">
             <a:extLst xmlns:a="http://schemas.openxmlformats.org/drawingml/2006/main">
               <a:ext uri="{FF2B5EF4-FFF2-40B4-BE49-F238E27FC236}">
-                <a16:creationId xmlns:a16="http://schemas.microsoft.com/office/drawing/2014/main" id="{27007C04-A26E-4208-847C-E8134F1B7B02}"/>
+                <a16:creationId xmlns:a16="http://schemas.microsoft.com/office/drawing/2014/main" id="{4162B7C7-1159-4668-B8B6-7A27F6119FFA}"/>
               </a:ext>
             </a:extLst>
           </p:cNvPr>
@@ -12770,7 +12770,7 @@
           <p:cNvPr id="22" name="">
             <a:extLst xmlns:a="http://schemas.openxmlformats.org/drawingml/2006/main">
               <a:ext uri="{FF2B5EF4-FFF2-40B4-BE49-F238E27FC236}">
-                <a16:creationId xmlns:a16="http://schemas.microsoft.com/office/drawing/2014/main" id="{DEB59B39-CF1C-43B9-A421-0D96E613B4E8}"/>
+                <a16:creationId xmlns:a16="http://schemas.microsoft.com/office/drawing/2014/main" id="{BA0000AB-A4D2-4967-BB46-8C345FC4C9AA}"/>
               </a:ext>
             </a:extLst>
           </p:cNvPr>
@@ -12801,7 +12801,7 @@
           <p:cNvPr id="23" name="04">
             <a:extLst xmlns:a="http://schemas.openxmlformats.org/drawingml/2006/main">
               <a:ext uri="{FF2B5EF4-FFF2-40B4-BE49-F238E27FC236}">
-                <a16:creationId xmlns:a16="http://schemas.microsoft.com/office/drawing/2014/main" id="{72ED71F9-7DCE-4372-AA8C-895FC37B1CA7}"/>
+                <a16:creationId xmlns:a16="http://schemas.microsoft.com/office/drawing/2014/main" id="{42150C76-90EB-4964-B6EB-C9741C6D1094}"/>
               </a:ext>
             </a:extLst>
           </p:cNvPr>
@@ -12959,7 +12959,7 @@
           <p:cNvPr id="24" name="STATE-02">
             <a:extLst xmlns:a="http://schemas.openxmlformats.org/drawingml/2006/main">
               <a:ext uri="{FF2B5EF4-FFF2-40B4-BE49-F238E27FC236}">
-                <a16:creationId xmlns:a16="http://schemas.microsoft.com/office/drawing/2014/main" id="{937AB14C-858E-44C5-A198-F5514D531595}"/>
+                <a16:creationId xmlns:a16="http://schemas.microsoft.com/office/drawing/2014/main" id="{BCD9D450-65D6-4ADB-A420-C4F46F2DF802}"/>
               </a:ext>
             </a:extLst>
           </p:cNvPr>
@@ -13117,7 +13117,7 @@
           <p:cNvPr id="25" name="Context 증가">
             <a:extLst xmlns:a="http://schemas.openxmlformats.org/drawingml/2006/main">
               <a:ext uri="{FF2B5EF4-FFF2-40B4-BE49-F238E27FC236}">
-                <a16:creationId xmlns:a16="http://schemas.microsoft.com/office/drawing/2014/main" id="{7B009DDF-131F-4299-B0DB-7674A7A96686}"/>
+                <a16:creationId xmlns:a16="http://schemas.microsoft.com/office/drawing/2014/main" id="{80E45300-261A-4F9E-821B-114EBEC4DDFD}"/>
               </a:ext>
             </a:extLst>
           </p:cNvPr>
@@ -13275,7 +13275,7 @@
           <p:cNvPr id="26" name="">
             <a:extLst xmlns:a="http://schemas.openxmlformats.org/drawingml/2006/main">
               <a:ext uri="{FF2B5EF4-FFF2-40B4-BE49-F238E27FC236}">
-                <a16:creationId xmlns:a16="http://schemas.microsoft.com/office/drawing/2014/main" id="{1F90ABD1-E72F-4C49-8E8E-01A88CD7A653}"/>
+                <a16:creationId xmlns:a16="http://schemas.microsoft.com/office/drawing/2014/main" id="{6F461D61-FF68-4694-AEF5-25410E756256}"/>
               </a:ext>
             </a:extLst>
           </p:cNvPr>
@@ -13306,7 +13306,7 @@
           <p:cNvPr id="27" name="05">
             <a:extLst xmlns:a="http://schemas.openxmlformats.org/drawingml/2006/main">
               <a:ext uri="{FF2B5EF4-FFF2-40B4-BE49-F238E27FC236}">
-                <a16:creationId xmlns:a16="http://schemas.microsoft.com/office/drawing/2014/main" id="{A299C04B-9BE0-4F2A-9E1C-A4D6E0C47918}"/>
+                <a16:creationId xmlns:a16="http://schemas.microsoft.com/office/drawing/2014/main" id="{D56EEF61-9B61-42BF-8EC7-C966775A8049}"/>
               </a:ext>
             </a:extLst>
           </p:cNvPr>
@@ -13464,7 +13464,7 @@
           <p:cNvPr id="28" name="STATE-03">
             <a:extLst xmlns:a="http://schemas.openxmlformats.org/drawingml/2006/main">
               <a:ext uri="{FF2B5EF4-FFF2-40B4-BE49-F238E27FC236}">
-                <a16:creationId xmlns:a16="http://schemas.microsoft.com/office/drawing/2014/main" id="{A14E3366-6D81-4091-A5EC-7C63E17F4FB6}"/>
+                <a16:creationId xmlns:a16="http://schemas.microsoft.com/office/drawing/2014/main" id="{A48B10DE-31BD-416E-9159-015C00D8BCDC}"/>
               </a:ext>
             </a:extLst>
           </p:cNvPr>
@@ -13622,7 +13622,7 @@
           <p:cNvPr id="29" name="상세 정보로 연결">
             <a:extLst xmlns:a="http://schemas.openxmlformats.org/drawingml/2006/main">
               <a:ext uri="{FF2B5EF4-FFF2-40B4-BE49-F238E27FC236}">
-                <a16:creationId xmlns:a16="http://schemas.microsoft.com/office/drawing/2014/main" id="{4CD2CACB-C3C6-4AE0-BC27-8A49303193F6}"/>
+                <a16:creationId xmlns:a16="http://schemas.microsoft.com/office/drawing/2014/main" id="{CA3BB36E-7972-4722-9A26-5AA8C076C337}"/>
               </a:ext>
             </a:extLst>
           </p:cNvPr>
@@ -13780,7 +13780,7 @@
           <p:cNvPr id="30" name="">
             <a:extLst xmlns:a="http://schemas.openxmlformats.org/drawingml/2006/main">
               <a:ext uri="{FF2B5EF4-FFF2-40B4-BE49-F238E27FC236}">
-                <a16:creationId xmlns:a16="http://schemas.microsoft.com/office/drawing/2014/main" id="{88A47837-DE17-4239-AA2F-EF22217BD91E}"/>
+                <a16:creationId xmlns:a16="http://schemas.microsoft.com/office/drawing/2014/main" id="{F46EB469-051A-44A0-92D8-64D2CF7E5CAC}"/>
               </a:ext>
             </a:extLst>
           </p:cNvPr>
@@ -13810,7 +13810,7 @@
           <p:cNvPr id="31" name="">
             <a:extLst xmlns:a="http://schemas.openxmlformats.org/drawingml/2006/main">
               <a:ext uri="{FF2B5EF4-FFF2-40B4-BE49-F238E27FC236}">
-                <a16:creationId xmlns:a16="http://schemas.microsoft.com/office/drawing/2014/main" id="{32DE37DE-0B8B-4A63-95B2-3911EF345761}"/>
+                <a16:creationId xmlns:a16="http://schemas.microsoft.com/office/drawing/2014/main" id="{5AFBC380-7EE6-4490-858B-0F35FA0A5742}"/>
               </a:ext>
             </a:extLst>
           </p:cNvPr>
@@ -13841,7 +13841,7 @@
           <p:cNvPr id="32" name="06">
             <a:extLst xmlns:a="http://schemas.openxmlformats.org/drawingml/2006/main">
               <a:ext uri="{FF2B5EF4-FFF2-40B4-BE49-F238E27FC236}">
-                <a16:creationId xmlns:a16="http://schemas.microsoft.com/office/drawing/2014/main" id="{99D9FE3B-1733-4838-BC25-3BB57DDDD21E}"/>
+                <a16:creationId xmlns:a16="http://schemas.microsoft.com/office/drawing/2014/main" id="{23C126CB-BD67-48B9-A3D1-8FE7EA50CA97}"/>
               </a:ext>
             </a:extLst>
           </p:cNvPr>
@@ -13999,7 +13999,7 @@
           <p:cNvPr id="33" name="STATE-04">
             <a:extLst xmlns:a="http://schemas.openxmlformats.org/drawingml/2006/main">
               <a:ext uri="{FF2B5EF4-FFF2-40B4-BE49-F238E27FC236}">
-                <a16:creationId xmlns:a16="http://schemas.microsoft.com/office/drawing/2014/main" id="{096780B2-370E-4F79-9677-1CD3F07A7CF0}"/>
+                <a16:creationId xmlns:a16="http://schemas.microsoft.com/office/drawing/2014/main" id="{6658E524-F812-41CC-AF9A-0AAD11B8D953}"/>
               </a:ext>
             </a:extLst>
           </p:cNvPr>
@@ -14157,7 +14157,7 @@
           <p:cNvPr id="34" name="재사용 Workflow">
             <a:extLst xmlns:a="http://schemas.openxmlformats.org/drawingml/2006/main">
               <a:ext uri="{FF2B5EF4-FFF2-40B4-BE49-F238E27FC236}">
-                <a16:creationId xmlns:a16="http://schemas.microsoft.com/office/drawing/2014/main" id="{6AC3455A-453E-4B7B-BF87-04A67B491323}"/>
+                <a16:creationId xmlns:a16="http://schemas.microsoft.com/office/drawing/2014/main" id="{13D5A3BC-F0FA-47B3-81B0-20777D31F9A6}"/>
               </a:ext>
             </a:extLst>
           </p:cNvPr>
@@ -14315,7 +14315,7 @@
           <p:cNvPr id="35" name="">
             <a:extLst xmlns:a="http://schemas.openxmlformats.org/drawingml/2006/main">
               <a:ext uri="{FF2B5EF4-FFF2-40B4-BE49-F238E27FC236}">
-                <a16:creationId xmlns:a16="http://schemas.microsoft.com/office/drawing/2014/main" id="{69DCFE5F-D1E8-46EF-9983-210AB0881194}"/>
+                <a16:creationId xmlns:a16="http://schemas.microsoft.com/office/drawing/2014/main" id="{6C42370F-493B-4E92-A4E4-33728A639F89}"/>
               </a:ext>
             </a:extLst>
           </p:cNvPr>
@@ -14345,7 +14345,7 @@
           <p:cNvPr id="36" name="">
             <a:extLst xmlns:a="http://schemas.openxmlformats.org/drawingml/2006/main">
               <a:ext uri="{FF2B5EF4-FFF2-40B4-BE49-F238E27FC236}">
-                <a16:creationId xmlns:a16="http://schemas.microsoft.com/office/drawing/2014/main" id="{CCAEE1B6-847C-4C65-A9F8-012F6541C6DF}"/>
+                <a16:creationId xmlns:a16="http://schemas.microsoft.com/office/drawing/2014/main" id="{1BC2CD6A-BB1F-45F3-87E0-19153EB88438}"/>
               </a:ext>
             </a:extLst>
           </p:cNvPr>
@@ -14376,7 +14376,7 @@
           <p:cNvPr id="37" name="07">
             <a:extLst xmlns:a="http://schemas.openxmlformats.org/drawingml/2006/main">
               <a:ext uri="{FF2B5EF4-FFF2-40B4-BE49-F238E27FC236}">
-                <a16:creationId xmlns:a16="http://schemas.microsoft.com/office/drawing/2014/main" id="{6614C635-5731-4361-9D0E-08FF59BA08C6}"/>
+                <a16:creationId xmlns:a16="http://schemas.microsoft.com/office/drawing/2014/main" id="{804F3FAE-8798-4F70-A781-0C1DA0FCFC80}"/>
               </a:ext>
             </a:extLst>
           </p:cNvPr>
@@ -14534,7 +14534,7 @@
           <p:cNvPr id="38" name="STATE-04-PERF">
             <a:extLst xmlns:a="http://schemas.openxmlformats.org/drawingml/2006/main">
               <a:ext uri="{FF2B5EF4-FFF2-40B4-BE49-F238E27FC236}">
-                <a16:creationId xmlns:a16="http://schemas.microsoft.com/office/drawing/2014/main" id="{939F9032-CA51-4455-9FA7-290574FDBAAE}"/>
+                <a16:creationId xmlns:a16="http://schemas.microsoft.com/office/drawing/2014/main" id="{1FD89C8B-964F-4575-9BEC-FD572033D69C}"/>
               </a:ext>
             </a:extLst>
           </p:cNvPr>
@@ -14692,7 +14692,7 @@
           <p:cNvPr id="39" name="검증된 제품 변경">
             <a:extLst xmlns:a="http://schemas.openxmlformats.org/drawingml/2006/main">
               <a:ext uri="{FF2B5EF4-FFF2-40B4-BE49-F238E27FC236}">
-                <a16:creationId xmlns:a16="http://schemas.microsoft.com/office/drawing/2014/main" id="{EDFD3E2E-E6F4-4C35-8D56-35EDAECE6D0D}"/>
+                <a16:creationId xmlns:a16="http://schemas.microsoft.com/office/drawing/2014/main" id="{4DC72B87-85F9-4061-AF17-94E54FB3059B}"/>
               </a:ext>
             </a:extLst>
           </p:cNvPr>
@@ -14850,7 +14850,7 @@
           <p:cNvPr id="40" name="">
             <a:extLst xmlns:a="http://schemas.openxmlformats.org/drawingml/2006/main">
               <a:ext uri="{FF2B5EF4-FFF2-40B4-BE49-F238E27FC236}">
-                <a16:creationId xmlns:a16="http://schemas.microsoft.com/office/drawing/2014/main" id="{18ACE59F-BC71-49A7-8FAD-A78A6F2D0FA2}"/>
+                <a16:creationId xmlns:a16="http://schemas.microsoft.com/office/drawing/2014/main" id="{1E70EA24-447F-4B30-A768-CE93B843DF18}"/>
               </a:ext>
             </a:extLst>
           </p:cNvPr>
@@ -14880,7 +14880,7 @@
           <p:cNvPr id="41" name="">
             <a:extLst xmlns:a="http://schemas.openxmlformats.org/drawingml/2006/main">
               <a:ext uri="{FF2B5EF4-FFF2-40B4-BE49-F238E27FC236}">
-                <a16:creationId xmlns:a16="http://schemas.microsoft.com/office/drawing/2014/main" id="{EDBB410D-2BF4-4D17-87CD-32FC5E7D3A5F}"/>
+                <a16:creationId xmlns:a16="http://schemas.microsoft.com/office/drawing/2014/main" id="{10604DD1-3C9C-4798-9E26-042598884C76}"/>
               </a:ext>
             </a:extLst>
           </p:cNvPr>
@@ -14911,7 +14911,7 @@
           <p:cNvPr id="42" name="앞서 본 근거 다시 보기">
             <a:extLst xmlns:a="http://schemas.openxmlformats.org/drawingml/2006/main">
               <a:ext uri="{FF2B5EF4-FFF2-40B4-BE49-F238E27FC236}">
-                <a16:creationId xmlns:a16="http://schemas.microsoft.com/office/drawing/2014/main" id="{5587AB44-7E68-4B35-9907-0F07B2A65DDF}"/>
+                <a16:creationId xmlns:a16="http://schemas.microsoft.com/office/drawing/2014/main" id="{842AB964-815C-4623-A62B-544A048FC4C0}"/>
               </a:ext>
             </a:extLst>
           </p:cNvPr>
@@ -15069,7 +15069,7 @@
           <p:cNvPr id="43" name="">
             <a:extLst xmlns:a="http://schemas.openxmlformats.org/drawingml/2006/main">
               <a:ext uri="{FF2B5EF4-FFF2-40B4-BE49-F238E27FC236}">
-                <a16:creationId xmlns:a16="http://schemas.microsoft.com/office/drawing/2014/main" id="{24412E54-52AD-43E9-99A7-831BBE2A36C3}"/>
+                <a16:creationId xmlns:a16="http://schemas.microsoft.com/office/drawing/2014/main" id="{A1E5E756-FC1A-40D3-AC96-B441E83112E2}"/>
               </a:ext>
             </a:extLst>
           </p:cNvPr>
@@ -15079,7 +15079,7 @@
           <p:nvPr/>
         </p:nvPicPr>
         <p:blipFill>
-          <a:blip xmlns:r="http://schemas.openxmlformats.org/officeDocument/2006/relationships" xmlns:a="http://schemas.openxmlformats.org/drawingml/2006/main" r:embed="Rcdbce1d957e14689"/>
+          <a:blip xmlns:r="http://schemas.openxmlformats.org/officeDocument/2006/relationships" xmlns:a="http://schemas.openxmlformats.org/drawingml/2006/main" r:embed="Re573e92d81af404c"/>
           <a:srcRect xmlns:a="http://schemas.openxmlformats.org/drawingml/2006/main" l="5000" t="40741" r="5000" b="18519"/>
           <a:stretch xmlns:a="http://schemas.openxmlformats.org/drawingml/2006/main"/>
         </p:blipFill>
@@ -15098,7 +15098,7 @@
           <p:cNvPr id="44" name="crop 계약 수정">
             <a:extLst xmlns:a="http://schemas.openxmlformats.org/drawingml/2006/main">
               <a:ext uri="{FF2B5EF4-FFF2-40B4-BE49-F238E27FC236}">
-                <a16:creationId xmlns:a16="http://schemas.microsoft.com/office/drawing/2014/main" id="{A4E96786-B9B7-46AE-970B-890B804D8F64}"/>
+                <a16:creationId xmlns:a16="http://schemas.microsoft.com/office/drawing/2014/main" id="{C6CF550B-6574-4DB6-95A9-7FA9A5216DFE}"/>
               </a:ext>
             </a:extLst>
           </p:cNvPr>
@@ -15256,7 +15256,7 @@
           <p:cNvPr id="45" name="S18 · STATE-00 → STATE-00-FIXED">
             <a:extLst xmlns:a="http://schemas.openxmlformats.org/drawingml/2006/main">
               <a:ext uri="{FF2B5EF4-FFF2-40B4-BE49-F238E27FC236}">
-                <a16:creationId xmlns:a16="http://schemas.microsoft.com/office/drawing/2014/main" id="{0C239C58-DB0B-428C-B08A-2AC37FB870D5}"/>
+                <a16:creationId xmlns:a16="http://schemas.microsoft.com/office/drawing/2014/main" id="{BE265552-4B7A-4B34-9BBB-E2C128AAE35C}"/>
               </a:ext>
             </a:extLst>
           </p:cNvPr>
@@ -15414,7 +15414,7 @@
           <p:cNvPr id="46" name="">
             <a:extLst xmlns:a="http://schemas.openxmlformats.org/drawingml/2006/main">
               <a:ext uri="{FF2B5EF4-FFF2-40B4-BE49-F238E27FC236}">
-                <a16:creationId xmlns:a16="http://schemas.microsoft.com/office/drawing/2014/main" id="{3B0F1BF0-4437-49D5-BBBA-FF15B23688D7}"/>
+                <a16:creationId xmlns:a16="http://schemas.microsoft.com/office/drawing/2014/main" id="{26718D17-86A6-45A8-9935-5098C3CC57D7}"/>
               </a:ext>
             </a:extLst>
           </p:cNvPr>
@@ -15424,7 +15424,7 @@
           <p:nvPr/>
         </p:nvPicPr>
         <p:blipFill>
-          <a:blip xmlns:r="http://schemas.openxmlformats.org/officeDocument/2006/relationships" xmlns:a="http://schemas.openxmlformats.org/drawingml/2006/main" r:embed="R81b9c9f6c60b4a43"/>
+          <a:blip xmlns:r="http://schemas.openxmlformats.org/officeDocument/2006/relationships" xmlns:a="http://schemas.openxmlformats.org/drawingml/2006/main" r:embed="R762ccea8e8b147f7"/>
           <a:srcRect xmlns:a="http://schemas.openxmlformats.org/drawingml/2006/main" l="5000" t="39352" r="5000" b="26852"/>
           <a:stretch xmlns:a="http://schemas.openxmlformats.org/drawingml/2006/main"/>
         </p:blipFill>
@@ -15443,7 +15443,7 @@
           <p:cNvPr id="47" name="상세 문서로 분리">
             <a:extLst xmlns:a="http://schemas.openxmlformats.org/drawingml/2006/main">
               <a:ext uri="{FF2B5EF4-FFF2-40B4-BE49-F238E27FC236}">
-                <a16:creationId xmlns:a16="http://schemas.microsoft.com/office/drawing/2014/main" id="{85FCFCA0-93F4-4B6D-B672-3353CFA97B71}"/>
+                <a16:creationId xmlns:a16="http://schemas.microsoft.com/office/drawing/2014/main" id="{85DB35FE-A5A1-4BAB-A2C4-BA478800F562}"/>
               </a:ext>
             </a:extLst>
           </p:cNvPr>
@@ -15598,10 +15598,10 @@
       </p:sp>
       <p:sp>
         <p:nvSpPr>
-          <p:cNvPr id="48" name="S42 · STATE-02 → STATE-03">
+          <p:cNvPr id="48" name="S43 · STATE-02 → STATE-03">
             <a:extLst xmlns:a="http://schemas.openxmlformats.org/drawingml/2006/main">
               <a:ext uri="{FF2B5EF4-FFF2-40B4-BE49-F238E27FC236}">
-                <a16:creationId xmlns:a16="http://schemas.microsoft.com/office/drawing/2014/main" id="{D1C4CB32-25A7-4E7F-BC36-709B39BF1DEE}"/>
+                <a16:creationId xmlns:a16="http://schemas.microsoft.com/office/drawing/2014/main" id="{28A5DDAB-3D9D-4432-A03D-321EA7A0E797}"/>
               </a:ext>
             </a:extLst>
           </p:cNvPr>
@@ -15749,7 +15749,7 @@
                 <a:ea typeface="Consolas"/>
                 <a:cs typeface="Consolas"/>
               </a:rPr>
-              <a:t>S42 · STATE-02 → STATE-03</a:t>
+              <a:t>S43 · STATE-02 → STATE-03</a:t>
             </a:r>
           </a:p>
         </p:txBody>
@@ -15759,7 +15759,7 @@
           <p:cNvPr id="49" name="">
             <a:extLst xmlns:a="http://schemas.openxmlformats.org/drawingml/2006/main">
               <a:ext uri="{FF2B5EF4-FFF2-40B4-BE49-F238E27FC236}">
-                <a16:creationId xmlns:a16="http://schemas.microsoft.com/office/drawing/2014/main" id="{8E00783C-7A31-41C4-A509-D9A64BF59D6D}"/>
+                <a16:creationId xmlns:a16="http://schemas.microsoft.com/office/drawing/2014/main" id="{6890F19E-AFDB-4D8F-880B-AE08F305127B}"/>
               </a:ext>
             </a:extLst>
           </p:cNvPr>
@@ -15769,7 +15769,7 @@
           <p:nvPr/>
         </p:nvPicPr>
         <p:blipFill>
-          <a:blip xmlns:r="http://schemas.openxmlformats.org/officeDocument/2006/relationships" xmlns:a="http://schemas.openxmlformats.org/drawingml/2006/main" r:embed="R6a09f8cfb40f451b"/>
+          <a:blip xmlns:r="http://schemas.openxmlformats.org/officeDocument/2006/relationships" xmlns:a="http://schemas.openxmlformats.org/drawingml/2006/main" r:embed="R0b005031891046e9"/>
           <a:srcRect xmlns:a="http://schemas.openxmlformats.org/drawingml/2006/main" l="5000" t="33333" r="5000" b="16667"/>
           <a:stretch xmlns:a="http://schemas.openxmlformats.org/drawingml/2006/main"/>
         </p:blipFill>
@@ -15788,7 +15788,7 @@
           <p:cNvPr id="50" name="같은 조건의 성능 비교">
             <a:extLst xmlns:a="http://schemas.openxmlformats.org/drawingml/2006/main">
               <a:ext uri="{FF2B5EF4-FFF2-40B4-BE49-F238E27FC236}">
-                <a16:creationId xmlns:a16="http://schemas.microsoft.com/office/drawing/2014/main" id="{7E6C2A39-3AF2-42C4-899B-8842782A07AF}"/>
+                <a16:creationId xmlns:a16="http://schemas.microsoft.com/office/drawing/2014/main" id="{EAE562F4-0404-4EF5-8122-4C0AF97F5F65}"/>
               </a:ext>
             </a:extLst>
           </p:cNvPr>
@@ -15943,10 +15943,10 @@
       </p:sp>
       <p:sp>
         <p:nvSpPr>
-          <p:cNvPr id="51" name="S55 · STATE-04 → STATE-04-PERF">
+          <p:cNvPr id="51" name="S58 · STATE-04 → STATE-04-PERF">
             <a:extLst xmlns:a="http://schemas.openxmlformats.org/drawingml/2006/main">
               <a:ext uri="{FF2B5EF4-FFF2-40B4-BE49-F238E27FC236}">
-                <a16:creationId xmlns:a16="http://schemas.microsoft.com/office/drawing/2014/main" id="{A9DE7642-2FD8-4196-A7FB-B81A4A908822}"/>
+                <a16:creationId xmlns:a16="http://schemas.microsoft.com/office/drawing/2014/main" id="{D62F0F26-B661-4528-8C4B-50D5EF728A81}"/>
               </a:ext>
             </a:extLst>
           </p:cNvPr>
@@ -16094,7 +16094,7 @@
                 <a:ea typeface="Consolas"/>
                 <a:cs typeface="Consolas"/>
               </a:rPr>
-              <a:t>S55 · STATE-04 → STATE-04-PERF</a:t>
+              <a:t>S58 · STATE-04 → STATE-04-PERF</a:t>
             </a:r>
           </a:p>
         </p:txBody>
@@ -16104,7 +16104,7 @@
           <p:cNvPr id="52" name="각 변화의 출발점은, 그때 마주친 문제였다.">
             <a:extLst xmlns:a="http://schemas.openxmlformats.org/drawingml/2006/main">
               <a:ext uri="{FF2B5EF4-FFF2-40B4-BE49-F238E27FC236}">
-                <a16:creationId xmlns:a16="http://schemas.microsoft.com/office/drawing/2014/main" id="{713B0037-0294-4CC2-9E9C-362655E40D76}"/>
+                <a16:creationId xmlns:a16="http://schemas.microsoft.com/office/drawing/2014/main" id="{0815902E-9D80-4AD5-85F1-4BF5F4E7A677}"/>
               </a:ext>
             </a:extLst>
           </p:cNvPr>
@@ -16262,7 +16262,7 @@
           <p:cNvPr id="53" name="Legacy module connection">
             <a:extLst xmlns:a="http://schemas.openxmlformats.org/drawingml/2006/main">
               <a:ext uri="{FF2B5EF4-FFF2-40B4-BE49-F238E27FC236}">
-                <a16:creationId xmlns:a16="http://schemas.microsoft.com/office/drawing/2014/main" id="{4242A164-C4EE-45A1-AF47-F3EA0C7E0C42}"/>
+                <a16:creationId xmlns:a16="http://schemas.microsoft.com/office/drawing/2014/main" id="{5C2E12A2-77FF-42F5-82A1-A78D82895935}"/>
               </a:ext>
             </a:extLst>
           </p:cNvPr>
@@ -16418,7 +16418,7 @@
     </p:spTree>
     <p:extLst>
       <p:ext uri="{BB962C8B-B14F-4D97-AF65-F5344CB8AC3E}">
-        <p14:creationId xmlns:p14="http://schemas.microsoft.com/office/powerpoint/2010/main" val="129554898"/>
+        <p14:creationId xmlns:p14="http://schemas.microsoft.com/office/powerpoint/2010/main" val="1015776768"/>
       </p:ext>
     </p:extLst>
   </p:cSld>
@@ -16449,7 +16449,7 @@
           <p:cNvPr id="16" name="ACT 5 · 이번 Demo의 선택 기준">
             <a:extLst xmlns:a="http://schemas.openxmlformats.org/drawingml/2006/main">
               <a:ext uri="{FF2B5EF4-FFF2-40B4-BE49-F238E27FC236}">
-                <a16:creationId xmlns:a16="http://schemas.microsoft.com/office/drawing/2014/main" id="{B842D864-35C1-4A78-9008-0926C30AA46A}"/>
+                <a16:creationId xmlns:a16="http://schemas.microsoft.com/office/drawing/2014/main" id="{D3111D74-547B-458C-AE02-075E1C885314}"/>
               </a:ext>
             </a:extLst>
           </p:cNvPr>
@@ -16604,10 +16604,10 @@
       </p:sp>
       <p:sp>
         <p:nvSpPr>
-          <p:cNvPr id="2" name="S85">
+          <p:cNvPr id="2" name="S88">
             <a:extLst xmlns:a="http://schemas.openxmlformats.org/drawingml/2006/main">
               <a:ext uri="{FF2B5EF4-FFF2-40B4-BE49-F238E27FC236}">
-                <a16:creationId xmlns:a16="http://schemas.microsoft.com/office/drawing/2014/main" id="{763E6DD6-23EE-43C0-B833-8B928D472F43}"/>
+                <a16:creationId xmlns:a16="http://schemas.microsoft.com/office/drawing/2014/main" id="{358E0686-81B5-4375-8856-C5CBAB81D17A}"/>
               </a:ext>
             </a:extLst>
           </p:cNvPr>
@@ -16755,7 +16755,7 @@
                 <a:ea typeface="Malgun Gothic"/>
                 <a:cs typeface="Malgun Gothic"/>
               </a:rPr>
-              <a:t>S85</a:t>
+              <a:t>S88</a:t>
             </a:r>
           </a:p>
         </p:txBody>
@@ -16765,7 +16765,7 @@
           <p:cNvPr id="3" name="필요성이 입증되지 않은 것은 보류했다">
             <a:extLst xmlns:a="http://schemas.openxmlformats.org/drawingml/2006/main">
               <a:ext uri="{FF2B5EF4-FFF2-40B4-BE49-F238E27FC236}">
-                <a16:creationId xmlns:a16="http://schemas.microsoft.com/office/drawing/2014/main" id="{182ABFCB-AC4D-42A6-A37A-57DA9F76B3D0}"/>
+                <a16:creationId xmlns:a16="http://schemas.microsoft.com/office/drawing/2014/main" id="{779AC3EB-4C4E-42B7-BDAA-872106A0A86D}"/>
               </a:ext>
             </a:extLst>
           </p:cNvPr>
@@ -16923,7 +16923,7 @@
           <p:cNvPr id="4" name="">
             <a:extLst xmlns:a="http://schemas.openxmlformats.org/drawingml/2006/main">
               <a:ext uri="{FF2B5EF4-FFF2-40B4-BE49-F238E27FC236}">
-                <a16:creationId xmlns:a16="http://schemas.microsoft.com/office/drawing/2014/main" id="{E8EC2254-7888-49DC-86BE-C38F49AC0BCC}"/>
+                <a16:creationId xmlns:a16="http://schemas.microsoft.com/office/drawing/2014/main" id="{F24DE5EE-FBD5-4122-B38F-CB85F638319D}"/>
               </a:ext>
             </a:extLst>
           </p:cNvPr>
@@ -16954,7 +16954,7 @@
           <p:cNvPr id="5" name="STATE-04-PERF · DEC-0018 · 이번 작업의 선택을 회고">
             <a:extLst xmlns:a="http://schemas.openxmlformats.org/drawingml/2006/main">
               <a:ext uri="{FF2B5EF4-FFF2-40B4-BE49-F238E27FC236}">
-                <a16:creationId xmlns:a16="http://schemas.microsoft.com/office/drawing/2014/main" id="{8A04B21F-3F2E-4F3D-85C2-DE23C4DBF41F}"/>
+                <a16:creationId xmlns:a16="http://schemas.microsoft.com/office/drawing/2014/main" id="{722E878D-8350-474F-BC99-E8867418102E}"/>
               </a:ext>
             </a:extLst>
           </p:cNvPr>
@@ -17112,7 +17112,7 @@
           <p:cNvPr id="6" name="모든 프로젝트에서 Subagent·Memory가 불필요하거나 적을수록 좋다는 뜻은 아니다.">
             <a:extLst xmlns:a="http://schemas.openxmlformats.org/drawingml/2006/main">
               <a:ext uri="{FF2B5EF4-FFF2-40B4-BE49-F238E27FC236}">
-                <a16:creationId xmlns:a16="http://schemas.microsoft.com/office/drawing/2014/main" id="{9BE3D2E3-6680-4B1D-B618-B293BFB7888E}"/>
+                <a16:creationId xmlns:a16="http://schemas.microsoft.com/office/drawing/2014/main" id="{670315A1-B9F0-46B5-A8C8-B49784F4EB87}"/>
               </a:ext>
             </a:extLst>
           </p:cNvPr>
@@ -17270,7 +17270,7 @@
           <p:cNvPr id="7" name="이 구성요소가 현재 문제에 필요한가?">
             <a:extLst xmlns:a="http://schemas.openxmlformats.org/drawingml/2006/main">
               <a:ext uri="{FF2B5EF4-FFF2-40B4-BE49-F238E27FC236}">
-                <a16:creationId xmlns:a16="http://schemas.microsoft.com/office/drawing/2014/main" id="{D2A78921-E518-4FB6-BFB3-ECCB39AD4D6F}"/>
+                <a16:creationId xmlns:a16="http://schemas.microsoft.com/office/drawing/2014/main" id="{A7381220-A643-41ED-8A79-CDAED5FA3AE9}"/>
               </a:ext>
             </a:extLst>
           </p:cNvPr>
@@ -17428,7 +17428,7 @@
           <p:cNvPr id="8" name="이번 문제에 필요했던 것">
             <a:extLst xmlns:a="http://schemas.openxmlformats.org/drawingml/2006/main">
               <a:ext uri="{FF2B5EF4-FFF2-40B4-BE49-F238E27FC236}">
-                <a16:creationId xmlns:a16="http://schemas.microsoft.com/office/drawing/2014/main" id="{2D82997E-62F7-4C49-906C-26FBA6827B6B}"/>
+                <a16:creationId xmlns:a16="http://schemas.microsoft.com/office/drawing/2014/main" id="{AE14F4D9-7BAD-4239-895C-BA011D86FF51}"/>
               </a:ext>
             </a:extLst>
           </p:cNvPr>
@@ -17586,7 +17586,7 @@
           <p:cNvPr id="9" name="이번에는 정당화하지 못한 것">
             <a:extLst xmlns:a="http://schemas.openxmlformats.org/drawingml/2006/main">
               <a:ext uri="{FF2B5EF4-FFF2-40B4-BE49-F238E27FC236}">
-                <a16:creationId xmlns:a16="http://schemas.microsoft.com/office/drawing/2014/main" id="{AF259D31-1361-4B15-8E04-817AAF5B9DEF}"/>
+                <a16:creationId xmlns:a16="http://schemas.microsoft.com/office/drawing/2014/main" id="{46F793A9-6689-4964-BA15-4DDA788B724D}"/>
               </a:ext>
             </a:extLst>
           </p:cNvPr>
@@ -17744,7 +17744,7 @@
           <p:cNvPr id="10" name="">
             <a:extLst xmlns:a="http://schemas.openxmlformats.org/drawingml/2006/main">
               <a:ext uri="{FF2B5EF4-FFF2-40B4-BE49-F238E27FC236}">
-                <a16:creationId xmlns:a16="http://schemas.microsoft.com/office/drawing/2014/main" id="{6BB421C9-6640-4CFB-861C-39F85588E749}"/>
+                <a16:creationId xmlns:a16="http://schemas.microsoft.com/office/drawing/2014/main" id="{1744BEB8-C5DD-45D2-B7D4-F8425DB1DB07}"/>
               </a:ext>
             </a:extLst>
           </p:cNvPr>
@@ -17775,7 +17775,7 @@
           <p:cNvPr id="11" name="">
             <a:extLst xmlns:a="http://schemas.openxmlformats.org/drawingml/2006/main">
               <a:ext uri="{FF2B5EF4-FFF2-40B4-BE49-F238E27FC236}">
-                <a16:creationId xmlns:a16="http://schemas.microsoft.com/office/drawing/2014/main" id="{B1D6617B-A214-45E0-8E10-25B14C9201C9}"/>
+                <a16:creationId xmlns:a16="http://schemas.microsoft.com/office/drawing/2014/main" id="{11C92135-8022-44C6-BDEF-BA037A2DF317}"/>
               </a:ext>
             </a:extLst>
           </p:cNvPr>
@@ -17806,7 +17806,7 @@
           <p:cNvPr id="12" name="Task Prompt&#10;Context와 Routing&#10;재사용 Workflow&#10;Tests와 Benchmark">
             <a:extLst xmlns:a="http://schemas.openxmlformats.org/drawingml/2006/main">
               <a:ext uri="{FF2B5EF4-FFF2-40B4-BE49-F238E27FC236}">
-                <a16:creationId xmlns:a16="http://schemas.microsoft.com/office/drawing/2014/main" id="{879CD844-452A-49AB-97DF-ABC43EC7555C}"/>
+                <a16:creationId xmlns:a16="http://schemas.microsoft.com/office/drawing/2014/main" id="{7D5B8376-72AF-4057-A871-93725E0288D2}"/>
               </a:ext>
             </a:extLst>
           </p:cNvPr>
@@ -18033,7 +18033,7 @@
           <p:cNvPr id="13" name="Subagent&#10;Memory">
             <a:extLst xmlns:a="http://schemas.openxmlformats.org/drawingml/2006/main">
               <a:ext uri="{FF2B5EF4-FFF2-40B4-BE49-F238E27FC236}">
-                <a16:creationId xmlns:a16="http://schemas.microsoft.com/office/drawing/2014/main" id="{951CC118-FBDA-4E82-9CA0-5E628E9C4F52}"/>
+                <a16:creationId xmlns:a16="http://schemas.microsoft.com/office/drawing/2014/main" id="{0C8452C5-79D7-4E05-9078-E3D46D70CA8C}"/>
               </a:ext>
             </a:extLst>
           </p:cNvPr>
@@ -18214,7 +18214,7 @@
           <p:cNvPr id="14" name="현재 문제가 필요로 하는 만큼 설계한다.">
             <a:extLst xmlns:a="http://schemas.openxmlformats.org/drawingml/2006/main">
               <a:ext uri="{FF2B5EF4-FFF2-40B4-BE49-F238E27FC236}">
-                <a16:creationId xmlns:a16="http://schemas.microsoft.com/office/drawing/2014/main" id="{635F10A4-4840-4C71-8E67-011E1C590A4B}"/>
+                <a16:creationId xmlns:a16="http://schemas.microsoft.com/office/drawing/2014/main" id="{33AEF13C-2509-47A8-955D-F03198E23346}"/>
               </a:ext>
             </a:extLst>
           </p:cNvPr>
@@ -18372,7 +18372,7 @@
           <p:cNvPr id="15" name="Legacy module connection">
             <a:extLst xmlns:a="http://schemas.openxmlformats.org/drawingml/2006/main">
               <a:ext uri="{FF2B5EF4-FFF2-40B4-BE49-F238E27FC236}">
-                <a16:creationId xmlns:a16="http://schemas.microsoft.com/office/drawing/2014/main" id="{52CA1FA7-1034-4299-B2A2-9B481E2642EA}"/>
+                <a16:creationId xmlns:a16="http://schemas.microsoft.com/office/drawing/2014/main" id="{914254D6-8FAB-4FF0-8554-D2ED6FCB6D39}"/>
               </a:ext>
             </a:extLst>
           </p:cNvPr>
@@ -18528,7 +18528,7 @@
     </p:spTree>
     <p:extLst>
       <p:ext uri="{BB962C8B-B14F-4D97-AF65-F5344CB8AC3E}">
-        <p14:creationId xmlns:p14="http://schemas.microsoft.com/office/powerpoint/2010/main" val="838719893"/>
+        <p14:creationId xmlns:p14="http://schemas.microsoft.com/office/powerpoint/2010/main" val="1493183691"/>
       </p:ext>
     </p:extLst>
   </p:cSld>
@@ -18559,7 +18559,7 @@
           <p:cNvPr id="23" name="ACT 5 · 개발자의 판단">
             <a:extLst xmlns:a="http://schemas.openxmlformats.org/drawingml/2006/main">
               <a:ext uri="{FF2B5EF4-FFF2-40B4-BE49-F238E27FC236}">
-                <a16:creationId xmlns:a16="http://schemas.microsoft.com/office/drawing/2014/main" id="{9F6E3CE3-28CB-44B9-89DC-CF2ACD569917}"/>
+                <a16:creationId xmlns:a16="http://schemas.microsoft.com/office/drawing/2014/main" id="{15239897-EE4B-43F2-8292-6C8901B0CCAB}"/>
               </a:ext>
             </a:extLst>
           </p:cNvPr>
@@ -18714,10 +18714,10 @@
       </p:sp>
       <p:sp>
         <p:nvSpPr>
-          <p:cNvPr id="2" name="S86">
+          <p:cNvPr id="2" name="S89">
             <a:extLst xmlns:a="http://schemas.openxmlformats.org/drawingml/2006/main">
               <a:ext uri="{FF2B5EF4-FFF2-40B4-BE49-F238E27FC236}">
-                <a16:creationId xmlns:a16="http://schemas.microsoft.com/office/drawing/2014/main" id="{F800472B-B23A-43A6-8B4F-1B668A584A23}"/>
+                <a16:creationId xmlns:a16="http://schemas.microsoft.com/office/drawing/2014/main" id="{D0E70D68-9107-4035-B34C-8CEE97538678}"/>
               </a:ext>
             </a:extLst>
           </p:cNvPr>
@@ -18865,7 +18865,7 @@
                 <a:ea typeface="Malgun Gothic"/>
                 <a:cs typeface="Malgun Gothic"/>
               </a:rPr>
-              <a:t>S86</a:t>
+              <a:t>S89</a:t>
             </a:r>
           </a:p>
         </p:txBody>
@@ -18875,7 +18875,7 @@
           <p:cNvPr id="3" name="위임이 늘어도 개발자 책임은 남는다">
             <a:extLst xmlns:a="http://schemas.openxmlformats.org/drawingml/2006/main">
               <a:ext uri="{FF2B5EF4-FFF2-40B4-BE49-F238E27FC236}">
-                <a16:creationId xmlns:a16="http://schemas.microsoft.com/office/drawing/2014/main" id="{8B99A25C-8560-40E4-8D5C-76E967F06076}"/>
+                <a16:creationId xmlns:a16="http://schemas.microsoft.com/office/drawing/2014/main" id="{08F15CAE-49FB-406E-B4B2-B28330DF1FD4}"/>
               </a:ext>
             </a:extLst>
           </p:cNvPr>
@@ -19033,7 +19033,7 @@
           <p:cNvPr id="4" name="">
             <a:extLst xmlns:a="http://schemas.openxmlformats.org/drawingml/2006/main">
               <a:ext uri="{FF2B5EF4-FFF2-40B4-BE49-F238E27FC236}">
-                <a16:creationId xmlns:a16="http://schemas.microsoft.com/office/drawing/2014/main" id="{419B4881-5C34-40BB-9EF3-FFBB38835D71}"/>
+                <a16:creationId xmlns:a16="http://schemas.microsoft.com/office/drawing/2014/main" id="{B5CA09A5-1730-4937-AA6D-A06D52B5FF1D}"/>
               </a:ext>
             </a:extLst>
           </p:cNvPr>
@@ -19064,7 +19064,7 @@
           <p:cNvPr id="5" name="BEAT-061–062 · 이 교육의 책임 원칙">
             <a:extLst xmlns:a="http://schemas.openxmlformats.org/drawingml/2006/main">
               <a:ext uri="{FF2B5EF4-FFF2-40B4-BE49-F238E27FC236}">
-                <a16:creationId xmlns:a16="http://schemas.microsoft.com/office/drawing/2014/main" id="{BA6F7DB2-DC55-4539-A92C-C0912A66FF0A}"/>
+                <a16:creationId xmlns:a16="http://schemas.microsoft.com/office/drawing/2014/main" id="{3AF614A4-EC84-4E68-8942-C12B7E9C5098}"/>
               </a:ext>
             </a:extLst>
           </p:cNvPr>
@@ -19222,7 +19222,7 @@
           <p:cNvPr id="6" name="Agent와 개발자의 역할을 고정된 분업표로 제시하는 것은 아니다.">
             <a:extLst xmlns:a="http://schemas.openxmlformats.org/drawingml/2006/main">
               <a:ext uri="{FF2B5EF4-FFF2-40B4-BE49-F238E27FC236}">
-                <a16:creationId xmlns:a16="http://schemas.microsoft.com/office/drawing/2014/main" id="{9768693A-34E6-4E34-A52D-C3842250B085}"/>
+                <a16:creationId xmlns:a16="http://schemas.microsoft.com/office/drawing/2014/main" id="{18061C7B-B8F4-487E-978E-8F532C523EA5}"/>
               </a:ext>
             </a:extLst>
           </p:cNvPr>
@@ -19380,7 +19380,7 @@
           <p:cNvPr id="7" name="AI가 조사·생성·변경·실행·비교를 도와도">
             <a:extLst xmlns:a="http://schemas.openxmlformats.org/drawingml/2006/main">
               <a:ext uri="{FF2B5EF4-FFF2-40B4-BE49-F238E27FC236}">
-                <a16:creationId xmlns:a16="http://schemas.microsoft.com/office/drawing/2014/main" id="{88D56A26-8805-4B70-822E-CAC728C8A71A}"/>
+                <a16:creationId xmlns:a16="http://schemas.microsoft.com/office/drawing/2014/main" id="{D79C06A3-0339-4EF6-9853-BF74C008027F}"/>
               </a:ext>
             </a:extLst>
           </p:cNvPr>
@@ -19538,7 +19538,7 @@
           <p:cNvPr id="8" name="결과를 수용하는 판단은 누가 하는가?">
             <a:extLst xmlns:a="http://schemas.openxmlformats.org/drawingml/2006/main">
               <a:ext uri="{FF2B5EF4-FFF2-40B4-BE49-F238E27FC236}">
-                <a16:creationId xmlns:a16="http://schemas.microsoft.com/office/drawing/2014/main" id="{80C5382D-54D2-4BEB-BDB4-A9F46AF2A182}"/>
+                <a16:creationId xmlns:a16="http://schemas.microsoft.com/office/drawing/2014/main" id="{4499E1A0-E3B4-4EF0-A799-5F32DE815B79}"/>
               </a:ext>
             </a:extLst>
           </p:cNvPr>
@@ -19696,7 +19696,7 @@
           <p:cNvPr id="9" name="">
             <a:extLst xmlns:a="http://schemas.openxmlformats.org/drawingml/2006/main">
               <a:ext uri="{FF2B5EF4-FFF2-40B4-BE49-F238E27FC236}">
-                <a16:creationId xmlns:a16="http://schemas.microsoft.com/office/drawing/2014/main" id="{32FC4DA9-5B8E-4BBF-96AF-0B25BDD49110}"/>
+                <a16:creationId xmlns:a16="http://schemas.microsoft.com/office/drawing/2014/main" id="{17DA0115-EA66-4AF5-A268-DF87EC11FC3C}"/>
               </a:ext>
             </a:extLst>
           </p:cNvPr>
@@ -19727,7 +19727,7 @@
           <p:cNvPr id="10" name="목표">
             <a:extLst xmlns:a="http://schemas.openxmlformats.org/drawingml/2006/main">
               <a:ext uri="{FF2B5EF4-FFF2-40B4-BE49-F238E27FC236}">
-                <a16:creationId xmlns:a16="http://schemas.microsoft.com/office/drawing/2014/main" id="{EB21F8F1-251B-4033-8394-8A1764BDC837}"/>
+                <a16:creationId xmlns:a16="http://schemas.microsoft.com/office/drawing/2014/main" id="{F99FE079-DE00-432C-A5D7-35084DF8796F}"/>
               </a:ext>
             </a:extLst>
           </p:cNvPr>
@@ -19885,7 +19885,7 @@
           <p:cNvPr id="11" name="무엇을 해결할까?">
             <a:extLst xmlns:a="http://schemas.openxmlformats.org/drawingml/2006/main">
               <a:ext uri="{FF2B5EF4-FFF2-40B4-BE49-F238E27FC236}">
-                <a16:creationId xmlns:a16="http://schemas.microsoft.com/office/drawing/2014/main" id="{20CD83C9-3B66-4500-8BBD-5F3EEE7EA266}"/>
+                <a16:creationId xmlns:a16="http://schemas.microsoft.com/office/drawing/2014/main" id="{4881B9DA-1AAA-4708-B349-FE0C63F009AB}"/>
               </a:ext>
             </a:extLst>
           </p:cNvPr>
@@ -20043,7 +20043,7 @@
           <p:cNvPr id="12" name="">
             <a:extLst xmlns:a="http://schemas.openxmlformats.org/drawingml/2006/main">
               <a:ext uri="{FF2B5EF4-FFF2-40B4-BE49-F238E27FC236}">
-                <a16:creationId xmlns:a16="http://schemas.microsoft.com/office/drawing/2014/main" id="{F75A40E5-9CB0-47D4-ABEC-A5C02AC18891}"/>
+                <a16:creationId xmlns:a16="http://schemas.microsoft.com/office/drawing/2014/main" id="{6245A888-3C2B-4BB4-9600-462439F9A15E}"/>
               </a:ext>
             </a:extLst>
           </p:cNvPr>
@@ -20074,7 +20074,7 @@
           <p:cNvPr id="13" name="판단">
             <a:extLst xmlns:a="http://schemas.openxmlformats.org/drawingml/2006/main">
               <a:ext uri="{FF2B5EF4-FFF2-40B4-BE49-F238E27FC236}">
-                <a16:creationId xmlns:a16="http://schemas.microsoft.com/office/drawing/2014/main" id="{EE6431D6-A5CC-40C6-BADD-C3D594569410}"/>
+                <a16:creationId xmlns:a16="http://schemas.microsoft.com/office/drawing/2014/main" id="{1A7B7614-EA3C-41E0-9D14-2C12F78D9550}"/>
               </a:ext>
             </a:extLst>
           </p:cNvPr>
@@ -20232,7 +20232,7 @@
           <p:cNvPr id="14" name="어떤 선택이&#10;적절할까?">
             <a:extLst xmlns:a="http://schemas.openxmlformats.org/drawingml/2006/main">
               <a:ext uri="{FF2B5EF4-FFF2-40B4-BE49-F238E27FC236}">
-                <a16:creationId xmlns:a16="http://schemas.microsoft.com/office/drawing/2014/main" id="{45084A3E-8927-4527-ADF7-77608F8C0584}"/>
+                <a16:creationId xmlns:a16="http://schemas.microsoft.com/office/drawing/2014/main" id="{F5C73327-4454-468A-A711-E4C7870BBC66}"/>
               </a:ext>
             </a:extLst>
           </p:cNvPr>
@@ -20413,7 +20413,7 @@
           <p:cNvPr id="15" name="">
             <a:extLst xmlns:a="http://schemas.openxmlformats.org/drawingml/2006/main">
               <a:ext uri="{FF2B5EF4-FFF2-40B4-BE49-F238E27FC236}">
-                <a16:creationId xmlns:a16="http://schemas.microsoft.com/office/drawing/2014/main" id="{924503EE-9ED6-413F-9340-9953CEA1D9FB}"/>
+                <a16:creationId xmlns:a16="http://schemas.microsoft.com/office/drawing/2014/main" id="{08B28567-B41F-407E-9896-8DFC7D7530C4}"/>
               </a:ext>
             </a:extLst>
           </p:cNvPr>
@@ -20444,7 +20444,7 @@
           <p:cNvPr id="16" name="검증">
             <a:extLst xmlns:a="http://schemas.openxmlformats.org/drawingml/2006/main">
               <a:ext uri="{FF2B5EF4-FFF2-40B4-BE49-F238E27FC236}">
-                <a16:creationId xmlns:a16="http://schemas.microsoft.com/office/drawing/2014/main" id="{B59E2AF2-F877-464B-9942-BA8F7C57390F}"/>
+                <a16:creationId xmlns:a16="http://schemas.microsoft.com/office/drawing/2014/main" id="{BF363384-A52F-4782-BD68-C122394124F7}"/>
               </a:ext>
             </a:extLst>
           </p:cNvPr>
@@ -20602,7 +20602,7 @@
           <p:cNvPr id="17" name="무엇으로&#10;확인할까?">
             <a:extLst xmlns:a="http://schemas.openxmlformats.org/drawingml/2006/main">
               <a:ext uri="{FF2B5EF4-FFF2-40B4-BE49-F238E27FC236}">
-                <a16:creationId xmlns:a16="http://schemas.microsoft.com/office/drawing/2014/main" id="{AEFFB6A3-B412-414C-A8F8-553BC3CB4472}"/>
+                <a16:creationId xmlns:a16="http://schemas.microsoft.com/office/drawing/2014/main" id="{89730A14-3D06-45FB-BBBA-CE70ED4C741E}"/>
               </a:ext>
             </a:extLst>
           </p:cNvPr>
@@ -20783,7 +20783,7 @@
           <p:cNvPr id="18" name="">
             <a:extLst xmlns:a="http://schemas.openxmlformats.org/drawingml/2006/main">
               <a:ext uri="{FF2B5EF4-FFF2-40B4-BE49-F238E27FC236}">
-                <a16:creationId xmlns:a16="http://schemas.microsoft.com/office/drawing/2014/main" id="{B5439A01-809B-44CE-A9F9-A7B4A1BCB072}"/>
+                <a16:creationId xmlns:a16="http://schemas.microsoft.com/office/drawing/2014/main" id="{BC4195B1-A1D1-4336-887D-7FCAB8C7AE9F}"/>
               </a:ext>
             </a:extLst>
           </p:cNvPr>
@@ -20814,7 +20814,7 @@
           <p:cNvPr id="19" name="책임">
             <a:extLst xmlns:a="http://schemas.openxmlformats.org/drawingml/2006/main">
               <a:ext uri="{FF2B5EF4-FFF2-40B4-BE49-F238E27FC236}">
-                <a16:creationId xmlns:a16="http://schemas.microsoft.com/office/drawing/2014/main" id="{0EEB8913-80AD-44DC-9934-97DDA682EA25}"/>
+                <a16:creationId xmlns:a16="http://schemas.microsoft.com/office/drawing/2014/main" id="{8CB930C4-D2B1-4F2F-9845-5F552ECE1E9E}"/>
               </a:ext>
             </a:extLst>
           </p:cNvPr>
@@ -20972,7 +20972,7 @@
           <p:cNvPr id="20" name="완료를&#10;수용해도 될까?">
             <a:extLst xmlns:a="http://schemas.openxmlformats.org/drawingml/2006/main">
               <a:ext uri="{FF2B5EF4-FFF2-40B4-BE49-F238E27FC236}">
-                <a16:creationId xmlns:a16="http://schemas.microsoft.com/office/drawing/2014/main" id="{BD32FABA-7088-4EBC-9804-99DDAA0FCF64}"/>
+                <a16:creationId xmlns:a16="http://schemas.microsoft.com/office/drawing/2014/main" id="{E38AD9C2-70A7-48F1-B1FD-3B7E1CF46564}"/>
               </a:ext>
             </a:extLst>
           </p:cNvPr>
@@ -21153,7 +21153,7 @@
           <p:cNvPr id="21" name="결과를 받는 일에는, 결과를 판단하는 책임이 함께 남는다.">
             <a:extLst xmlns:a="http://schemas.openxmlformats.org/drawingml/2006/main">
               <a:ext uri="{FF2B5EF4-FFF2-40B4-BE49-F238E27FC236}">
-                <a16:creationId xmlns:a16="http://schemas.microsoft.com/office/drawing/2014/main" id="{B2D9C7F3-4084-44A9-B372-202485D95A1A}"/>
+                <a16:creationId xmlns:a16="http://schemas.microsoft.com/office/drawing/2014/main" id="{D9F98855-5B77-40E6-9B17-D276D9D78BDB}"/>
               </a:ext>
             </a:extLst>
           </p:cNvPr>
@@ -21311,7 +21311,7 @@
           <p:cNvPr id="22" name="Legacy module connection">
             <a:extLst xmlns:a="http://schemas.openxmlformats.org/drawingml/2006/main">
               <a:ext uri="{FF2B5EF4-FFF2-40B4-BE49-F238E27FC236}">
-                <a16:creationId xmlns:a16="http://schemas.microsoft.com/office/drawing/2014/main" id="{0DAF445A-35B8-4EF5-ACC6-40E613167BA9}"/>
+                <a16:creationId xmlns:a16="http://schemas.microsoft.com/office/drawing/2014/main" id="{CFEF2967-97EF-4CCF-945B-0B36F4862402}"/>
               </a:ext>
             </a:extLst>
           </p:cNvPr>
@@ -21467,7 +21467,7 @@
     </p:spTree>
     <p:extLst>
       <p:ext uri="{BB962C8B-B14F-4D97-AF65-F5344CB8AC3E}">
-        <p14:creationId xmlns:p14="http://schemas.microsoft.com/office/powerpoint/2010/main" val="1454043329"/>
+        <p14:creationId xmlns:p14="http://schemas.microsoft.com/office/powerpoint/2010/main" val="862316461"/>
       </p:ext>
     </p:extLst>
   </p:cSld>
@@ -21498,7 +21498,7 @@
           <p:cNvPr id="18" name="ACT 5 · 일하는 환경을 설계한다">
             <a:extLst xmlns:a="http://schemas.openxmlformats.org/drawingml/2006/main">
               <a:ext uri="{FF2B5EF4-FFF2-40B4-BE49-F238E27FC236}">
-                <a16:creationId xmlns:a16="http://schemas.microsoft.com/office/drawing/2014/main" id="{9B211AA1-939D-45E8-B135-6B583E97531B}"/>
+                <a16:creationId xmlns:a16="http://schemas.microsoft.com/office/drawing/2014/main" id="{8DD33AC8-4E10-4C6A-9829-3965278B35CA}"/>
               </a:ext>
             </a:extLst>
           </p:cNvPr>
@@ -21653,10 +21653,10 @@
       </p:sp>
       <p:sp>
         <p:nvSpPr>
-          <p:cNvPr id="2" name="S87">
+          <p:cNvPr id="2" name="S90">
             <a:extLst xmlns:a="http://schemas.openxmlformats.org/drawingml/2006/main">
               <a:ext uri="{FF2B5EF4-FFF2-40B4-BE49-F238E27FC236}">
-                <a16:creationId xmlns:a16="http://schemas.microsoft.com/office/drawing/2014/main" id="{A5B1D69A-67ED-45DC-A8F7-1A6ACB75E080}"/>
+                <a16:creationId xmlns:a16="http://schemas.microsoft.com/office/drawing/2014/main" id="{614FF142-1AFD-4C7C-92B7-38663F4A9E9D}"/>
               </a:ext>
             </a:extLst>
           </p:cNvPr>
@@ -21804,7 +21804,7 @@
                 <a:ea typeface="Malgun Gothic"/>
                 <a:cs typeface="Malgun Gothic"/>
               </a:rPr>
-              <a:t>S87</a:t>
+              <a:t>S90</a:t>
             </a:r>
           </a:p>
         </p:txBody>
@@ -21814,7 +21814,7 @@
           <p:cNvPr id="3" name="AI-Native Development는&#10;이 교육의 운영 모델">
             <a:extLst xmlns:a="http://schemas.openxmlformats.org/drawingml/2006/main">
               <a:ext uri="{FF2B5EF4-FFF2-40B4-BE49-F238E27FC236}">
-                <a16:creationId xmlns:a16="http://schemas.microsoft.com/office/drawing/2014/main" id="{62F11DBB-F1AF-48D4-9915-A5DA95DBCD55}"/>
+                <a16:creationId xmlns:a16="http://schemas.microsoft.com/office/drawing/2014/main" id="{3CF45006-4A9C-46EC-A5F6-6C26DBB25C22}"/>
               </a:ext>
             </a:extLst>
           </p:cNvPr>
@@ -21995,7 +21995,7 @@
           <p:cNvPr id="4" name="">
             <a:extLst xmlns:a="http://schemas.openxmlformats.org/drawingml/2006/main">
               <a:ext uri="{FF2B5EF4-FFF2-40B4-BE49-F238E27FC236}">
-                <a16:creationId xmlns:a16="http://schemas.microsoft.com/office/drawing/2014/main" id="{444C732E-BC4F-4685-ADEB-0E16DB4B2A58}"/>
+                <a16:creationId xmlns:a16="http://schemas.microsoft.com/office/drawing/2014/main" id="{1CBB96B5-F61D-4693-96EE-1205A2E5D44D}"/>
               </a:ext>
             </a:extLst>
           </p:cNvPr>
@@ -22026,7 +22026,7 @@
           <p:cNvPr id="5" name="DEC-0023 · 과정에서 사용하는 운영 모델">
             <a:extLst xmlns:a="http://schemas.openxmlformats.org/drawingml/2006/main">
               <a:ext uri="{FF2B5EF4-FFF2-40B4-BE49-F238E27FC236}">
-                <a16:creationId xmlns:a16="http://schemas.microsoft.com/office/drawing/2014/main" id="{858CFD7C-168B-47ED-9D5F-D69C1CC9FDA6}"/>
+                <a16:creationId xmlns:a16="http://schemas.microsoft.com/office/drawing/2014/main" id="{5EAD5662-7191-42A9-AAD5-D079A4C890FE}"/>
               </a:ext>
             </a:extLst>
           </p:cNvPr>
@@ -22184,7 +22184,7 @@
           <p:cNvPr id="6" name="공식·보편 정의가 아니며, 모든 Task에 모든 구성요소를 넣으라는 뜻은 아니다.">
             <a:extLst xmlns:a="http://schemas.openxmlformats.org/drawingml/2006/main">
               <a:ext uri="{FF2B5EF4-FFF2-40B4-BE49-F238E27FC236}">
-                <a16:creationId xmlns:a16="http://schemas.microsoft.com/office/drawing/2014/main" id="{9B2DBA03-2740-4CEB-B269-62323109B849}"/>
+                <a16:creationId xmlns:a16="http://schemas.microsoft.com/office/drawing/2014/main" id="{4876B4B6-7E2D-4C83-9B77-9ACF6BB3D921}"/>
               </a:ext>
             </a:extLst>
           </p:cNvPr>
@@ -22342,7 +22342,7 @@
           <p:cNvPr id="7" name="AI가 일할 조건과, 결과를 확인할 경로를 설계한다.">
             <a:extLst xmlns:a="http://schemas.openxmlformats.org/drawingml/2006/main">
               <a:ext uri="{FF2B5EF4-FFF2-40B4-BE49-F238E27FC236}">
-                <a16:creationId xmlns:a16="http://schemas.microsoft.com/office/drawing/2014/main" id="{E25C1812-68E1-4B40-9CF6-AF80306B455A}"/>
+                <a16:creationId xmlns:a16="http://schemas.microsoft.com/office/drawing/2014/main" id="{A1826F8E-F402-4290-A56C-48A2CF0B645E}"/>
               </a:ext>
             </a:extLst>
           </p:cNvPr>
@@ -22500,7 +22500,7 @@
           <p:cNvPr id="8" name="">
             <a:extLst xmlns:a="http://schemas.openxmlformats.org/drawingml/2006/main">
               <a:ext uri="{FF2B5EF4-FFF2-40B4-BE49-F238E27FC236}">
-                <a16:creationId xmlns:a16="http://schemas.microsoft.com/office/drawing/2014/main" id="{95C27722-BD8B-4B8C-B4BC-50B2C2B7090F}"/>
+                <a16:creationId xmlns:a16="http://schemas.microsoft.com/office/drawing/2014/main" id="{1FA35914-67C2-4F41-A01A-FE48BAC3AF60}"/>
               </a:ext>
             </a:extLst>
           </p:cNvPr>
@@ -22531,7 +22531,7 @@
           <p:cNvPr id="9" name="작업 경계">
             <a:extLst xmlns:a="http://schemas.openxmlformats.org/drawingml/2006/main">
               <a:ext uri="{FF2B5EF4-FFF2-40B4-BE49-F238E27FC236}">
-                <a16:creationId xmlns:a16="http://schemas.microsoft.com/office/drawing/2014/main" id="{C30E4274-980A-43AF-8F60-2D58495B57DB}"/>
+                <a16:creationId xmlns:a16="http://schemas.microsoft.com/office/drawing/2014/main" id="{5DD0AE30-84D6-433A-BE62-9B18C303A03E}"/>
               </a:ext>
             </a:extLst>
           </p:cNvPr>
@@ -22689,7 +22689,7 @@
           <p:cNvPr id="10" name="무엇을 맡기고&#10;어디까지 바꿀까?">
             <a:extLst xmlns:a="http://schemas.openxmlformats.org/drawingml/2006/main">
               <a:ext uri="{FF2B5EF4-FFF2-40B4-BE49-F238E27FC236}">
-                <a16:creationId xmlns:a16="http://schemas.microsoft.com/office/drawing/2014/main" id="{6BABE98A-576B-4BD2-B0EB-4BF66FE89580}"/>
+                <a16:creationId xmlns:a16="http://schemas.microsoft.com/office/drawing/2014/main" id="{F3EF2BD9-9A6B-4582-85EB-3E9B8EBEC059}"/>
               </a:ext>
             </a:extLst>
           </p:cNvPr>
@@ -22870,7 +22870,7 @@
           <p:cNvPr id="11" name="">
             <a:extLst xmlns:a="http://schemas.openxmlformats.org/drawingml/2006/main">
               <a:ext uri="{FF2B5EF4-FFF2-40B4-BE49-F238E27FC236}">
-                <a16:creationId xmlns:a16="http://schemas.microsoft.com/office/drawing/2014/main" id="{0773233E-C6C8-47DC-874C-E06AC93421D5}"/>
+                <a16:creationId xmlns:a16="http://schemas.microsoft.com/office/drawing/2014/main" id="{C4C37669-F2DC-4CC0-8A06-414E48420281}"/>
               </a:ext>
             </a:extLst>
           </p:cNvPr>
@@ -22901,7 +22901,7 @@
           <p:cNvPr id="12" name="지식 · 절차">
             <a:extLst xmlns:a="http://schemas.openxmlformats.org/drawingml/2006/main">
               <a:ext uri="{FF2B5EF4-FFF2-40B4-BE49-F238E27FC236}">
-                <a16:creationId xmlns:a16="http://schemas.microsoft.com/office/drawing/2014/main" id="{BB12F4A7-3412-4730-B383-8BDB4770257B}"/>
+                <a16:creationId xmlns:a16="http://schemas.microsoft.com/office/drawing/2014/main" id="{C59E929B-813B-48C2-A25F-F25E41802C13}"/>
               </a:ext>
             </a:extLst>
           </p:cNvPr>
@@ -23059,7 +23059,7 @@
           <p:cNvPr id="13" name="무엇을 알고&#10;어떤 방식으로 일할까?">
             <a:extLst xmlns:a="http://schemas.openxmlformats.org/drawingml/2006/main">
               <a:ext uri="{FF2B5EF4-FFF2-40B4-BE49-F238E27FC236}">
-                <a16:creationId xmlns:a16="http://schemas.microsoft.com/office/drawing/2014/main" id="{640E55CB-DD83-49A8-9055-6C1FBB31A7A9}"/>
+                <a16:creationId xmlns:a16="http://schemas.microsoft.com/office/drawing/2014/main" id="{89D6B22D-8431-4982-A1D1-47BF774815F4}"/>
               </a:ext>
             </a:extLst>
           </p:cNvPr>
@@ -23240,7 +23240,7 @@
           <p:cNvPr id="14" name="">
             <a:extLst xmlns:a="http://schemas.openxmlformats.org/drawingml/2006/main">
               <a:ext uri="{FF2B5EF4-FFF2-40B4-BE49-F238E27FC236}">
-                <a16:creationId xmlns:a16="http://schemas.microsoft.com/office/drawing/2014/main" id="{007C8C11-0203-403B-B5C2-2B37F129687F}"/>
+                <a16:creationId xmlns:a16="http://schemas.microsoft.com/office/drawing/2014/main" id="{9A43F3E9-C0C7-4BBE-BBE5-683CDB9F4E3C}"/>
               </a:ext>
             </a:extLst>
           </p:cNvPr>
@@ -23271,7 +23271,7 @@
           <p:cNvPr id="15" name="검증 · 피드백">
             <a:extLst xmlns:a="http://schemas.openxmlformats.org/drawingml/2006/main">
               <a:ext uri="{FF2B5EF4-FFF2-40B4-BE49-F238E27FC236}">
-                <a16:creationId xmlns:a16="http://schemas.microsoft.com/office/drawing/2014/main" id="{47C3CF85-297E-4E95-8E7E-189DBCF8C8D5}"/>
+                <a16:creationId xmlns:a16="http://schemas.microsoft.com/office/drawing/2014/main" id="{B5665A4E-EBB1-4900-B883-35922CBD68EF}"/>
               </a:ext>
             </a:extLst>
           </p:cNvPr>
@@ -23429,7 +23429,7 @@
           <p:cNvPr id="16" name="어떻게 확인하고&#10;다음 작업을 바꿀까?">
             <a:extLst xmlns:a="http://schemas.openxmlformats.org/drawingml/2006/main">
               <a:ext uri="{FF2B5EF4-FFF2-40B4-BE49-F238E27FC236}">
-                <a16:creationId xmlns:a16="http://schemas.microsoft.com/office/drawing/2014/main" id="{4A6CB78F-9E31-4B91-8E8D-FB4632F654C8}"/>
+                <a16:creationId xmlns:a16="http://schemas.microsoft.com/office/drawing/2014/main" id="{14ACCB61-0F2A-402B-A513-BA3C98FAC38B}"/>
               </a:ext>
             </a:extLst>
           </p:cNvPr>
@@ -23610,7 +23610,7 @@
           <p:cNvPr id="17" name="Legacy module connection">
             <a:extLst xmlns:a="http://schemas.openxmlformats.org/drawingml/2006/main">
               <a:ext uri="{FF2B5EF4-FFF2-40B4-BE49-F238E27FC236}">
-                <a16:creationId xmlns:a16="http://schemas.microsoft.com/office/drawing/2014/main" id="{DCA44E10-B09A-46B3-BF33-5C8CCC048A86}"/>
+                <a16:creationId xmlns:a16="http://schemas.microsoft.com/office/drawing/2014/main" id="{FD416285-6071-4197-BFA2-20536E6720DF}"/>
               </a:ext>
             </a:extLst>
           </p:cNvPr>
@@ -23766,7 +23766,7 @@
     </p:spTree>
     <p:extLst>
       <p:ext uri="{BB962C8B-B14F-4D97-AF65-F5344CB8AC3E}">
-        <p14:creationId xmlns:p14="http://schemas.microsoft.com/office/powerpoint/2010/main" val="1038767028"/>
+        <p14:creationId xmlns:p14="http://schemas.microsoft.com/office/powerpoint/2010/main" val="1489452644"/>
       </p:ext>
     </p:extLst>
   </p:cSld>
@@ -23797,7 +23797,7 @@
           <p:cNvPr id="34" name="ACT 5 · C++ VISION / 내 업무로 연결">
             <a:extLst xmlns:a="http://schemas.openxmlformats.org/drawingml/2006/main">
               <a:ext uri="{FF2B5EF4-FFF2-40B4-BE49-F238E27FC236}">
-                <a16:creationId xmlns:a16="http://schemas.microsoft.com/office/drawing/2014/main" id="{E9353AC0-BD34-458A-9425-497DE7A80A26}"/>
+                <a16:creationId xmlns:a16="http://schemas.microsoft.com/office/drawing/2014/main" id="{5EF0F9FB-90C5-4A4E-B953-791669054CF3}"/>
               </a:ext>
             </a:extLst>
           </p:cNvPr>
@@ -23952,10 +23952,10 @@
       </p:sp>
       <p:sp>
         <p:nvSpPr>
-          <p:cNvPr id="2" name="S88">
+          <p:cNvPr id="2" name="S91">
             <a:extLst xmlns:a="http://schemas.openxmlformats.org/drawingml/2006/main">
               <a:ext uri="{FF2B5EF4-FFF2-40B4-BE49-F238E27FC236}">
-                <a16:creationId xmlns:a16="http://schemas.microsoft.com/office/drawing/2014/main" id="{F9F59FAC-0E06-4D35-BAA4-AB5519CE65BF}"/>
+                <a16:creationId xmlns:a16="http://schemas.microsoft.com/office/drawing/2014/main" id="{809667EF-AB48-413F-8A48-BE6CD22E5456}"/>
               </a:ext>
             </a:extLst>
           </p:cNvPr>
@@ -24103,7 +24103,7 @@
                 <a:ea typeface="Malgun Gothic"/>
                 <a:cs typeface="Malgun Gothic"/>
               </a:rPr>
-              <a:t>S88</a:t>
+              <a:t>S91</a:t>
             </a:r>
           </a:p>
         </p:txBody>
@@ -24113,7 +24113,7 @@
           <p:cNvPr id="3" name="어느 Layer에서 마찰이 반복되는가?">
             <a:extLst xmlns:a="http://schemas.openxmlformats.org/drawingml/2006/main">
               <a:ext uri="{FF2B5EF4-FFF2-40B4-BE49-F238E27FC236}">
-                <a16:creationId xmlns:a16="http://schemas.microsoft.com/office/drawing/2014/main" id="{3A49B3C0-E9B3-43C7-8F95-E8682FB9F73A}"/>
+                <a16:creationId xmlns:a16="http://schemas.microsoft.com/office/drawing/2014/main" id="{1729334A-1DB9-47FD-B61F-D3C1DC01B0DA}"/>
               </a:ext>
             </a:extLst>
           </p:cNvPr>
@@ -24271,7 +24271,7 @@
           <p:cNvPr id="4" name="">
             <a:extLst xmlns:a="http://schemas.openxmlformats.org/drawingml/2006/main">
               <a:ext uri="{FF2B5EF4-FFF2-40B4-BE49-F238E27FC236}">
-                <a16:creationId xmlns:a16="http://schemas.microsoft.com/office/drawing/2014/main" id="{68382B3A-760E-49D8-BCC9-14FB99B1A4B7}"/>
+                <a16:creationId xmlns:a16="http://schemas.microsoft.com/office/drawing/2014/main" id="{5BD7340D-EDE3-4725-8479-2592CCBB1878}"/>
               </a:ext>
             </a:extLst>
           </p:cNvPr>
@@ -24302,7 +24302,7 @@
           <p:cNvPr id="5" name="BEAT-068–069 · 업무 적용을 위한 교육용 질문">
             <a:extLst xmlns:a="http://schemas.openxmlformats.org/drawingml/2006/main">
               <a:ext uri="{FF2B5EF4-FFF2-40B4-BE49-F238E27FC236}">
-                <a16:creationId xmlns:a16="http://schemas.microsoft.com/office/drawing/2014/main" id="{BF8FEA0E-1312-433C-84F7-806238BC20E0}"/>
+                <a16:creationId xmlns:a16="http://schemas.microsoft.com/office/drawing/2014/main" id="{AB8C812D-7355-49A8-81F2-D609C8EBCC6F}"/>
               </a:ext>
             </a:extLst>
           </p:cNvPr>
@@ -24460,7 +24460,7 @@
           <p:cNvPr id="6" name="같은 수준의 선택지다. 특정 C++ 프로젝트에서 검증된 절차나 필수 도입 순서가 아니다.">
             <a:extLst xmlns:a="http://schemas.openxmlformats.org/drawingml/2006/main">
               <a:ext uri="{FF2B5EF4-FFF2-40B4-BE49-F238E27FC236}">
-                <a16:creationId xmlns:a16="http://schemas.microsoft.com/office/drawing/2014/main" id="{4F6E7E16-7594-486D-9A30-03F01FFE4AB7}"/>
+                <a16:creationId xmlns:a16="http://schemas.microsoft.com/office/drawing/2014/main" id="{FB1C5736-6C5A-4951-99D4-C940EFA7502E}"/>
               </a:ext>
             </a:extLst>
           </p:cNvPr>
@@ -24618,7 +24618,7 @@
           <p:cNvPr id="7" name="지금 내 업무와 가장 가까운 한 곳을 떠올려 본다.">
             <a:extLst xmlns:a="http://schemas.openxmlformats.org/drawingml/2006/main">
               <a:ext uri="{FF2B5EF4-FFF2-40B4-BE49-F238E27FC236}">
-                <a16:creationId xmlns:a16="http://schemas.microsoft.com/office/drawing/2014/main" id="{61220B4E-5357-4348-AB70-E191AECF9026}"/>
+                <a16:creationId xmlns:a16="http://schemas.microsoft.com/office/drawing/2014/main" id="{D4BDD153-6D1B-4A06-9D50-A8D13B742230}"/>
               </a:ext>
             </a:extLst>
           </p:cNvPr>
@@ -24776,7 +24776,7 @@
           <p:cNvPr id="8" name="">
             <a:extLst xmlns:a="http://schemas.openxmlformats.org/drawingml/2006/main">
               <a:ext uri="{FF2B5EF4-FFF2-40B4-BE49-F238E27FC236}">
-                <a16:creationId xmlns:a16="http://schemas.microsoft.com/office/drawing/2014/main" id="{9A0A7902-8D22-48B8-8B9C-F7F6E760819C}"/>
+                <a16:creationId xmlns:a16="http://schemas.microsoft.com/office/drawing/2014/main" id="{3EFC4FA6-A57A-413F-A338-47F6FA14402B}"/>
               </a:ext>
             </a:extLst>
           </p:cNvPr>
@@ -24807,7 +24807,7 @@
           <p:cNvPr id="9" name="">
             <a:extLst xmlns:a="http://schemas.openxmlformats.org/drawingml/2006/main">
               <a:ext uri="{FF2B5EF4-FFF2-40B4-BE49-F238E27FC236}">
-                <a16:creationId xmlns:a16="http://schemas.microsoft.com/office/drawing/2014/main" id="{50FAD7BF-A94D-4CCE-AC21-E13B7479BEA8}"/>
+                <a16:creationId xmlns:a16="http://schemas.microsoft.com/office/drawing/2014/main" id="{6883C940-D61E-40E7-85C9-75ADF454ABC9}"/>
               </a:ext>
             </a:extLst>
           </p:cNvPr>
@@ -24838,7 +24838,7 @@
           <p:cNvPr id="10" name="A">
             <a:extLst xmlns:a="http://schemas.openxmlformats.org/drawingml/2006/main">
               <a:ext uri="{FF2B5EF4-FFF2-40B4-BE49-F238E27FC236}">
-                <a16:creationId xmlns:a16="http://schemas.microsoft.com/office/drawing/2014/main" id="{BD2EEEF7-68DC-44B8-9EFA-D5245EA736FC}"/>
+                <a16:creationId xmlns:a16="http://schemas.microsoft.com/office/drawing/2014/main" id="{644A040F-DFA4-4016-818E-30FEB99F580A}"/>
               </a:ext>
             </a:extLst>
           </p:cNvPr>
@@ -24996,7 +24996,7 @@
           <p:cNvPr id="11" name="Task">
             <a:extLst xmlns:a="http://schemas.openxmlformats.org/drawingml/2006/main">
               <a:ext uri="{FF2B5EF4-FFF2-40B4-BE49-F238E27FC236}">
-                <a16:creationId xmlns:a16="http://schemas.microsoft.com/office/drawing/2014/main" id="{709E2A64-C0DA-4738-8504-D4340CFF480D}"/>
+                <a16:creationId xmlns:a16="http://schemas.microsoft.com/office/drawing/2014/main" id="{7329B4CE-308A-4BF3-B275-EF6C6074634E}"/>
               </a:ext>
             </a:extLst>
           </p:cNvPr>
@@ -25154,7 +25154,7 @@
           <p:cNvPr id="12" name="조사할 성능 병목의 범위가 흐리다">
             <a:extLst xmlns:a="http://schemas.openxmlformats.org/drawingml/2006/main">
               <a:ext uri="{FF2B5EF4-FFF2-40B4-BE49-F238E27FC236}">
-                <a16:creationId xmlns:a16="http://schemas.microsoft.com/office/drawing/2014/main" id="{F03765E1-553E-4624-A4C5-B9795B9DA4EA}"/>
+                <a16:creationId xmlns:a16="http://schemas.microsoft.com/office/drawing/2014/main" id="{0F50EC28-9251-4394-B256-651737463F61}"/>
               </a:ext>
             </a:extLst>
           </p:cNvPr>
@@ -25312,7 +25312,7 @@
           <p:cNvPr id="13" name="">
             <a:extLst xmlns:a="http://schemas.openxmlformats.org/drawingml/2006/main">
               <a:ext uri="{FF2B5EF4-FFF2-40B4-BE49-F238E27FC236}">
-                <a16:creationId xmlns:a16="http://schemas.microsoft.com/office/drawing/2014/main" id="{51059EA7-6870-42BB-B63A-1746E8E1C6F3}"/>
+                <a16:creationId xmlns:a16="http://schemas.microsoft.com/office/drawing/2014/main" id="{1B85C141-9AFA-4118-B272-B19554CBC7D9}"/>
               </a:ext>
             </a:extLst>
           </p:cNvPr>
@@ -25343,7 +25343,7 @@
           <p:cNvPr id="14" name="">
             <a:extLst xmlns:a="http://schemas.openxmlformats.org/drawingml/2006/main">
               <a:ext uri="{FF2B5EF4-FFF2-40B4-BE49-F238E27FC236}">
-                <a16:creationId xmlns:a16="http://schemas.microsoft.com/office/drawing/2014/main" id="{CBBEB0A9-807A-4DA1-8066-C683E4A4FA6F}"/>
+                <a16:creationId xmlns:a16="http://schemas.microsoft.com/office/drawing/2014/main" id="{1A487A02-4D05-4F62-981C-63891DE8CD75}"/>
               </a:ext>
             </a:extLst>
           </p:cNvPr>
@@ -25374,7 +25374,7 @@
           <p:cNvPr id="15" name="B">
             <a:extLst xmlns:a="http://schemas.openxmlformats.org/drawingml/2006/main">
               <a:ext uri="{FF2B5EF4-FFF2-40B4-BE49-F238E27FC236}">
-                <a16:creationId xmlns:a16="http://schemas.microsoft.com/office/drawing/2014/main" id="{F7C6481B-00EA-4C76-AE47-0A3F12CB0E7A}"/>
+                <a16:creationId xmlns:a16="http://schemas.microsoft.com/office/drawing/2014/main" id="{7DF8FF53-C295-478F-8865-1DC9EF0954A2}"/>
               </a:ext>
             </a:extLst>
           </p:cNvPr>
@@ -25532,7 +25532,7 @@
           <p:cNvPr id="16" name="Context">
             <a:extLst xmlns:a="http://schemas.openxmlformats.org/drawingml/2006/main">
               <a:ext uri="{FF2B5EF4-FFF2-40B4-BE49-F238E27FC236}">
-                <a16:creationId xmlns:a16="http://schemas.microsoft.com/office/drawing/2014/main" id="{66797C3A-702D-4733-98AA-4F6CA805D1F9}"/>
+                <a16:creationId xmlns:a16="http://schemas.microsoft.com/office/drawing/2014/main" id="{5F5C8969-4F0B-4815-B291-911B1FA1924C}"/>
               </a:ext>
             </a:extLst>
           </p:cNvPr>
@@ -25690,7 +25690,7 @@
           <p:cNvPr id="17" name="빌드 조건·계약·하드웨어 가정을 반복 설명한다">
             <a:extLst xmlns:a="http://schemas.openxmlformats.org/drawingml/2006/main">
               <a:ext uri="{FF2B5EF4-FFF2-40B4-BE49-F238E27FC236}">
-                <a16:creationId xmlns:a16="http://schemas.microsoft.com/office/drawing/2014/main" id="{AD5ED72A-310D-42CC-8BDA-1C912AC8CCAA}"/>
+                <a16:creationId xmlns:a16="http://schemas.microsoft.com/office/drawing/2014/main" id="{9856A6B2-6D86-4BB9-AF77-912E437B729D}"/>
               </a:ext>
             </a:extLst>
           </p:cNvPr>
@@ -25848,7 +25848,7 @@
           <p:cNvPr id="18" name="">
             <a:extLst xmlns:a="http://schemas.openxmlformats.org/drawingml/2006/main">
               <a:ext uri="{FF2B5EF4-FFF2-40B4-BE49-F238E27FC236}">
-                <a16:creationId xmlns:a16="http://schemas.microsoft.com/office/drawing/2014/main" id="{6706648F-6492-4AF7-827C-D2949D73EA53}"/>
+                <a16:creationId xmlns:a16="http://schemas.microsoft.com/office/drawing/2014/main" id="{7B407054-CD18-4CBC-95F8-9FEB4DA28730}"/>
               </a:ext>
             </a:extLst>
           </p:cNvPr>
@@ -25879,7 +25879,7 @@
           <p:cNvPr id="19" name="">
             <a:extLst xmlns:a="http://schemas.openxmlformats.org/drawingml/2006/main">
               <a:ext uri="{FF2B5EF4-FFF2-40B4-BE49-F238E27FC236}">
-                <a16:creationId xmlns:a16="http://schemas.microsoft.com/office/drawing/2014/main" id="{39831497-1645-43D3-A282-050DE78BE267}"/>
+                <a16:creationId xmlns:a16="http://schemas.microsoft.com/office/drawing/2014/main" id="{A6B4BB02-4BA2-4B9C-8BE1-6B1504C10A9E}"/>
               </a:ext>
             </a:extLst>
           </p:cNvPr>
@@ -25910,7 +25910,7 @@
           <p:cNvPr id="20" name="C">
             <a:extLst xmlns:a="http://schemas.openxmlformats.org/drawingml/2006/main">
               <a:ext uri="{FF2B5EF4-FFF2-40B4-BE49-F238E27FC236}">
-                <a16:creationId xmlns:a16="http://schemas.microsoft.com/office/drawing/2014/main" id="{38836124-B8F0-4103-B55F-8B0A2E57C3D5}"/>
+                <a16:creationId xmlns:a16="http://schemas.microsoft.com/office/drawing/2014/main" id="{DE6575E0-FCD6-470B-BB8C-4B7B125AE646}"/>
               </a:ext>
             </a:extLst>
           </p:cNvPr>
@@ -26068,7 +26068,7 @@
           <p:cNvPr id="21" name="Workflow">
             <a:extLst xmlns:a="http://schemas.openxmlformats.org/drawingml/2006/main">
               <a:ext uri="{FF2B5EF4-FFF2-40B4-BE49-F238E27FC236}">
-                <a16:creationId xmlns:a16="http://schemas.microsoft.com/office/drawing/2014/main" id="{F0C5F217-05C5-4DB0-BEA6-579EC49E1F2E}"/>
+                <a16:creationId xmlns:a16="http://schemas.microsoft.com/office/drawing/2014/main" id="{CD7AFF7C-3282-40AA-97AA-483F3922E03A}"/>
               </a:ext>
             </a:extLst>
           </p:cNvPr>
@@ -26226,7 +26226,7 @@
           <p:cNvPr id="22" name="분석 → 변경 → 측정 → 회귀 확인을 매번 적는다">
             <a:extLst xmlns:a="http://schemas.openxmlformats.org/drawingml/2006/main">
               <a:ext uri="{FF2B5EF4-FFF2-40B4-BE49-F238E27FC236}">
-                <a16:creationId xmlns:a16="http://schemas.microsoft.com/office/drawing/2014/main" id="{1BB756DE-E92E-4F64-A0CC-56B527D1D1C6}"/>
+                <a16:creationId xmlns:a16="http://schemas.microsoft.com/office/drawing/2014/main" id="{51AC0889-3C83-4505-A7F8-E7620D585B14}"/>
               </a:ext>
             </a:extLst>
           </p:cNvPr>
@@ -26384,7 +26384,7 @@
           <p:cNvPr id="23" name="">
             <a:extLst xmlns:a="http://schemas.openxmlformats.org/drawingml/2006/main">
               <a:ext uri="{FF2B5EF4-FFF2-40B4-BE49-F238E27FC236}">
-                <a16:creationId xmlns:a16="http://schemas.microsoft.com/office/drawing/2014/main" id="{96DD480B-FFD4-412C-A0E6-FDDB76186210}"/>
+                <a16:creationId xmlns:a16="http://schemas.microsoft.com/office/drawing/2014/main" id="{7AC37A99-1E1A-4267-A18E-4A1BE526AA14}"/>
               </a:ext>
             </a:extLst>
           </p:cNvPr>
@@ -26415,7 +26415,7 @@
           <p:cNvPr id="24" name="">
             <a:extLst xmlns:a="http://schemas.openxmlformats.org/drawingml/2006/main">
               <a:ext uri="{FF2B5EF4-FFF2-40B4-BE49-F238E27FC236}">
-                <a16:creationId xmlns:a16="http://schemas.microsoft.com/office/drawing/2014/main" id="{A4B35D36-0198-4DE3-A838-64408ACAAC06}"/>
+                <a16:creationId xmlns:a16="http://schemas.microsoft.com/office/drawing/2014/main" id="{4C3833AE-6BE2-4048-8804-6014E17C3B06}"/>
               </a:ext>
             </a:extLst>
           </p:cNvPr>
@@ -26446,7 +26446,7 @@
           <p:cNvPr id="25" name="D">
             <a:extLst xmlns:a="http://schemas.openxmlformats.org/drawingml/2006/main">
               <a:ext uri="{FF2B5EF4-FFF2-40B4-BE49-F238E27FC236}">
-                <a16:creationId xmlns:a16="http://schemas.microsoft.com/office/drawing/2014/main" id="{45CDF66F-5611-4D74-A843-A73B737CC76C}"/>
+                <a16:creationId xmlns:a16="http://schemas.microsoft.com/office/drawing/2014/main" id="{7400AFE4-590F-44C8-8C77-255A1694197B}"/>
               </a:ext>
             </a:extLst>
           </p:cNvPr>
@@ -26604,7 +26604,7 @@
           <p:cNvPr id="26" name="Verification">
             <a:extLst xmlns:a="http://schemas.openxmlformats.org/drawingml/2006/main">
               <a:ext uri="{FF2B5EF4-FFF2-40B4-BE49-F238E27FC236}">
-                <a16:creationId xmlns:a16="http://schemas.microsoft.com/office/drawing/2014/main" id="{9C6C2D66-4DC6-439D-A547-17E7334AD193}"/>
+                <a16:creationId xmlns:a16="http://schemas.microsoft.com/office/drawing/2014/main" id="{B76212E5-8026-4F59-A538-6FDE20B71490}"/>
               </a:ext>
             </a:extLst>
           </p:cNvPr>
@@ -26762,7 +26762,7 @@
           <p:cNvPr id="27" name="테스트와 Benchmark의 확인 기준이 모호하다">
             <a:extLst xmlns:a="http://schemas.openxmlformats.org/drawingml/2006/main">
               <a:ext uri="{FF2B5EF4-FFF2-40B4-BE49-F238E27FC236}">
-                <a16:creationId xmlns:a16="http://schemas.microsoft.com/office/drawing/2014/main" id="{1C7C4FB8-37B5-4EDE-9EFE-F81BF3C6619D}"/>
+                <a16:creationId xmlns:a16="http://schemas.microsoft.com/office/drawing/2014/main" id="{A81FCA10-2F32-4563-AF2C-889D6F6A6009}"/>
               </a:ext>
             </a:extLst>
           </p:cNvPr>
@@ -26920,7 +26920,7 @@
           <p:cNvPr id="28" name="">
             <a:extLst xmlns:a="http://schemas.openxmlformats.org/drawingml/2006/main">
               <a:ext uri="{FF2B5EF4-FFF2-40B4-BE49-F238E27FC236}">
-                <a16:creationId xmlns:a16="http://schemas.microsoft.com/office/drawing/2014/main" id="{CB05F4E8-0F14-4D64-A108-0ED6FE76CC9B}"/>
+                <a16:creationId xmlns:a16="http://schemas.microsoft.com/office/drawing/2014/main" id="{4C59492C-19A6-4415-899A-B8BDD420C39E}"/>
               </a:ext>
             </a:extLst>
           </p:cNvPr>
@@ -26951,7 +26951,7 @@
           <p:cNvPr id="29" name="">
             <a:extLst xmlns:a="http://schemas.openxmlformats.org/drawingml/2006/main">
               <a:ext uri="{FF2B5EF4-FFF2-40B4-BE49-F238E27FC236}">
-                <a16:creationId xmlns:a16="http://schemas.microsoft.com/office/drawing/2014/main" id="{416FB53F-1808-46A2-8D53-E1591A959CC8}"/>
+                <a16:creationId xmlns:a16="http://schemas.microsoft.com/office/drawing/2014/main" id="{8D3D5C68-15D3-4D66-A021-DC141734532A}"/>
               </a:ext>
             </a:extLst>
           </p:cNvPr>
@@ -26982,7 +26982,7 @@
           <p:cNvPr id="30" name="E">
             <a:extLst xmlns:a="http://schemas.openxmlformats.org/drawingml/2006/main">
               <a:ext uri="{FF2B5EF4-FFF2-40B4-BE49-F238E27FC236}">
-                <a16:creationId xmlns:a16="http://schemas.microsoft.com/office/drawing/2014/main" id="{4BEC0EDE-D881-4FAF-BDD7-DB0CC5981A69}"/>
+                <a16:creationId xmlns:a16="http://schemas.microsoft.com/office/drawing/2014/main" id="{6D8BC67F-DC27-4490-BD3F-FCE1BA390093}"/>
               </a:ext>
             </a:extLst>
           </p:cNvPr>
@@ -27140,7 +27140,7 @@
           <p:cNvPr id="31" name="Feedback Loop">
             <a:extLst xmlns:a="http://schemas.openxmlformats.org/drawingml/2006/main">
               <a:ext uri="{FF2B5EF4-FFF2-40B4-BE49-F238E27FC236}">
-                <a16:creationId xmlns:a16="http://schemas.microsoft.com/office/drawing/2014/main" id="{5FBA6086-3509-45A0-82A9-E6A383252137}"/>
+                <a16:creationId xmlns:a16="http://schemas.microsoft.com/office/drawing/2014/main" id="{BF2630AD-91C9-4E5F-B18B-D5AE010216C3}"/>
               </a:ext>
             </a:extLst>
           </p:cNvPr>
@@ -27298,7 +27298,7 @@
           <p:cNvPr id="32" name="같은 문제가 다시 생겨도 관련 시스템을 안 바꾼다">
             <a:extLst xmlns:a="http://schemas.openxmlformats.org/drawingml/2006/main">
               <a:ext uri="{FF2B5EF4-FFF2-40B4-BE49-F238E27FC236}">
-                <a16:creationId xmlns:a16="http://schemas.microsoft.com/office/drawing/2014/main" id="{8BACEDA6-62F9-4F9D-8EB5-7492F2440A80}"/>
+                <a16:creationId xmlns:a16="http://schemas.microsoft.com/office/drawing/2014/main" id="{169D1BF6-BB83-4992-8BE2-EFC819B56CD1}"/>
               </a:ext>
             </a:extLst>
           </p:cNvPr>
@@ -27456,7 +27456,7 @@
           <p:cNvPr id="33" name="Legacy module connection">
             <a:extLst xmlns:a="http://schemas.openxmlformats.org/drawingml/2006/main">
               <a:ext uri="{FF2B5EF4-FFF2-40B4-BE49-F238E27FC236}">
-                <a16:creationId xmlns:a16="http://schemas.microsoft.com/office/drawing/2014/main" id="{03D895B4-FF87-4A51-922D-A5E360EC970A}"/>
+                <a16:creationId xmlns:a16="http://schemas.microsoft.com/office/drawing/2014/main" id="{17763D88-8F1E-4100-9FBE-D42DE1EE7EB0}"/>
               </a:ext>
             </a:extLst>
           </p:cNvPr>
@@ -27612,7 +27612,7 @@
     </p:spTree>
     <p:extLst>
       <p:ext uri="{BB962C8B-B14F-4D97-AF65-F5344CB8AC3E}">
-        <p14:creationId xmlns:p14="http://schemas.microsoft.com/office/powerpoint/2010/main" val="881150143"/>
+        <p14:creationId xmlns:p14="http://schemas.microsoft.com/office/powerpoint/2010/main" val="903215036"/>
       </p:ext>
     </p:extLst>
   </p:cSld>
@@ -27643,7 +27643,7 @@
           <p:cNvPr id="18" name="ACT 5 · 잠시 생각해 보기">
             <a:extLst xmlns:a="http://schemas.openxmlformats.org/drawingml/2006/main">
               <a:ext uri="{FF2B5EF4-FFF2-40B4-BE49-F238E27FC236}">
-                <a16:creationId xmlns:a16="http://schemas.microsoft.com/office/drawing/2014/main" id="{17B762EE-12B3-4D20-B590-D00E8BA639CD}"/>
+                <a16:creationId xmlns:a16="http://schemas.microsoft.com/office/drawing/2014/main" id="{2BB89084-B407-4939-B229-350081B65397}"/>
               </a:ext>
             </a:extLst>
           </p:cNvPr>
@@ -27798,10 +27798,10 @@
       </p:sp>
       <p:sp>
         <p:nvSpPr>
-          <p:cNvPr id="2" name="S89">
+          <p:cNvPr id="2" name="S92">
             <a:extLst xmlns:a="http://schemas.openxmlformats.org/drawingml/2006/main">
               <a:ext uri="{FF2B5EF4-FFF2-40B4-BE49-F238E27FC236}">
-                <a16:creationId xmlns:a16="http://schemas.microsoft.com/office/drawing/2014/main" id="{8FDD5C10-4476-4638-925B-83E3BF54E3AA}"/>
+                <a16:creationId xmlns:a16="http://schemas.microsoft.com/office/drawing/2014/main" id="{76E36672-4F66-4CDE-96D1-F0A893D2B521}"/>
               </a:ext>
             </a:extLst>
           </p:cNvPr>
@@ -27949,7 +27949,7 @@
                 <a:ea typeface="Malgun Gothic"/>
                 <a:cs typeface="Malgun Gothic"/>
               </a:rPr>
-              <a:t>S89</a:t>
+              <a:t>S92</a:t>
             </a:r>
           </a:p>
         </p:txBody>
@@ -27959,7 +27959,7 @@
           <p:cNvPr id="3" name="다음 작은 행동을 개인적으로 고른다">
             <a:extLst xmlns:a="http://schemas.openxmlformats.org/drawingml/2006/main">
               <a:ext uri="{FF2B5EF4-FFF2-40B4-BE49-F238E27FC236}">
-                <a16:creationId xmlns:a16="http://schemas.microsoft.com/office/drawing/2014/main" id="{3AB8A09C-B647-4274-BCE3-9869D517A29B}"/>
+                <a16:creationId xmlns:a16="http://schemas.microsoft.com/office/drawing/2014/main" id="{014431AA-999B-4EBD-AD03-48C99B150A1D}"/>
               </a:ext>
             </a:extLst>
           </p:cNvPr>
@@ -28117,7 +28117,7 @@
           <p:cNvPr id="4" name="">
             <a:extLst xmlns:a="http://schemas.openxmlformats.org/drawingml/2006/main">
               <a:ext uri="{FF2B5EF4-FFF2-40B4-BE49-F238E27FC236}">
-                <a16:creationId xmlns:a16="http://schemas.microsoft.com/office/drawing/2014/main" id="{004B5199-FC6C-4A28-8D56-DB5A890AB4CD}"/>
+                <a16:creationId xmlns:a16="http://schemas.microsoft.com/office/drawing/2014/main" id="{427BB438-CD0F-4A30-84CD-2E1DF19DDA41}"/>
               </a:ext>
             </a:extLst>
           </p:cNvPr>
@@ -28148,7 +28148,7 @@
           <p:cNvPr id="5" name="BEAT-070–071 · 개인 성찰">
             <a:extLst xmlns:a="http://schemas.openxmlformats.org/drawingml/2006/main">
               <a:ext uri="{FF2B5EF4-FFF2-40B4-BE49-F238E27FC236}">
-                <a16:creationId xmlns:a16="http://schemas.microsoft.com/office/drawing/2014/main" id="{3603B7B0-B76A-4BED-B773-9FA5CF8BDB8D}"/>
+                <a16:creationId xmlns:a16="http://schemas.microsoft.com/office/drawing/2014/main" id="{1681D109-C88A-42A7-AADD-D3269CFCDB8D}"/>
               </a:ext>
             </a:extLst>
           </p:cNvPr>
@@ -28306,7 +28306,7 @@
           <p:cNvPr id="6" name="마음속으로 떠올리는 시간이다. 기록·발표·제출은 요구하지 않는다.">
             <a:extLst xmlns:a="http://schemas.openxmlformats.org/drawingml/2006/main">
               <a:ext uri="{FF2B5EF4-FFF2-40B4-BE49-F238E27FC236}">
-                <a16:creationId xmlns:a16="http://schemas.microsoft.com/office/drawing/2014/main" id="{7BDBAF69-0368-442F-84AB-6073E62C64A5}"/>
+                <a16:creationId xmlns:a16="http://schemas.microsoft.com/office/drawing/2014/main" id="{C28D98A6-5161-4605-8CE9-B3548B438FC0}"/>
               </a:ext>
             </a:extLst>
           </p:cNvPr>
@@ -28464,7 +28464,7 @@
           <p:cNvPr id="7" name="떠올린 마찰에서, 작은 행동 하나를 마음속으로.">
             <a:extLst xmlns:a="http://schemas.openxmlformats.org/drawingml/2006/main">
               <a:ext uri="{FF2B5EF4-FFF2-40B4-BE49-F238E27FC236}">
-                <a16:creationId xmlns:a16="http://schemas.microsoft.com/office/drawing/2014/main" id="{AC700CC5-81F5-4BA0-99C3-ECDA756AEB6F}"/>
+                <a16:creationId xmlns:a16="http://schemas.microsoft.com/office/drawing/2014/main" id="{C339EBF6-BC87-4786-A693-D1EADB3A6152}"/>
               </a:ext>
             </a:extLst>
           </p:cNvPr>
@@ -28622,7 +28622,7 @@
           <p:cNvPr id="8" name="">
             <a:extLst xmlns:a="http://schemas.openxmlformats.org/drawingml/2006/main">
               <a:ext uri="{FF2B5EF4-FFF2-40B4-BE49-F238E27FC236}">
-                <a16:creationId xmlns:a16="http://schemas.microsoft.com/office/drawing/2014/main" id="{93D2A7CC-D6C5-4A00-B985-D70E1B25426A}"/>
+                <a16:creationId xmlns:a16="http://schemas.microsoft.com/office/drawing/2014/main" id="{DFC14672-4348-43A4-A63A-318ABB4630CF}"/>
               </a:ext>
             </a:extLst>
           </p:cNvPr>
@@ -28653,7 +28653,7 @@
           <p:cNvPr id="9" name="01">
             <a:extLst xmlns:a="http://schemas.openxmlformats.org/drawingml/2006/main">
               <a:ext uri="{FF2B5EF4-FFF2-40B4-BE49-F238E27FC236}">
-                <a16:creationId xmlns:a16="http://schemas.microsoft.com/office/drawing/2014/main" id="{A7359FA6-9A45-4506-B419-609ADA6FC6EF}"/>
+                <a16:creationId xmlns:a16="http://schemas.microsoft.com/office/drawing/2014/main" id="{707DD57F-AAEB-454D-9F79-4F6CE41E7D52}"/>
               </a:ext>
             </a:extLst>
           </p:cNvPr>
@@ -28811,7 +28811,7 @@
           <p:cNvPr id="10" name="반복 설명 하나를 다음 작업에서는 어떻게 줄일까?">
             <a:extLst xmlns:a="http://schemas.openxmlformats.org/drawingml/2006/main">
               <a:ext uri="{FF2B5EF4-FFF2-40B4-BE49-F238E27FC236}">
-                <a16:creationId xmlns:a16="http://schemas.microsoft.com/office/drawing/2014/main" id="{10167B50-2904-4FC5-9C64-9C45029B67BF}"/>
+                <a16:creationId xmlns:a16="http://schemas.microsoft.com/office/drawing/2014/main" id="{D2F2F353-2D03-423C-BFFA-DCFF0E033EEC}"/>
               </a:ext>
             </a:extLst>
           </p:cNvPr>
@@ -28969,7 +28969,7 @@
           <p:cNvPr id="11" name="">
             <a:extLst xmlns:a="http://schemas.openxmlformats.org/drawingml/2006/main">
               <a:ext uri="{FF2B5EF4-FFF2-40B4-BE49-F238E27FC236}">
-                <a16:creationId xmlns:a16="http://schemas.microsoft.com/office/drawing/2014/main" id="{91C7D972-2319-4F0E-A2B6-A15B3AD17D3E}"/>
+                <a16:creationId xmlns:a16="http://schemas.microsoft.com/office/drawing/2014/main" id="{EF4156E6-0FF8-45B6-8986-AA93BFC7E7F4}"/>
               </a:ext>
             </a:extLst>
           </p:cNvPr>
@@ -29000,7 +29000,7 @@
           <p:cNvPr id="12" name="02">
             <a:extLst xmlns:a="http://schemas.openxmlformats.org/drawingml/2006/main">
               <a:ext uri="{FF2B5EF4-FFF2-40B4-BE49-F238E27FC236}">
-                <a16:creationId xmlns:a16="http://schemas.microsoft.com/office/drawing/2014/main" id="{51764AC7-A25B-4E02-8E11-6A0BA69C5F77}"/>
+                <a16:creationId xmlns:a16="http://schemas.microsoft.com/office/drawing/2014/main" id="{41772F0A-9E0D-4F0A-AAE6-FB56DAFE2703}"/>
               </a:ext>
             </a:extLst>
           </p:cNvPr>
@@ -29158,7 +29158,7 @@
           <p:cNvPr id="13" name="AI가 다시 찾는 프로젝트 사실 하나를 어디에 둘까?">
             <a:extLst xmlns:a="http://schemas.openxmlformats.org/drawingml/2006/main">
               <a:ext uri="{FF2B5EF4-FFF2-40B4-BE49-F238E27FC236}">
-                <a16:creationId xmlns:a16="http://schemas.microsoft.com/office/drawing/2014/main" id="{B3DEEF9D-3B51-445A-9BCB-426087F32913}"/>
+                <a16:creationId xmlns:a16="http://schemas.microsoft.com/office/drawing/2014/main" id="{94531D57-BF12-44FB-B402-8F9BE1B7275D}"/>
               </a:ext>
             </a:extLst>
           </p:cNvPr>
@@ -29316,7 +29316,7 @@
           <p:cNvPr id="14" name="">
             <a:extLst xmlns:a="http://schemas.openxmlformats.org/drawingml/2006/main">
               <a:ext uri="{FF2B5EF4-FFF2-40B4-BE49-F238E27FC236}">
-                <a16:creationId xmlns:a16="http://schemas.microsoft.com/office/drawing/2014/main" id="{2794A3EA-FA99-4FED-86D4-B37626E62BDD}"/>
+                <a16:creationId xmlns:a16="http://schemas.microsoft.com/office/drawing/2014/main" id="{5DE02424-C38C-432F-B6B5-43DEE06ED3CC}"/>
               </a:ext>
             </a:extLst>
           </p:cNvPr>
@@ -29347,7 +29347,7 @@
           <p:cNvPr id="15" name="03">
             <a:extLst xmlns:a="http://schemas.openxmlformats.org/drawingml/2006/main">
               <a:ext uri="{FF2B5EF4-FFF2-40B4-BE49-F238E27FC236}">
-                <a16:creationId xmlns:a16="http://schemas.microsoft.com/office/drawing/2014/main" id="{BB0C3DEA-53B9-479B-8605-342C8CD3F204}"/>
+                <a16:creationId xmlns:a16="http://schemas.microsoft.com/office/drawing/2014/main" id="{4E4BA36D-F034-4C1E-8E43-191319F690AA}"/>
               </a:ext>
             </a:extLst>
           </p:cNvPr>
@@ -29505,7 +29505,7 @@
           <p:cNvPr id="16" name="같은 실패가 또 생기면 어느 Layer부터 확인할까?">
             <a:extLst xmlns:a="http://schemas.openxmlformats.org/drawingml/2006/main">
               <a:ext uri="{FF2B5EF4-FFF2-40B4-BE49-F238E27FC236}">
-                <a16:creationId xmlns:a16="http://schemas.microsoft.com/office/drawing/2014/main" id="{CCEA07E5-2A0A-41C6-8850-BD968E1C353F}"/>
+                <a16:creationId xmlns:a16="http://schemas.microsoft.com/office/drawing/2014/main" id="{B8CBEB00-8DF5-4E8C-8667-5DD24DAEC956}"/>
               </a:ext>
             </a:extLst>
           </p:cNvPr>
@@ -29663,7 +29663,7 @@
           <p:cNvPr id="17" name="Legacy module connection">
             <a:extLst xmlns:a="http://schemas.openxmlformats.org/drawingml/2006/main">
               <a:ext uri="{FF2B5EF4-FFF2-40B4-BE49-F238E27FC236}">
-                <a16:creationId xmlns:a16="http://schemas.microsoft.com/office/drawing/2014/main" id="{EC7ADA6F-850E-49C6-8E93-6529432A12E8}"/>
+                <a16:creationId xmlns:a16="http://schemas.microsoft.com/office/drawing/2014/main" id="{8F1F42CD-2AE2-4B94-9F20-D21C01E95642}"/>
               </a:ext>
             </a:extLst>
           </p:cNvPr>
@@ -29819,7 +29819,7 @@
     </p:spTree>
     <p:extLst>
       <p:ext uri="{BB962C8B-B14F-4D97-AF65-F5344CB8AC3E}">
-        <p14:creationId xmlns:p14="http://schemas.microsoft.com/office/powerpoint/2010/main" val="1292463496"/>
+        <p14:creationId xmlns:p14="http://schemas.microsoft.com/office/powerpoint/2010/main" val="1219792202"/>
       </p:ext>
     </p:extLst>
   </p:cSld>
@@ -29850,7 +29850,7 @@
           <p:cNvPr id="12" name="ACT 5 · 마지막 질문">
             <a:extLst xmlns:a="http://schemas.openxmlformats.org/drawingml/2006/main">
               <a:ext uri="{FF2B5EF4-FFF2-40B4-BE49-F238E27FC236}">
-                <a16:creationId xmlns:a16="http://schemas.microsoft.com/office/drawing/2014/main" id="{1BD090D0-B220-4C89-A028-7AABED8A8F6F}"/>
+                <a16:creationId xmlns:a16="http://schemas.microsoft.com/office/drawing/2014/main" id="{DF9AC35E-90E3-4E97-8B4D-F76D390E5C35}"/>
               </a:ext>
             </a:extLst>
           </p:cNvPr>
@@ -30005,10 +30005,10 @@
       </p:sp>
       <p:sp>
         <p:nvSpPr>
-          <p:cNvPr id="2" name="S90">
+          <p:cNvPr id="2" name="S93">
             <a:extLst xmlns:a="http://schemas.openxmlformats.org/drawingml/2006/main">
               <a:ext uri="{FF2B5EF4-FFF2-40B4-BE49-F238E27FC236}">
-                <a16:creationId xmlns:a16="http://schemas.microsoft.com/office/drawing/2014/main" id="{39193DF2-5E56-4384-B4D3-79DBE1BCE22D}"/>
+                <a16:creationId xmlns:a16="http://schemas.microsoft.com/office/drawing/2014/main" id="{52AD1192-8EED-4694-99A3-A641CD751480}"/>
               </a:ext>
             </a:extLst>
           </p:cNvPr>
@@ -30156,7 +30156,7 @@
                 <a:ea typeface="Malgun Gothic"/>
                 <a:cs typeface="Malgun Gothic"/>
               </a:rPr>
-              <a:t>S90</a:t>
+              <a:t>S93</a:t>
             </a:r>
           </a:p>
         </p:txBody>
@@ -30166,7 +30166,7 @@
           <p:cNvPr id="3" name="Q&amp;A와 교육 마무리">
             <a:extLst xmlns:a="http://schemas.openxmlformats.org/drawingml/2006/main">
               <a:ext uri="{FF2B5EF4-FFF2-40B4-BE49-F238E27FC236}">
-                <a16:creationId xmlns:a16="http://schemas.microsoft.com/office/drawing/2014/main" id="{D40DE2D9-0349-40CF-8836-D1AEC35C1616}"/>
+                <a16:creationId xmlns:a16="http://schemas.microsoft.com/office/drawing/2014/main" id="{59BE4473-1EEA-4FCB-8481-ED3BC60204AD}"/>
               </a:ext>
             </a:extLst>
           </p:cNvPr>
@@ -30324,7 +30324,7 @@
           <p:cNvPr id="4" name="">
             <a:extLst xmlns:a="http://schemas.openxmlformats.org/drawingml/2006/main">
               <a:ext uri="{FF2B5EF4-FFF2-40B4-BE49-F238E27FC236}">
-                <a16:creationId xmlns:a16="http://schemas.microsoft.com/office/drawing/2014/main" id="{9AA25BAD-1A6C-4584-9F38-191F0C427574}"/>
+                <a16:creationId xmlns:a16="http://schemas.microsoft.com/office/drawing/2014/main" id="{D5D09058-D6B5-4E2B-B162-43DD7C31A69E}"/>
               </a:ext>
             </a:extLst>
           </p:cNvPr>
@@ -30355,7 +30355,7 @@
           <p:cNvPr id="5" name="BEAT-070–071 · 이 교육의 마무리">
             <a:extLst xmlns:a="http://schemas.openxmlformats.org/drawingml/2006/main">
               <a:ext uri="{FF2B5EF4-FFF2-40B4-BE49-F238E27FC236}">
-                <a16:creationId xmlns:a16="http://schemas.microsoft.com/office/drawing/2014/main" id="{7A255A8C-F0B1-4A00-9A15-B85D2D681226}"/>
+                <a16:creationId xmlns:a16="http://schemas.microsoft.com/office/drawing/2014/main" id="{270C8AA4-261F-4D92-BA21-6D87C1AE4B0B}"/>
               </a:ext>
             </a:extLst>
           </p:cNvPr>
@@ -30513,7 +30513,7 @@
           <p:cNvPr id="6" name="목표 · 판단 · 검증 · 책임은 개발자에게 남는다.">
             <a:extLst xmlns:a="http://schemas.openxmlformats.org/drawingml/2006/main">
               <a:ext uri="{FF2B5EF4-FFF2-40B4-BE49-F238E27FC236}">
-                <a16:creationId xmlns:a16="http://schemas.microsoft.com/office/drawing/2014/main" id="{11E2F897-D092-44CF-8DDB-60310803CA68}"/>
+                <a16:creationId xmlns:a16="http://schemas.microsoft.com/office/drawing/2014/main" id="{6567C66A-0E82-4EBF-BA60-7A05E7CFD288}"/>
               </a:ext>
             </a:extLst>
           </p:cNvPr>
@@ -30671,7 +30671,7 @@
           <p:cNvPr id="7" name="내 업무에서 무엇부터 바꿀까요?">
             <a:extLst xmlns:a="http://schemas.openxmlformats.org/drawingml/2006/main">
               <a:ext uri="{FF2B5EF4-FFF2-40B4-BE49-F238E27FC236}">
-                <a16:creationId xmlns:a16="http://schemas.microsoft.com/office/drawing/2014/main" id="{9BA86A7F-8A6F-489D-8AE0-531EFC76EBDD}"/>
+                <a16:creationId xmlns:a16="http://schemas.microsoft.com/office/drawing/2014/main" id="{94A8A17A-5263-44F3-BFD8-F9714EE3E359}"/>
               </a:ext>
             </a:extLst>
           </p:cNvPr>
@@ -30829,7 +30829,7 @@
           <p:cNvPr id="8" name="">
             <a:extLst xmlns:a="http://schemas.openxmlformats.org/drawingml/2006/main">
               <a:ext uri="{FF2B5EF4-FFF2-40B4-BE49-F238E27FC236}">
-                <a16:creationId xmlns:a16="http://schemas.microsoft.com/office/drawing/2014/main" id="{C9FCE43E-28F9-45DE-B8FF-E1FF86FB4502}"/>
+                <a16:creationId xmlns:a16="http://schemas.microsoft.com/office/drawing/2014/main" id="{731DD17A-F868-45E7-B6D7-9F2AF61ABEFB}"/>
               </a:ext>
             </a:extLst>
           </p:cNvPr>
@@ -30860,7 +30860,7 @@
           <p:cNvPr id="9" name="AI가 잘 일할 환경을&#10;설계한다.">
             <a:extLst xmlns:a="http://schemas.openxmlformats.org/drawingml/2006/main">
               <a:ext uri="{FF2B5EF4-FFF2-40B4-BE49-F238E27FC236}">
-                <a16:creationId xmlns:a16="http://schemas.microsoft.com/office/drawing/2014/main" id="{8EA99484-449B-4249-B04C-C9477A5E8AB5}"/>
+                <a16:creationId xmlns:a16="http://schemas.microsoft.com/office/drawing/2014/main" id="{39A87D87-86A3-4C4A-A4B6-8F862E7058EB}"/>
               </a:ext>
             </a:extLst>
           </p:cNvPr>
@@ -31041,7 +31041,7 @@
           <p:cNvPr id="10" name="Question  →  Task  →  Context  →  System  →  Feedback Loop">
             <a:extLst xmlns:a="http://schemas.openxmlformats.org/drawingml/2006/main">
               <a:ext uri="{FF2B5EF4-FFF2-40B4-BE49-F238E27FC236}">
-                <a16:creationId xmlns:a16="http://schemas.microsoft.com/office/drawing/2014/main" id="{64A04B1A-9368-4A65-AEEF-AE87014AF427}"/>
+                <a16:creationId xmlns:a16="http://schemas.microsoft.com/office/drawing/2014/main" id="{94FD3032-198E-40C2-B48D-4A738067C595}"/>
               </a:ext>
             </a:extLst>
           </p:cNvPr>
@@ -31199,7 +31199,7 @@
           <p:cNvPr id="11" name="Legacy module connection">
             <a:extLst xmlns:a="http://schemas.openxmlformats.org/drawingml/2006/main">
               <a:ext uri="{FF2B5EF4-FFF2-40B4-BE49-F238E27FC236}">
-                <a16:creationId xmlns:a16="http://schemas.microsoft.com/office/drawing/2014/main" id="{7C8AF543-1044-4045-90FD-57F10702E75B}"/>
+                <a16:creationId xmlns:a16="http://schemas.microsoft.com/office/drawing/2014/main" id="{8F86D51E-CE86-45A9-97DD-7926FA9635B5}"/>
               </a:ext>
             </a:extLst>
           </p:cNvPr>
@@ -31355,7 +31355,7 @@
     </p:spTree>
     <p:extLst>
       <p:ext uri="{BB962C8B-B14F-4D97-AF65-F5344CB8AC3E}">
-        <p14:creationId xmlns:p14="http://schemas.microsoft.com/office/powerpoint/2010/main" val="1065107597"/>
+        <p14:creationId xmlns:p14="http://schemas.microsoft.com/office/powerpoint/2010/main" val="1947642130"/>
       </p:ext>
     </p:extLst>
   </p:cSld>

</xml_diff>

<commit_message>
feat(slides): expand ACT0 investigation into six slides
Separate the crop outcome, evidence, environment limit and context
collection roles so the ACT0 transition is clear without narration.

Split the existing demo and case budgets, add two lecture minutes, and
migrate downstream slides and notes to the 99-slide, 387-minute plan.

Render all seven decks and preserve the other 93 screens apart from
their IDs and cross-references. Retain the recorded claim boundaries.
</commit_message>
<xml_diff>
--- a/production/ACT_5.pptx
+++ b/production/ACT_5.pptx
@@ -2,23 +2,23 @@
 <file path=ppt/presentation.xml><?xml version="1.0" encoding="utf-8"?>
 <p:presentation xmlns:p="http://schemas.openxmlformats.org/presentationml/2006/main">
   <p:sldMasterIdLst>
-    <p:sldMasterId xmlns:r="http://schemas.openxmlformats.org/officeDocument/2006/relationships" id="2147483648" r:id="R64e097316bbe48b2"/>
+    <p:sldMasterId xmlns:r="http://schemas.openxmlformats.org/officeDocument/2006/relationships" id="2147483648" r:id="R4ddf366f2f344c4f"/>
   </p:sldMasterIdLst>
   <p:notesMasterIdLst>
-    <p:notesMasterId xmlns:r="http://schemas.openxmlformats.org/officeDocument/2006/relationships" r:id="Rd188c31955b54f48"/>
+    <p:notesMasterId xmlns:r="http://schemas.openxmlformats.org/officeDocument/2006/relationships" r:id="R72b32c17d8564820"/>
   </p:notesMasterIdLst>
   <p:sldIdLst>
-    <p:sldId xmlns:r="http://schemas.openxmlformats.org/officeDocument/2006/relationships" id="256" r:id="R22cc80999cc64a12"/>
-    <p:sldId xmlns:r="http://schemas.openxmlformats.org/officeDocument/2006/relationships" id="257" r:id="Rc076de35a2304d0f"/>
-    <p:sldId xmlns:r="http://schemas.openxmlformats.org/officeDocument/2006/relationships" id="258" r:id="R9bed0d5bb730477b"/>
-    <p:sldId xmlns:r="http://schemas.openxmlformats.org/officeDocument/2006/relationships" id="259" r:id="R008a5da6dbef4209"/>
-    <p:sldId xmlns:r="http://schemas.openxmlformats.org/officeDocument/2006/relationships" id="260" r:id="Rd5fbe8a7c93e41eb"/>
-    <p:sldId xmlns:r="http://schemas.openxmlformats.org/officeDocument/2006/relationships" id="261" r:id="Rb06e15ffa9124724"/>
-    <p:sldId xmlns:r="http://schemas.openxmlformats.org/officeDocument/2006/relationships" id="262" r:id="Ra6f8f6e25504487d"/>
-    <p:sldId xmlns:r="http://schemas.openxmlformats.org/officeDocument/2006/relationships" id="263" r:id="Rf1dcd9fc8c4f41c4"/>
-    <p:sldId xmlns:r="http://schemas.openxmlformats.org/officeDocument/2006/relationships" id="264" r:id="Ra0971338188d483f"/>
-    <p:sldId xmlns:r="http://schemas.openxmlformats.org/officeDocument/2006/relationships" id="265" r:id="R9bb74b6d9ed64654"/>
-    <p:sldId xmlns:r="http://schemas.openxmlformats.org/officeDocument/2006/relationships" id="266" r:id="R2e703bb3f4504849"/>
+    <p:sldId xmlns:r="http://schemas.openxmlformats.org/officeDocument/2006/relationships" id="256" r:id="R674cbd7ad5da4e80"/>
+    <p:sldId xmlns:r="http://schemas.openxmlformats.org/officeDocument/2006/relationships" id="257" r:id="R839db14daed8442b"/>
+    <p:sldId xmlns:r="http://schemas.openxmlformats.org/officeDocument/2006/relationships" id="258" r:id="R3d78441f0b0647ba"/>
+    <p:sldId xmlns:r="http://schemas.openxmlformats.org/officeDocument/2006/relationships" id="259" r:id="Rb43325c883bc4c01"/>
+    <p:sldId xmlns:r="http://schemas.openxmlformats.org/officeDocument/2006/relationships" id="260" r:id="Rf499ef43fdb74d52"/>
+    <p:sldId xmlns:r="http://schemas.openxmlformats.org/officeDocument/2006/relationships" id="261" r:id="R631db52c36ce4d50"/>
+    <p:sldId xmlns:r="http://schemas.openxmlformats.org/officeDocument/2006/relationships" id="262" r:id="R79e2440776d84602"/>
+    <p:sldId xmlns:r="http://schemas.openxmlformats.org/officeDocument/2006/relationships" id="263" r:id="R8007b07e65c5472e"/>
+    <p:sldId xmlns:r="http://schemas.openxmlformats.org/officeDocument/2006/relationships" id="264" r:id="Rdee222acd6bb4b15"/>
+    <p:sldId xmlns:r="http://schemas.openxmlformats.org/officeDocument/2006/relationships" id="265" r:id="Rba55f196431d48f4"/>
+    <p:sldId xmlns:r="http://schemas.openxmlformats.org/officeDocument/2006/relationships" id="266" r:id="Ref828f4fc7b84ce6"/>
   </p:sldIdLst>
   <p:sldSz cx="12192000" cy="6858000"/>
   <p:notesSz cx="6858000" cy="9144000"/>
@@ -452,7 +452,7 @@
           <a:lstStyle xmlns:a="http://schemas.openxmlformats.org/drawingml/2006/main"/>
           <a:p xmlns:a="http://schemas.openxmlformats.org/drawingml/2006/main">
             <a:r>
-              <a:t>## S86 — 문제에 맞춰, 일하는 방식을 넓혔다</a:t>
+              <a:t>## S89 — 문제에 맞춰, 일하는 방식을 넓혔다</a:t>
             </a:r>
           </a:p>
           <a:p xmlns:a="http://schemas.openxmlformats.org/drawingml/2006/main">
@@ -467,7 +467,7 @@
           </a:p>
           <a:p xmlns:a="http://schemas.openxmlformats.org/drawingml/2006/main">
             <a:r>
-              <a:t>S86</a:t>
+              <a:t>S89</a:t>
             </a:r>
           </a:p>
           <a:p xmlns:a="http://schemas.openxmlformats.org/drawingml/2006/main">
@@ -572,7 +572,7 @@
           </a:p>
           <a:p xmlns:a="http://schemas.openxmlformats.org/drawingml/2006/main">
             <a:r>
-              <a:t>1. (0:00–0:30 / Lecture) S85가 닫은 검증 조건·유지 판단에서 전체 여정으로 시야를 넓힌다. 이번 장은 학습자 수준 평가나 새 성찰 시간이 아니라 문제와 대응의 회수다.</a:t>
+              <a:t>1. (0:00–0:30 / Lecture) S88가 닫은 검증 조건·유지 판단에서 전체 여정으로 시야를 넓힌다. 이번 장은 학습자 수준 평가나 새 성찰 시간이 아니라 문제와 대응의 회수다.</a:t>
             </a:r>
           </a:p>
           <a:p xmlns:a="http://schemas.openxmlformats.org/drawingml/2006/main">
@@ -582,7 +582,7 @@
           </a:p>
           <a:p xmlns:a="http://schemas.openxmlformats.org/drawingml/2006/main">
             <a:r>
-              <a:t>3. (2:45–4:00 / Lecture) 필요한 대응이 더해졌고 모든 프로젝트가 같은 순서로 이동하거나 모든 구성요소를 도입할 필요는 없다고 한정한다. 다음 S87은 이 전체 모델 가운데 실제 Product 이력만 별도로 회수한다.</a:t>
+              <a:t>3. (2:45–4:00 / Lecture) 필요한 대응이 더해졌고 모든 프로젝트가 같은 순서로 이동하거나 모든 구성요소를 도입할 필요는 없다고 한정한다. 다음 S90은 이 전체 모델 가운데 실제 Product 이력만 별도로 회수한다.</a:t>
             </a:r>
           </a:p>
           <a:p xmlns:a="http://schemas.openxmlformats.org/drawingml/2006/main">
@@ -687,7 +687,7 @@
           </a:p>
           <a:p xmlns:a="http://schemas.openxmlformats.org/drawingml/2006/main">
             <a:r>
-              <a:t>앞선 사례를 회상하게 하되 현재 수준 발표·투표·응답은 요구하지 않는다. 다음 행동의 개인 선택은 S94/S95에 남긴다.</a:t>
+              <a:t>앞선 사례를 회상하게 하되 현재 수준 발표·투표·응답은 요구하지 않는다. 다음 행동의 개인 선택은 S97/S98에 남긴다.</a:t>
             </a:r>
           </a:p>
           <a:p xmlns:a="http://schemas.openxmlformats.org/drawingml/2006/main">
@@ -732,7 +732,7 @@
           </a:p>
           <a:p xmlns:a="http://schemas.openxmlformats.org/drawingml/2006/main">
             <a:r>
-              <a:t>LOCAL STATIC ARTIFACT — production/ACT_5.pptx의 S86와 production/preview/act5/S86.png를 사용한다. 새 실행·원본 실행 캡처로 표현하지 않는다. 현재 화면과 Notes 검토는 production/evaluation/ACT_5_FLOW_REVISION.md에 기록한다.</a:t>
+              <a:t>LOCAL STATIC ARTIFACT — production/ACT_5.pptx의 S89와 production/preview/act5/S89.png를 사용한다. 새 실행·원본 실행 캡처로 표현하지 않는다. 현재 화면과 Notes 검토는 production/evaluation/ACT_5_FLOW_REVISION.md에 기록한다.</a:t>
             </a:r>
           </a:p>
           <a:p xmlns:a="http://schemas.openxmlformats.org/drawingml/2006/main">
@@ -817,7 +817,7 @@
           <a:lstStyle xmlns:a="http://schemas.openxmlformats.org/drawingml/2006/main"/>
           <a:p xmlns:a="http://schemas.openxmlformats.org/drawingml/2006/main">
             <a:r>
-              <a:t>## S95 — 고른 문제에서, 다음 행동 하나로</a:t>
+              <a:t>## S98 — 고른 문제에서, 다음 행동 하나로</a:t>
             </a:r>
           </a:p>
           <a:p xmlns:a="http://schemas.openxmlformats.org/drawingml/2006/main">
@@ -832,7 +832,7 @@
           </a:p>
           <a:p xmlns:a="http://schemas.openxmlformats.org/drawingml/2006/main">
             <a:r>
-              <a:t>S95</a:t>
+              <a:t>S98</a:t>
             </a:r>
           </a:p>
           <a:p xmlns:a="http://schemas.openxmlformats.org/drawingml/2006/main">
@@ -907,7 +907,7 @@
           </a:p>
           <a:p xmlns:a="http://schemas.openxmlformats.org/drawingml/2006/main">
             <a:r>
-              <a:t>S94에서 고른 A–E를 같은 글자의 작은 다음 행동으로 이어 받는다. B는 출처·검토자와 중복 지침 통합, C는 수행 절차·역할의 통합·제거 후보와 둘 위치·갱신 책임을 생각한다. 확인 근거 하나를 함께 고르되 다섯 행동을 모두 수행하거나 약속할 필요는 없다.</a:t>
+              <a:t>S97에서 고른 A–E를 같은 글자의 작은 다음 행동으로 이어 받는다. B는 출처·검토자와 중복 지침 통합, C는 수행 절차·역할의 통합·제거 후보와 둘 위치·갱신 책임을 생각한다. 확인 근거 하나를 함께 고르되 다섯 행동을 모두 수행하거나 약속할 필요는 없다.</a:t>
             </a:r>
           </a:p>
           <a:p xmlns:a="http://schemas.openxmlformats.org/drawingml/2006/main">
@@ -937,7 +937,7 @@
           </a:p>
           <a:p xmlns:a="http://schemas.openxmlformats.org/drawingml/2006/main">
             <a:r>
-              <a:t>1. (0:00–1:00 / Lecture) S94에서 마음속으로 고른 같은 글자의 행동만 생각하도록 안내한다. A 목표·변경 범위를 요청에 적기, B 출처·검토자를 정하고 중복 지침 통합, C 절차·역할의 통합·제거 후보와 둘 위치·갱신자, D 완료 판단 검사, E 반복 실패의 기록·원인 대조다. 모든 항목을 도입하는 목록이 아니다.</a:t>
+              <a:t>1. (0:00–1:00 / Lecture) S97에서 마음속으로 고른 같은 글자의 행동만 생각하도록 안내한다. A 목표·변경 범위를 요청에 적기, B 출처·검토자를 정하고 중복 지침 통합, C 절차·역할의 통합·제거 후보와 둘 위치·갱신자, D 완료 판단 검사, E 반복 실패의 기록·원인 대조다. 모든 항목을 도입하는 목록이 아니다.</a:t>
             </a:r>
           </a:p>
           <a:p xmlns:a="http://schemas.openxmlformats.org/drawingml/2006/main">
@@ -1037,7 +1037,7 @@
           </a:p>
           <a:p xmlns:a="http://schemas.openxmlformats.org/drawingml/2006/main">
             <a:r>
-              <a:t>왼쪽 A–E 행동은 S94과 같은 글자로 대응한다. 오른쪽은 모든 선택에 공통인 확인 근거 질문이다. 새 Trial이나 실행 결과·성공 판정은 없다. 선택은 마음속으로 하며 화면상 특정 항목을 강제로 선택하지 않는다. B의 중복 지침 통합, C의 절차·역할 통합·제거는 하나의 선택 가능한 후보이며 실행 명령이나 과제가 아니다. 공통 질문 아래의 출처·검토·갱신 책임도 짚는다.</a:t>
+              <a:t>왼쪽 A–E 행동은 S97과 같은 글자로 대응한다. 오른쪽은 모든 선택에 공통인 확인 근거 질문이다. 새 Trial이나 실행 결과·성공 판정은 없다. 선택은 마음속으로 하며 화면상 특정 항목을 강제로 선택하지 않는다. B의 중복 지침 통합, C의 절차·역할 통합·제거는 하나의 선택 가능한 후보이며 실행 명령이나 과제가 아니다. 공통 질문 아래의 출처·검토·갱신 책임도 짚는다.</a:t>
             </a:r>
           </a:p>
           <a:p xmlns:a="http://schemas.openxmlformats.org/drawingml/2006/main">
@@ -1082,7 +1082,7 @@
           </a:p>
           <a:p xmlns:a="http://schemas.openxmlformats.org/drawingml/2006/main">
             <a:r>
-              <a:t>Lecture2분+Reflection2분=4분. S94의 증상을 다시 읽거나 다섯 기술을 재강의하지 않는다. Reflection은2분에 끝내고 Q&amp;A와 구분한다.</a:t>
+              <a:t>Lecture2분+Reflection2분=4분. S97의 증상을 다시 읽거나 다섯 기술을 재강의하지 않는다. Reflection은2분에 끝내고 Q&amp;A와 구분한다.</a:t>
             </a:r>
           </a:p>
           <a:p xmlns:a="http://schemas.openxmlformats.org/drawingml/2006/main">
@@ -1097,7 +1097,7 @@
           </a:p>
           <a:p xmlns:a="http://schemas.openxmlformats.org/drawingml/2006/main">
             <a:r>
-              <a:t>LOCAL STATIC ARTIFACT — production/ACT_5.pptx의 S95와 production/preview/act5/S95.png를 사용한다. 새 실행·원본 실행 캡처로 표현하지 않는다. 현재 화면과 Notes 검토는 production/evaluation/ACT_5_HARNESS_REASSESSMENT.md에 기록한다.</a:t>
+              <a:t>LOCAL STATIC ARTIFACT — production/ACT_5.pptx의 S98와 production/preview/act5/S98.png를 사용한다. 새 실행·원본 실행 캡처로 표현하지 않는다. 현재 화면과 Notes 검토는 production/evaluation/ACT_5_HARNESS_REASSESSMENT.md에 기록한다.</a:t>
             </a:r>
           </a:p>
           <a:p xmlns:a="http://schemas.openxmlformats.org/drawingml/2006/main">
@@ -1182,7 +1182,7 @@
           <a:lstStyle xmlns:a="http://schemas.openxmlformats.org/drawingml/2006/main"/>
           <a:p xmlns:a="http://schemas.openxmlformats.org/drawingml/2006/main">
             <a:r>
-              <a:t>## S96 — Q&amp;A와 교육 마무리</a:t>
+              <a:t>## S99 — Q&amp;A와 교육 마무리</a:t>
             </a:r>
           </a:p>
           <a:p xmlns:a="http://schemas.openxmlformats.org/drawingml/2006/main">
@@ -1197,7 +1197,7 @@
           </a:p>
           <a:p xmlns:a="http://schemas.openxmlformats.org/drawingml/2006/main">
             <a:r>
-              <a:t>S96</a:t>
+              <a:t>S99</a:t>
             </a:r>
           </a:p>
           <a:p xmlns:a="http://schemas.openxmlformats.org/drawingml/2006/main">
@@ -1302,12 +1302,12 @@
           </a:p>
           <a:p xmlns:a="http://schemas.openxmlformats.org/drawingml/2006/main">
             <a:r>
-              <a:t>1. (0:00–4:00 / Q&amp;A) 상단의 남은 질문은 무엇인가요를 가리키며 질문을 받는다. S95에서 고른 행동을 다시 발표시키지 않는다. 질문이 없으면 “결과를 수용할 때 어떤 근거를 받아야 할까요?” 또는 “반복되는 실패라면 바꾸기 전에 어떤 기록을 먼저 봐야 할까요?”를 사용한다. 새 제품 사실·설명·Demo를 추가하지 않는다.</a:t>
-            </a:r>
-          </a:p>
-          <a:p xmlns:a="http://schemas.openxmlformats.org/drawingml/2006/main">
-            <a:r>
-              <a:t>2. (4:00–6:00 / Closing Transition) 질문을 마감한다. 중앙의 AI가 잘 일할 환경을 설계한다를 남기고 하단의 Chatbot→Prompt→Context→Harness→Loop를 짧게 회수한다. S86과 같은 용어이며 Question/Task/System을 새 단계로 소개하지 않는다. 설계에는 필요성 재평가와 근거에 따른 통합·제거도 포함된다는 한 문장만 회수한다. 새 단계나 개념을 도입하지 않고 개인 선택 질문이나 전체 강의를 다시 열지 않는다.</a:t>
+              <a:t>1. (0:00–4:00 / Q&amp;A) 상단의 남은 질문은 무엇인가요를 가리키며 질문을 받는다. S98에서 고른 행동을 다시 발표시키지 않는다. 질문이 없으면 “결과를 수용할 때 어떤 근거를 받아야 할까요?” 또는 “반복되는 실패라면 바꾸기 전에 어떤 기록을 먼저 봐야 할까요?”를 사용한다. 새 제품 사실·설명·Demo를 추가하지 않는다.</a:t>
+            </a:r>
+          </a:p>
+          <a:p xmlns:a="http://schemas.openxmlformats.org/drawingml/2006/main">
+            <a:r>
+              <a:t>2. (4:00–6:00 / Closing Transition) 질문을 마감한다. 중앙의 AI가 잘 일할 환경을 설계한다를 남기고 하단의 Chatbot→Prompt→Context→Harness→Loop를 짧게 회수한다. S89과 같은 용어이며 Question/Task/System을 새 단계로 소개하지 않는다. 설계에는 필요성 재평가와 근거에 따른 통합·제거도 포함된다는 한 문장만 회수한다. 새 단계나 개념을 도입하지 않고 개인 선택 질문이나 전체 강의를 다시 열지 않는다.</a:t>
             </a:r>
           </a:p>
           <a:p xmlns:a="http://schemas.openxmlformats.org/drawingml/2006/main">
@@ -1417,7 +1417,7 @@
           </a:p>
           <a:p xmlns:a="http://schemas.openxmlformats.org/drawingml/2006/main">
             <a:r>
-              <a:t>Q&amp;A4분. 질문이 없으면 기존 교육 범위의 확인 질문 하나로 운영한다. S95 개인 성찰을 공개 제출·실천 약속으로 바꾸지 않는다.</a:t>
+              <a:t>Q&amp;A4분. 질문이 없으면 기존 교육 범위의 확인 질문 하나로 운영한다. S98 개인 성찰을 공개 제출·실천 약속으로 바꾸지 않는다.</a:t>
             </a:r>
           </a:p>
           <a:p xmlns:a="http://schemas.openxmlformats.org/drawingml/2006/main">
@@ -1462,7 +1462,7 @@
           </a:p>
           <a:p xmlns:a="http://schemas.openxmlformats.org/drawingml/2006/main">
             <a:r>
-              <a:t>LOCAL STATIC ARTIFACT — production/ACT_5.pptx의 S96와 production/preview/act5/S96.png를 사용한다. 새 실행·원본 실행 캡처로 표현하지 않는다. 현재 화면과 Notes 검토는 production/evaluation/ACT_5_HARNESS_REASSESSMENT.md에 기록한다.</a:t>
+              <a:t>LOCAL STATIC ARTIFACT — production/ACT_5.pptx의 S99와 production/preview/act5/S99.png를 사용한다. 새 실행·원본 실행 캡처로 표현하지 않는다. 현재 화면과 Notes 검토는 production/evaluation/ACT_5_HARNESS_REASSESSMENT.md에 기록한다.</a:t>
             </a:r>
           </a:p>
           <a:p xmlns:a="http://schemas.openxmlformats.org/drawingml/2006/main">
@@ -1547,7 +1547,7 @@
           <a:lstStyle xmlns:a="http://schemas.openxmlformats.org/drawingml/2006/main"/>
           <a:p xmlns:a="http://schemas.openxmlformats.org/drawingml/2006/main">
             <a:r>
-              <a:t>## S87 — 실제 Demo는 문제에 맞춰 바뀌었다</a:t>
+              <a:t>## S90 — 실제 Demo는 문제에 맞춰 바뀌었다</a:t>
             </a:r>
           </a:p>
           <a:p xmlns:a="http://schemas.openxmlformats.org/drawingml/2006/main">
@@ -1562,7 +1562,7 @@
           </a:p>
           <a:p xmlns:a="http://schemas.openxmlformats.org/drawingml/2006/main">
             <a:r>
-              <a:t>S87</a:t>
+              <a:t>S90</a:t>
             </a:r>
           </a:p>
           <a:p xmlns:a="http://schemas.openxmlformats.org/drawingml/2006/main">
@@ -1672,7 +1672,7 @@
           </a:p>
           <a:p xmlns:a="http://schemas.openxmlformats.org/drawingml/2006/main">
             <a:r>
-              <a:t>2. (1:00–2:30 / VISUAL Demo) 첫째 crop 경계 오류를 끝 좌표 제외 명세에 맞게 고쳤다(STATE-00→STATE-00-FIXED, TRIAL-002/S18). 둘째 지침의 반복·증가를 기본 안내와 상세 문서로 정리했다(STATE-01→STATE-02→STATE-03, TRIAL-003/004/005A/B 및 S43). 셋째 반복 절차를 Skill로 재사용하고 밝기 통계 제품 변경을 검증했다(STATE-04→STATE-04-PERF, TRIAL-008/S58). 각 변화와 문제의 연결만 회수하고 수치·전체 코드·개별 Trial을 다시 읽지 않는다.</a:t>
+              <a:t>2. (1:00–2:30 / VISUAL Demo) 첫째 crop 경계 오류를 끝 좌표 제외 명세에 맞게 고쳤다(STATE-00→STATE-00-FIXED, TRIAL-002/S21). 둘째 지침의 반복·증가를 기본 안내와 상세 문서로 정리했다(STATE-01→STATE-02→STATE-03, TRIAL-003/004/005A/B 및 S46). 셋째 반복 절차를 Skill로 재사용하고 밝기 통계 제품 변경을 검증했다(STATE-04→STATE-04-PERF, TRIAL-008/S61). 각 변화와 문제의 연결만 회수하고 수치·전체 코드·개별 Trial을 다시 읽지 않는다.</a:t>
             </a:r>
           </a:p>
           <a:p xmlns:a="http://schemas.openxmlformats.org/drawingml/2006/main">
@@ -1692,12 +1692,12 @@
           </a:p>
           <a:p xmlns:a="http://schemas.openxmlformats.org/drawingml/2006/main">
             <a:r>
-              <a:t>OBSERVED_PRODUCT · DEMO-12 · ai-dev-training-demo의 named Git State/tag 이력. 전체 순서는 STATE-00→STATE-00-FIXED→STATE-01→STATE-02→STATE-03→STATE-04→STATE-04-PERF다. crop 수정은 TRIAL-002/S18, 지침·문서 재구성은 TRIAL-003/004/005A/B 및 S43, Skill과 제품 성능 검증은 TRIAL-008·STATE-04-PERF/S58에 연결한다. 화면은 기록을 요약한 Native 도식이며 실행 Screenshot이 아니다.</a:t>
-            </a:r>
-          </a:p>
-          <a:p xmlns:a="http://schemas.openxmlformats.org/drawingml/2006/main">
-            <a:r>
-              <a:t>이전 화면의 세 발표자료 발췌는 가독성 때문에 현재 화면에서 내렸다. 원본·provenance는 assets/slide-illustrations/recap/S16-source.png, S32-source.png, S47-source.png 및 ASSET_MANIFEST.json에 보존한다. 최초80장판 파일명이며 현재 대응은 S18/S43/S58다. 해당 그림은 원본 실행 화면이 아닌 당시 발표자료 발췌였다.</a:t>
+              <a:t>OBSERVED_PRODUCT · DEMO-12 · ai-dev-training-demo의 named Git State/tag 이력. 전체 순서는 STATE-00→STATE-00-FIXED→STATE-01→STATE-02→STATE-03→STATE-04→STATE-04-PERF다. crop 수정은 TRIAL-002/S21, 지침·문서 재구성은 TRIAL-003/004/005A/B 및 S46, Skill과 제품 성능 검증은 TRIAL-008·STATE-04-PERF/S61에 연결한다. 화면은 기록을 요약한 Native 도식이며 실행 Screenshot이 아니다.</a:t>
+            </a:r>
+          </a:p>
+          <a:p xmlns:a="http://schemas.openxmlformats.org/drawingml/2006/main">
+            <a:r>
+              <a:t>이전 화면의 세 발표자료 발췌는 가독성 때문에 현재 화면에서 내렸다. 원본·provenance는 assets/slide-illustrations/recap/S16-source.png, S32-source.png, S47-source.png 및 ASSET_MANIFEST.json에 보존한다. 최초80장판 파일명이며 현재 대응은 S21/S46/S61다. 해당 그림은 원본 실행 화면이 아닌 당시 발표자료 발췌였다.</a:t>
             </a:r>
           </a:p>
           <a:p xmlns:a="http://schemas.openxmlformats.org/drawingml/2006/main">
@@ -1832,7 +1832,7 @@
           </a:p>
           <a:p xmlns:a="http://schemas.openxmlformats.org/drawingml/2006/main">
             <a:r>
-              <a:t>LOCAL STATIC ARTIFACT — production/ACT_5.pptx의 S87와 production/preview/act5/S87.png를 사용한다. 새 실행·원본 실행 캡처로 표현하지 않는다. 현재 화면과 Notes 검토는 production/evaluation/ACT_5_FLOW_REVISION.md에 기록한다.</a:t>
+              <a:t>LOCAL STATIC ARTIFACT — production/ACT_5.pptx의 S90와 production/preview/act5/S90.png를 사용한다. 새 실행·원본 실행 캡처로 표현하지 않는다. 현재 화면과 Notes 검토는 production/evaluation/ACT_5_FLOW_REVISION.md에 기록한다.</a:t>
             </a:r>
           </a:p>
           <a:p xmlns:a="http://schemas.openxmlformats.org/drawingml/2006/main">
@@ -1917,7 +1917,7 @@
           <a:lstStyle xmlns:a="http://schemas.openxmlformats.org/drawingml/2006/main"/>
           <a:p xmlns:a="http://schemas.openxmlformats.org/drawingml/2006/main">
             <a:r>
-              <a:t>## S88 — 이번 문제에 필요한 구성만 선택했다</a:t>
+              <a:t>## S91 — 이번 문제에 필요한 구성만 선택했다</a:t>
             </a:r>
           </a:p>
           <a:p xmlns:a="http://schemas.openxmlformats.org/drawingml/2006/main">
@@ -1932,7 +1932,7 @@
           </a:p>
           <a:p xmlns:a="http://schemas.openxmlformats.org/drawingml/2006/main">
             <a:r>
-              <a:t>S88</a:t>
+              <a:t>S91</a:t>
             </a:r>
           </a:p>
           <a:p xmlns:a="http://schemas.openxmlformats.org/drawingml/2006/main">
@@ -2037,7 +2037,7 @@
           </a:p>
           <a:p xmlns:a="http://schemas.openxmlformats.org/drawingml/2006/main">
             <a:r>
-              <a:t>1. (0:00–0:30 / Lecture) S87의 실제 이력을 이어 받아 왼쪽 사용한 구성은 짧게만 회수한다. Task Prompt, Context와 Routing, 재사용 Skill, 테스트와 Benchmark다.</a:t>
+              <a:t>1. (0:00–0:30 / Lecture) S90의 실제 이력을 이어 받아 왼쪽 사용한 구성은 짧게만 회수한다. Task Prompt, Context와 Routing, 재사용 Skill, 테스트와 Benchmark다.</a:t>
             </a:r>
           </a:p>
           <a:p xmlns:a="http://schemas.openxmlformats.org/drawingml/2006/main">
@@ -2047,7 +2047,7 @@
           </a:p>
           <a:p xmlns:a="http://schemas.openxmlformats.org/drawingml/2006/main">
             <a:r>
-              <a:t>3. (1:20–2:00 / Lecture) 현재 문제가 필요로 하는 만큼 설계한다는 기준을 남긴다. 미사용 자체가 더 빠르거나 정확하다는 측정 결과는 없다. 필요한 구성 선택 다음에도 결과의 수용 판단은 남는다고 S89로 넘긴다.</a:t>
+              <a:t>3. (1:20–2:00 / Lecture) 현재 문제가 필요로 하는 만큼 설계한다는 기준을 남긴다. 미사용 자체가 더 빠르거나 정확하다는 측정 결과는 없다. 필요한 구성 선택 다음에도 결과의 수용 판단은 남는다고 S92로 넘긴다.</a:t>
             </a:r>
           </a:p>
           <a:p xmlns:a="http://schemas.openxmlformats.org/drawingml/2006/main">
@@ -2137,7 +2137,7 @@
           </a:p>
           <a:p xmlns:a="http://schemas.openxmlformats.org/drawingml/2006/main">
             <a:r>
-              <a:t>왼쪽은 사용한 구성 목록, 오른쪽은 두 보류 판단과 각각의 이유다. 실제 Subagent 실행·Memory 저장·비교 실험이 없다. 코드→문서→Skill→기록은 S62에서 이미 본 출처다.</a:t>
+              <a:t>왼쪽은 사용한 구성 목록, 오른쪽은 두 보류 판단과 각각의 이유다. 실제 Subagent 실행·Memory 저장·비교 실험이 없다. 코드→문서→Skill→기록은 S65에서 이미 본 출처다.</a:t>
             </a:r>
           </a:p>
           <a:p xmlns:a="http://schemas.openxmlformats.org/drawingml/2006/main">
@@ -2197,7 +2197,7 @@
           </a:p>
           <a:p xmlns:a="http://schemas.openxmlformats.org/drawingml/2006/main">
             <a:r>
-              <a:t>LOCAL STATIC ARTIFACT — production/ACT_5.pptx의 S88와 production/preview/act5/S88.png를 사용한다. 새 실행·원본 실행 캡처로 표현하지 않는다. 현재 화면과 Notes 검토는 production/evaluation/ACT_5_FLOW_REVISION.md에 기록한다.</a:t>
+              <a:t>LOCAL STATIC ARTIFACT — production/ACT_5.pptx의 S91와 production/preview/act5/S91.png를 사용한다. 새 실행·원본 실행 캡처로 표현하지 않는다. 현재 화면과 Notes 검토는 production/evaluation/ACT_5_FLOW_REVISION.md에 기록한다.</a:t>
             </a:r>
           </a:p>
           <a:p xmlns:a="http://schemas.openxmlformats.org/drawingml/2006/main">
@@ -2282,7 +2282,7 @@
           <a:lstStyle xmlns:a="http://schemas.openxmlformats.org/drawingml/2006/main"/>
           <a:p xmlns:a="http://schemas.openxmlformats.org/drawingml/2006/main">
             <a:r>
-              <a:t>## S89 — 결과를 수용할지는 사람이 판단한다</a:t>
+              <a:t>## S92 — 결과를 수용할지는 사람이 판단한다</a:t>
             </a:r>
           </a:p>
           <a:p xmlns:a="http://schemas.openxmlformats.org/drawingml/2006/main">
@@ -2297,7 +2297,7 @@
           </a:p>
           <a:p xmlns:a="http://schemas.openxmlformats.org/drawingml/2006/main">
             <a:r>
-              <a:t>S89</a:t>
+              <a:t>S92</a:t>
             </a:r>
           </a:p>
           <a:p xmlns:a="http://schemas.openxmlformats.org/drawingml/2006/main">
@@ -2402,7 +2402,7 @@
           </a:p>
           <a:p xmlns:a="http://schemas.openxmlformats.org/drawingml/2006/main">
             <a:r>
-              <a:t>1. (0:00–0:40 / Lecture) S88의 구성 선택에서 결과 수용으로 넘어간다. 왼쪽 AI의 작업 결과는 교육용 묶음이지 실제 실행 보고서나 제품 UI가 아니다. AI는 조사·생성·변경·실행·비교를 도울 수 있다.</a:t>
+              <a:t>1. (0:00–0:40 / Lecture) S91의 구성 선택에서 결과 수용으로 넘어간다. 왼쪽 AI의 작업 결과는 교육용 묶음이지 실제 실행 보고서나 제품 UI가 아니다. AI는 조사·생성·변경·실행·비교를 도울 수 있다.</a:t>
             </a:r>
           </a:p>
           <a:p xmlns:a="http://schemas.openxmlformats.org/drawingml/2006/main">
@@ -2412,7 +2412,7 @@
           </a:p>
           <a:p xmlns:a="http://schemas.openxmlformats.org/drawingml/2006/main">
             <a:r>
-              <a:t>3. (2:20–3:00 / Lecture) 고정된 인간/Agent 분업이 아니라 개발자의 판단과 책임을 강조한다. S90에서는 이 판단에 필요한 자료가 나오도록 작업 환경을 준비하는 설계로 시점을 바꾼다.</a:t>
+              <a:t>3. (2:20–3:00 / Lecture) 고정된 인간/Agent 분업이 아니라 개발자의 판단과 책임을 강조한다. S93에서는 이 판단에 필요한 자료가 나오도록 작업 환경을 준비하는 설계로 시점을 바꾼다.</a:t>
             </a:r>
           </a:p>
           <a:p xmlns:a="http://schemas.openxmlformats.org/drawingml/2006/main">
@@ -2562,7 +2562,7 @@
           </a:p>
           <a:p xmlns:a="http://schemas.openxmlformats.org/drawingml/2006/main">
             <a:r>
-              <a:t>LOCAL STATIC ARTIFACT — production/ACT_5.pptx의 S89와 production/preview/act5/S89.png를 사용한다. 새 실행·원본 실행 캡처로 표현하지 않는다. 현재 화면과 Notes 검토는 production/evaluation/ACT_5_FLOW_REVISION.md에 기록한다.</a:t>
+              <a:t>LOCAL STATIC ARTIFACT — production/ACT_5.pptx의 S92와 production/preview/act5/S92.png를 사용한다. 새 실행·원본 실행 캡처로 표현하지 않는다. 현재 화면과 Notes 검토는 production/evaluation/ACT_5_FLOW_REVISION.md에 기록한다.</a:t>
             </a:r>
           </a:p>
           <a:p xmlns:a="http://schemas.openxmlformats.org/drawingml/2006/main">
@@ -2647,7 +2647,7 @@
           <a:lstStyle xmlns:a="http://schemas.openxmlformats.org/drawingml/2006/main"/>
           <a:p xmlns:a="http://schemas.openxmlformats.org/drawingml/2006/main">
             <a:r>
-              <a:t>## S90 — AI가 일할 조건과 확인 경로를 설계한다</a:t>
+              <a:t>## S93 — AI가 일할 조건과 확인 경로를 설계한다</a:t>
             </a:r>
           </a:p>
           <a:p xmlns:a="http://schemas.openxmlformats.org/drawingml/2006/main">
@@ -2662,7 +2662,7 @@
           </a:p>
           <a:p xmlns:a="http://schemas.openxmlformats.org/drawingml/2006/main">
             <a:r>
-              <a:t>S90</a:t>
+              <a:t>S93</a:t>
             </a:r>
           </a:p>
           <a:p xmlns:a="http://schemas.openxmlformats.org/drawingml/2006/main">
@@ -2767,7 +2767,7 @@
           </a:p>
           <a:p xmlns:a="http://schemas.openxmlformats.org/drawingml/2006/main">
             <a:r>
-              <a:t>1. (0:00–0:30 / Lecture) S89의 사람이 판단할 질문을 이어 받는다. 이번 장은 판단 책임을 다시 나열하지 않고, 판단할 근거가 나올 작업 조건을 설계하는 관점이다.</a:t>
+              <a:t>1. (0:00–0:30 / Lecture) S92의 사람이 판단할 질문을 이어 받는다. 이번 장은 판단 책임을 다시 나열하지 않고, 판단할 근거가 나올 작업 조건을 설계하는 관점이다.</a:t>
             </a:r>
           </a:p>
           <a:p xmlns:a="http://schemas.openxmlformats.org/drawingml/2006/main">
@@ -2777,7 +2777,7 @@
           </a:p>
           <a:p xmlns:a="http://schemas.openxmlformats.org/drawingml/2006/main">
             <a:r>
-              <a:t>3. (2:20–3:00 / Lecture) 이 설계·운영 방식을 이 과정의 AI-Native Development로 부른다고 이름만 회수한다. 공식·보편 정의 또는 모든 Task의 의무 목록이 아니다. 이제 이미 만든 환경도 모델·플랫폼·업무 조건이 달라지면 재평가해야 한다는 S91로 이동한다. 추가가 설계의 전부가 아니라는 질문만 열고3장 내용을 미리 설명하지 않는다.</a:t>
+              <a:t>3. (2:20–3:00 / Lecture) 이 설계·운영 방식을 이 과정의 AI-Native Development로 부른다고 이름만 회수한다. 공식·보편 정의 또는 모든 Task의 의무 목록이 아니다. 이제 이미 만든 환경도 모델·플랫폼·업무 조건이 달라지면 재평가해야 한다는 S94로 이동한다. 추가가 설계의 전부가 아니라는 질문만 열고3장 내용을 미리 설명하지 않는다.</a:t>
             </a:r>
           </a:p>
           <a:p xmlns:a="http://schemas.openxmlformats.org/drawingml/2006/main">
@@ -2852,7 +2852,7 @@
           </a:p>
           <a:p xmlns:a="http://schemas.openxmlformats.org/drawingml/2006/main">
             <a:r>
-              <a:t>재평가3장을 거쳐 S94에서 C++ Vision 업무와 자신의 Repository로 transfer한다.</a:t>
+              <a:t>재평가3장을 거쳐 S97에서 C++ Vision 업무와 자신의 Repository로 transfer한다.</a:t>
             </a:r>
           </a:p>
           <a:p xmlns:a="http://schemas.openxmlformats.org/drawingml/2006/main">
@@ -2927,7 +2927,7 @@
           </a:p>
           <a:p xmlns:a="http://schemas.openxmlformats.org/drawingml/2006/main">
             <a:r>
-              <a:t>LOCAL STATIC ARTIFACT — production/ACT_5.pptx의 S90와 production/preview/act5/S90.png를 사용한다. 새 실행·원본 실행 캡처로 표현하지 않는다. 현재 화면과 Notes 검토는 production/evaluation/ACT_5_HARNESS_REASSESSMENT.md에 기록한다.</a:t>
+              <a:t>LOCAL STATIC ARTIFACT — production/ACT_5.pptx의 S93와 production/preview/act5/S93.png를 사용한다. 새 실행·원본 실행 캡처로 표현하지 않는다. 현재 화면과 Notes 검토는 production/evaluation/ACT_5_HARNESS_REASSESSMENT.md에 기록한다.</a:t>
             </a:r>
           </a:p>
           <a:p xmlns:a="http://schemas.openxmlformats.org/drawingml/2006/main">
@@ -3012,7 +3012,7 @@
           <a:lstStyle xmlns:a="http://schemas.openxmlformats.org/drawingml/2006/main"/>
           <a:p xmlns:a="http://schemas.openxmlformats.org/drawingml/2006/main">
             <a:r>
-              <a:t>## S91 — 모델·플랫폼이 바뀌면 Harness도 다시 본다</a:t>
+              <a:t>## S94 — 모델·플랫폼이 바뀌면 Harness도 다시 본다</a:t>
             </a:r>
           </a:p>
           <a:p xmlns:a="http://schemas.openxmlformats.org/drawingml/2006/main">
@@ -3027,7 +3027,7 @@
           </a:p>
           <a:p xmlns:a="http://schemas.openxmlformats.org/drawingml/2006/main">
             <a:r>
-              <a:t>S91</a:t>
+              <a:t>S94</a:t>
             </a:r>
           </a:p>
           <a:p xmlns:a="http://schemas.openxmlformats.org/drawingml/2006/main">
@@ -3132,7 +3132,7 @@
           </a:p>
           <a:p xmlns:a="http://schemas.openxmlformats.org/drawingml/2006/main">
             <a:r>
-              <a:t>1. (0:00–0:25 / Lecture) S90의 설계 관점에서 “그때 필요했던 보조 장치가 지금도 필요한가?”를 묻는다. S88은 처음부터 필요하지 않아 도입하지 않은 판단이고, 여기서는 이전에 쓸 이유가 있었던 구조의 후속 재평가다.</a:t>
+              <a:t>1. (0:00–0:25 / Lecture) S93의 설계 관점에서 “그때 필요했던 보조 장치가 지금도 필요한가?”를 묻는다. S91은 처음부터 필요하지 않아 도입하지 않은 판단이고, 여기서는 이전에 쓸 이유가 있었던 구조의 후속 재평가다.</a:t>
             </a:r>
           </a:p>
           <a:p xmlns:a="http://schemas.openxmlformats.org/drawingml/2006/main">
@@ -3142,7 +3142,7 @@
           </a:p>
           <a:p xmlns:a="http://schemas.openxmlformats.org/drawingml/2006/main">
             <a:r>
-              <a:t>3. (1:25–2:00 / Lecture) 새 모델이나 플랫폼이면 무조건 합치라는 뜻이 아니며 우리 Demo의 통합·비용·품질 비교 실험도 아니라고 한정한다. 외부 수치나 모델명 성능을 추가하지 않고 S92의 판단 기준으로 넘긴다.</a:t>
+              <a:t>3. (1:25–2:00 / Lecture) 새 모델이나 플랫폼이면 무조건 합치라는 뜻이 아니며 우리 Demo의 통합·비용·품질 비교 실험도 아니라고 한정한다. 외부 수치나 모델명 성능을 추가하지 않고 S95의 판단 기준으로 넘긴다.</a:t>
             </a:r>
           </a:p>
           <a:p xmlns:a="http://schemas.openxmlformats.org/drawingml/2006/main">
@@ -3247,7 +3247,7 @@
           </a:p>
           <a:p xmlns:a="http://schemas.openxmlformats.org/drawingml/2006/main">
             <a:r>
-              <a:t>질문은 설명을 여는 수사적 질문이다. 응답·실습·기록·제출을 요구하지 않는다. 개인 선택은 S94/S95에 남긴다.</a:t>
+              <a:t>질문은 설명을 여는 수사적 질문이다. 응답·실습·기록·제출을 요구하지 않는다. 개인 선택은 S97/S98에 남긴다.</a:t>
             </a:r>
           </a:p>
           <a:p xmlns:a="http://schemas.openxmlformats.org/drawingml/2006/main">
@@ -3292,7 +3292,7 @@
           </a:p>
           <a:p xmlns:a="http://schemas.openxmlformats.org/drawingml/2006/main">
             <a:r>
-              <a:t>LOCAL STATIC ARTIFACT — production/ACT_5.pptx의 S91와 production/preview/act5/S91.png. Native 도식은 공개 사례 각색/교육용 판단 모델이며 실행 Screenshot이 아니다.</a:t>
+              <a:t>LOCAL STATIC ARTIFACT — production/ACT_5.pptx의 S94와 production/preview/act5/S94.png. Native 도식은 공개 사례 각색/교육용 판단 모델이며 실행 Screenshot이 아니다.</a:t>
             </a:r>
           </a:p>
           <a:p xmlns:a="http://schemas.openxmlformats.org/drawingml/2006/main">
@@ -3377,7 +3377,7 @@
           <a:lstStyle xmlns:a="http://schemas.openxmlformats.org/drawingml/2006/main"/>
           <a:p xmlns:a="http://schemas.openxmlformats.org/drawingml/2006/main">
             <a:r>
-              <a:t>## S92 — 무엇을 남기고, 무엇을 덜어낼까?</a:t>
+              <a:t>## S95 — 무엇을 남기고, 무엇을 덜어낼까?</a:t>
             </a:r>
           </a:p>
           <a:p xmlns:a="http://schemas.openxmlformats.org/drawingml/2006/main">
@@ -3392,7 +3392,7 @@
           </a:p>
           <a:p xmlns:a="http://schemas.openxmlformats.org/drawingml/2006/main">
             <a:r>
-              <a:t>S92</a:t>
+              <a:t>S95</a:t>
             </a:r>
           </a:p>
           <a:p xmlns:a="http://schemas.openxmlformats.org/drawingml/2006/main">
@@ -3497,7 +3497,7 @@
           </a:p>
           <a:p xmlns:a="http://schemas.openxmlformats.org/drawingml/2006/main">
             <a:r>
-              <a:t>1. (0:00–0:25 / Lecture) S91의 조건 변화가 기존 요소의 존재 이유를 재확인하는 계기라고 연결한다. 이 장은 공급사 결과표가 아니라 이 교육의 판단 기준이다.</a:t>
+              <a:t>1. (0:00–0:25 / Lecture) S94의 조건 변화가 기존 요소의 존재 이유를 재확인하는 계기라고 연결한다. 이 장은 공급사 결과표가 아니라 이 교육의 판단 기준이다.</a:t>
             </a:r>
           </a:p>
           <a:p xmlns:a="http://schemas.openxmlformats.org/drawingml/2006/main">
@@ -3507,7 +3507,7 @@
           </a:p>
           <a:p xmlns:a="http://schemas.openxmlformats.org/drawingml/2006/main">
             <a:r>
-              <a:t>3. (1:25–2:00 / Lecture) 통합·제거는 후보이며 아직 품질이 유지됐다는 결과가 없다고 짚는다. 원래 요구를 보존한 채 실제 작업에서 무엇을 확인할지 S93으로 연결한다.</a:t>
+              <a:t>3. (1:25–2:00 / Lecture) 통합·제거는 후보이며 아직 품질이 유지됐다는 결과가 없다고 짚는다. 원래 요구를 보존한 채 실제 작업에서 무엇을 확인할지 S96으로 연결한다.</a:t>
             </a:r>
           </a:p>
           <a:p xmlns:a="http://schemas.openxmlformats.org/drawingml/2006/main">
@@ -3612,7 +3612,7 @@
           </a:p>
           <a:p xmlns:a="http://schemas.openxmlformats.org/drawingml/2006/main">
             <a:r>
-              <a:t>질문은 설명을 여는 수사적 질문이다. 응답·실습·기록·제출을 요구하지 않는다. 개인 선택은 S94/S95에 남긴다.</a:t>
+              <a:t>질문은 설명을 여는 수사적 질문이다. 응답·실습·기록·제출을 요구하지 않는다. 개인 선택은 S97/S98에 남긴다.</a:t>
             </a:r>
           </a:p>
           <a:p xmlns:a="http://schemas.openxmlformats.org/drawingml/2006/main">
@@ -3657,7 +3657,7 @@
           </a:p>
           <a:p xmlns:a="http://schemas.openxmlformats.org/drawingml/2006/main">
             <a:r>
-              <a:t>LOCAL STATIC ARTIFACT — production/ACT_5.pptx의 S92와 production/preview/act5/S92.png. Native 도식은 공개 사례 각색/교육용 판단 모델이며 실행 Screenshot이 아니다.</a:t>
+              <a:t>LOCAL STATIC ARTIFACT — production/ACT_5.pptx의 S95와 production/preview/act5/S95.png. Native 도식은 공개 사례 각색/교육용 판단 모델이며 실행 Screenshot이 아니다.</a:t>
             </a:r>
           </a:p>
           <a:p xmlns:a="http://schemas.openxmlformats.org/drawingml/2006/main">
@@ -3742,7 +3742,7 @@
           <a:lstStyle xmlns:a="http://schemas.openxmlformats.org/drawingml/2006/main"/>
           <a:p xmlns:a="http://schemas.openxmlformats.org/drawingml/2006/main">
             <a:r>
-              <a:t>## S93 — 덜어낸 뒤에도 필요한 일을 하는가?</a:t>
+              <a:t>## S96 — 덜어낸 뒤에도 필요한 일을 하는가?</a:t>
             </a:r>
           </a:p>
           <a:p xmlns:a="http://schemas.openxmlformats.org/drawingml/2006/main">
@@ -3757,7 +3757,7 @@
           </a:p>
           <a:p xmlns:a="http://schemas.openxmlformats.org/drawingml/2006/main">
             <a:r>
-              <a:t>S93</a:t>
+              <a:t>S96</a:t>
             </a:r>
           </a:p>
           <a:p xmlns:a="http://schemas.openxmlformats.org/drawingml/2006/main">
@@ -3862,7 +3862,7 @@
           </a:p>
           <a:p xmlns:a="http://schemas.openxmlformats.org/drawingml/2006/main">
             <a:r>
-              <a:t>1. (0:00–0:25 / Lecture) S92에서 고른 후보가 간단해졌다는 인상만으로 채택되지 않는다고 연결한다. 화면은 평가 설계이며 우리 프로젝트의 새 실행·점수·PASS 결과가 아니다.</a:t>
+              <a:t>1. (0:00–0:25 / Lecture) S95에서 고른 후보가 간단해졌다는 인상만으로 채택되지 않는다고 연결한다. 화면은 평가 설계이며 우리 프로젝트의 새 실행·점수·PASS 결과가 아니다.</a:t>
             </a:r>
           </a:p>
           <a:p xmlns:a="http://schemas.openxmlformats.org/drawingml/2006/main">
@@ -3872,7 +3872,7 @@
           </a:p>
           <a:p xmlns:a="http://schemas.openxmlformats.org/drawingml/2006/main">
             <a:r>
-              <a:t>3. (1:20–2:00 / Lecture) 확인한 범위만 채택하고 나빠지면 기존 구성으로 되돌리며 이유를 남긴다고 닫는다. 검증 기준을 통과했다는 새 주장을 하지 않는다. S94에서 자신의 부족한 기준과 중복 구성을 포함한 문제 하나를 고른다.</a:t>
+              <a:t>3. (1:20–2:00 / Lecture) 확인한 범위만 채택하고 나빠지면 기존 구성으로 되돌리며 이유를 남긴다고 닫는다. 검증 기준을 통과했다는 새 주장을 하지 않는다. S97에서 자신의 부족한 기준과 중복 구성을 포함한 문제 하나를 고른다.</a:t>
             </a:r>
           </a:p>
           <a:p xmlns:a="http://schemas.openxmlformats.org/drawingml/2006/main">
@@ -3977,7 +3977,7 @@
           </a:p>
           <a:p xmlns:a="http://schemas.openxmlformats.org/drawingml/2006/main">
             <a:r>
-              <a:t>질문은 설명을 여는 수사적 질문이다. 응답·실습·기록·제출을 요구하지 않는다. 개인 선택은 S94/S95에 남긴다.</a:t>
+              <a:t>질문은 설명을 여는 수사적 질문이다. 응답·실습·기록·제출을 요구하지 않는다. 개인 선택은 S97/S98에 남긴다.</a:t>
             </a:r>
           </a:p>
           <a:p xmlns:a="http://schemas.openxmlformats.org/drawingml/2006/main">
@@ -4022,7 +4022,7 @@
           </a:p>
           <a:p xmlns:a="http://schemas.openxmlformats.org/drawingml/2006/main">
             <a:r>
-              <a:t>LOCAL STATIC ARTIFACT — production/ACT_5.pptx의 S93와 production/preview/act5/S93.png. Native 도식은 공개 사례 각색/교육용 판단 모델이며 실행 Screenshot이 아니다.</a:t>
+              <a:t>LOCAL STATIC ARTIFACT — production/ACT_5.pptx의 S96와 production/preview/act5/S96.png. Native 도식은 공개 사례 각색/교육용 판단 모델이며 실행 Screenshot이 아니다.</a:t>
             </a:r>
           </a:p>
           <a:p xmlns:a="http://schemas.openxmlformats.org/drawingml/2006/main">
@@ -4107,7 +4107,7 @@
           <a:lstStyle xmlns:a="http://schemas.openxmlformats.org/drawingml/2006/main"/>
           <a:p xmlns:a="http://schemas.openxmlformats.org/drawingml/2006/main">
             <a:r>
-              <a:t>## S94 — 내 업무에서는 무엇이 반복해서 막힐까?</a:t>
+              <a:t>## S97 — 내 업무에서는 무엇이 반복해서 막힐까?</a:t>
             </a:r>
           </a:p>
           <a:p xmlns:a="http://schemas.openxmlformats.org/drawingml/2006/main">
@@ -4122,7 +4122,7 @@
           </a:p>
           <a:p xmlns:a="http://schemas.openxmlformats.org/drawingml/2006/main">
             <a:r>
-              <a:t>S94</a:t>
+              <a:t>S97</a:t>
             </a:r>
           </a:p>
           <a:p xmlns:a="http://schemas.openxmlformats.org/drawingml/2006/main">
@@ -4237,7 +4237,7 @@
           </a:p>
           <a:p xmlns:a="http://schemas.openxmlformats.org/drawingml/2006/main">
             <a:r>
-              <a:t>3. (3:00–5:00 / Transition) 자기 업무와 가까운 문제 하나만 마음속으로 떠올리게 한다. E는 실패가 반복됐으니 무조건 추가·통합·제거하라는 뜻이 아니라 기록·원인·기준을 다시 보는 출발점이다. S95에서 같은 글자의 다음 행동과 확인 근거를 생각하게 한다. 새 분류 이론·Demo를 열지 않는다.</a:t>
+              <a:t>3. (3:00–5:00 / Transition) 자기 업무와 가까운 문제 하나만 마음속으로 떠올리게 한다. E는 실패가 반복됐으니 무조건 추가·통합·제거하라는 뜻이 아니라 기록·원인·기준을 다시 보는 출발점이다. S98에서 같은 글자의 다음 행동과 확인 근거를 생각하게 한다. 새 분류 이론·Demo를 열지 않는다.</a:t>
             </a:r>
           </a:p>
           <a:p xmlns:a="http://schemas.openxmlformats.org/drawingml/2006/main">
@@ -4342,7 +4342,7 @@
           </a:p>
           <a:p xmlns:a="http://schemas.openxmlformats.org/drawingml/2006/main">
             <a:r>
-              <a:t>청중의 선택 발표·투표·실습·제출을 요구하지 않는다. 고른 문제의 A–E를 마음속에 남기고 S95의 같은 글자로 이어간다.</a:t>
+              <a:t>청중의 선택 발표·투표·실습·제출을 요구하지 않는다. 고른 문제의 A–E를 마음속에 남기고 S98의 같은 글자로 이어간다.</a:t>
             </a:r>
           </a:p>
           <a:p xmlns:a="http://schemas.openxmlformats.org/drawingml/2006/main">
@@ -4387,7 +4387,7 @@
           </a:p>
           <a:p xmlns:a="http://schemas.openxmlformats.org/drawingml/2006/main">
             <a:r>
-              <a:t>LOCAL STATIC ARTIFACT — production/ACT_5.pptx의 S94와 production/preview/act5/S94.png를 사용한다. 새 실행·원본 실행 캡처로 표현하지 않는다. 현재 화면과 Notes 검토는 production/evaluation/ACT_5_HARNESS_REASSESSMENT.md에 기록한다.</a:t>
+              <a:t>LOCAL STATIC ARTIFACT — production/ACT_5.pptx의 S97와 production/preview/act5/S97.png를 사용한다. 새 실행·원본 실행 캡처로 표현하지 않는다. 현재 화면과 Notes 검토는 production/evaluation/ACT_5_HARNESS_REASSESSMENT.md에 기록한다.</a:t>
             </a:r>
           </a:p>
           <a:p xmlns:a="http://schemas.openxmlformats.org/drawingml/2006/main">
@@ -4449,7 +4449,7 @@
           <p:cNvPr id="3" name="Title">
             <a:extLst xmlns:a="http://schemas.openxmlformats.org/drawingml/2006/main">
               <a:ext uri="{FF2B5EF4-FFF2-40B4-BE49-F238E27FC236}">
-                <a16:creationId xmlns:a16="http://schemas.microsoft.com/office/drawing/2014/main" id="{3EDE3247-4637-450A-B565-4A266C5C0B5C}"/>
+                <a16:creationId xmlns:a16="http://schemas.microsoft.com/office/drawing/2014/main" id="{82444FA3-45CF-4D1D-9014-F5BD0D6A00CF}"/>
               </a:ext>
             </a:extLst>
           </p:cNvPr>
@@ -4678,7 +4678,7 @@
           <p:cNvPr id="2" name="Subtitle">
             <a:extLst xmlns:a="http://schemas.openxmlformats.org/drawingml/2006/main">
               <a:ext uri="{FF2B5EF4-FFF2-40B4-BE49-F238E27FC236}">
-                <a16:creationId xmlns:a16="http://schemas.microsoft.com/office/drawing/2014/main" id="{3E16AB64-7394-4B35-8CF3-EC00252E783A}"/>
+                <a16:creationId xmlns:a16="http://schemas.microsoft.com/office/drawing/2014/main" id="{7658BA6E-D790-404D-B4B8-61EE13BC97DE}"/>
               </a:ext>
             </a:extLst>
           </p:cNvPr>
@@ -4924,7 +4924,7 @@
           <p:cNvPr id="2" name="Section title">
             <a:extLst xmlns:a="http://schemas.openxmlformats.org/drawingml/2006/main">
               <a:ext uri="{FF2B5EF4-FFF2-40B4-BE49-F238E27FC236}">
-                <a16:creationId xmlns:a16="http://schemas.microsoft.com/office/drawing/2014/main" id="{4CB37C7D-B32A-401C-A451-06D3960B3B55}"/>
+                <a16:creationId xmlns:a16="http://schemas.microsoft.com/office/drawing/2014/main" id="{5281AE49-2395-43BF-ACB9-FB107ADFFAFD}"/>
               </a:ext>
             </a:extLst>
           </p:cNvPr>
@@ -5170,7 +5170,7 @@
           <p:cNvPr id="3" name="Title">
             <a:extLst xmlns:a="http://schemas.openxmlformats.org/drawingml/2006/main">
               <a:ext uri="{FF2B5EF4-FFF2-40B4-BE49-F238E27FC236}">
-                <a16:creationId xmlns:a16="http://schemas.microsoft.com/office/drawing/2014/main" id="{D41E7EC7-DCCF-4FC9-8334-A993ACA1F9D4}"/>
+                <a16:creationId xmlns:a16="http://schemas.microsoft.com/office/drawing/2014/main" id="{918A1E5D-FF6D-4CB6-96BA-E7366580F3D4}"/>
               </a:ext>
             </a:extLst>
           </p:cNvPr>
@@ -5399,7 +5399,7 @@
           <p:cNvPr id="2" name="Body">
             <a:extLst xmlns:a="http://schemas.openxmlformats.org/drawingml/2006/main">
               <a:ext uri="{FF2B5EF4-FFF2-40B4-BE49-F238E27FC236}">
-                <a16:creationId xmlns:a16="http://schemas.microsoft.com/office/drawing/2014/main" id="{FA938B71-743A-45ED-8C81-7EAFAEFE3A89}"/>
+                <a16:creationId xmlns:a16="http://schemas.microsoft.com/office/drawing/2014/main" id="{D84B2AFF-D390-4BF0-818E-209E5F741388}"/>
               </a:ext>
             </a:extLst>
           </p:cNvPr>
@@ -5645,7 +5645,7 @@
           <p:cNvPr id="4" name="Title">
             <a:extLst xmlns:a="http://schemas.openxmlformats.org/drawingml/2006/main">
               <a:ext uri="{FF2B5EF4-FFF2-40B4-BE49-F238E27FC236}">
-                <a16:creationId xmlns:a16="http://schemas.microsoft.com/office/drawing/2014/main" id="{2255E8BC-CB4E-4B18-BD5E-7BCE39D14703}"/>
+                <a16:creationId xmlns:a16="http://schemas.microsoft.com/office/drawing/2014/main" id="{770D279D-3E1D-4C57-BA61-305E4B339691}"/>
               </a:ext>
             </a:extLst>
           </p:cNvPr>
@@ -5874,7 +5874,7 @@
           <p:cNvPr id="2" name="Left column">
             <a:extLst xmlns:a="http://schemas.openxmlformats.org/drawingml/2006/main">
               <a:ext uri="{FF2B5EF4-FFF2-40B4-BE49-F238E27FC236}">
-                <a16:creationId xmlns:a16="http://schemas.microsoft.com/office/drawing/2014/main" id="{2BF06BBC-928D-404D-958A-60B97C1423C4}"/>
+                <a16:creationId xmlns:a16="http://schemas.microsoft.com/office/drawing/2014/main" id="{EAE92323-F328-41F7-BAB2-1F33B5874B00}"/>
               </a:ext>
             </a:extLst>
           </p:cNvPr>
@@ -6103,7 +6103,7 @@
           <p:cNvPr id="3" name="Right column">
             <a:extLst xmlns:a="http://schemas.openxmlformats.org/drawingml/2006/main">
               <a:ext uri="{FF2B5EF4-FFF2-40B4-BE49-F238E27FC236}">
-                <a16:creationId xmlns:a16="http://schemas.microsoft.com/office/drawing/2014/main" id="{6F04E055-1D4E-4AC3-8FC5-9D11ED2AA125}"/>
+                <a16:creationId xmlns:a16="http://schemas.microsoft.com/office/drawing/2014/main" id="{434C33FA-81D8-4882-ACFB-DEDDFB0088E8}"/>
               </a:ext>
             </a:extLst>
           </p:cNvPr>
@@ -6349,7 +6349,7 @@
           <p:cNvPr id="3" name="Title">
             <a:extLst xmlns:a="http://schemas.openxmlformats.org/drawingml/2006/main">
               <a:ext uri="{FF2B5EF4-FFF2-40B4-BE49-F238E27FC236}">
-                <a16:creationId xmlns:a16="http://schemas.microsoft.com/office/drawing/2014/main" id="{8A1C0F6B-C76F-4D2F-B55A-B95347E9F75E}"/>
+                <a16:creationId xmlns:a16="http://schemas.microsoft.com/office/drawing/2014/main" id="{931DA757-59B3-4D9D-9385-60B26B355205}"/>
               </a:ext>
             </a:extLst>
           </p:cNvPr>
@@ -6578,7 +6578,7 @@
           <p:cNvPr id="2" name="Left column">
             <a:extLst xmlns:a="http://schemas.openxmlformats.org/drawingml/2006/main">
               <a:ext uri="{FF2B5EF4-FFF2-40B4-BE49-F238E27FC236}">
-                <a16:creationId xmlns:a16="http://schemas.microsoft.com/office/drawing/2014/main" id="{B9699E53-5872-4CBC-A5C6-130782D74575}"/>
+                <a16:creationId xmlns:a16="http://schemas.microsoft.com/office/drawing/2014/main" id="{BA4F34AB-C69C-4CD1-B7A7-92D39C317082}"/>
               </a:ext>
             </a:extLst>
           </p:cNvPr>
@@ -6845,12 +6845,12 @@
   </p:cSld>
   <p:clrMap bg1="lt1" tx1="dk1" bg2="lt2" tx2="dk2" accent1="accent1" accent2="accent2" accent3="accent3" accent4="accent4" accent5="accent5" accent6="accent6" hlink="hlink" folHlink="folHlink"/>
   <p:sldLayoutIdLst>
-    <p:sldLayoutId xmlns:r="http://schemas.openxmlformats.org/officeDocument/2006/relationships" id="2147483649" r:id="Rf9dd3190fdbe4f2c"/>
-    <p:sldLayoutId xmlns:r="http://schemas.openxmlformats.org/officeDocument/2006/relationships" id="2147483650" r:id="R6acb33e126634c29"/>
-    <p:sldLayoutId xmlns:r="http://schemas.openxmlformats.org/officeDocument/2006/relationships" id="2147483651" r:id="Re62994b593244017"/>
-    <p:sldLayoutId xmlns:r="http://schemas.openxmlformats.org/officeDocument/2006/relationships" id="2147483652" r:id="R651e66a949d840d0"/>
-    <p:sldLayoutId xmlns:r="http://schemas.openxmlformats.org/officeDocument/2006/relationships" id="2147483653" r:id="R0010c14802304d1e"/>
-    <p:sldLayoutId xmlns:r="http://schemas.openxmlformats.org/officeDocument/2006/relationships" id="2147483654" r:id="R3957ae64dc7043fc"/>
+    <p:sldLayoutId xmlns:r="http://schemas.openxmlformats.org/officeDocument/2006/relationships" id="2147483649" r:id="R0f13622d8fa74dab"/>
+    <p:sldLayoutId xmlns:r="http://schemas.openxmlformats.org/officeDocument/2006/relationships" id="2147483650" r:id="R7234f95e224449b1"/>
+    <p:sldLayoutId xmlns:r="http://schemas.openxmlformats.org/officeDocument/2006/relationships" id="2147483651" r:id="Ra2fd60dd8d3d4b92"/>
+    <p:sldLayoutId xmlns:r="http://schemas.openxmlformats.org/officeDocument/2006/relationships" id="2147483652" r:id="Re3f7ebbdd5bd4fc8"/>
+    <p:sldLayoutId xmlns:r="http://schemas.openxmlformats.org/officeDocument/2006/relationships" id="2147483653" r:id="R5afbf7571c634c27"/>
+    <p:sldLayoutId xmlns:r="http://schemas.openxmlformats.org/officeDocument/2006/relationships" id="2147483654" r:id="Ra51f3a81b1c24dd7"/>
   </p:sldLayoutIdLst>
   <p:txStyles>
     <p:titleStyle>
@@ -7401,7 +7401,7 @@
           <p:cNvPr id="34" name="ACT 5 · 전체 여정 회수">
             <a:extLst xmlns:a="http://schemas.openxmlformats.org/drawingml/2006/main">
               <a:ext uri="{FF2B5EF4-FFF2-40B4-BE49-F238E27FC236}">
-                <a16:creationId xmlns:a16="http://schemas.microsoft.com/office/drawing/2014/main" id="{0D28F1B7-B19B-45B2-B367-67D985DE7223}"/>
+                <a16:creationId xmlns:a16="http://schemas.microsoft.com/office/drawing/2014/main" id="{FE381C6A-A1F0-4D44-BBD6-2A345345655C}"/>
               </a:ext>
             </a:extLst>
           </p:cNvPr>
@@ -7556,10 +7556,10 @@
       </p:sp>
       <p:sp>
         <p:nvSpPr>
-          <p:cNvPr id="2" name="S86">
+          <p:cNvPr id="2" name="S89">
             <a:extLst xmlns:a="http://schemas.openxmlformats.org/drawingml/2006/main">
               <a:ext uri="{FF2B5EF4-FFF2-40B4-BE49-F238E27FC236}">
-                <a16:creationId xmlns:a16="http://schemas.microsoft.com/office/drawing/2014/main" id="{D14369C3-603B-404C-9D02-1CB4FD6A9E5B}"/>
+                <a16:creationId xmlns:a16="http://schemas.microsoft.com/office/drawing/2014/main" id="{371C1EBC-ADD4-4C74-B85A-0301AE99074C}"/>
               </a:ext>
             </a:extLst>
           </p:cNvPr>
@@ -7707,7 +7707,7 @@
                 <a:ea typeface="Malgun Gothic"/>
                 <a:cs typeface="Malgun Gothic"/>
               </a:rPr>
-              <a:t>S86</a:t>
+              <a:t>S89</a:t>
             </a:r>
           </a:p>
         </p:txBody>
@@ -7717,7 +7717,7 @@
           <p:cNvPr id="3" name="문제에 맞춰, 일하는 방식을 넓혔다">
             <a:extLst xmlns:a="http://schemas.openxmlformats.org/drawingml/2006/main">
               <a:ext uri="{FF2B5EF4-FFF2-40B4-BE49-F238E27FC236}">
-                <a16:creationId xmlns:a16="http://schemas.microsoft.com/office/drawing/2014/main" id="{E266302E-1E90-4150-8959-462BDEE30298}"/>
+                <a16:creationId xmlns:a16="http://schemas.microsoft.com/office/drawing/2014/main" id="{C008490E-AD44-4641-8A17-4294FA0FD029}"/>
               </a:ext>
             </a:extLst>
           </p:cNvPr>
@@ -7875,7 +7875,7 @@
           <p:cNvPr id="4" name="">
             <a:extLst xmlns:a="http://schemas.openxmlformats.org/drawingml/2006/main">
               <a:ext uri="{FF2B5EF4-FFF2-40B4-BE49-F238E27FC236}">
-                <a16:creationId xmlns:a16="http://schemas.microsoft.com/office/drawing/2014/main" id="{C54A6767-D4C3-47D1-B631-67587743C810}"/>
+                <a16:creationId xmlns:a16="http://schemas.microsoft.com/office/drawing/2014/main" id="{05CED6D5-F022-4D82-B7CA-5842EF0FFAA6}"/>
               </a:ext>
             </a:extLst>
           </p:cNvPr>
@@ -7906,7 +7906,7 @@
           <p:cNvPr id="5" name="BEAT-060 · 이 교육의 문제 중심 진화 모델">
             <a:extLst xmlns:a="http://schemas.openxmlformats.org/drawingml/2006/main">
               <a:ext uri="{FF2B5EF4-FFF2-40B4-BE49-F238E27FC236}">
-                <a16:creationId xmlns:a16="http://schemas.microsoft.com/office/drawing/2014/main" id="{1D171FC1-6D33-4364-BE8E-EAE62E88E267}"/>
+                <a16:creationId xmlns:a16="http://schemas.microsoft.com/office/drawing/2014/main" id="{515B972B-C45E-48F0-AFCB-3BA9C8EFB5C5}"/>
               </a:ext>
             </a:extLst>
           </p:cNvPr>
@@ -8064,7 +8064,7 @@
           <p:cNvPr id="6" name="앞의 방식을 버리거나, 모든 프로젝트가 같은 순서로 발전해야 한다는 뜻은 아니다.">
             <a:extLst xmlns:a="http://schemas.openxmlformats.org/drawingml/2006/main">
               <a:ext uri="{FF2B5EF4-FFF2-40B4-BE49-F238E27FC236}">
-                <a16:creationId xmlns:a16="http://schemas.microsoft.com/office/drawing/2014/main" id="{6FDD06AC-3EB7-4087-917D-52FAAD0E2057}"/>
+                <a16:creationId xmlns:a16="http://schemas.microsoft.com/office/drawing/2014/main" id="{5BF12785-44C0-4525-B53A-87AC3C1CB414}"/>
               </a:ext>
             </a:extLst>
           </p:cNvPr>
@@ -8222,7 +8222,7 @@
           <p:cNvPr id="7" name="필요한 대응을 더하며, 여기까지 왔다">
             <a:extLst xmlns:a="http://schemas.openxmlformats.org/drawingml/2006/main">
               <a:ext uri="{FF2B5EF4-FFF2-40B4-BE49-F238E27FC236}">
-                <a16:creationId xmlns:a16="http://schemas.microsoft.com/office/drawing/2014/main" id="{A0BC1CE5-55A6-492F-8B86-33B11D2A4ED0}"/>
+                <a16:creationId xmlns:a16="http://schemas.microsoft.com/office/drawing/2014/main" id="{F30FB798-B344-4FCC-9DE3-1CBA4F6F8C67}"/>
               </a:ext>
             </a:extLst>
           </p:cNvPr>
@@ -8380,7 +8380,7 @@
           <p:cNvPr id="8" name="답을 구하던 출발점">
             <a:extLst xmlns:a="http://schemas.openxmlformats.org/drawingml/2006/main">
               <a:ext uri="{FF2B5EF4-FFF2-40B4-BE49-F238E27FC236}">
-                <a16:creationId xmlns:a16="http://schemas.microsoft.com/office/drawing/2014/main" id="{89849717-F2B9-40B0-AA2A-F61BC3EB82E0}"/>
+                <a16:creationId xmlns:a16="http://schemas.microsoft.com/office/drawing/2014/main" id="{0605A82D-5702-469E-B59F-1395A75F8B83}"/>
               </a:ext>
             </a:extLst>
           </p:cNvPr>
@@ -8538,7 +8538,7 @@
           <p:cNvPr id="9" name="">
             <a:extLst xmlns:a="http://schemas.openxmlformats.org/drawingml/2006/main">
               <a:ext uri="{FF2B5EF4-FFF2-40B4-BE49-F238E27FC236}">
-                <a16:creationId xmlns:a16="http://schemas.microsoft.com/office/drawing/2014/main" id="{48F6616D-455F-4437-BF99-1F18FF666215}"/>
+                <a16:creationId xmlns:a16="http://schemas.microsoft.com/office/drawing/2014/main" id="{125359CD-FB6E-4878-B174-37B1BDC6D7A7}"/>
               </a:ext>
             </a:extLst>
           </p:cNvPr>
@@ -8569,7 +8569,7 @@
           <p:cNvPr id="10" name="Chatbot">
             <a:extLst xmlns:a="http://schemas.openxmlformats.org/drawingml/2006/main">
               <a:ext uri="{FF2B5EF4-FFF2-40B4-BE49-F238E27FC236}">
-                <a16:creationId xmlns:a16="http://schemas.microsoft.com/office/drawing/2014/main" id="{971F2D89-3AFA-462C-A5BD-B4834D79D7AB}"/>
+                <a16:creationId xmlns:a16="http://schemas.microsoft.com/office/drawing/2014/main" id="{4D29AD83-7C1B-4295-9FCE-89887224D5D8}"/>
               </a:ext>
             </a:extLst>
           </p:cNvPr>
@@ -8727,7 +8727,7 @@
           <p:cNvPr id="11" name="질문하고&#10;답을 받는다">
             <a:extLst xmlns:a="http://schemas.openxmlformats.org/drawingml/2006/main">
               <a:ext uri="{FF2B5EF4-FFF2-40B4-BE49-F238E27FC236}">
-                <a16:creationId xmlns:a16="http://schemas.microsoft.com/office/drawing/2014/main" id="{EEBE0A77-5F8F-4EFA-9E4D-2BC3D33A027D}"/>
+                <a16:creationId xmlns:a16="http://schemas.microsoft.com/office/drawing/2014/main" id="{78C18230-A9FF-47E8-A981-7AD8C9FFF0CE}"/>
               </a:ext>
             </a:extLst>
           </p:cNvPr>
@@ -8908,7 +8908,7 @@
           <p:cNvPr id="12" name="">
             <a:extLst xmlns:a="http://schemas.openxmlformats.org/drawingml/2006/main">
               <a:ext uri="{FF2B5EF4-FFF2-40B4-BE49-F238E27FC236}">
-                <a16:creationId xmlns:a16="http://schemas.microsoft.com/office/drawing/2014/main" id="{ED5EA339-2D75-4845-A961-C03B7CAB66A0}"/>
+                <a16:creationId xmlns:a16="http://schemas.microsoft.com/office/drawing/2014/main" id="{A6D4B6C3-7D26-43B7-A5F7-388F094A1FB7}"/>
               </a:ext>
             </a:extLst>
           </p:cNvPr>
@@ -8936,7 +8936,7 @@
           <p:cNvPr id="13" name="요청이 모호하면">
             <a:extLst xmlns:a="http://schemas.openxmlformats.org/drawingml/2006/main">
               <a:ext uri="{FF2B5EF4-FFF2-40B4-BE49-F238E27FC236}">
-                <a16:creationId xmlns:a16="http://schemas.microsoft.com/office/drawing/2014/main" id="{A7A48DCA-8EC7-4415-8708-6E42C0C2CE6B}"/>
+                <a16:creationId xmlns:a16="http://schemas.microsoft.com/office/drawing/2014/main" id="{F7DC3EB1-7AA8-4747-8F69-60E0E4A27D69}"/>
               </a:ext>
             </a:extLst>
           </p:cNvPr>
@@ -9094,7 +9094,7 @@
           <p:cNvPr id="14" name="">
             <a:extLst xmlns:a="http://schemas.openxmlformats.org/drawingml/2006/main">
               <a:ext uri="{FF2B5EF4-FFF2-40B4-BE49-F238E27FC236}">
-                <a16:creationId xmlns:a16="http://schemas.microsoft.com/office/drawing/2014/main" id="{C560EC80-D464-4DF1-8AEC-BC01120FA6FA}"/>
+                <a16:creationId xmlns:a16="http://schemas.microsoft.com/office/drawing/2014/main" id="{82548FD9-49FF-4746-BF10-1ECB1BAB4A42}"/>
               </a:ext>
             </a:extLst>
           </p:cNvPr>
@@ -9125,7 +9125,7 @@
           <p:cNvPr id="15" name="Prompt">
             <a:extLst xmlns:a="http://schemas.openxmlformats.org/drawingml/2006/main">
               <a:ext uri="{FF2B5EF4-FFF2-40B4-BE49-F238E27FC236}">
-                <a16:creationId xmlns:a16="http://schemas.microsoft.com/office/drawing/2014/main" id="{1AF20849-7232-4866-9279-385BD8BA6C2C}"/>
+                <a16:creationId xmlns:a16="http://schemas.microsoft.com/office/drawing/2014/main" id="{249771EC-F5EA-4DAA-80B3-D5D55C3708D0}"/>
               </a:ext>
             </a:extLst>
           </p:cNvPr>
@@ -9283,7 +9283,7 @@
           <p:cNvPr id="16" name="이번 작업을&#10;구체화한다">
             <a:extLst xmlns:a="http://schemas.openxmlformats.org/drawingml/2006/main">
               <a:ext uri="{FF2B5EF4-FFF2-40B4-BE49-F238E27FC236}">
-                <a16:creationId xmlns:a16="http://schemas.microsoft.com/office/drawing/2014/main" id="{BC030753-3A56-40B5-A7C1-F9FBA7CA63F0}"/>
+                <a16:creationId xmlns:a16="http://schemas.microsoft.com/office/drawing/2014/main" id="{E7BAD15C-72C1-4D67-A404-9158FE957503}"/>
               </a:ext>
             </a:extLst>
           </p:cNvPr>
@@ -9464,7 +9464,7 @@
           <p:cNvPr id="17" name="">
             <a:extLst xmlns:a="http://schemas.openxmlformats.org/drawingml/2006/main">
               <a:ext uri="{FF2B5EF4-FFF2-40B4-BE49-F238E27FC236}">
-                <a16:creationId xmlns:a16="http://schemas.microsoft.com/office/drawing/2014/main" id="{8BD997E9-B56A-48FF-8B5A-FFCC3ED868EB}"/>
+                <a16:creationId xmlns:a16="http://schemas.microsoft.com/office/drawing/2014/main" id="{562A8722-E706-4821-B3D0-D96D640061FC}"/>
               </a:ext>
             </a:extLst>
           </p:cNvPr>
@@ -9492,7 +9492,7 @@
           <p:cNvPr id="18" name="설명을 반복하면">
             <a:extLst xmlns:a="http://schemas.openxmlformats.org/drawingml/2006/main">
               <a:ext uri="{FF2B5EF4-FFF2-40B4-BE49-F238E27FC236}">
-                <a16:creationId xmlns:a16="http://schemas.microsoft.com/office/drawing/2014/main" id="{DB351E86-0B1D-4925-B747-68CD32EF7A6C}"/>
+                <a16:creationId xmlns:a16="http://schemas.microsoft.com/office/drawing/2014/main" id="{2D8317E2-1409-4215-B4E6-DF97CEFCC203}"/>
               </a:ext>
             </a:extLst>
           </p:cNvPr>
@@ -9650,7 +9650,7 @@
           <p:cNvPr id="19" name="">
             <a:extLst xmlns:a="http://schemas.openxmlformats.org/drawingml/2006/main">
               <a:ext uri="{FF2B5EF4-FFF2-40B4-BE49-F238E27FC236}">
-                <a16:creationId xmlns:a16="http://schemas.microsoft.com/office/drawing/2014/main" id="{F26CC5E9-1343-4280-BA6E-271F1DACCDAC}"/>
+                <a16:creationId xmlns:a16="http://schemas.microsoft.com/office/drawing/2014/main" id="{CF132057-AA5C-441F-9C93-5A969B143494}"/>
               </a:ext>
             </a:extLst>
           </p:cNvPr>
@@ -9681,7 +9681,7 @@
           <p:cNvPr id="20" name="Context">
             <a:extLst xmlns:a="http://schemas.openxmlformats.org/drawingml/2006/main">
               <a:ext uri="{FF2B5EF4-FFF2-40B4-BE49-F238E27FC236}">
-                <a16:creationId xmlns:a16="http://schemas.microsoft.com/office/drawing/2014/main" id="{67EC7911-C7FF-4D4B-93BF-9F76173231BC}"/>
+                <a16:creationId xmlns:a16="http://schemas.microsoft.com/office/drawing/2014/main" id="{8EC8E107-0114-4E07-9AAE-83B9E802D41A}"/>
               </a:ext>
             </a:extLst>
           </p:cNvPr>
@@ -9839,7 +9839,7 @@
           <p:cNvPr id="21" name="프로젝트 지식의&#10;출처를 둔다">
             <a:extLst xmlns:a="http://schemas.openxmlformats.org/drawingml/2006/main">
               <a:ext uri="{FF2B5EF4-FFF2-40B4-BE49-F238E27FC236}">
-                <a16:creationId xmlns:a16="http://schemas.microsoft.com/office/drawing/2014/main" id="{56119425-5B7F-47A5-922F-FEB587A77AA8}"/>
+                <a16:creationId xmlns:a16="http://schemas.microsoft.com/office/drawing/2014/main" id="{466D96F2-3755-488A-ACE0-ED5EF48B7B4A}"/>
               </a:ext>
             </a:extLst>
           </p:cNvPr>
@@ -10020,7 +10020,7 @@
           <p:cNvPr id="22" name="">
             <a:extLst xmlns:a="http://schemas.openxmlformats.org/drawingml/2006/main">
               <a:ext uri="{FF2B5EF4-FFF2-40B4-BE49-F238E27FC236}">
-                <a16:creationId xmlns:a16="http://schemas.microsoft.com/office/drawing/2014/main" id="{C6CBC21C-4190-462C-9AAD-36D73642A100}"/>
+                <a16:creationId xmlns:a16="http://schemas.microsoft.com/office/drawing/2014/main" id="{3A725148-F71F-40A4-A58B-DD15E4D38AED}"/>
               </a:ext>
             </a:extLst>
           </p:cNvPr>
@@ -10048,7 +10048,7 @@
           <p:cNvPr id="23" name="절차를 반복하면">
             <a:extLst xmlns:a="http://schemas.openxmlformats.org/drawingml/2006/main">
               <a:ext uri="{FF2B5EF4-FFF2-40B4-BE49-F238E27FC236}">
-                <a16:creationId xmlns:a16="http://schemas.microsoft.com/office/drawing/2014/main" id="{22FCC14C-C004-4352-8FC4-4B080B331DB7}"/>
+                <a16:creationId xmlns:a16="http://schemas.microsoft.com/office/drawing/2014/main" id="{6A872098-EC68-4EBB-B75E-726AC1A1C1FF}"/>
               </a:ext>
             </a:extLst>
           </p:cNvPr>
@@ -10206,7 +10206,7 @@
           <p:cNvPr id="24" name="">
             <a:extLst xmlns:a="http://schemas.openxmlformats.org/drawingml/2006/main">
               <a:ext uri="{FF2B5EF4-FFF2-40B4-BE49-F238E27FC236}">
-                <a16:creationId xmlns:a16="http://schemas.microsoft.com/office/drawing/2014/main" id="{9D3189DA-F0DC-4954-997A-AF1B4F03B54D}"/>
+                <a16:creationId xmlns:a16="http://schemas.microsoft.com/office/drawing/2014/main" id="{B1FAB1E8-5F52-41F3-89F2-0CDBE479F524}"/>
               </a:ext>
             </a:extLst>
           </p:cNvPr>
@@ -10237,7 +10237,7 @@
           <p:cNvPr id="25" name="Harness">
             <a:extLst xmlns:a="http://schemas.openxmlformats.org/drawingml/2006/main">
               <a:ext uri="{FF2B5EF4-FFF2-40B4-BE49-F238E27FC236}">
-                <a16:creationId xmlns:a16="http://schemas.microsoft.com/office/drawing/2014/main" id="{D3B55508-5DE9-4EEE-92E5-A18B8D8CBE1C}"/>
+                <a16:creationId xmlns:a16="http://schemas.microsoft.com/office/drawing/2014/main" id="{86E275C2-8899-4E14-9FAF-36D2FD276DE6}"/>
               </a:ext>
             </a:extLst>
           </p:cNvPr>
@@ -10395,7 +10395,7 @@
           <p:cNvPr id="26" name="일하는 환경을&#10;설계한다">
             <a:extLst xmlns:a="http://schemas.openxmlformats.org/drawingml/2006/main">
               <a:ext uri="{FF2B5EF4-FFF2-40B4-BE49-F238E27FC236}">
-                <a16:creationId xmlns:a16="http://schemas.microsoft.com/office/drawing/2014/main" id="{CED9E044-887D-4327-BD25-599719D086A7}"/>
+                <a16:creationId xmlns:a16="http://schemas.microsoft.com/office/drawing/2014/main" id="{CD711FF6-C20A-4531-878E-DE707F382B75}"/>
               </a:ext>
             </a:extLst>
           </p:cNvPr>
@@ -10576,7 +10576,7 @@
           <p:cNvPr id="27" name="">
             <a:extLst xmlns:a="http://schemas.openxmlformats.org/drawingml/2006/main">
               <a:ext uri="{FF2B5EF4-FFF2-40B4-BE49-F238E27FC236}">
-                <a16:creationId xmlns:a16="http://schemas.microsoft.com/office/drawing/2014/main" id="{204813B9-EFFF-4EEA-B4A3-94D1AA2B7043}"/>
+                <a16:creationId xmlns:a16="http://schemas.microsoft.com/office/drawing/2014/main" id="{F5BEC520-2B88-4B94-A1C9-859356A82633}"/>
               </a:ext>
             </a:extLst>
           </p:cNvPr>
@@ -10604,7 +10604,7 @@
           <p:cNvPr id="28" name="조건이 달라지면">
             <a:extLst xmlns:a="http://schemas.openxmlformats.org/drawingml/2006/main">
               <a:ext uri="{FF2B5EF4-FFF2-40B4-BE49-F238E27FC236}">
-                <a16:creationId xmlns:a16="http://schemas.microsoft.com/office/drawing/2014/main" id="{6471052A-36E7-4D25-AB7F-2E27715A9B8B}"/>
+                <a16:creationId xmlns:a16="http://schemas.microsoft.com/office/drawing/2014/main" id="{0642FB4A-EC1F-4B9C-A11B-660FACB35C84}"/>
               </a:ext>
             </a:extLst>
           </p:cNvPr>
@@ -10762,7 +10762,7 @@
           <p:cNvPr id="29" name="">
             <a:extLst xmlns:a="http://schemas.openxmlformats.org/drawingml/2006/main">
               <a:ext uri="{FF2B5EF4-FFF2-40B4-BE49-F238E27FC236}">
-                <a16:creationId xmlns:a16="http://schemas.microsoft.com/office/drawing/2014/main" id="{6E982761-B7CA-4665-96FA-C377432A34DB}"/>
+                <a16:creationId xmlns:a16="http://schemas.microsoft.com/office/drawing/2014/main" id="{D1424D84-21F6-4FC6-95C5-66CC7C340630}"/>
               </a:ext>
             </a:extLst>
           </p:cNvPr>
@@ -10793,7 +10793,7 @@
           <p:cNvPr id="30" name="Loop">
             <a:extLst xmlns:a="http://schemas.openxmlformats.org/drawingml/2006/main">
               <a:ext uri="{FF2B5EF4-FFF2-40B4-BE49-F238E27FC236}">
-                <a16:creationId xmlns:a16="http://schemas.microsoft.com/office/drawing/2014/main" id="{6A71BF13-3800-40E2-A196-BB730B1B5933}"/>
+                <a16:creationId xmlns:a16="http://schemas.microsoft.com/office/drawing/2014/main" id="{E7EC2A10-3292-4B3A-9572-D7D07B611793}"/>
               </a:ext>
             </a:extLst>
           </p:cNvPr>
@@ -10951,7 +10951,7 @@
           <p:cNvPr id="31" name="근거를 확인해&#10;시스템을 고친다">
             <a:extLst xmlns:a="http://schemas.openxmlformats.org/drawingml/2006/main">
               <a:ext uri="{FF2B5EF4-FFF2-40B4-BE49-F238E27FC236}">
-                <a16:creationId xmlns:a16="http://schemas.microsoft.com/office/drawing/2014/main" id="{E3E18890-A004-4458-8622-A2B328E9FCDE}"/>
+                <a16:creationId xmlns:a16="http://schemas.microsoft.com/office/drawing/2014/main" id="{4D55BFF5-F1B7-4243-8DD1-BA5D27E5A82F}"/>
               </a:ext>
             </a:extLst>
           </p:cNvPr>
@@ -11132,7 +11132,7 @@
           <p:cNvPr id="32" name="문제에 따라 더해진 대응이지, 기능을 모두 갖추는 순서는 아니다">
             <a:extLst xmlns:a="http://schemas.openxmlformats.org/drawingml/2006/main">
               <a:ext uri="{FF2B5EF4-FFF2-40B4-BE49-F238E27FC236}">
-                <a16:creationId xmlns:a16="http://schemas.microsoft.com/office/drawing/2014/main" id="{4E5F94E8-57EA-4CF5-8846-751ABCF37EDA}"/>
+                <a16:creationId xmlns:a16="http://schemas.microsoft.com/office/drawing/2014/main" id="{D5BFEFF0-891D-485B-A41B-304AEAFA9F23}"/>
               </a:ext>
             </a:extLst>
           </p:cNvPr>
@@ -11290,7 +11290,7 @@
           <p:cNvPr id="33" name="Legacy module connection">
             <a:extLst xmlns:a="http://schemas.openxmlformats.org/drawingml/2006/main">
               <a:ext uri="{FF2B5EF4-FFF2-40B4-BE49-F238E27FC236}">
-                <a16:creationId xmlns:a16="http://schemas.microsoft.com/office/drawing/2014/main" id="{D52D490A-94E5-499D-8B4F-CB8F3059B88D}"/>
+                <a16:creationId xmlns:a16="http://schemas.microsoft.com/office/drawing/2014/main" id="{BF76AA57-8A41-414D-8676-F888BF5E1D14}"/>
               </a:ext>
             </a:extLst>
           </p:cNvPr>
@@ -11446,7 +11446,7 @@
     </p:spTree>
     <p:extLst>
       <p:ext uri="{BB962C8B-B14F-4D97-AF65-F5344CB8AC3E}">
-        <p14:creationId xmlns:p14="http://schemas.microsoft.com/office/powerpoint/2010/main" val="1706450471"/>
+        <p14:creationId xmlns:p14="http://schemas.microsoft.com/office/powerpoint/2010/main" val="725493305"/>
       </p:ext>
     </p:extLst>
   </p:cSld>
@@ -11477,7 +11477,7 @@
           <p:cNvPr id="32" name="ACT 5 · 개인 성찰 / 같은 글자로 이어 보기">
             <a:extLst xmlns:a="http://schemas.openxmlformats.org/drawingml/2006/main">
               <a:ext uri="{FF2B5EF4-FFF2-40B4-BE49-F238E27FC236}">
-                <a16:creationId xmlns:a16="http://schemas.microsoft.com/office/drawing/2014/main" id="{C37A2365-B56D-4C40-9AA0-D20F6AB422DA}"/>
+                <a16:creationId xmlns:a16="http://schemas.microsoft.com/office/drawing/2014/main" id="{DE3FCFFD-BB58-4591-8506-D683CB757A91}"/>
               </a:ext>
             </a:extLst>
           </p:cNvPr>
@@ -11632,10 +11632,10 @@
       </p:sp>
       <p:sp>
         <p:nvSpPr>
-          <p:cNvPr id="2" name="S95">
+          <p:cNvPr id="2" name="S98">
             <a:extLst xmlns:a="http://schemas.openxmlformats.org/drawingml/2006/main">
               <a:ext uri="{FF2B5EF4-FFF2-40B4-BE49-F238E27FC236}">
-                <a16:creationId xmlns:a16="http://schemas.microsoft.com/office/drawing/2014/main" id="{22CD6DF4-5174-4050-BC7E-AF7F9476A4EC}"/>
+                <a16:creationId xmlns:a16="http://schemas.microsoft.com/office/drawing/2014/main" id="{A0E70C68-4EC0-4367-A51F-CD5800BC1A77}"/>
               </a:ext>
             </a:extLst>
           </p:cNvPr>
@@ -11783,7 +11783,7 @@
                 <a:ea typeface="Malgun Gothic"/>
                 <a:cs typeface="Malgun Gothic"/>
               </a:rPr>
-              <a:t>S95</a:t>
+              <a:t>S98</a:t>
             </a:r>
           </a:p>
         </p:txBody>
@@ -11793,7 +11793,7 @@
           <p:cNvPr id="3" name="고른 문제에서, 다음 행동 하나로">
             <a:extLst xmlns:a="http://schemas.openxmlformats.org/drawingml/2006/main">
               <a:ext uri="{FF2B5EF4-FFF2-40B4-BE49-F238E27FC236}">
-                <a16:creationId xmlns:a16="http://schemas.microsoft.com/office/drawing/2014/main" id="{7B12FF14-7986-4A11-971D-68469A5ADF0A}"/>
+                <a16:creationId xmlns:a16="http://schemas.microsoft.com/office/drawing/2014/main" id="{79CDAE8E-0F00-4992-A752-BF1888D3694E}"/>
               </a:ext>
             </a:extLst>
           </p:cNvPr>
@@ -11951,7 +11951,7 @@
           <p:cNvPr id="4" name="">
             <a:extLst xmlns:a="http://schemas.openxmlformats.org/drawingml/2006/main">
               <a:ext uri="{FF2B5EF4-FFF2-40B4-BE49-F238E27FC236}">
-                <a16:creationId xmlns:a16="http://schemas.microsoft.com/office/drawing/2014/main" id="{C27C8BF2-F54B-49C3-8F08-7FF8DBA1FA8C}"/>
+                <a16:creationId xmlns:a16="http://schemas.microsoft.com/office/drawing/2014/main" id="{0FEFB467-4BDB-494A-BD1A-7FB06C5B3E98}"/>
               </a:ext>
             </a:extLst>
           </p:cNvPr>
@@ -11982,7 +11982,7 @@
           <p:cNvPr id="5" name="BEAT-070–071 · 다음 행동과 확인 근거를 떠올리는 개인 성찰">
             <a:extLst xmlns:a="http://schemas.openxmlformats.org/drawingml/2006/main">
               <a:ext uri="{FF2B5EF4-FFF2-40B4-BE49-F238E27FC236}">
-                <a16:creationId xmlns:a16="http://schemas.microsoft.com/office/drawing/2014/main" id="{F863A35C-CED3-4F88-9938-A3FD64C7A890}"/>
+                <a16:creationId xmlns:a16="http://schemas.microsoft.com/office/drawing/2014/main" id="{795EE859-23CC-4624-A25E-E269C3B88107}"/>
               </a:ext>
             </a:extLst>
           </p:cNvPr>
@@ -12140,7 +12140,7 @@
           <p:cNvPr id="6" name="마음속으로 떠올리는 시간 · 기록·발표·제출·실천 약속은 요구하지 않음">
             <a:extLst xmlns:a="http://schemas.openxmlformats.org/drawingml/2006/main">
               <a:ext uri="{FF2B5EF4-FFF2-40B4-BE49-F238E27FC236}">
-                <a16:creationId xmlns:a16="http://schemas.microsoft.com/office/drawing/2014/main" id="{AB4A9A38-E582-4A10-9939-437DC2EBD869}"/>
+                <a16:creationId xmlns:a16="http://schemas.microsoft.com/office/drawing/2014/main" id="{AAE7D76B-FF82-4AF1-AD57-D25F0E229782}"/>
               </a:ext>
             </a:extLst>
           </p:cNvPr>
@@ -12298,7 +12298,7 @@
           <p:cNvPr id="7" name="방금 고른 A–E에서, 다음 작업의 작은 행동 하나만">
             <a:extLst xmlns:a="http://schemas.openxmlformats.org/drawingml/2006/main">
               <a:ext uri="{FF2B5EF4-FFF2-40B4-BE49-F238E27FC236}">
-                <a16:creationId xmlns:a16="http://schemas.microsoft.com/office/drawing/2014/main" id="{B159BE6C-E44E-45FB-B01A-16B2CDA2DB85}"/>
+                <a16:creationId xmlns:a16="http://schemas.microsoft.com/office/drawing/2014/main" id="{4478113A-13AC-4A89-81EE-5ECCA8E4487A}"/>
               </a:ext>
             </a:extLst>
           </p:cNvPr>
@@ -12456,7 +12456,7 @@
           <p:cNvPr id="8" name="">
             <a:extLst xmlns:a="http://schemas.openxmlformats.org/drawingml/2006/main">
               <a:ext uri="{FF2B5EF4-FFF2-40B4-BE49-F238E27FC236}">
-                <a16:creationId xmlns:a16="http://schemas.microsoft.com/office/drawing/2014/main" id="{96D88CA2-7E6A-4E2D-B220-606295C41089}"/>
+                <a16:creationId xmlns:a16="http://schemas.microsoft.com/office/drawing/2014/main" id="{4AAB0313-401B-4EA5-A1E6-36FE1A780F3E}"/>
               </a:ext>
             </a:extLst>
           </p:cNvPr>
@@ -12487,7 +12487,7 @@
           <p:cNvPr id="9" name="">
             <a:extLst xmlns:a="http://schemas.openxmlformats.org/drawingml/2006/main">
               <a:ext uri="{FF2B5EF4-FFF2-40B4-BE49-F238E27FC236}">
-                <a16:creationId xmlns:a16="http://schemas.microsoft.com/office/drawing/2014/main" id="{29E8AE1F-18A3-4C44-BA02-AF7AB9B98A0A}"/>
+                <a16:creationId xmlns:a16="http://schemas.microsoft.com/office/drawing/2014/main" id="{AF0B2B96-295B-40CA-8ACE-FE0BCCA2AA83}"/>
               </a:ext>
             </a:extLst>
           </p:cNvPr>
@@ -12518,7 +12518,7 @@
           <p:cNvPr id="10" name="A">
             <a:extLst xmlns:a="http://schemas.openxmlformats.org/drawingml/2006/main">
               <a:ext uri="{FF2B5EF4-FFF2-40B4-BE49-F238E27FC236}">
-                <a16:creationId xmlns:a16="http://schemas.microsoft.com/office/drawing/2014/main" id="{5D63EE89-8D57-4401-B101-59D683C12FE6}"/>
+                <a16:creationId xmlns:a16="http://schemas.microsoft.com/office/drawing/2014/main" id="{F9A35229-5352-46A2-A30A-1C5FDEB7639C}"/>
               </a:ext>
             </a:extLst>
           </p:cNvPr>
@@ -12676,7 +12676,7 @@
           <p:cNvPr id="11" name="목표·변경 범위를 요청에 적어 본다">
             <a:extLst xmlns:a="http://schemas.openxmlformats.org/drawingml/2006/main">
               <a:ext uri="{FF2B5EF4-FFF2-40B4-BE49-F238E27FC236}">
-                <a16:creationId xmlns:a16="http://schemas.microsoft.com/office/drawing/2014/main" id="{A2BE9C9C-4BD6-410A-BD81-C1BAB846EA0C}"/>
+                <a16:creationId xmlns:a16="http://schemas.microsoft.com/office/drawing/2014/main" id="{49B1D942-EE31-49F3-8B41-539301B4607D}"/>
               </a:ext>
             </a:extLst>
           </p:cNvPr>
@@ -12834,7 +12834,7 @@
           <p:cNvPr id="12" name="">
             <a:extLst xmlns:a="http://schemas.openxmlformats.org/drawingml/2006/main">
               <a:ext uri="{FF2B5EF4-FFF2-40B4-BE49-F238E27FC236}">
-                <a16:creationId xmlns:a16="http://schemas.microsoft.com/office/drawing/2014/main" id="{066C7BFC-F68E-4C81-9749-7D613C07B1FB}"/>
+                <a16:creationId xmlns:a16="http://schemas.microsoft.com/office/drawing/2014/main" id="{1AFE61D1-1FFB-423E-B95A-1F372A424AC6}"/>
               </a:ext>
             </a:extLst>
           </p:cNvPr>
@@ -12865,7 +12865,7 @@
           <p:cNvPr id="13" name="">
             <a:extLst xmlns:a="http://schemas.openxmlformats.org/drawingml/2006/main">
               <a:ext uri="{FF2B5EF4-FFF2-40B4-BE49-F238E27FC236}">
-                <a16:creationId xmlns:a16="http://schemas.microsoft.com/office/drawing/2014/main" id="{27FC0410-3AC2-4E2C-ACAD-85D58E3389E9}"/>
+                <a16:creationId xmlns:a16="http://schemas.microsoft.com/office/drawing/2014/main" id="{8860E9B8-2937-4A00-8C7A-CD5F215EAA69}"/>
               </a:ext>
             </a:extLst>
           </p:cNvPr>
@@ -12896,7 +12896,7 @@
           <p:cNvPr id="14" name="B">
             <a:extLst xmlns:a="http://schemas.openxmlformats.org/drawingml/2006/main">
               <a:ext uri="{FF2B5EF4-FFF2-40B4-BE49-F238E27FC236}">
-                <a16:creationId xmlns:a16="http://schemas.microsoft.com/office/drawing/2014/main" id="{4118330F-A22D-4C4E-939E-640E4CBB5CD7}"/>
+                <a16:creationId xmlns:a16="http://schemas.microsoft.com/office/drawing/2014/main" id="{87E8ECC0-90B2-4B48-B9C5-C942A946B941}"/>
               </a:ext>
             </a:extLst>
           </p:cNvPr>
@@ -13054,7 +13054,7 @@
           <p:cNvPr id="15" name="출처·검토자를 정하고 중복 지침을 합친다">
             <a:extLst xmlns:a="http://schemas.openxmlformats.org/drawingml/2006/main">
               <a:ext uri="{FF2B5EF4-FFF2-40B4-BE49-F238E27FC236}">
-                <a16:creationId xmlns:a16="http://schemas.microsoft.com/office/drawing/2014/main" id="{77CEA6D0-F75F-4E38-B532-D9FC1BD56BAA}"/>
+                <a16:creationId xmlns:a16="http://schemas.microsoft.com/office/drawing/2014/main" id="{103B629B-0025-4F2B-8219-577A2FF5A808}"/>
               </a:ext>
             </a:extLst>
           </p:cNvPr>
@@ -13212,7 +13212,7 @@
           <p:cNvPr id="16" name="">
             <a:extLst xmlns:a="http://schemas.openxmlformats.org/drawingml/2006/main">
               <a:ext uri="{FF2B5EF4-FFF2-40B4-BE49-F238E27FC236}">
-                <a16:creationId xmlns:a16="http://schemas.microsoft.com/office/drawing/2014/main" id="{52BB6342-5B28-4276-A915-C2209CF8F34F}"/>
+                <a16:creationId xmlns:a16="http://schemas.microsoft.com/office/drawing/2014/main" id="{CFE08AD9-D5B1-43F2-AED1-0FA7AC90E0DE}"/>
               </a:ext>
             </a:extLst>
           </p:cNvPr>
@@ -13243,7 +13243,7 @@
           <p:cNvPr id="17" name="">
             <a:extLst xmlns:a="http://schemas.openxmlformats.org/drawingml/2006/main">
               <a:ext uri="{FF2B5EF4-FFF2-40B4-BE49-F238E27FC236}">
-                <a16:creationId xmlns:a16="http://schemas.microsoft.com/office/drawing/2014/main" id="{4C8E2E95-6168-4AA3-B442-716B22D5FA5F}"/>
+                <a16:creationId xmlns:a16="http://schemas.microsoft.com/office/drawing/2014/main" id="{C3455C1F-C57E-4DC5-A882-6DA32E1C38A5}"/>
               </a:ext>
             </a:extLst>
           </p:cNvPr>
@@ -13274,7 +13274,7 @@
           <p:cNvPr id="18" name="C">
             <a:extLst xmlns:a="http://schemas.openxmlformats.org/drawingml/2006/main">
               <a:ext uri="{FF2B5EF4-FFF2-40B4-BE49-F238E27FC236}">
-                <a16:creationId xmlns:a16="http://schemas.microsoft.com/office/drawing/2014/main" id="{3C9EF3CC-76F4-4B3E-B6E5-127E78D13BFF}"/>
+                <a16:creationId xmlns:a16="http://schemas.microsoft.com/office/drawing/2014/main" id="{4B146916-4055-4854-B64E-068F2C5EFE33}"/>
               </a:ext>
             </a:extLst>
           </p:cNvPr>
@@ -13432,7 +13432,7 @@
           <p:cNvPr id="19" name="절차·역할의 통합·제거 후보를 고른다">
             <a:extLst xmlns:a="http://schemas.openxmlformats.org/drawingml/2006/main">
               <a:ext uri="{FF2B5EF4-FFF2-40B4-BE49-F238E27FC236}">
-                <a16:creationId xmlns:a16="http://schemas.microsoft.com/office/drawing/2014/main" id="{ADDC1449-CE23-4539-8A74-F0918D40A3EC}"/>
+                <a16:creationId xmlns:a16="http://schemas.microsoft.com/office/drawing/2014/main" id="{1ECF8934-453C-4CF6-B56E-F99D7209B6B8}"/>
               </a:ext>
             </a:extLst>
           </p:cNvPr>
@@ -13590,7 +13590,7 @@
           <p:cNvPr id="20" name="">
             <a:extLst xmlns:a="http://schemas.openxmlformats.org/drawingml/2006/main">
               <a:ext uri="{FF2B5EF4-FFF2-40B4-BE49-F238E27FC236}">
-                <a16:creationId xmlns:a16="http://schemas.microsoft.com/office/drawing/2014/main" id="{321D779A-1C2E-4063-A25F-34F492ED1E4D}"/>
+                <a16:creationId xmlns:a16="http://schemas.microsoft.com/office/drawing/2014/main" id="{73E453F5-45D7-46EF-A940-0F7EB10A240A}"/>
               </a:ext>
             </a:extLst>
           </p:cNvPr>
@@ -13621,7 +13621,7 @@
           <p:cNvPr id="21" name="">
             <a:extLst xmlns:a="http://schemas.openxmlformats.org/drawingml/2006/main">
               <a:ext uri="{FF2B5EF4-FFF2-40B4-BE49-F238E27FC236}">
-                <a16:creationId xmlns:a16="http://schemas.microsoft.com/office/drawing/2014/main" id="{49DE42A3-9CBD-4D67-A527-84B918AD05DF}"/>
+                <a16:creationId xmlns:a16="http://schemas.microsoft.com/office/drawing/2014/main" id="{A5CE974D-F965-4F2C-A004-2FFBFA6FAFC9}"/>
               </a:ext>
             </a:extLst>
           </p:cNvPr>
@@ -13652,7 +13652,7 @@
           <p:cNvPr id="22" name="D">
             <a:extLst xmlns:a="http://schemas.openxmlformats.org/drawingml/2006/main">
               <a:ext uri="{FF2B5EF4-FFF2-40B4-BE49-F238E27FC236}">
-                <a16:creationId xmlns:a16="http://schemas.microsoft.com/office/drawing/2014/main" id="{639FBA41-7C9F-40A7-91D1-FBA5A2A03B1A}"/>
+                <a16:creationId xmlns:a16="http://schemas.microsoft.com/office/drawing/2014/main" id="{3290FC49-4341-4915-97CF-AA471C191644}"/>
               </a:ext>
             </a:extLst>
           </p:cNvPr>
@@ -13810,7 +13810,7 @@
           <p:cNvPr id="23" name="완료 판단에 필요한 검사를 정해 본다">
             <a:extLst xmlns:a="http://schemas.openxmlformats.org/drawingml/2006/main">
               <a:ext uri="{FF2B5EF4-FFF2-40B4-BE49-F238E27FC236}">
-                <a16:creationId xmlns:a16="http://schemas.microsoft.com/office/drawing/2014/main" id="{EF214E92-A988-4803-B868-1FBCFA87A1F4}"/>
+                <a16:creationId xmlns:a16="http://schemas.microsoft.com/office/drawing/2014/main" id="{C8E9AA84-C0BE-407F-B9C1-F274829B58FB}"/>
               </a:ext>
             </a:extLst>
           </p:cNvPr>
@@ -13968,7 +13968,7 @@
           <p:cNvPr id="24" name="">
             <a:extLst xmlns:a="http://schemas.openxmlformats.org/drawingml/2006/main">
               <a:ext uri="{FF2B5EF4-FFF2-40B4-BE49-F238E27FC236}">
-                <a16:creationId xmlns:a16="http://schemas.microsoft.com/office/drawing/2014/main" id="{45EF13DF-0868-4C99-8BDD-4F84D3CACD90}"/>
+                <a16:creationId xmlns:a16="http://schemas.microsoft.com/office/drawing/2014/main" id="{B43A6C44-F9CF-4A11-B0A6-662FF5A52161}"/>
               </a:ext>
             </a:extLst>
           </p:cNvPr>
@@ -13999,7 +13999,7 @@
           <p:cNvPr id="25" name="">
             <a:extLst xmlns:a="http://schemas.openxmlformats.org/drawingml/2006/main">
               <a:ext uri="{FF2B5EF4-FFF2-40B4-BE49-F238E27FC236}">
-                <a16:creationId xmlns:a16="http://schemas.microsoft.com/office/drawing/2014/main" id="{E1CE7858-EC0E-476A-ADF0-F8FFB00B484F}"/>
+                <a16:creationId xmlns:a16="http://schemas.microsoft.com/office/drawing/2014/main" id="{66E354DA-C80D-4540-BF5C-0060AF27C2C7}"/>
               </a:ext>
             </a:extLst>
           </p:cNvPr>
@@ -14030,7 +14030,7 @@
           <p:cNvPr id="26" name="E">
             <a:extLst xmlns:a="http://schemas.openxmlformats.org/drawingml/2006/main">
               <a:ext uri="{FF2B5EF4-FFF2-40B4-BE49-F238E27FC236}">
-                <a16:creationId xmlns:a16="http://schemas.microsoft.com/office/drawing/2014/main" id="{F3513F75-7A99-465A-A76A-236A747E4F43}"/>
+                <a16:creationId xmlns:a16="http://schemas.microsoft.com/office/drawing/2014/main" id="{04D1050E-7D4B-4072-97B8-74A7770E5B3B}"/>
               </a:ext>
             </a:extLst>
           </p:cNvPr>
@@ -14188,7 +14188,7 @@
           <p:cNvPr id="27" name="반복 실패의 기록·원인부터 대조한다">
             <a:extLst xmlns:a="http://schemas.openxmlformats.org/drawingml/2006/main">
               <a:ext uri="{FF2B5EF4-FFF2-40B4-BE49-F238E27FC236}">
-                <a16:creationId xmlns:a16="http://schemas.microsoft.com/office/drawing/2014/main" id="{57159BD2-ECF0-4623-9A36-8724C128B5B6}"/>
+                <a16:creationId xmlns:a16="http://schemas.microsoft.com/office/drawing/2014/main" id="{BA2C2C36-EAF4-45C1-96D4-43989E095A73}"/>
               </a:ext>
             </a:extLst>
           </p:cNvPr>
@@ -14346,7 +14346,7 @@
           <p:cNvPr id="28" name="그리고,&#10;확인할 근거 하나">
             <a:extLst xmlns:a="http://schemas.openxmlformats.org/drawingml/2006/main">
               <a:ext uri="{FF2B5EF4-FFF2-40B4-BE49-F238E27FC236}">
-                <a16:creationId xmlns:a16="http://schemas.microsoft.com/office/drawing/2014/main" id="{772C7D00-094C-4E3A-84B1-6E14FDE92D00}"/>
+                <a16:creationId xmlns:a16="http://schemas.microsoft.com/office/drawing/2014/main" id="{85AB18B7-9078-44D9-97C0-EB8C6E7E8D03}"/>
               </a:ext>
             </a:extLst>
           </p:cNvPr>
@@ -14527,7 +14527,7 @@
           <p:cNvPr id="29" name="무엇이 달라졌는지&#10;어떤 기록으로 볼까?">
             <a:extLst xmlns:a="http://schemas.openxmlformats.org/drawingml/2006/main">
               <a:ext uri="{FF2B5EF4-FFF2-40B4-BE49-F238E27FC236}">
-                <a16:creationId xmlns:a16="http://schemas.microsoft.com/office/drawing/2014/main" id="{4C4660BD-2234-4C7C-B32A-016340CD62AC}"/>
+                <a16:creationId xmlns:a16="http://schemas.microsoft.com/office/drawing/2014/main" id="{446A7B10-9184-48B4-9023-FD620D8F50A8}"/>
               </a:ext>
             </a:extLst>
           </p:cNvPr>
@@ -14708,7 +14708,7 @@
           <p:cNvPr id="30" name="출처·검토·갱신 책임도 함께">
             <a:extLst xmlns:a="http://schemas.openxmlformats.org/drawingml/2006/main">
               <a:ext uri="{FF2B5EF4-FFF2-40B4-BE49-F238E27FC236}">
-                <a16:creationId xmlns:a16="http://schemas.microsoft.com/office/drawing/2014/main" id="{93C81ABB-BCDB-49CE-A6BE-9DC78686DD69}"/>
+                <a16:creationId xmlns:a16="http://schemas.microsoft.com/office/drawing/2014/main" id="{FB150E4C-A4E5-4972-AF2E-DFBA81EECC6A}"/>
               </a:ext>
             </a:extLst>
           </p:cNvPr>
@@ -14866,7 +14866,7 @@
           <p:cNvPr id="31" name="Legacy module connection">
             <a:extLst xmlns:a="http://schemas.openxmlformats.org/drawingml/2006/main">
               <a:ext uri="{FF2B5EF4-FFF2-40B4-BE49-F238E27FC236}">
-                <a16:creationId xmlns:a16="http://schemas.microsoft.com/office/drawing/2014/main" id="{394610F8-8A1B-4091-A418-F19882CEDD75}"/>
+                <a16:creationId xmlns:a16="http://schemas.microsoft.com/office/drawing/2014/main" id="{AB943D2B-9031-4856-A38B-C693268419A7}"/>
               </a:ext>
             </a:extLst>
           </p:cNvPr>
@@ -15022,7 +15022,7 @@
     </p:spTree>
     <p:extLst>
       <p:ext uri="{BB962C8B-B14F-4D97-AF65-F5344CB8AC3E}">
-        <p14:creationId xmlns:p14="http://schemas.microsoft.com/office/powerpoint/2010/main" val="219351112"/>
+        <p14:creationId xmlns:p14="http://schemas.microsoft.com/office/powerpoint/2010/main" val="192048566"/>
       </p:ext>
     </p:extLst>
   </p:cSld>
@@ -15053,7 +15053,7 @@
           <p:cNvPr id="12" name="ACT 5 · 남은 질문과 마지막 한 문장">
             <a:extLst xmlns:a="http://schemas.openxmlformats.org/drawingml/2006/main">
               <a:ext uri="{FF2B5EF4-FFF2-40B4-BE49-F238E27FC236}">
-                <a16:creationId xmlns:a16="http://schemas.microsoft.com/office/drawing/2014/main" id="{54CA0BFD-5832-44BE-B5ED-0D633EE34692}"/>
+                <a16:creationId xmlns:a16="http://schemas.microsoft.com/office/drawing/2014/main" id="{018F7610-7355-4BEF-A86E-942327CE579A}"/>
               </a:ext>
             </a:extLst>
           </p:cNvPr>
@@ -15208,10 +15208,10 @@
       </p:sp>
       <p:sp>
         <p:nvSpPr>
-          <p:cNvPr id="2" name="S96">
+          <p:cNvPr id="2" name="S99">
             <a:extLst xmlns:a="http://schemas.openxmlformats.org/drawingml/2006/main">
               <a:ext uri="{FF2B5EF4-FFF2-40B4-BE49-F238E27FC236}">
-                <a16:creationId xmlns:a16="http://schemas.microsoft.com/office/drawing/2014/main" id="{96DED278-3292-4AC8-A155-C31ACD00FEA7}"/>
+                <a16:creationId xmlns:a16="http://schemas.microsoft.com/office/drawing/2014/main" id="{8697E4CD-6F60-424C-9452-FF3322708E93}"/>
               </a:ext>
             </a:extLst>
           </p:cNvPr>
@@ -15359,7 +15359,7 @@
                 <a:ea typeface="Malgun Gothic"/>
                 <a:cs typeface="Malgun Gothic"/>
               </a:rPr>
-              <a:t>S96</a:t>
+              <a:t>S99</a:t>
             </a:r>
           </a:p>
         </p:txBody>
@@ -15369,7 +15369,7 @@
           <p:cNvPr id="3" name="Q&amp;A와 교육 마무리">
             <a:extLst xmlns:a="http://schemas.openxmlformats.org/drawingml/2006/main">
               <a:ext uri="{FF2B5EF4-FFF2-40B4-BE49-F238E27FC236}">
-                <a16:creationId xmlns:a16="http://schemas.microsoft.com/office/drawing/2014/main" id="{C6889F06-5E9F-4D9E-9D84-3589097CF6B6}"/>
+                <a16:creationId xmlns:a16="http://schemas.microsoft.com/office/drawing/2014/main" id="{E1A3297D-D5EE-4B60-AA0F-92882F57C8BF}"/>
               </a:ext>
             </a:extLst>
           </p:cNvPr>
@@ -15527,7 +15527,7 @@
           <p:cNvPr id="4" name="">
             <a:extLst xmlns:a="http://schemas.openxmlformats.org/drawingml/2006/main">
               <a:ext uri="{FF2B5EF4-FFF2-40B4-BE49-F238E27FC236}">
-                <a16:creationId xmlns:a16="http://schemas.microsoft.com/office/drawing/2014/main" id="{4096DAC6-9AC4-48D8-8D72-71F3D4685F27}"/>
+                <a16:creationId xmlns:a16="http://schemas.microsoft.com/office/drawing/2014/main" id="{85727E7F-0E89-446D-B030-5A2C8C43E7B1}"/>
               </a:ext>
             </a:extLst>
           </p:cNvPr>
@@ -15558,7 +15558,7 @@
           <p:cNvPr id="5" name="BEAT-070–071 · 이 교육의 마무리">
             <a:extLst xmlns:a="http://schemas.openxmlformats.org/drawingml/2006/main">
               <a:ext uri="{FF2B5EF4-FFF2-40B4-BE49-F238E27FC236}">
-                <a16:creationId xmlns:a16="http://schemas.microsoft.com/office/drawing/2014/main" id="{42401DDC-D32B-4DEA-A1CB-40C0CE401976}"/>
+                <a16:creationId xmlns:a16="http://schemas.microsoft.com/office/drawing/2014/main" id="{7677B480-94B2-46D3-9354-82222FB5CEAE}"/>
               </a:ext>
             </a:extLst>
           </p:cNvPr>
@@ -15716,7 +15716,7 @@
           <p:cNvPr id="6" name="목표 · 판단 · 검증 · 책임은 개발자에게 남는다.">
             <a:extLst xmlns:a="http://schemas.openxmlformats.org/drawingml/2006/main">
               <a:ext uri="{FF2B5EF4-FFF2-40B4-BE49-F238E27FC236}">
-                <a16:creationId xmlns:a16="http://schemas.microsoft.com/office/drawing/2014/main" id="{6BF0C661-352F-47ED-A68D-1C3E4230772D}"/>
+                <a16:creationId xmlns:a16="http://schemas.microsoft.com/office/drawing/2014/main" id="{AB46E1EA-8E86-492D-9971-5C8CF119574D}"/>
               </a:ext>
             </a:extLst>
           </p:cNvPr>
@@ -15874,7 +15874,7 @@
           <p:cNvPr id="7" name="남은 질문은 무엇인가요?">
             <a:extLst xmlns:a="http://schemas.openxmlformats.org/drawingml/2006/main">
               <a:ext uri="{FF2B5EF4-FFF2-40B4-BE49-F238E27FC236}">
-                <a16:creationId xmlns:a16="http://schemas.microsoft.com/office/drawing/2014/main" id="{AEEC1B0D-8636-400B-ACAC-22AAC009683A}"/>
+                <a16:creationId xmlns:a16="http://schemas.microsoft.com/office/drawing/2014/main" id="{1506D707-A21B-49BB-B841-2056288CF10D}"/>
               </a:ext>
             </a:extLst>
           </p:cNvPr>
@@ -16032,7 +16032,7 @@
           <p:cNvPr id="8" name="">
             <a:extLst xmlns:a="http://schemas.openxmlformats.org/drawingml/2006/main">
               <a:ext uri="{FF2B5EF4-FFF2-40B4-BE49-F238E27FC236}">
-                <a16:creationId xmlns:a16="http://schemas.microsoft.com/office/drawing/2014/main" id="{FC195FDB-DBBC-440E-963C-06668BE3D3A9}"/>
+                <a16:creationId xmlns:a16="http://schemas.microsoft.com/office/drawing/2014/main" id="{28852279-AA85-47AD-92E7-55319DDAE90B}"/>
               </a:ext>
             </a:extLst>
           </p:cNvPr>
@@ -16063,7 +16063,7 @@
           <p:cNvPr id="9" name="AI가 잘 일할 환경을&#10;설계한다.">
             <a:extLst xmlns:a="http://schemas.openxmlformats.org/drawingml/2006/main">
               <a:ext uri="{FF2B5EF4-FFF2-40B4-BE49-F238E27FC236}">
-                <a16:creationId xmlns:a16="http://schemas.microsoft.com/office/drawing/2014/main" id="{2EAA797D-0E9A-434F-A46A-B8C3778C37EE}"/>
+                <a16:creationId xmlns:a16="http://schemas.microsoft.com/office/drawing/2014/main" id="{0134B1C5-AB3F-4BDF-BF1B-BB6B230A9218}"/>
               </a:ext>
             </a:extLst>
           </p:cNvPr>
@@ -16244,7 +16244,7 @@
           <p:cNvPr id="10" name="Chatbot  →  Prompt  →  Context  →  Harness  →  Loop">
             <a:extLst xmlns:a="http://schemas.openxmlformats.org/drawingml/2006/main">
               <a:ext uri="{FF2B5EF4-FFF2-40B4-BE49-F238E27FC236}">
-                <a16:creationId xmlns:a16="http://schemas.microsoft.com/office/drawing/2014/main" id="{30417B14-C4B3-4D36-9E75-DFD9EB377D7C}"/>
+                <a16:creationId xmlns:a16="http://schemas.microsoft.com/office/drawing/2014/main" id="{313791DC-57FD-4C26-9583-683AA340E26F}"/>
               </a:ext>
             </a:extLst>
           </p:cNvPr>
@@ -16402,7 +16402,7 @@
           <p:cNvPr id="11" name="Legacy module connection">
             <a:extLst xmlns:a="http://schemas.openxmlformats.org/drawingml/2006/main">
               <a:ext uri="{FF2B5EF4-FFF2-40B4-BE49-F238E27FC236}">
-                <a16:creationId xmlns:a16="http://schemas.microsoft.com/office/drawing/2014/main" id="{66605FE6-148D-44D2-A447-61E3A2926FBD}"/>
+                <a16:creationId xmlns:a16="http://schemas.microsoft.com/office/drawing/2014/main" id="{3D06BD5E-7EBE-4AA7-AE8C-54601AA2BF58}"/>
               </a:ext>
             </a:extLst>
           </p:cNvPr>
@@ -16558,7 +16558,7 @@
     </p:spTree>
     <p:extLst>
       <p:ext uri="{BB962C8B-B14F-4D97-AF65-F5344CB8AC3E}">
-        <p14:creationId xmlns:p14="http://schemas.microsoft.com/office/powerpoint/2010/main" val="1488106834"/>
+        <p14:creationId xmlns:p14="http://schemas.microsoft.com/office/powerpoint/2010/main" val="348916961"/>
       </p:ext>
     </p:extLst>
   </p:cSld>
@@ -16589,7 +16589,7 @@
           <p:cNvPr id="27" name="ACT 5 · OBSERVED PRODUCT / 제품 저장소의 변경 이력">
             <a:extLst xmlns:a="http://schemas.openxmlformats.org/drawingml/2006/main">
               <a:ext uri="{FF2B5EF4-FFF2-40B4-BE49-F238E27FC236}">
-                <a16:creationId xmlns:a16="http://schemas.microsoft.com/office/drawing/2014/main" id="{9F9B686F-87FD-4AF5-8E1B-01C37A53C3D1}"/>
+                <a16:creationId xmlns:a16="http://schemas.microsoft.com/office/drawing/2014/main" id="{4E5B8956-0B3B-45B9-8FAF-41CA9357725F}"/>
               </a:ext>
             </a:extLst>
           </p:cNvPr>
@@ -16744,10 +16744,10 @@
       </p:sp>
       <p:sp>
         <p:nvSpPr>
-          <p:cNvPr id="2" name="S87">
+          <p:cNvPr id="2" name="S90">
             <a:extLst xmlns:a="http://schemas.openxmlformats.org/drawingml/2006/main">
               <a:ext uri="{FF2B5EF4-FFF2-40B4-BE49-F238E27FC236}">
-                <a16:creationId xmlns:a16="http://schemas.microsoft.com/office/drawing/2014/main" id="{3BC26BF8-17EC-4685-83E0-DC9B2C612404}"/>
+                <a16:creationId xmlns:a16="http://schemas.microsoft.com/office/drawing/2014/main" id="{5007DE23-29AF-4F0A-B005-07198ADC7C56}"/>
               </a:ext>
             </a:extLst>
           </p:cNvPr>
@@ -16895,7 +16895,7 @@
                 <a:ea typeface="Malgun Gothic"/>
                 <a:cs typeface="Malgun Gothic"/>
               </a:rPr>
-              <a:t>S87</a:t>
+              <a:t>S90</a:t>
             </a:r>
           </a:p>
         </p:txBody>
@@ -16905,7 +16905,7 @@
           <p:cNvPr id="3" name="실제 Demo는 문제에 맞춰 바뀌었다">
             <a:extLst xmlns:a="http://schemas.openxmlformats.org/drawingml/2006/main">
               <a:ext uri="{FF2B5EF4-FFF2-40B4-BE49-F238E27FC236}">
-                <a16:creationId xmlns:a16="http://schemas.microsoft.com/office/drawing/2014/main" id="{EFECC252-A8E1-4AE3-BD53-BE7DE5DBB207}"/>
+                <a16:creationId xmlns:a16="http://schemas.microsoft.com/office/drawing/2014/main" id="{E482CB98-6B67-41FF-A2CA-4B12971BDDBC}"/>
               </a:ext>
             </a:extLst>
           </p:cNvPr>
@@ -17063,7 +17063,7 @@
           <p:cNvPr id="4" name="">
             <a:extLst xmlns:a="http://schemas.openxmlformats.org/drawingml/2006/main">
               <a:ext uri="{FF2B5EF4-FFF2-40B4-BE49-F238E27FC236}">
-                <a16:creationId xmlns:a16="http://schemas.microsoft.com/office/drawing/2014/main" id="{725447A7-7F59-47D7-905F-26626A7C39AE}"/>
+                <a16:creationId xmlns:a16="http://schemas.microsoft.com/office/drawing/2014/main" id="{BFECBCD9-15C8-46DB-9050-7C1FCBF398E0}"/>
               </a:ext>
             </a:extLst>
           </p:cNvPr>
@@ -17094,7 +17094,7 @@
           <p:cNvPr id="5" name="DEMO-12 · 실제 Git State 이력 · TRIAL-002 / TRIAL-005 / STATE-04">
             <a:extLst xmlns:a="http://schemas.openxmlformats.org/drawingml/2006/main">
               <a:ext uri="{FF2B5EF4-FFF2-40B4-BE49-F238E27FC236}">
-                <a16:creationId xmlns:a16="http://schemas.microsoft.com/office/drawing/2014/main" id="{25057508-FF44-408C-803B-911EA283BFB5}"/>
+                <a16:creationId xmlns:a16="http://schemas.microsoft.com/office/drawing/2014/main" id="{000A5E55-1D3B-4F37-A0E2-A44FAD40E85D}"/>
               </a:ext>
             </a:extLst>
           </p:cNvPr>
@@ -17252,7 +17252,7 @@
           <p:cNvPr id="6" name="기록을 요약한 도식 · State는 성숙도 등급이 아님 · 성능은 해당 코드·입력·환경 범위">
             <a:extLst xmlns:a="http://schemas.openxmlformats.org/drawingml/2006/main">
               <a:ext uri="{FF2B5EF4-FFF2-40B4-BE49-F238E27FC236}">
-                <a16:creationId xmlns:a16="http://schemas.microsoft.com/office/drawing/2014/main" id="{395512D0-8348-4519-B482-C776AA627D09}"/>
+                <a16:creationId xmlns:a16="http://schemas.microsoft.com/office/drawing/2014/main" id="{0333E3E3-A254-46DF-99D0-99B0F509D80F}"/>
               </a:ext>
             </a:extLst>
           </p:cNvPr>
@@ -17410,7 +17410,7 @@
           <p:cNvPr id="7" name="전체 교육 모델 중, 제품 저장소에서 확인한 변화만">
             <a:extLst xmlns:a="http://schemas.openxmlformats.org/drawingml/2006/main">
               <a:ext uri="{FF2B5EF4-FFF2-40B4-BE49-F238E27FC236}">
-                <a16:creationId xmlns:a16="http://schemas.microsoft.com/office/drawing/2014/main" id="{B8895B83-2930-419F-85D2-F6EFA0FABF8D}"/>
+                <a16:creationId xmlns:a16="http://schemas.microsoft.com/office/drawing/2014/main" id="{5089927C-2484-405A-ACD4-F14CC01E7EA8}"/>
               </a:ext>
             </a:extLst>
           </p:cNvPr>
@@ -17568,7 +17568,7 @@
           <p:cNvPr id="8" name="마주친 문제">
             <a:extLst xmlns:a="http://schemas.openxmlformats.org/drawingml/2006/main">
               <a:ext uri="{FF2B5EF4-FFF2-40B4-BE49-F238E27FC236}">
-                <a16:creationId xmlns:a16="http://schemas.microsoft.com/office/drawing/2014/main" id="{60050EC3-7572-4A43-A2DB-960A8EA29EAB}"/>
+                <a16:creationId xmlns:a16="http://schemas.microsoft.com/office/drawing/2014/main" id="{1B98A7BF-96DB-48AA-8B5E-00257072F8CD}"/>
               </a:ext>
             </a:extLst>
           </p:cNvPr>
@@ -17726,7 +17726,7 @@
           <p:cNvPr id="9" name="실제로 바꾼 것">
             <a:extLst xmlns:a="http://schemas.openxmlformats.org/drawingml/2006/main">
               <a:ext uri="{FF2B5EF4-FFF2-40B4-BE49-F238E27FC236}">
-                <a16:creationId xmlns:a16="http://schemas.microsoft.com/office/drawing/2014/main" id="{B73C90D1-43B0-49DC-8580-700209163E94}"/>
+                <a16:creationId xmlns:a16="http://schemas.microsoft.com/office/drawing/2014/main" id="{850205D3-EA36-4D23-A09C-2F47ABBBDE7A}"/>
               </a:ext>
             </a:extLst>
           </p:cNvPr>
@@ -17884,7 +17884,7 @@
           <p:cNvPr id="10" name="">
             <a:extLst xmlns:a="http://schemas.openxmlformats.org/drawingml/2006/main">
               <a:ext uri="{FF2B5EF4-FFF2-40B4-BE49-F238E27FC236}">
-                <a16:creationId xmlns:a16="http://schemas.microsoft.com/office/drawing/2014/main" id="{E0C44533-D16A-4483-BCC1-231DD1840D15}"/>
+                <a16:creationId xmlns:a16="http://schemas.microsoft.com/office/drawing/2014/main" id="{33E07B11-DEAE-40F7-868D-E72EFA903D1D}"/>
               </a:ext>
             </a:extLst>
           </p:cNvPr>
@@ -17915,7 +17915,7 @@
           <p:cNvPr id="11" name="crop 경계 오류">
             <a:extLst xmlns:a="http://schemas.openxmlformats.org/drawingml/2006/main">
               <a:ext uri="{FF2B5EF4-FFF2-40B4-BE49-F238E27FC236}">
-                <a16:creationId xmlns:a16="http://schemas.microsoft.com/office/drawing/2014/main" id="{5BC7209C-D9FE-4EC1-8598-0A46B5960D14}"/>
+                <a16:creationId xmlns:a16="http://schemas.microsoft.com/office/drawing/2014/main" id="{E26D2525-2E69-4754-82F6-CA716580A31D}"/>
               </a:ext>
             </a:extLst>
           </p:cNvPr>
@@ -18073,7 +18073,7 @@
           <p:cNvPr id="12" name="">
             <a:extLst xmlns:a="http://schemas.openxmlformats.org/drawingml/2006/main">
               <a:ext uri="{FF2B5EF4-FFF2-40B4-BE49-F238E27FC236}">
-                <a16:creationId xmlns:a16="http://schemas.microsoft.com/office/drawing/2014/main" id="{119A973D-48B1-4279-8B13-4FCB974124F6}"/>
+                <a16:creationId xmlns:a16="http://schemas.microsoft.com/office/drawing/2014/main" id="{38E2D12D-9444-4F80-80DD-E66566F55C68}"/>
               </a:ext>
             </a:extLst>
           </p:cNvPr>
@@ -18101,7 +18101,7 @@
           <p:cNvPr id="13" name="끝 좌표 제외 명세에 맞춰 구현 수정">
             <a:extLst xmlns:a="http://schemas.openxmlformats.org/drawingml/2006/main">
               <a:ext uri="{FF2B5EF4-FFF2-40B4-BE49-F238E27FC236}">
-                <a16:creationId xmlns:a16="http://schemas.microsoft.com/office/drawing/2014/main" id="{0F596471-C0D1-4AE1-B16E-457070E717F9}"/>
+                <a16:creationId xmlns:a16="http://schemas.microsoft.com/office/drawing/2014/main" id="{2E130B45-65A3-4BF4-B122-D9BD4D3B462D}"/>
               </a:ext>
             </a:extLst>
           </p:cNvPr>
@@ -18259,7 +18259,7 @@
           <p:cNvPr id="14" name="STATE-00  →  STATE-00-FIXED">
             <a:extLst xmlns:a="http://schemas.openxmlformats.org/drawingml/2006/main">
               <a:ext uri="{FF2B5EF4-FFF2-40B4-BE49-F238E27FC236}">
-                <a16:creationId xmlns:a16="http://schemas.microsoft.com/office/drawing/2014/main" id="{023A1A1A-340F-4FE7-979C-AABF7F98A576}"/>
+                <a16:creationId xmlns:a16="http://schemas.microsoft.com/office/drawing/2014/main" id="{50ED75CA-9223-48FF-811E-7B8825DB2855}"/>
               </a:ext>
             </a:extLst>
           </p:cNvPr>
@@ -18417,7 +18417,7 @@
           <p:cNvPr id="15" name="">
             <a:extLst xmlns:a="http://schemas.openxmlformats.org/drawingml/2006/main">
               <a:ext uri="{FF2B5EF4-FFF2-40B4-BE49-F238E27FC236}">
-                <a16:creationId xmlns:a16="http://schemas.microsoft.com/office/drawing/2014/main" id="{45DFC9B6-7DAB-4281-9CC6-0B3B3E2D8F7F}"/>
+                <a16:creationId xmlns:a16="http://schemas.microsoft.com/office/drawing/2014/main" id="{51F4E2E2-CDBE-4450-A39B-A7928B31932C}"/>
               </a:ext>
             </a:extLst>
           </p:cNvPr>
@@ -18448,7 +18448,7 @@
           <p:cNvPr id="16" name="프로젝트 지침의&#10;반복·증가">
             <a:extLst xmlns:a="http://schemas.openxmlformats.org/drawingml/2006/main">
               <a:ext uri="{FF2B5EF4-FFF2-40B4-BE49-F238E27FC236}">
-                <a16:creationId xmlns:a16="http://schemas.microsoft.com/office/drawing/2014/main" id="{6EDA325D-71C3-4461-B9BF-9586F4B8ED13}"/>
+                <a16:creationId xmlns:a16="http://schemas.microsoft.com/office/drawing/2014/main" id="{334BE4D7-FEAD-4A2A-8477-BB0A4B5E8362}"/>
               </a:ext>
             </a:extLst>
           </p:cNvPr>
@@ -18629,7 +18629,7 @@
           <p:cNvPr id="17" name="">
             <a:extLst xmlns:a="http://schemas.openxmlformats.org/drawingml/2006/main">
               <a:ext uri="{FF2B5EF4-FFF2-40B4-BE49-F238E27FC236}">
-                <a16:creationId xmlns:a16="http://schemas.microsoft.com/office/drawing/2014/main" id="{FCA23D49-DD91-4A0C-9230-9B81232D0CD4}"/>
+                <a16:creationId xmlns:a16="http://schemas.microsoft.com/office/drawing/2014/main" id="{3D890CBC-E8D1-486E-ABEE-E5CFF7409942}"/>
               </a:ext>
             </a:extLst>
           </p:cNvPr>
@@ -18657,7 +18657,7 @@
           <p:cNvPr id="18" name="기본 안내와 필요한 상세 문서로 정리">
             <a:extLst xmlns:a="http://schemas.openxmlformats.org/drawingml/2006/main">
               <a:ext uri="{FF2B5EF4-FFF2-40B4-BE49-F238E27FC236}">
-                <a16:creationId xmlns:a16="http://schemas.microsoft.com/office/drawing/2014/main" id="{3733F7BC-85B0-4D0B-99CB-515D7BA0F198}"/>
+                <a16:creationId xmlns:a16="http://schemas.microsoft.com/office/drawing/2014/main" id="{02061093-1D8D-4010-9544-04B80A2E671C}"/>
               </a:ext>
             </a:extLst>
           </p:cNvPr>
@@ -18815,7 +18815,7 @@
           <p:cNvPr id="19" name="STATE-01  →  STATE-02  →  STATE-03">
             <a:extLst xmlns:a="http://schemas.openxmlformats.org/drawingml/2006/main">
               <a:ext uri="{FF2B5EF4-FFF2-40B4-BE49-F238E27FC236}">
-                <a16:creationId xmlns:a16="http://schemas.microsoft.com/office/drawing/2014/main" id="{AA2C424F-6431-476D-8DB9-FB839E795599}"/>
+                <a16:creationId xmlns:a16="http://schemas.microsoft.com/office/drawing/2014/main" id="{D6B87A1D-6018-4E7B-9C29-9828EFE9196B}"/>
               </a:ext>
             </a:extLst>
           </p:cNvPr>
@@ -18973,7 +18973,7 @@
           <p:cNvPr id="20" name="">
             <a:extLst xmlns:a="http://schemas.openxmlformats.org/drawingml/2006/main">
               <a:ext uri="{FF2B5EF4-FFF2-40B4-BE49-F238E27FC236}">
-                <a16:creationId xmlns:a16="http://schemas.microsoft.com/office/drawing/2014/main" id="{AF8B79E5-DABE-40E9-8C65-998C8566154D}"/>
+                <a16:creationId xmlns:a16="http://schemas.microsoft.com/office/drawing/2014/main" id="{89B90513-21DA-4BB2-9BBF-7535E54965A5}"/>
               </a:ext>
             </a:extLst>
           </p:cNvPr>
@@ -19004,7 +19004,7 @@
           <p:cNvPr id="21" name="같은 조사·검증&#10;절차 반복">
             <a:extLst xmlns:a="http://schemas.openxmlformats.org/drawingml/2006/main">
               <a:ext uri="{FF2B5EF4-FFF2-40B4-BE49-F238E27FC236}">
-                <a16:creationId xmlns:a16="http://schemas.microsoft.com/office/drawing/2014/main" id="{99ECBE73-45F2-4147-A1BB-414BC738491A}"/>
+                <a16:creationId xmlns:a16="http://schemas.microsoft.com/office/drawing/2014/main" id="{833AF313-F2E7-4D64-B767-A93B71402775}"/>
               </a:ext>
             </a:extLst>
           </p:cNvPr>
@@ -19185,7 +19185,7 @@
           <p:cNvPr id="22" name="">
             <a:extLst xmlns:a="http://schemas.openxmlformats.org/drawingml/2006/main">
               <a:ext uri="{FF2B5EF4-FFF2-40B4-BE49-F238E27FC236}">
-                <a16:creationId xmlns:a16="http://schemas.microsoft.com/office/drawing/2014/main" id="{96EEA6BC-E34E-4EA5-8DA9-8F112FAB7E17}"/>
+                <a16:creationId xmlns:a16="http://schemas.microsoft.com/office/drawing/2014/main" id="{AB9B2B21-0D87-4149-8420-0A382963600A}"/>
               </a:ext>
             </a:extLst>
           </p:cNvPr>
@@ -19213,7 +19213,7 @@
           <p:cNvPr id="23" name="Skill을 재사용하고 제품 변경을 검증">
             <a:extLst xmlns:a="http://schemas.openxmlformats.org/drawingml/2006/main">
               <a:ext uri="{FF2B5EF4-FFF2-40B4-BE49-F238E27FC236}">
-                <a16:creationId xmlns:a16="http://schemas.microsoft.com/office/drawing/2014/main" id="{7E05E847-C4CF-444D-99D4-FB614A00008F}"/>
+                <a16:creationId xmlns:a16="http://schemas.microsoft.com/office/drawing/2014/main" id="{7F4DEB06-90BF-4508-9D68-07B73B4D46C0}"/>
               </a:ext>
             </a:extLst>
           </p:cNvPr>
@@ -19371,7 +19371,7 @@
           <p:cNvPr id="24" name="STATE-04  →  STATE-04-PERF">
             <a:extLst xmlns:a="http://schemas.openxmlformats.org/drawingml/2006/main">
               <a:ext uri="{FF2B5EF4-FFF2-40B4-BE49-F238E27FC236}">
-                <a16:creationId xmlns:a16="http://schemas.microsoft.com/office/drawing/2014/main" id="{AD5F5E5E-56B2-4C6D-80A1-4AF04A7B74CA}"/>
+                <a16:creationId xmlns:a16="http://schemas.microsoft.com/office/drawing/2014/main" id="{8686CB87-DF52-4719-8D06-66A376365F91}"/>
               </a:ext>
             </a:extLst>
           </p:cNvPr>
@@ -19529,7 +19529,7 @@
           <p:cNvPr id="25" name="Loop는 앞 ACT의 가상 사례·실제 제작 기록에서 따로 살펴봤다">
             <a:extLst xmlns:a="http://schemas.openxmlformats.org/drawingml/2006/main">
               <a:ext uri="{FF2B5EF4-FFF2-40B4-BE49-F238E27FC236}">
-                <a16:creationId xmlns:a16="http://schemas.microsoft.com/office/drawing/2014/main" id="{79CE5E62-1495-4EDC-9D74-F545EBBEC35C}"/>
+                <a16:creationId xmlns:a16="http://schemas.microsoft.com/office/drawing/2014/main" id="{C5178D65-59DB-4511-8B86-6D1876CB52CC}"/>
               </a:ext>
             </a:extLst>
           </p:cNvPr>
@@ -19687,7 +19687,7 @@
           <p:cNvPr id="26" name="Legacy module connection">
             <a:extLst xmlns:a="http://schemas.openxmlformats.org/drawingml/2006/main">
               <a:ext uri="{FF2B5EF4-FFF2-40B4-BE49-F238E27FC236}">
-                <a16:creationId xmlns:a16="http://schemas.microsoft.com/office/drawing/2014/main" id="{904175D2-BBC5-4ADD-8081-10E9EBE43884}"/>
+                <a16:creationId xmlns:a16="http://schemas.microsoft.com/office/drawing/2014/main" id="{8E5C49EC-CACF-4FB7-8138-1A9BDA192C6E}"/>
               </a:ext>
             </a:extLst>
           </p:cNvPr>
@@ -19843,7 +19843,7 @@
     </p:spTree>
     <p:extLst>
       <p:ext uri="{BB962C8B-B14F-4D97-AF65-F5344CB8AC3E}">
-        <p14:creationId xmlns:p14="http://schemas.microsoft.com/office/powerpoint/2010/main" val="505583651"/>
+        <p14:creationId xmlns:p14="http://schemas.microsoft.com/office/powerpoint/2010/main" val="1952293057"/>
       </p:ext>
     </p:extLst>
   </p:cSld>
@@ -19874,7 +19874,7 @@
           <p:cNvPr id="19" name="ACT 5 · 이번 Demo의 선택 기준">
             <a:extLst xmlns:a="http://schemas.openxmlformats.org/drawingml/2006/main">
               <a:ext uri="{FF2B5EF4-FFF2-40B4-BE49-F238E27FC236}">
-                <a16:creationId xmlns:a16="http://schemas.microsoft.com/office/drawing/2014/main" id="{4D8E6A00-798C-4D09-820F-197EB1611C77}"/>
+                <a16:creationId xmlns:a16="http://schemas.microsoft.com/office/drawing/2014/main" id="{CABDB28E-A702-4CD8-BD0E-E52F6C8F9D3B}"/>
               </a:ext>
             </a:extLst>
           </p:cNvPr>
@@ -20029,10 +20029,10 @@
       </p:sp>
       <p:sp>
         <p:nvSpPr>
-          <p:cNvPr id="2" name="S88">
+          <p:cNvPr id="2" name="S91">
             <a:extLst xmlns:a="http://schemas.openxmlformats.org/drawingml/2006/main">
               <a:ext uri="{FF2B5EF4-FFF2-40B4-BE49-F238E27FC236}">
-                <a16:creationId xmlns:a16="http://schemas.microsoft.com/office/drawing/2014/main" id="{01AE2776-4035-4594-9F26-48187E74F07E}"/>
+                <a16:creationId xmlns:a16="http://schemas.microsoft.com/office/drawing/2014/main" id="{2CAFD898-8D4B-46D0-876E-A4DE67C35A5D}"/>
               </a:ext>
             </a:extLst>
           </p:cNvPr>
@@ -20180,7 +20180,7 @@
                 <a:ea typeface="Malgun Gothic"/>
                 <a:cs typeface="Malgun Gothic"/>
               </a:rPr>
-              <a:t>S88</a:t>
+              <a:t>S91</a:t>
             </a:r>
           </a:p>
         </p:txBody>
@@ -20190,7 +20190,7 @@
           <p:cNvPr id="3" name="이번 문제에 필요한 구성만 선택했다">
             <a:extLst xmlns:a="http://schemas.openxmlformats.org/drawingml/2006/main">
               <a:ext uri="{FF2B5EF4-FFF2-40B4-BE49-F238E27FC236}">
-                <a16:creationId xmlns:a16="http://schemas.microsoft.com/office/drawing/2014/main" id="{719DDDDF-BBEC-47E4-BBE4-0835B0AD7EA3}"/>
+                <a16:creationId xmlns:a16="http://schemas.microsoft.com/office/drawing/2014/main" id="{8CCC34FE-6CC6-408D-BE35-7A2067C9416A}"/>
               </a:ext>
             </a:extLst>
           </p:cNvPr>
@@ -20348,7 +20348,7 @@
           <p:cNvPr id="4" name="">
             <a:extLst xmlns:a="http://schemas.openxmlformats.org/drawingml/2006/main">
               <a:ext uri="{FF2B5EF4-FFF2-40B4-BE49-F238E27FC236}">
-                <a16:creationId xmlns:a16="http://schemas.microsoft.com/office/drawing/2014/main" id="{22FBD74A-1C20-4207-A9E1-A1D749CC7997}"/>
+                <a16:creationId xmlns:a16="http://schemas.microsoft.com/office/drawing/2014/main" id="{0DF73D57-8917-4E7B-9CCA-10E20BC68F0C}"/>
               </a:ext>
             </a:extLst>
           </p:cNvPr>
@@ -20379,7 +20379,7 @@
           <p:cNvPr id="5" name="STATE-04-PERF · DEC-0018 · 현재 작업의 구성·지식 출처 감사">
             <a:extLst xmlns:a="http://schemas.openxmlformats.org/drawingml/2006/main">
               <a:ext uri="{FF2B5EF4-FFF2-40B4-BE49-F238E27FC236}">
-                <a16:creationId xmlns:a16="http://schemas.microsoft.com/office/drawing/2014/main" id="{35861C29-F4FA-41DD-944F-248B71B15396}"/>
+                <a16:creationId xmlns:a16="http://schemas.microsoft.com/office/drawing/2014/main" id="{FBD86692-D29C-402E-9998-BE61CCE34127}"/>
               </a:ext>
             </a:extLst>
           </p:cNvPr>
@@ -20537,7 +20537,7 @@
           <p:cNvPr id="6" name="비교 실험 결과가 아님 · 모든 프로젝트에 Subagent·Memory가 불필요하거나 적을수록 좋다는 뜻은 ">
             <a:extLst xmlns:a="http://schemas.openxmlformats.org/drawingml/2006/main">
               <a:ext uri="{FF2B5EF4-FFF2-40B4-BE49-F238E27FC236}">
-                <a16:creationId xmlns:a16="http://schemas.microsoft.com/office/drawing/2014/main" id="{6DBF37D8-08E0-4C33-988E-53E8CFBA3668}"/>
+                <a16:creationId xmlns:a16="http://schemas.microsoft.com/office/drawing/2014/main" id="{FCB160A8-6400-46CE-B3A8-E1ECA6E1EE84}"/>
               </a:ext>
             </a:extLst>
           </p:cNvPr>
@@ -20695,7 +20695,7 @@
           <p:cNvPr id="7" name="도구 수보다, 현재 문제에서 필요한 이유를 본다">
             <a:extLst xmlns:a="http://schemas.openxmlformats.org/drawingml/2006/main">
               <a:ext uri="{FF2B5EF4-FFF2-40B4-BE49-F238E27FC236}">
-                <a16:creationId xmlns:a16="http://schemas.microsoft.com/office/drawing/2014/main" id="{DA386A9E-247F-415A-839F-7CF5A00549CC}"/>
+                <a16:creationId xmlns:a16="http://schemas.microsoft.com/office/drawing/2014/main" id="{F7576419-FA75-4464-A0BA-8D9D00482195}"/>
               </a:ext>
             </a:extLst>
           </p:cNvPr>
@@ -20853,7 +20853,7 @@
           <p:cNvPr id="8" name="사용한 구성">
             <a:extLst xmlns:a="http://schemas.openxmlformats.org/drawingml/2006/main">
               <a:ext uri="{FF2B5EF4-FFF2-40B4-BE49-F238E27FC236}">
-                <a16:creationId xmlns:a16="http://schemas.microsoft.com/office/drawing/2014/main" id="{AE0360B2-8C4C-4163-8025-A3C34F8075AD}"/>
+                <a16:creationId xmlns:a16="http://schemas.microsoft.com/office/drawing/2014/main" id="{94AA49C4-8260-4EA7-BD2A-E6A0F122479C}"/>
               </a:ext>
             </a:extLst>
           </p:cNvPr>
@@ -21011,7 +21011,7 @@
           <p:cNvPr id="9" name="">
             <a:extLst xmlns:a="http://schemas.openxmlformats.org/drawingml/2006/main">
               <a:ext uri="{FF2B5EF4-FFF2-40B4-BE49-F238E27FC236}">
-                <a16:creationId xmlns:a16="http://schemas.microsoft.com/office/drawing/2014/main" id="{9E82AE68-C898-443C-8F6F-D3D933A4E9AA}"/>
+                <a16:creationId xmlns:a16="http://schemas.microsoft.com/office/drawing/2014/main" id="{EFB22D26-528C-48F6-AF2D-0DF83C3C154C}"/>
               </a:ext>
             </a:extLst>
           </p:cNvPr>
@@ -21042,7 +21042,7 @@
           <p:cNvPr id="10" name="작업 요청&#10;Context와 Routing&#10;재사용 Skill&#10;테스트와 Benchmark">
             <a:extLst xmlns:a="http://schemas.openxmlformats.org/drawingml/2006/main">
               <a:ext uri="{FF2B5EF4-FFF2-40B4-BE49-F238E27FC236}">
-                <a16:creationId xmlns:a16="http://schemas.microsoft.com/office/drawing/2014/main" id="{E98B08B4-8017-4837-B144-716981FB1B7B}"/>
+                <a16:creationId xmlns:a16="http://schemas.microsoft.com/office/drawing/2014/main" id="{5B7C636F-9090-4078-BB31-BB63CFAEC3B7}"/>
               </a:ext>
             </a:extLst>
           </p:cNvPr>
@@ -21269,7 +21269,7 @@
           <p:cNvPr id="11" name="이번에는 보류한 이유">
             <a:extLst xmlns:a="http://schemas.openxmlformats.org/drawingml/2006/main">
               <a:ext uri="{FF2B5EF4-FFF2-40B4-BE49-F238E27FC236}">
-                <a16:creationId xmlns:a16="http://schemas.microsoft.com/office/drawing/2014/main" id="{F3961C4D-796D-4081-8F7D-D175FEA9977F}"/>
+                <a16:creationId xmlns:a16="http://schemas.microsoft.com/office/drawing/2014/main" id="{4893BF14-7B34-44F0-B2D0-C9519A8D7F22}"/>
               </a:ext>
             </a:extLst>
           </p:cNvPr>
@@ -21427,7 +21427,7 @@
           <p:cNvPr id="12" name="">
             <a:extLst xmlns:a="http://schemas.openxmlformats.org/drawingml/2006/main">
               <a:ext uri="{FF2B5EF4-FFF2-40B4-BE49-F238E27FC236}">
-                <a16:creationId xmlns:a16="http://schemas.microsoft.com/office/drawing/2014/main" id="{19BB9A19-0A15-4953-9219-B12C63E672E7}"/>
+                <a16:creationId xmlns:a16="http://schemas.microsoft.com/office/drawing/2014/main" id="{1EAAEC02-B520-49C9-B14C-40BA99F76626}"/>
               </a:ext>
             </a:extLst>
           </p:cNvPr>
@@ -21458,7 +21458,7 @@
           <p:cNvPr id="13" name="Subagent">
             <a:extLst xmlns:a="http://schemas.openxmlformats.org/drawingml/2006/main">
               <a:ext uri="{FF2B5EF4-FFF2-40B4-BE49-F238E27FC236}">
-                <a16:creationId xmlns:a16="http://schemas.microsoft.com/office/drawing/2014/main" id="{D1FDB2F2-DAEC-4726-A17D-497D5BE7D29A}"/>
+                <a16:creationId xmlns:a16="http://schemas.microsoft.com/office/drawing/2014/main" id="{4A69D992-15CC-450C-8881-9A20D09E7A5D}"/>
               </a:ext>
             </a:extLst>
           </p:cNvPr>
@@ -21616,7 +21616,7 @@
           <p:cNvPr id="14" name="같은 코드의 조사 → 변경 → 검증이 이어짐">
             <a:extLst xmlns:a="http://schemas.openxmlformats.org/drawingml/2006/main">
               <a:ext uri="{FF2B5EF4-FFF2-40B4-BE49-F238E27FC236}">
-                <a16:creationId xmlns:a16="http://schemas.microsoft.com/office/drawing/2014/main" id="{8919CCDB-D2C7-473B-BCD6-B97B6DF19B89}"/>
+                <a16:creationId xmlns:a16="http://schemas.microsoft.com/office/drawing/2014/main" id="{3C1F1662-FE95-42CC-ACE6-34FFAA0E2065}"/>
               </a:ext>
             </a:extLst>
           </p:cNvPr>
@@ -21774,7 +21774,7 @@
           <p:cNvPr id="15" name="Memory">
             <a:extLst xmlns:a="http://schemas.openxmlformats.org/drawingml/2006/main">
               <a:ext uri="{FF2B5EF4-FFF2-40B4-BE49-F238E27FC236}">
-                <a16:creationId xmlns:a16="http://schemas.microsoft.com/office/drawing/2014/main" id="{2FEDF557-E97A-4A60-BAE3-88F8C8A38DA3}"/>
+                <a16:creationId xmlns:a16="http://schemas.microsoft.com/office/drawing/2014/main" id="{944D5AFB-9650-40C0-9F57-31ECAEDA9E13}"/>
               </a:ext>
             </a:extLst>
           </p:cNvPr>
@@ -21932,7 +21932,7 @@
           <p:cNvPr id="16" name="필요한 지식이 기존 출처에 이미 있었음">
             <a:extLst xmlns:a="http://schemas.openxmlformats.org/drawingml/2006/main">
               <a:ext uri="{FF2B5EF4-FFF2-40B4-BE49-F238E27FC236}">
-                <a16:creationId xmlns:a16="http://schemas.microsoft.com/office/drawing/2014/main" id="{906230AA-0A21-431A-B785-8F803C0A7497}"/>
+                <a16:creationId xmlns:a16="http://schemas.microsoft.com/office/drawing/2014/main" id="{8791F766-19EE-4865-8905-C37E97ED473E}"/>
               </a:ext>
             </a:extLst>
           </p:cNvPr>
@@ -22090,7 +22090,7 @@
           <p:cNvPr id="17" name="현재 문제가 필요로 하는 만큼 설계한다">
             <a:extLst xmlns:a="http://schemas.openxmlformats.org/drawingml/2006/main">
               <a:ext uri="{FF2B5EF4-FFF2-40B4-BE49-F238E27FC236}">
-                <a16:creationId xmlns:a16="http://schemas.microsoft.com/office/drawing/2014/main" id="{A7DA2A59-D3CF-47BE-AF75-0C3752723772}"/>
+                <a16:creationId xmlns:a16="http://schemas.microsoft.com/office/drawing/2014/main" id="{66FA918B-CDCC-4DCC-A361-4F71D909B8C5}"/>
               </a:ext>
             </a:extLst>
           </p:cNvPr>
@@ -22248,7 +22248,7 @@
           <p:cNvPr id="18" name="Legacy module connection">
             <a:extLst xmlns:a="http://schemas.openxmlformats.org/drawingml/2006/main">
               <a:ext uri="{FF2B5EF4-FFF2-40B4-BE49-F238E27FC236}">
-                <a16:creationId xmlns:a16="http://schemas.microsoft.com/office/drawing/2014/main" id="{C461E494-5417-485C-8047-41B24B824D04}"/>
+                <a16:creationId xmlns:a16="http://schemas.microsoft.com/office/drawing/2014/main" id="{180EE651-6C27-4BFE-8A3D-E6080607F5FD}"/>
               </a:ext>
             </a:extLst>
           </p:cNvPr>
@@ -22404,7 +22404,7 @@
     </p:spTree>
     <p:extLst>
       <p:ext uri="{BB962C8B-B14F-4D97-AF65-F5344CB8AC3E}">
-        <p14:creationId xmlns:p14="http://schemas.microsoft.com/office/powerpoint/2010/main" val="1199732343"/>
+        <p14:creationId xmlns:p14="http://schemas.microsoft.com/office/powerpoint/2010/main" val="1197033263"/>
       </p:ext>
     </p:extLst>
   </p:cSld>
@@ -22435,7 +22435,7 @@
           <p:cNvPr id="26" name="ACT 5 · 개발자에게 남는 판단과 책임">
             <a:extLst xmlns:a="http://schemas.openxmlformats.org/drawingml/2006/main">
               <a:ext uri="{FF2B5EF4-FFF2-40B4-BE49-F238E27FC236}">
-                <a16:creationId xmlns:a16="http://schemas.microsoft.com/office/drawing/2014/main" id="{CC698577-55E7-46F8-97EA-4A4A8BD618F4}"/>
+                <a16:creationId xmlns:a16="http://schemas.microsoft.com/office/drawing/2014/main" id="{AFAF1561-05A2-44D9-A338-3C37AF349BD8}"/>
               </a:ext>
             </a:extLst>
           </p:cNvPr>
@@ -22590,10 +22590,10 @@
       </p:sp>
       <p:sp>
         <p:nvSpPr>
-          <p:cNvPr id="2" name="S89">
+          <p:cNvPr id="2" name="S92">
             <a:extLst xmlns:a="http://schemas.openxmlformats.org/drawingml/2006/main">
               <a:ext uri="{FF2B5EF4-FFF2-40B4-BE49-F238E27FC236}">
-                <a16:creationId xmlns:a16="http://schemas.microsoft.com/office/drawing/2014/main" id="{15E8ED20-3F86-417A-8FD8-EE64DB1AE762}"/>
+                <a16:creationId xmlns:a16="http://schemas.microsoft.com/office/drawing/2014/main" id="{1E28501C-AA2D-4D40-B7B0-500FA41FBFA0}"/>
               </a:ext>
             </a:extLst>
           </p:cNvPr>
@@ -22741,7 +22741,7 @@
                 <a:ea typeface="Malgun Gothic"/>
                 <a:cs typeface="Malgun Gothic"/>
               </a:rPr>
-              <a:t>S89</a:t>
+              <a:t>S92</a:t>
             </a:r>
           </a:p>
         </p:txBody>
@@ -22751,7 +22751,7 @@
           <p:cNvPr id="3" name="결과를 수용할지는 사람이 판단한다">
             <a:extLst xmlns:a="http://schemas.openxmlformats.org/drawingml/2006/main">
               <a:ext uri="{FF2B5EF4-FFF2-40B4-BE49-F238E27FC236}">
-                <a16:creationId xmlns:a16="http://schemas.microsoft.com/office/drawing/2014/main" id="{D9997B09-4179-4D6C-A3C7-D592C567CC7B}"/>
+                <a16:creationId xmlns:a16="http://schemas.microsoft.com/office/drawing/2014/main" id="{B05EFE71-1EA1-4887-8141-E94BB8E8B80E}"/>
               </a:ext>
             </a:extLst>
           </p:cNvPr>
@@ -22909,7 +22909,7 @@
           <p:cNvPr id="4" name="">
             <a:extLst xmlns:a="http://schemas.openxmlformats.org/drawingml/2006/main">
               <a:ext uri="{FF2B5EF4-FFF2-40B4-BE49-F238E27FC236}">
-                <a16:creationId xmlns:a16="http://schemas.microsoft.com/office/drawing/2014/main" id="{8DD31EB1-1835-4500-A74E-7A9EF4B3DED0}"/>
+                <a16:creationId xmlns:a16="http://schemas.microsoft.com/office/drawing/2014/main" id="{3F1DBF21-8407-4D91-BCC8-5312BB5D613A}"/>
               </a:ext>
             </a:extLst>
           </p:cNvPr>
@@ -22940,7 +22940,7 @@
           <p:cNvPr id="5" name="BEAT-061–062 · 이 교육의 책임 원칙">
             <a:extLst xmlns:a="http://schemas.openxmlformats.org/drawingml/2006/main">
               <a:ext uri="{FF2B5EF4-FFF2-40B4-BE49-F238E27FC236}">
-                <a16:creationId xmlns:a16="http://schemas.microsoft.com/office/drawing/2014/main" id="{4FEE24AA-E766-4D33-8994-F85AA1B20980}"/>
+                <a16:creationId xmlns:a16="http://schemas.microsoft.com/office/drawing/2014/main" id="{4623200E-F6AB-4A98-80CA-74EDC25D0FD1}"/>
               </a:ext>
             </a:extLst>
           </p:cNvPr>
@@ -23098,7 +23098,7 @@
           <p:cNvPr id="6" name="Agent와 개발자의 역할을 고정된 분업표로 제시하는 것은 아니다.">
             <a:extLst xmlns:a="http://schemas.openxmlformats.org/drawingml/2006/main">
               <a:ext uri="{FF2B5EF4-FFF2-40B4-BE49-F238E27FC236}">
-                <a16:creationId xmlns:a16="http://schemas.microsoft.com/office/drawing/2014/main" id="{3276CB73-8790-4AAF-B2A7-95D776E1084D}"/>
+                <a16:creationId xmlns:a16="http://schemas.microsoft.com/office/drawing/2014/main" id="{5DAE866F-CB1D-404F-8CF5-3DB57EF10800}"/>
               </a:ext>
             </a:extLst>
           </p:cNvPr>
@@ -23256,7 +23256,7 @@
           <p:cNvPr id="7" name="AI가 조사·생성·변경·실행·비교를 도와도">
             <a:extLst xmlns:a="http://schemas.openxmlformats.org/drawingml/2006/main">
               <a:ext uri="{FF2B5EF4-FFF2-40B4-BE49-F238E27FC236}">
-                <a16:creationId xmlns:a16="http://schemas.microsoft.com/office/drawing/2014/main" id="{3EA73B15-8E8D-4BFA-8736-A542ECB1E343}"/>
+                <a16:creationId xmlns:a16="http://schemas.microsoft.com/office/drawing/2014/main" id="{1A3AD503-DF47-48C2-99E2-BFA7FB726059}"/>
               </a:ext>
             </a:extLst>
           </p:cNvPr>
@@ -23414,7 +23414,7 @@
           <p:cNvPr id="8" name="AI의 작업 결과">
             <a:extLst xmlns:a="http://schemas.openxmlformats.org/drawingml/2006/main">
               <a:ext uri="{FF2B5EF4-FFF2-40B4-BE49-F238E27FC236}">
-                <a16:creationId xmlns:a16="http://schemas.microsoft.com/office/drawing/2014/main" id="{010B22F1-4E24-4EC8-85F9-097D5600E5A6}"/>
+                <a16:creationId xmlns:a16="http://schemas.microsoft.com/office/drawing/2014/main" id="{83AFAB3F-C651-4910-BA08-C5A28E650754}"/>
               </a:ext>
             </a:extLst>
           </p:cNvPr>
@@ -23572,7 +23572,7 @@
           <p:cNvPr id="9" name="">
             <a:extLst xmlns:a="http://schemas.openxmlformats.org/drawingml/2006/main">
               <a:ext uri="{FF2B5EF4-FFF2-40B4-BE49-F238E27FC236}">
-                <a16:creationId xmlns:a16="http://schemas.microsoft.com/office/drawing/2014/main" id="{DCE313DA-735C-4522-8FDC-8EB31C72C463}"/>
+                <a16:creationId xmlns:a16="http://schemas.microsoft.com/office/drawing/2014/main" id="{4782C871-F50B-45D8-9E73-CC792938C22E}"/>
               </a:ext>
             </a:extLst>
           </p:cNvPr>
@@ -23603,7 +23603,7 @@
           <p:cNvPr id="10" name="변경 내용&#10;실행·검사·비교 기록">
             <a:extLst xmlns:a="http://schemas.openxmlformats.org/drawingml/2006/main">
               <a:ext uri="{FF2B5EF4-FFF2-40B4-BE49-F238E27FC236}">
-                <a16:creationId xmlns:a16="http://schemas.microsoft.com/office/drawing/2014/main" id="{3A23B495-40D8-4F92-B2EB-6CDF315A7B33}"/>
+                <a16:creationId xmlns:a16="http://schemas.microsoft.com/office/drawing/2014/main" id="{C97194E8-FA85-4389-A8C2-4EBF473B506D}"/>
               </a:ext>
             </a:extLst>
           </p:cNvPr>
@@ -23784,7 +23784,7 @@
           <p:cNvPr id="11" name="">
             <a:extLst xmlns:a="http://schemas.openxmlformats.org/drawingml/2006/main">
               <a:ext uri="{FF2B5EF4-FFF2-40B4-BE49-F238E27FC236}">
-                <a16:creationId xmlns:a16="http://schemas.microsoft.com/office/drawing/2014/main" id="{65EF42EB-9F39-4F9B-B094-E4D3BD0B638E}"/>
+                <a16:creationId xmlns:a16="http://schemas.microsoft.com/office/drawing/2014/main" id="{2F06EAE4-EC46-41B6-9663-A782184D83DD}"/>
               </a:ext>
             </a:extLst>
           </p:cNvPr>
@@ -23812,7 +23812,7 @@
           <p:cNvPr id="12" name="사람의 수용 판단">
             <a:extLst xmlns:a="http://schemas.openxmlformats.org/drawingml/2006/main">
               <a:ext uri="{FF2B5EF4-FFF2-40B4-BE49-F238E27FC236}">
-                <a16:creationId xmlns:a16="http://schemas.microsoft.com/office/drawing/2014/main" id="{FA161F5E-5578-49D0-AE21-207DFCE03DB8}"/>
+                <a16:creationId xmlns:a16="http://schemas.microsoft.com/office/drawing/2014/main" id="{25AEE5BA-C22D-4E0E-A3F4-DAD0B651C5A4}"/>
               </a:ext>
             </a:extLst>
           </p:cNvPr>
@@ -23970,7 +23970,7 @@
           <p:cNvPr id="13" name="">
             <a:extLst xmlns:a="http://schemas.openxmlformats.org/drawingml/2006/main">
               <a:ext uri="{FF2B5EF4-FFF2-40B4-BE49-F238E27FC236}">
-                <a16:creationId xmlns:a16="http://schemas.microsoft.com/office/drawing/2014/main" id="{38B83176-1A30-4B6B-9A04-64246A99E6C4}"/>
+                <a16:creationId xmlns:a16="http://schemas.microsoft.com/office/drawing/2014/main" id="{5F84A076-4C7A-4395-8E72-7AFDED5D96B0}"/>
               </a:ext>
             </a:extLst>
           </p:cNvPr>
@@ -24001,7 +24001,7 @@
           <p:cNvPr id="14" name="목표">
             <a:extLst xmlns:a="http://schemas.openxmlformats.org/drawingml/2006/main">
               <a:ext uri="{FF2B5EF4-FFF2-40B4-BE49-F238E27FC236}">
-                <a16:creationId xmlns:a16="http://schemas.microsoft.com/office/drawing/2014/main" id="{3F3126FC-8FE8-45EB-9794-8DCA458DEDB9}"/>
+                <a16:creationId xmlns:a16="http://schemas.microsoft.com/office/drawing/2014/main" id="{6550D570-8C11-4F87-8DA5-3DAF01D07B6F}"/>
               </a:ext>
             </a:extLst>
           </p:cNvPr>
@@ -24159,7 +24159,7 @@
           <p:cNvPr id="15" name="목표·제약에 맞나?">
             <a:extLst xmlns:a="http://schemas.openxmlformats.org/drawingml/2006/main">
               <a:ext uri="{FF2B5EF4-FFF2-40B4-BE49-F238E27FC236}">
-                <a16:creationId xmlns:a16="http://schemas.microsoft.com/office/drawing/2014/main" id="{9A8E6D03-4C41-4B11-B6D8-EEC370D30AB1}"/>
+                <a16:creationId xmlns:a16="http://schemas.microsoft.com/office/drawing/2014/main" id="{489BE2C3-186C-48B9-95A9-283303D671AE}"/>
               </a:ext>
             </a:extLst>
           </p:cNvPr>
@@ -24317,7 +24317,7 @@
           <p:cNvPr id="16" name="">
             <a:extLst xmlns:a="http://schemas.openxmlformats.org/drawingml/2006/main">
               <a:ext uri="{FF2B5EF4-FFF2-40B4-BE49-F238E27FC236}">
-                <a16:creationId xmlns:a16="http://schemas.microsoft.com/office/drawing/2014/main" id="{DA8B0819-B16A-4CE0-9F67-54CEBA6829A3}"/>
+                <a16:creationId xmlns:a16="http://schemas.microsoft.com/office/drawing/2014/main" id="{1A8BD6C7-F781-49B1-B10A-1D58C1425A98}"/>
               </a:ext>
             </a:extLst>
           </p:cNvPr>
@@ -24348,7 +24348,7 @@
           <p:cNvPr id="17" name="판단">
             <a:extLst xmlns:a="http://schemas.openxmlformats.org/drawingml/2006/main">
               <a:ext uri="{FF2B5EF4-FFF2-40B4-BE49-F238E27FC236}">
-                <a16:creationId xmlns:a16="http://schemas.microsoft.com/office/drawing/2014/main" id="{B0B5FB1F-13D2-49E7-94ED-57B105F3E405}"/>
+                <a16:creationId xmlns:a16="http://schemas.microsoft.com/office/drawing/2014/main" id="{C96D63F3-817E-402D-A8A2-FC1F8CB3E9D7}"/>
               </a:ext>
             </a:extLst>
           </p:cNvPr>
@@ -24506,7 +24506,7 @@
           <p:cNvPr id="18" name="선택이 적절한가?">
             <a:extLst xmlns:a="http://schemas.openxmlformats.org/drawingml/2006/main">
               <a:ext uri="{FF2B5EF4-FFF2-40B4-BE49-F238E27FC236}">
-                <a16:creationId xmlns:a16="http://schemas.microsoft.com/office/drawing/2014/main" id="{241F4D82-BD5A-4E7F-B9C5-CBC98F33DFE7}"/>
+                <a16:creationId xmlns:a16="http://schemas.microsoft.com/office/drawing/2014/main" id="{D5427ACA-1FAC-49BA-93D2-D3773B6F0E1B}"/>
               </a:ext>
             </a:extLst>
           </p:cNvPr>
@@ -24664,7 +24664,7 @@
           <p:cNvPr id="19" name="">
             <a:extLst xmlns:a="http://schemas.openxmlformats.org/drawingml/2006/main">
               <a:ext uri="{FF2B5EF4-FFF2-40B4-BE49-F238E27FC236}">
-                <a16:creationId xmlns:a16="http://schemas.microsoft.com/office/drawing/2014/main" id="{76904A3C-2808-467F-9457-70BF3F1AE9FD}"/>
+                <a16:creationId xmlns:a16="http://schemas.microsoft.com/office/drawing/2014/main" id="{99E352F4-FD36-4168-A098-23F014B0D9BB}"/>
               </a:ext>
             </a:extLst>
           </p:cNvPr>
@@ -24695,7 +24695,7 @@
           <p:cNvPr id="20" name="검증">
             <a:extLst xmlns:a="http://schemas.openxmlformats.org/drawingml/2006/main">
               <a:ext uri="{FF2B5EF4-FFF2-40B4-BE49-F238E27FC236}">
-                <a16:creationId xmlns:a16="http://schemas.microsoft.com/office/drawing/2014/main" id="{EEA7F013-F1A9-405F-8C4A-38533721BC8D}"/>
+                <a16:creationId xmlns:a16="http://schemas.microsoft.com/office/drawing/2014/main" id="{EFBBD2BA-7D6C-43B0-98CD-A7CEB2BC515D}"/>
               </a:ext>
             </a:extLst>
           </p:cNvPr>
@@ -24853,7 +24853,7 @@
           <p:cNvPr id="21" name="근거로 확인했나?">
             <a:extLst xmlns:a="http://schemas.openxmlformats.org/drawingml/2006/main">
               <a:ext uri="{FF2B5EF4-FFF2-40B4-BE49-F238E27FC236}">
-                <a16:creationId xmlns:a16="http://schemas.microsoft.com/office/drawing/2014/main" id="{4B19C014-E437-4013-B7FD-D9B5FAC398A6}"/>
+                <a16:creationId xmlns:a16="http://schemas.microsoft.com/office/drawing/2014/main" id="{B440BB49-44FD-4D43-BEA3-A34A1921996A}"/>
               </a:ext>
             </a:extLst>
           </p:cNvPr>
@@ -25011,7 +25011,7 @@
           <p:cNvPr id="22" name="">
             <a:extLst xmlns:a="http://schemas.openxmlformats.org/drawingml/2006/main">
               <a:ext uri="{FF2B5EF4-FFF2-40B4-BE49-F238E27FC236}">
-                <a16:creationId xmlns:a16="http://schemas.microsoft.com/office/drawing/2014/main" id="{B39375C9-232C-4FAC-92DA-0B47ECD1E776}"/>
+                <a16:creationId xmlns:a16="http://schemas.microsoft.com/office/drawing/2014/main" id="{B10E59FE-6CC8-4C47-A160-C96B5BB0D77E}"/>
               </a:ext>
             </a:extLst>
           </p:cNvPr>
@@ -25042,7 +25042,7 @@
           <p:cNvPr id="23" name="책임">
             <a:extLst xmlns:a="http://schemas.openxmlformats.org/drawingml/2006/main">
               <a:ext uri="{FF2B5EF4-FFF2-40B4-BE49-F238E27FC236}">
-                <a16:creationId xmlns:a16="http://schemas.microsoft.com/office/drawing/2014/main" id="{9542E326-75A4-4506-A21F-29299C0FB4C6}"/>
+                <a16:creationId xmlns:a16="http://schemas.microsoft.com/office/drawing/2014/main" id="{0ABD7D69-03E1-4152-8011-481FC6F07C73}"/>
               </a:ext>
             </a:extLst>
           </p:cNvPr>
@@ -25200,7 +25200,7 @@
           <p:cNvPr id="24" name="남은 위험을 수용할까?">
             <a:extLst xmlns:a="http://schemas.openxmlformats.org/drawingml/2006/main">
               <a:ext uri="{FF2B5EF4-FFF2-40B4-BE49-F238E27FC236}">
-                <a16:creationId xmlns:a16="http://schemas.microsoft.com/office/drawing/2014/main" id="{D8EB52F0-E173-47C1-9D30-D63E79AA62B3}"/>
+                <a16:creationId xmlns:a16="http://schemas.microsoft.com/office/drawing/2014/main" id="{CB1AE150-0E07-4C30-8CB4-8CD9C66494F2}"/>
               </a:ext>
             </a:extLst>
           </p:cNvPr>
@@ -25358,7 +25358,7 @@
           <p:cNvPr id="25" name="Legacy module connection">
             <a:extLst xmlns:a="http://schemas.openxmlformats.org/drawingml/2006/main">
               <a:ext uri="{FF2B5EF4-FFF2-40B4-BE49-F238E27FC236}">
-                <a16:creationId xmlns:a16="http://schemas.microsoft.com/office/drawing/2014/main" id="{1480C496-50A1-4BFF-B66F-BAEF8BE04B94}"/>
+                <a16:creationId xmlns:a16="http://schemas.microsoft.com/office/drawing/2014/main" id="{3F87C944-31BD-48AA-8D7D-3070CDEE089C}"/>
               </a:ext>
             </a:extLst>
           </p:cNvPr>
@@ -25514,7 +25514,7 @@
     </p:spTree>
     <p:extLst>
       <p:ext uri="{BB962C8B-B14F-4D97-AF65-F5344CB8AC3E}">
-        <p14:creationId xmlns:p14="http://schemas.microsoft.com/office/powerpoint/2010/main" val="661316093"/>
+        <p14:creationId xmlns:p14="http://schemas.microsoft.com/office/powerpoint/2010/main" val="1052762394"/>
       </p:ext>
     </p:extLst>
   </p:cSld>
@@ -25545,7 +25545,7 @@
           <p:cNvPr id="24" name="ACT 5 · AI-Native Development / 이 교육의 운영 모델">
             <a:extLst xmlns:a="http://schemas.openxmlformats.org/drawingml/2006/main">
               <a:ext uri="{FF2B5EF4-FFF2-40B4-BE49-F238E27FC236}">
-                <a16:creationId xmlns:a16="http://schemas.microsoft.com/office/drawing/2014/main" id="{9D11740D-8973-424C-8B50-117587F3C608}"/>
+                <a16:creationId xmlns:a16="http://schemas.microsoft.com/office/drawing/2014/main" id="{C741BD01-4777-4C5B-9325-F3B0390155F2}"/>
               </a:ext>
             </a:extLst>
           </p:cNvPr>
@@ -25700,10 +25700,10 @@
       </p:sp>
       <p:sp>
         <p:nvSpPr>
-          <p:cNvPr id="2" name="S90">
+          <p:cNvPr id="2" name="S93">
             <a:extLst xmlns:a="http://schemas.openxmlformats.org/drawingml/2006/main">
               <a:ext uri="{FF2B5EF4-FFF2-40B4-BE49-F238E27FC236}">
-                <a16:creationId xmlns:a16="http://schemas.microsoft.com/office/drawing/2014/main" id="{CF67B43B-C697-4B8B-B4D3-F71D18FA3901}"/>
+                <a16:creationId xmlns:a16="http://schemas.microsoft.com/office/drawing/2014/main" id="{D5083B75-5C15-4F0F-A02E-6CEAD7E367EE}"/>
               </a:ext>
             </a:extLst>
           </p:cNvPr>
@@ -25851,7 +25851,7 @@
                 <a:ea typeface="Malgun Gothic"/>
                 <a:cs typeface="Malgun Gothic"/>
               </a:rPr>
-              <a:t>S90</a:t>
+              <a:t>S93</a:t>
             </a:r>
           </a:p>
         </p:txBody>
@@ -25861,7 +25861,7 @@
           <p:cNvPr id="3" name="AI가 일할 조건과 확인 경로를 설계한다">
             <a:extLst xmlns:a="http://schemas.openxmlformats.org/drawingml/2006/main">
               <a:ext uri="{FF2B5EF4-FFF2-40B4-BE49-F238E27FC236}">
-                <a16:creationId xmlns:a16="http://schemas.microsoft.com/office/drawing/2014/main" id="{E780837E-2304-4D2D-82F6-64D4AF3BFD4F}"/>
+                <a16:creationId xmlns:a16="http://schemas.microsoft.com/office/drawing/2014/main" id="{E41832A6-12D7-4A2A-A211-2AD93C1951AA}"/>
               </a:ext>
             </a:extLst>
           </p:cNvPr>
@@ -26019,7 +26019,7 @@
           <p:cNvPr id="4" name="">
             <a:extLst xmlns:a="http://schemas.openxmlformats.org/drawingml/2006/main">
               <a:ext uri="{FF2B5EF4-FFF2-40B4-BE49-F238E27FC236}">
-                <a16:creationId xmlns:a16="http://schemas.microsoft.com/office/drawing/2014/main" id="{87FC5CA1-9A64-486F-A4EF-F3B2B1D14474}"/>
+                <a16:creationId xmlns:a16="http://schemas.microsoft.com/office/drawing/2014/main" id="{68FE9AC3-764B-4838-B5B1-216FE4B5E6FC}"/>
               </a:ext>
             </a:extLst>
           </p:cNvPr>
@@ -26050,7 +26050,7 @@
           <p:cNvPr id="5" name="DEC-0023 · 과정에서 사용하는 운영 모델">
             <a:extLst xmlns:a="http://schemas.openxmlformats.org/drawingml/2006/main">
               <a:ext uri="{FF2B5EF4-FFF2-40B4-BE49-F238E27FC236}">
-                <a16:creationId xmlns:a16="http://schemas.microsoft.com/office/drawing/2014/main" id="{7AAC6594-29FF-475E-9CC7-43BD501E3B2A}"/>
+                <a16:creationId xmlns:a16="http://schemas.microsoft.com/office/drawing/2014/main" id="{F0BEBDBE-9046-40A0-9790-F4BCBCB9A48E}"/>
               </a:ext>
             </a:extLst>
           </p:cNvPr>
@@ -26208,7 +26208,7 @@
           <p:cNvPr id="6" name="공식·보편 정의가 아니며, 모든 Task에 모든 구성요소를 넣으라는 뜻은 아니다.">
             <a:extLst xmlns:a="http://schemas.openxmlformats.org/drawingml/2006/main">
               <a:ext uri="{FF2B5EF4-FFF2-40B4-BE49-F238E27FC236}">
-                <a16:creationId xmlns:a16="http://schemas.microsoft.com/office/drawing/2014/main" id="{C46ADA31-05FC-4AAA-A362-5BC00E4FD2ED}"/>
+                <a16:creationId xmlns:a16="http://schemas.microsoft.com/office/drawing/2014/main" id="{F5E6F289-E172-4466-B2E1-5D4719EE18FF}"/>
               </a:ext>
             </a:extLst>
           </p:cNvPr>
@@ -26366,7 +26366,7 @@
           <p:cNvPr id="7" name="판단할 근거가 나오도록, 작업 환경을 준비한다">
             <a:extLst xmlns:a="http://schemas.openxmlformats.org/drawingml/2006/main">
               <a:ext uri="{FF2B5EF4-FFF2-40B4-BE49-F238E27FC236}">
-                <a16:creationId xmlns:a16="http://schemas.microsoft.com/office/drawing/2014/main" id="{1512C8F2-6ADD-4A13-8B55-17F4F452AE6C}"/>
+                <a16:creationId xmlns:a16="http://schemas.microsoft.com/office/drawing/2014/main" id="{C7649395-4A99-4E21-BFBC-B8BC1D57BF1A}"/>
               </a:ext>
             </a:extLst>
           </p:cNvPr>
@@ -26524,7 +26524,7 @@
           <p:cNvPr id="8" name="">
             <a:extLst xmlns:a="http://schemas.openxmlformats.org/drawingml/2006/main">
               <a:ext uri="{FF2B5EF4-FFF2-40B4-BE49-F238E27FC236}">
-                <a16:creationId xmlns:a16="http://schemas.microsoft.com/office/drawing/2014/main" id="{AA1A4422-73E7-4672-873B-CC92F8BEC333}"/>
+                <a16:creationId xmlns:a16="http://schemas.microsoft.com/office/drawing/2014/main" id="{61C3F319-D569-4130-85A5-C8DDDB0786A4}"/>
               </a:ext>
             </a:extLst>
           </p:cNvPr>
@@ -26555,7 +26555,7 @@
           <p:cNvPr id="9" name="맡길 범위">
             <a:extLst xmlns:a="http://schemas.openxmlformats.org/drawingml/2006/main">
               <a:ext uri="{FF2B5EF4-FFF2-40B4-BE49-F238E27FC236}">
-                <a16:creationId xmlns:a16="http://schemas.microsoft.com/office/drawing/2014/main" id="{01257179-0A74-475B-868E-86AEDD8F36B4}"/>
+                <a16:creationId xmlns:a16="http://schemas.microsoft.com/office/drawing/2014/main" id="{CDBF3F18-7026-4E62-906D-01FC5031A839}"/>
               </a:ext>
             </a:extLst>
           </p:cNvPr>
@@ -26713,7 +26713,7 @@
           <p:cNvPr id="10" name="목표·제약·변경 범위">
             <a:extLst xmlns:a="http://schemas.openxmlformats.org/drawingml/2006/main">
               <a:ext uri="{FF2B5EF4-FFF2-40B4-BE49-F238E27FC236}">
-                <a16:creationId xmlns:a16="http://schemas.microsoft.com/office/drawing/2014/main" id="{E090AA86-2177-483F-8365-ADDABFB0DF34}"/>
+                <a16:creationId xmlns:a16="http://schemas.microsoft.com/office/drawing/2014/main" id="{FD947834-26EE-4693-B2DE-F4F3539D7F63}"/>
               </a:ext>
             </a:extLst>
           </p:cNvPr>
@@ -26871,7 +26871,7 @@
           <p:cNvPr id="11" name="Task boundary">
             <a:extLst xmlns:a="http://schemas.openxmlformats.org/drawingml/2006/main">
               <a:ext uri="{FF2B5EF4-FFF2-40B4-BE49-F238E27FC236}">
-                <a16:creationId xmlns:a16="http://schemas.microsoft.com/office/drawing/2014/main" id="{9C56B0BF-B427-46F4-AEA4-D1D0D28945E9}"/>
+                <a16:creationId xmlns:a16="http://schemas.microsoft.com/office/drawing/2014/main" id="{FF5A11CE-9E60-44C9-8596-39C7C2A192FE}"/>
               </a:ext>
             </a:extLst>
           </p:cNvPr>
@@ -27029,7 +27029,7 @@
           <p:cNvPr id="12" name="">
             <a:extLst xmlns:a="http://schemas.openxmlformats.org/drawingml/2006/main">
               <a:ext uri="{FF2B5EF4-FFF2-40B4-BE49-F238E27FC236}">
-                <a16:creationId xmlns:a16="http://schemas.microsoft.com/office/drawing/2014/main" id="{45DE0553-D846-474C-8A38-13A504D10647}"/>
+                <a16:creationId xmlns:a16="http://schemas.microsoft.com/office/drawing/2014/main" id="{050CA912-2B6E-4612-AAEB-5B247520AD85}"/>
               </a:ext>
             </a:extLst>
           </p:cNvPr>
@@ -27057,7 +27057,7 @@
           <p:cNvPr id="13" name="">
             <a:extLst xmlns:a="http://schemas.openxmlformats.org/drawingml/2006/main">
               <a:ext uri="{FF2B5EF4-FFF2-40B4-BE49-F238E27FC236}">
-                <a16:creationId xmlns:a16="http://schemas.microsoft.com/office/drawing/2014/main" id="{24D7EB4B-2341-455E-8A61-9D22028CCD4C}"/>
+                <a16:creationId xmlns:a16="http://schemas.microsoft.com/office/drawing/2014/main" id="{68846B06-F84C-428B-8194-EDAD7B2C3EC5}"/>
               </a:ext>
             </a:extLst>
           </p:cNvPr>
@@ -27088,7 +27088,7 @@
           <p:cNvPr id="14" name="일할 조건">
             <a:extLst xmlns:a="http://schemas.openxmlformats.org/drawingml/2006/main">
               <a:ext uri="{FF2B5EF4-FFF2-40B4-BE49-F238E27FC236}">
-                <a16:creationId xmlns:a16="http://schemas.microsoft.com/office/drawing/2014/main" id="{83B4326F-DB28-4B1A-8B4C-E2ECE0B56926}"/>
+                <a16:creationId xmlns:a16="http://schemas.microsoft.com/office/drawing/2014/main" id="{EDB8AFB5-B8E2-4F96-9B84-5FACFEACE155}"/>
               </a:ext>
             </a:extLst>
           </p:cNvPr>
@@ -27246,7 +27246,7 @@
           <p:cNvPr id="15" name="프로젝트 지식&#10;재사용할 수행 방법">
             <a:extLst xmlns:a="http://schemas.openxmlformats.org/drawingml/2006/main">
               <a:ext uri="{FF2B5EF4-FFF2-40B4-BE49-F238E27FC236}">
-                <a16:creationId xmlns:a16="http://schemas.microsoft.com/office/drawing/2014/main" id="{CBDE090A-101E-4F01-922C-166A3F839C65}"/>
+                <a16:creationId xmlns:a16="http://schemas.microsoft.com/office/drawing/2014/main" id="{E0940E7A-AB83-46CA-AEB7-A298D3B60D2E}"/>
               </a:ext>
             </a:extLst>
           </p:cNvPr>
@@ -27427,7 +27427,7 @@
           <p:cNvPr id="16" name="Context · Workflow">
             <a:extLst xmlns:a="http://schemas.openxmlformats.org/drawingml/2006/main">
               <a:ext uri="{FF2B5EF4-FFF2-40B4-BE49-F238E27FC236}">
-                <a16:creationId xmlns:a16="http://schemas.microsoft.com/office/drawing/2014/main" id="{FA80B58D-3E37-402B-97D7-BBF08E30B846}"/>
+                <a16:creationId xmlns:a16="http://schemas.microsoft.com/office/drawing/2014/main" id="{AEB3834C-3A4D-4D74-B0AE-13EE0808B659}"/>
               </a:ext>
             </a:extLst>
           </p:cNvPr>
@@ -27585,7 +27585,7 @@
           <p:cNvPr id="17" name="">
             <a:extLst xmlns:a="http://schemas.openxmlformats.org/drawingml/2006/main">
               <a:ext uri="{FF2B5EF4-FFF2-40B4-BE49-F238E27FC236}">
-                <a16:creationId xmlns:a16="http://schemas.microsoft.com/office/drawing/2014/main" id="{77AA8EB7-742E-4145-98ED-6C0D8D616856}"/>
+                <a16:creationId xmlns:a16="http://schemas.microsoft.com/office/drawing/2014/main" id="{5242B624-350A-4401-ACE8-02F47D6DBFC9}"/>
               </a:ext>
             </a:extLst>
           </p:cNvPr>
@@ -27613,7 +27613,7 @@
           <p:cNvPr id="18" name="">
             <a:extLst xmlns:a="http://schemas.openxmlformats.org/drawingml/2006/main">
               <a:ext uri="{FF2B5EF4-FFF2-40B4-BE49-F238E27FC236}">
-                <a16:creationId xmlns:a16="http://schemas.microsoft.com/office/drawing/2014/main" id="{97142374-D599-4FCC-9FF5-76B44468CE3F}"/>
+                <a16:creationId xmlns:a16="http://schemas.microsoft.com/office/drawing/2014/main" id="{BB6EB1BD-082D-43CA-A2E9-F37E43F8D1FB}"/>
               </a:ext>
             </a:extLst>
           </p:cNvPr>
@@ -27644,7 +27644,7 @@
           <p:cNvPr id="19" name="확인과 피드백">
             <a:extLst xmlns:a="http://schemas.openxmlformats.org/drawingml/2006/main">
               <a:ext uri="{FF2B5EF4-FFF2-40B4-BE49-F238E27FC236}">
-                <a16:creationId xmlns:a16="http://schemas.microsoft.com/office/drawing/2014/main" id="{20908B52-07B4-4F9C-A44B-43C822B274D8}"/>
+                <a16:creationId xmlns:a16="http://schemas.microsoft.com/office/drawing/2014/main" id="{35BE6DFE-32B3-4002-BD3A-970E8ABAF2F4}"/>
               </a:ext>
             </a:extLst>
           </p:cNvPr>
@@ -27802,7 +27802,7 @@
           <p:cNvPr id="20" name="검증 근거&#10;다음 작업의 개선">
             <a:extLst xmlns:a="http://schemas.openxmlformats.org/drawingml/2006/main">
               <a:ext uri="{FF2B5EF4-FFF2-40B4-BE49-F238E27FC236}">
-                <a16:creationId xmlns:a16="http://schemas.microsoft.com/office/drawing/2014/main" id="{BB0A9F46-1F6F-41B3-954E-EFF227DC546B}"/>
+                <a16:creationId xmlns:a16="http://schemas.microsoft.com/office/drawing/2014/main" id="{22AA3F2E-34FE-4B97-A2D9-C6BE2CDACE33}"/>
               </a:ext>
             </a:extLst>
           </p:cNvPr>
@@ -27983,7 +27983,7 @@
           <p:cNvPr id="21" name="Verification · Feedback Loop">
             <a:extLst xmlns:a="http://schemas.openxmlformats.org/drawingml/2006/main">
               <a:ext uri="{FF2B5EF4-FFF2-40B4-BE49-F238E27FC236}">
-                <a16:creationId xmlns:a16="http://schemas.microsoft.com/office/drawing/2014/main" id="{B5DFF654-DF3A-4A0D-AAE1-4B7B4662D653}"/>
+                <a16:creationId xmlns:a16="http://schemas.microsoft.com/office/drawing/2014/main" id="{7949A116-21BF-4CCB-94B2-0676E1725F5B}"/>
               </a:ext>
             </a:extLst>
           </p:cNvPr>
@@ -28141,7 +28141,7 @@
           <p:cNvPr id="22" name="이 설계·운영 방식을, 이 교육에서는 AI-Native Development로 부른다">
             <a:extLst xmlns:a="http://schemas.openxmlformats.org/drawingml/2006/main">
               <a:ext uri="{FF2B5EF4-FFF2-40B4-BE49-F238E27FC236}">
-                <a16:creationId xmlns:a16="http://schemas.microsoft.com/office/drawing/2014/main" id="{9C1F06EA-C870-4C61-8551-C4991AA54372}"/>
+                <a16:creationId xmlns:a16="http://schemas.microsoft.com/office/drawing/2014/main" id="{9D6C9D4B-9151-49B7-BC77-CFDE8CE2F53C}"/>
               </a:ext>
             </a:extLst>
           </p:cNvPr>
@@ -28299,7 +28299,7 @@
           <p:cNvPr id="23" name="Legacy module connection">
             <a:extLst xmlns:a="http://schemas.openxmlformats.org/drawingml/2006/main">
               <a:ext uri="{FF2B5EF4-FFF2-40B4-BE49-F238E27FC236}">
-                <a16:creationId xmlns:a16="http://schemas.microsoft.com/office/drawing/2014/main" id="{C39B1CC6-EC06-4A80-88FB-FD61748088C1}"/>
+                <a16:creationId xmlns:a16="http://schemas.microsoft.com/office/drawing/2014/main" id="{8FDEE960-587E-4E80-9490-949A537E9F25}"/>
               </a:ext>
             </a:extLst>
           </p:cNvPr>
@@ -28455,7 +28455,7 @@
     </p:spTree>
     <p:extLst>
       <p:ext uri="{BB962C8B-B14F-4D97-AF65-F5344CB8AC3E}">
-        <p14:creationId xmlns:p14="http://schemas.microsoft.com/office/powerpoint/2010/main" val="1777732369"/>
+        <p14:creationId xmlns:p14="http://schemas.microsoft.com/office/powerpoint/2010/main" val="1903378960"/>
       </p:ext>
     </p:extLst>
   </p:cSld>
@@ -28486,7 +28486,7 @@
           <p:cNvPr id="32" name="ACT 5 · 재평가 1/3 · 공개 사례 + 교육용 구조 도식">
             <a:extLst xmlns:a="http://schemas.openxmlformats.org/drawingml/2006/main">
               <a:ext uri="{FF2B5EF4-FFF2-40B4-BE49-F238E27FC236}">
-                <a16:creationId xmlns:a16="http://schemas.microsoft.com/office/drawing/2014/main" id="{ECA9EE73-01D2-41E1-83F6-4875307A9372}"/>
+                <a16:creationId xmlns:a16="http://schemas.microsoft.com/office/drawing/2014/main" id="{66D17DA5-A112-48FC-92E9-9EB02E9AE2DF}"/>
               </a:ext>
             </a:extLst>
           </p:cNvPr>
@@ -28641,10 +28641,10 @@
       </p:sp>
       <p:sp>
         <p:nvSpPr>
-          <p:cNvPr id="2" name="S91">
+          <p:cNvPr id="2" name="S94">
             <a:extLst xmlns:a="http://schemas.openxmlformats.org/drawingml/2006/main">
               <a:ext uri="{FF2B5EF4-FFF2-40B4-BE49-F238E27FC236}">
-                <a16:creationId xmlns:a16="http://schemas.microsoft.com/office/drawing/2014/main" id="{3DDE17A1-148E-45F8-BDF7-A04674533C7B}"/>
+                <a16:creationId xmlns:a16="http://schemas.microsoft.com/office/drawing/2014/main" id="{7D63EAEB-8CAC-4FC0-BDD3-F63251BD659F}"/>
               </a:ext>
             </a:extLst>
           </p:cNvPr>
@@ -28792,7 +28792,7 @@
                 <a:ea typeface="Malgun Gothic"/>
                 <a:cs typeface="Malgun Gothic"/>
               </a:rPr>
-              <a:t>S91</a:t>
+              <a:t>S94</a:t>
             </a:r>
           </a:p>
         </p:txBody>
@@ -28802,7 +28802,7 @@
           <p:cNvPr id="3" name="모델·플랫폼이 바뀌면 Harness도 다시 본다">
             <a:extLst xmlns:a="http://schemas.openxmlformats.org/drawingml/2006/main">
               <a:ext uri="{FF2B5EF4-FFF2-40B4-BE49-F238E27FC236}">
-                <a16:creationId xmlns:a16="http://schemas.microsoft.com/office/drawing/2014/main" id="{1CC6A0B3-D43C-45EC-8E0C-A0BA5904958B}"/>
+                <a16:creationId xmlns:a16="http://schemas.microsoft.com/office/drawing/2014/main" id="{35D3E3C2-9818-4BAC-9930-BBA059641C96}"/>
               </a:ext>
             </a:extLst>
           </p:cNvPr>
@@ -28960,7 +28960,7 @@
           <p:cNvPr id="4" name="">
             <a:extLst xmlns:a="http://schemas.openxmlformats.org/drawingml/2006/main">
               <a:ext uri="{FF2B5EF4-FFF2-40B4-BE49-F238E27FC236}">
-                <a16:creationId xmlns:a16="http://schemas.microsoft.com/office/drawing/2014/main" id="{D27FA688-B055-4BDC-82AA-55DB7E144F6D}"/>
+                <a16:creationId xmlns:a16="http://schemas.microsoft.com/office/drawing/2014/main" id="{52863315-4040-4737-B158-21720D0F06BF}"/>
               </a:ext>
             </a:extLst>
           </p:cNvPr>
@@ -28991,7 +28991,7 @@
           <p:cNvPr id="5" name="SRC-0236 · Anthropic, 2026-10-22 · 일부 기업 Agent의 통합 사례를 각색">
             <a:extLst xmlns:a="http://schemas.openxmlformats.org/drawingml/2006/main">
               <a:ext uri="{FF2B5EF4-FFF2-40B4-BE49-F238E27FC236}">
-                <a16:creationId xmlns:a16="http://schemas.microsoft.com/office/drawing/2014/main" id="{E8D7D808-83FA-4F31-A558-35A6F9336830}"/>
+                <a16:creationId xmlns:a16="http://schemas.microsoft.com/office/drawing/2014/main" id="{69EA8451-5A95-401B-96C6-1F480B18C17C}"/>
               </a:ext>
             </a:extLst>
           </p:cNvPr>
@@ -29149,7 +29149,7 @@
           <p:cNvPr id="6" name="우리 Demo의 관찰·효과 측정이 아님 · 새 모델이면 무조건 통합한다는 뜻은 아님">
             <a:extLst xmlns:a="http://schemas.openxmlformats.org/drawingml/2006/main">
               <a:ext uri="{FF2B5EF4-FFF2-40B4-BE49-F238E27FC236}">
-                <a16:creationId xmlns:a16="http://schemas.microsoft.com/office/drawing/2014/main" id="{5393ACF4-F406-4E8C-B8D1-DCD5B1531E00}"/>
+                <a16:creationId xmlns:a16="http://schemas.microsoft.com/office/drawing/2014/main" id="{479E2336-2576-410E-A956-A9771EDA2DAA}"/>
               </a:ext>
             </a:extLst>
           </p:cNvPr>
@@ -29307,7 +29307,7 @@
           <p:cNvPr id="7" name="그때 필요했던 보조 장치가, 지금도 필요할까?">
             <a:extLst xmlns:a="http://schemas.openxmlformats.org/drawingml/2006/main">
               <a:ext uri="{FF2B5EF4-FFF2-40B4-BE49-F238E27FC236}">
-                <a16:creationId xmlns:a16="http://schemas.microsoft.com/office/drawing/2014/main" id="{2C9DE28A-F6FD-4017-9442-AC2AAF806CCA}"/>
+                <a16:creationId xmlns:a16="http://schemas.microsoft.com/office/drawing/2014/main" id="{E017DD18-F4B2-4BD6-B4D2-11975A81E575}"/>
               </a:ext>
             </a:extLst>
           </p:cNvPr>
@@ -29465,7 +29465,7 @@
           <p:cNvPr id="8" name="">
             <a:extLst xmlns:a="http://schemas.openxmlformats.org/drawingml/2006/main">
               <a:ext uri="{FF2B5EF4-FFF2-40B4-BE49-F238E27FC236}">
-                <a16:creationId xmlns:a16="http://schemas.microsoft.com/office/drawing/2014/main" id="{378F6529-0D75-40B2-85FE-A7EB0C8285C2}"/>
+                <a16:creationId xmlns:a16="http://schemas.microsoft.com/office/drawing/2014/main" id="{0AA4A979-28BE-4B97-824F-4EF9E44C7A9F}"/>
               </a:ext>
             </a:extLst>
           </p:cNvPr>
@@ -29496,7 +29496,7 @@
           <p:cNvPr id="9" name="">
             <a:extLst xmlns:a="http://schemas.openxmlformats.org/drawingml/2006/main">
               <a:ext uri="{FF2B5EF4-FFF2-40B4-BE49-F238E27FC236}">
-                <a16:creationId xmlns:a16="http://schemas.microsoft.com/office/drawing/2014/main" id="{BAF0B4B2-2BF3-4D45-BF68-8A8204F2ECB2}"/>
+                <a16:creationId xmlns:a16="http://schemas.microsoft.com/office/drawing/2014/main" id="{7EB91860-B82E-4C23-B925-7FEAB2749027}"/>
               </a:ext>
             </a:extLst>
           </p:cNvPr>
@@ -29527,7 +29527,7 @@
           <p:cNvPr id="10" name="이전 구성">
             <a:extLst xmlns:a="http://schemas.openxmlformats.org/drawingml/2006/main">
               <a:ext uri="{FF2B5EF4-FFF2-40B4-BE49-F238E27FC236}">
-                <a16:creationId xmlns:a16="http://schemas.microsoft.com/office/drawing/2014/main" id="{1001B2D9-5B89-49CB-BCF8-EA4FB2BEE8CE}"/>
+                <a16:creationId xmlns:a16="http://schemas.microsoft.com/office/drawing/2014/main" id="{784966B0-0190-4658-A07E-39B09D3C3AA9}"/>
               </a:ext>
             </a:extLst>
           </p:cNvPr>
@@ -29685,7 +29685,7 @@
           <p:cNvPr id="11" name="통합을 검토할 후보">
             <a:extLst xmlns:a="http://schemas.openxmlformats.org/drawingml/2006/main">
               <a:ext uri="{FF2B5EF4-FFF2-40B4-BE49-F238E27FC236}">
-                <a16:creationId xmlns:a16="http://schemas.microsoft.com/office/drawing/2014/main" id="{633EE4C2-BF04-42B9-83EE-5D24BCF8AA81}"/>
+                <a16:creationId xmlns:a16="http://schemas.microsoft.com/office/drawing/2014/main" id="{5CF8F643-D1FF-4C00-B608-A7E2C8D65B11}"/>
               </a:ext>
             </a:extLst>
           </p:cNvPr>
@@ -29843,7 +29843,7 @@
           <p:cNvPr id="12" name="">
             <a:extLst xmlns:a="http://schemas.openxmlformats.org/drawingml/2006/main">
               <a:ext uri="{FF2B5EF4-FFF2-40B4-BE49-F238E27FC236}">
-                <a16:creationId xmlns:a16="http://schemas.microsoft.com/office/drawing/2014/main" id="{30F8BAEC-3463-46EC-A3A8-941655E7DBD3}"/>
+                <a16:creationId xmlns:a16="http://schemas.microsoft.com/office/drawing/2014/main" id="{81D27F80-F053-4AB3-AC7C-37A9C338A686}"/>
               </a:ext>
             </a:extLst>
           </p:cNvPr>
@@ -29876,7 +29876,7 @@
           <p:cNvPr id="13" name="요청을 조율하는 Agent">
             <a:extLst xmlns:a="http://schemas.openxmlformats.org/drawingml/2006/main">
               <a:ext uri="{FF2B5EF4-FFF2-40B4-BE49-F238E27FC236}">
-                <a16:creationId xmlns:a16="http://schemas.microsoft.com/office/drawing/2014/main" id="{EA720412-5A73-43D6-AC38-C7410709F325}"/>
+                <a16:creationId xmlns:a16="http://schemas.microsoft.com/office/drawing/2014/main" id="{FB98E847-DF1B-4E3B-97D4-4EA2295746CE}"/>
               </a:ext>
             </a:extLst>
           </p:cNvPr>
@@ -30034,7 +30034,7 @@
           <p:cNvPr id="14" name="">
             <a:extLst xmlns:a="http://schemas.openxmlformats.org/drawingml/2006/main">
               <a:ext uri="{FF2B5EF4-FFF2-40B4-BE49-F238E27FC236}">
-                <a16:creationId xmlns:a16="http://schemas.microsoft.com/office/drawing/2014/main" id="{A396FDFD-8E36-4C0F-8839-F93E199297AC}"/>
+                <a16:creationId xmlns:a16="http://schemas.microsoft.com/office/drawing/2014/main" id="{A8022086-881A-4F26-93BA-7F5CF76395D2}"/>
               </a:ext>
             </a:extLst>
           </p:cNvPr>
@@ -30061,7 +30061,7 @@
           <p:cNvPr id="15" name="">
             <a:extLst xmlns:a="http://schemas.openxmlformats.org/drawingml/2006/main">
               <a:ext uri="{FF2B5EF4-FFF2-40B4-BE49-F238E27FC236}">
-                <a16:creationId xmlns:a16="http://schemas.microsoft.com/office/drawing/2014/main" id="{5EE58B64-00F5-4644-B6DC-A891239F9635}"/>
+                <a16:creationId xmlns:a16="http://schemas.microsoft.com/office/drawing/2014/main" id="{65908A1F-ECDB-48BA-8A7F-6DE7C4EB9C41}"/>
               </a:ext>
             </a:extLst>
           </p:cNvPr>
@@ -30088,7 +30088,7 @@
           <p:cNvPr id="16" name="">
             <a:extLst xmlns:a="http://schemas.openxmlformats.org/drawingml/2006/main">
               <a:ext uri="{FF2B5EF4-FFF2-40B4-BE49-F238E27FC236}">
-                <a16:creationId xmlns:a16="http://schemas.microsoft.com/office/drawing/2014/main" id="{7463146C-F030-446C-93A0-B7A2C743374B}"/>
+                <a16:creationId xmlns:a16="http://schemas.microsoft.com/office/drawing/2014/main" id="{517557A6-33A9-433F-82FF-6503DD87D406}"/>
               </a:ext>
             </a:extLst>
           </p:cNvPr>
@@ -30116,7 +30116,7 @@
           <p:cNvPr id="17" name="">
             <a:extLst xmlns:a="http://schemas.openxmlformats.org/drawingml/2006/main">
               <a:ext uri="{FF2B5EF4-FFF2-40B4-BE49-F238E27FC236}">
-                <a16:creationId xmlns:a16="http://schemas.microsoft.com/office/drawing/2014/main" id="{6156B1FB-12B0-46AB-9904-5A801D2F7F79}"/>
+                <a16:creationId xmlns:a16="http://schemas.microsoft.com/office/drawing/2014/main" id="{97DAA0ED-1EB9-4BC3-B599-D0E2918CD9BD}"/>
               </a:ext>
             </a:extLst>
           </p:cNvPr>
@@ -30149,7 +30149,7 @@
           <p:cNvPr id="18" name="Router">
             <a:extLst xmlns:a="http://schemas.openxmlformats.org/drawingml/2006/main">
               <a:ext uri="{FF2B5EF4-FFF2-40B4-BE49-F238E27FC236}">
-                <a16:creationId xmlns:a16="http://schemas.microsoft.com/office/drawing/2014/main" id="{D28547CC-01F8-4EBB-B210-08749467F354}"/>
+                <a16:creationId xmlns:a16="http://schemas.microsoft.com/office/drawing/2014/main" id="{AC45F44B-99A1-4307-AB72-B8414B34A669}"/>
               </a:ext>
             </a:extLst>
           </p:cNvPr>
@@ -30307,7 +30307,7 @@
           <p:cNvPr id="19" name="">
             <a:extLst xmlns:a="http://schemas.openxmlformats.org/drawingml/2006/main">
               <a:ext uri="{FF2B5EF4-FFF2-40B4-BE49-F238E27FC236}">
-                <a16:creationId xmlns:a16="http://schemas.microsoft.com/office/drawing/2014/main" id="{40061B98-A431-4949-ABAE-ACE9B8CC4839}"/>
+                <a16:creationId xmlns:a16="http://schemas.microsoft.com/office/drawing/2014/main" id="{70F03A0E-46A1-4466-9723-303759BF08CE}"/>
               </a:ext>
             </a:extLst>
           </p:cNvPr>
@@ -30335,7 +30335,7 @@
           <p:cNvPr id="20" name="">
             <a:extLst xmlns:a="http://schemas.openxmlformats.org/drawingml/2006/main">
               <a:ext uri="{FF2B5EF4-FFF2-40B4-BE49-F238E27FC236}">
-                <a16:creationId xmlns:a16="http://schemas.microsoft.com/office/drawing/2014/main" id="{8E0453D0-5809-4E8B-980C-AE90558DEF99}"/>
+                <a16:creationId xmlns:a16="http://schemas.microsoft.com/office/drawing/2014/main" id="{1D1D566E-95EF-468C-AC72-522296E98E62}"/>
               </a:ext>
             </a:extLst>
           </p:cNvPr>
@@ -30368,7 +30368,7 @@
           <p:cNvPr id="21" name="Planner">
             <a:extLst xmlns:a="http://schemas.openxmlformats.org/drawingml/2006/main">
               <a:ext uri="{FF2B5EF4-FFF2-40B4-BE49-F238E27FC236}">
-                <a16:creationId xmlns:a16="http://schemas.microsoft.com/office/drawing/2014/main" id="{BCFE92D2-91D5-4125-B251-0CBB243D8022}"/>
+                <a16:creationId xmlns:a16="http://schemas.microsoft.com/office/drawing/2014/main" id="{E4EBE6B8-FB3B-46D6-8D91-3F677C82B14D}"/>
               </a:ext>
             </a:extLst>
           </p:cNvPr>
@@ -30526,7 +30526,7 @@
           <p:cNvPr id="22" name="">
             <a:extLst xmlns:a="http://schemas.openxmlformats.org/drawingml/2006/main">
               <a:ext uri="{FF2B5EF4-FFF2-40B4-BE49-F238E27FC236}">
-                <a16:creationId xmlns:a16="http://schemas.microsoft.com/office/drawing/2014/main" id="{B6E0133F-CAC2-4B26-90A6-0CB98172B3BB}"/>
+                <a16:creationId xmlns:a16="http://schemas.microsoft.com/office/drawing/2014/main" id="{BBD184B1-A828-40BD-B3DC-34533A2A60AE}"/>
               </a:ext>
             </a:extLst>
           </p:cNvPr>
@@ -30554,7 +30554,7 @@
           <p:cNvPr id="23" name="">
             <a:extLst xmlns:a="http://schemas.openxmlformats.org/drawingml/2006/main">
               <a:ext uri="{FF2B5EF4-FFF2-40B4-BE49-F238E27FC236}">
-                <a16:creationId xmlns:a16="http://schemas.microsoft.com/office/drawing/2014/main" id="{9A0D4E88-1E32-4226-9513-B969FBF059EA}"/>
+                <a16:creationId xmlns:a16="http://schemas.microsoft.com/office/drawing/2014/main" id="{08973A7E-265A-452A-8C02-947F0D180338}"/>
               </a:ext>
             </a:extLst>
           </p:cNvPr>
@@ -30587,7 +30587,7 @@
           <p:cNvPr id="24" name="담당 Subagent">
             <a:extLst xmlns:a="http://schemas.openxmlformats.org/drawingml/2006/main">
               <a:ext uri="{FF2B5EF4-FFF2-40B4-BE49-F238E27FC236}">
-                <a16:creationId xmlns:a16="http://schemas.microsoft.com/office/drawing/2014/main" id="{254FF888-9A07-43A0-963F-A8717C85E504}"/>
+                <a16:creationId xmlns:a16="http://schemas.microsoft.com/office/drawing/2014/main" id="{543E317B-A6CD-42A4-8090-D150B64364B5}"/>
               </a:ext>
             </a:extLst>
           </p:cNvPr>
@@ -30745,7 +30745,7 @@
           <p:cNvPr id="25" name="">
             <a:extLst xmlns:a="http://schemas.openxmlformats.org/drawingml/2006/main">
               <a:ext uri="{FF2B5EF4-FFF2-40B4-BE49-F238E27FC236}">
-                <a16:creationId xmlns:a16="http://schemas.microsoft.com/office/drawing/2014/main" id="{0B985089-78D0-4AE8-ACF9-A2860C9225F5}"/>
+                <a16:creationId xmlns:a16="http://schemas.microsoft.com/office/drawing/2014/main" id="{E79003E1-5592-43A3-9D5C-C001A6B60A28}"/>
               </a:ext>
             </a:extLst>
           </p:cNvPr>
@@ -30773,7 +30773,7 @@
           <p:cNvPr id="26" name="">
             <a:extLst xmlns:a="http://schemas.openxmlformats.org/drawingml/2006/main">
               <a:ext uri="{FF2B5EF4-FFF2-40B4-BE49-F238E27FC236}">
-                <a16:creationId xmlns:a16="http://schemas.microsoft.com/office/drawing/2014/main" id="{A7150A5F-F180-428E-9AE7-8FBED54E9197}"/>
+                <a16:creationId xmlns:a16="http://schemas.microsoft.com/office/drawing/2014/main" id="{E6B3709F-676A-4FBF-989B-B462789F728A}"/>
               </a:ext>
             </a:extLst>
           </p:cNvPr>
@@ -30804,7 +30804,7 @@
           <p:cNvPr id="27" name="하나의 Agent Loop">
             <a:extLst xmlns:a="http://schemas.openxmlformats.org/drawingml/2006/main">
               <a:ext uri="{FF2B5EF4-FFF2-40B4-BE49-F238E27FC236}">
-                <a16:creationId xmlns:a16="http://schemas.microsoft.com/office/drawing/2014/main" id="{2E1F4605-D89A-40E3-B727-E0ECC03BA4D1}"/>
+                <a16:creationId xmlns:a16="http://schemas.microsoft.com/office/drawing/2014/main" id="{1AC753C0-9E75-482A-9B35-E2D360AB2577}"/>
               </a:ext>
             </a:extLst>
           </p:cNvPr>
@@ -30962,7 +30962,7 @@
           <p:cNvPr id="28" name="">
             <a:extLst xmlns:a="http://schemas.openxmlformats.org/drawingml/2006/main">
               <a:ext uri="{FF2B5EF4-FFF2-40B4-BE49-F238E27FC236}">
-                <a16:creationId xmlns:a16="http://schemas.microsoft.com/office/drawing/2014/main" id="{48B98BD4-6646-492E-8741-07CEC0FE71AF}"/>
+                <a16:creationId xmlns:a16="http://schemas.microsoft.com/office/drawing/2014/main" id="{EA918934-70DA-4219-A89D-6A413920579B}"/>
               </a:ext>
             </a:extLst>
           </p:cNvPr>
@@ -30990,7 +30990,7 @@
           <p:cNvPr id="29" name="필요한 Skill · Tool을 사용">
             <a:extLst xmlns:a="http://schemas.openxmlformats.org/drawingml/2006/main">
               <a:ext uri="{FF2B5EF4-FFF2-40B4-BE49-F238E27FC236}">
-                <a16:creationId xmlns:a16="http://schemas.microsoft.com/office/drawing/2014/main" id="{8545B0C0-FA09-4A4A-826B-C68F589F558A}"/>
+                <a16:creationId xmlns:a16="http://schemas.microsoft.com/office/drawing/2014/main" id="{D69300B1-E062-4D00-A8B5-8D1E84601D06}"/>
               </a:ext>
             </a:extLst>
           </p:cNvPr>
@@ -31148,7 +31148,7 @@
           <p:cNvPr id="30" name="모델이 맡을 수 있는 범위·플랫폼 제공 기능이 달라졌다면, 기존 역할을 재평가한다">
             <a:extLst xmlns:a="http://schemas.openxmlformats.org/drawingml/2006/main">
               <a:ext uri="{FF2B5EF4-FFF2-40B4-BE49-F238E27FC236}">
-                <a16:creationId xmlns:a16="http://schemas.microsoft.com/office/drawing/2014/main" id="{9AC5D75E-7DBE-4723-B3AC-0B68531F1D30}"/>
+                <a16:creationId xmlns:a16="http://schemas.microsoft.com/office/drawing/2014/main" id="{4A332F14-C0E4-4C5F-8DA9-B9F70C6C7F45}"/>
               </a:ext>
             </a:extLst>
           </p:cNvPr>
@@ -31306,7 +31306,7 @@
           <p:cNvPr id="31" name="Legacy module connection">
             <a:extLst xmlns:a="http://schemas.openxmlformats.org/drawingml/2006/main">
               <a:ext uri="{FF2B5EF4-FFF2-40B4-BE49-F238E27FC236}">
-                <a16:creationId xmlns:a16="http://schemas.microsoft.com/office/drawing/2014/main" id="{9CC2B2B5-17BF-4176-B47E-6D6751E4D1E8}"/>
+                <a16:creationId xmlns:a16="http://schemas.microsoft.com/office/drawing/2014/main" id="{9CE7893C-C861-4B3B-8EB8-28B6061DB875}"/>
               </a:ext>
             </a:extLst>
           </p:cNvPr>
@@ -31462,7 +31462,7 @@
     </p:spTree>
     <p:extLst>
       <p:ext uri="{BB962C8B-B14F-4D97-AF65-F5344CB8AC3E}">
-        <p14:creationId xmlns:p14="http://schemas.microsoft.com/office/powerpoint/2010/main" val="310857144"/>
+        <p14:creationId xmlns:p14="http://schemas.microsoft.com/office/powerpoint/2010/main" val="1089173277"/>
       </p:ext>
     </p:extLst>
   </p:cSld>
@@ -31493,7 +31493,7 @@
           <p:cNvPr id="22" name="ACT 5 · 재평가 2/3 · 이 교육의 판단 기준">
             <a:extLst xmlns:a="http://schemas.openxmlformats.org/drawingml/2006/main">
               <a:ext uri="{FF2B5EF4-FFF2-40B4-BE49-F238E27FC236}">
-                <a16:creationId xmlns:a16="http://schemas.microsoft.com/office/drawing/2014/main" id="{AE1EB508-50CB-412F-9852-4A13FDCA0BCD}"/>
+                <a16:creationId xmlns:a16="http://schemas.microsoft.com/office/drawing/2014/main" id="{94C58D37-DC06-43CE-8087-7D1A03252F99}"/>
               </a:ext>
             </a:extLst>
           </p:cNvPr>
@@ -31648,10 +31648,10 @@
       </p:sp>
       <p:sp>
         <p:nvSpPr>
-          <p:cNvPr id="2" name="S92">
+          <p:cNvPr id="2" name="S95">
             <a:extLst xmlns:a="http://schemas.openxmlformats.org/drawingml/2006/main">
               <a:ext uri="{FF2B5EF4-FFF2-40B4-BE49-F238E27FC236}">
-                <a16:creationId xmlns:a16="http://schemas.microsoft.com/office/drawing/2014/main" id="{25944500-774C-4016-8C42-46F3260DF83B}"/>
+                <a16:creationId xmlns:a16="http://schemas.microsoft.com/office/drawing/2014/main" id="{F78D8BE7-CC34-44EB-B638-1C0897EF86E9}"/>
               </a:ext>
             </a:extLst>
           </p:cNvPr>
@@ -31799,7 +31799,7 @@
                 <a:ea typeface="Malgun Gothic"/>
                 <a:cs typeface="Malgun Gothic"/>
               </a:rPr>
-              <a:t>S92</a:t>
+              <a:t>S95</a:t>
             </a:r>
           </a:p>
         </p:txBody>
@@ -31809,7 +31809,7 @@
           <p:cNvPr id="3" name="무엇을 남기고, 무엇을 덜어낼까?">
             <a:extLst xmlns:a="http://schemas.openxmlformats.org/drawingml/2006/main">
               <a:ext uri="{FF2B5EF4-FFF2-40B4-BE49-F238E27FC236}">
-                <a16:creationId xmlns:a16="http://schemas.microsoft.com/office/drawing/2014/main" id="{78EE7770-BC9B-478A-B513-3C8954046601}"/>
+                <a16:creationId xmlns:a16="http://schemas.microsoft.com/office/drawing/2014/main" id="{0CE94AE5-7B3D-4A3D-8378-5BE0F547DCB0}"/>
               </a:ext>
             </a:extLst>
           </p:cNvPr>
@@ -31967,7 +31967,7 @@
           <p:cNvPr id="4" name="">
             <a:extLst xmlns:a="http://schemas.openxmlformats.org/drawingml/2006/main">
               <a:ext uri="{FF2B5EF4-FFF2-40B4-BE49-F238E27FC236}">
-                <a16:creationId xmlns:a16="http://schemas.microsoft.com/office/drawing/2014/main" id="{BF926E16-BC84-4EC6-A6F2-584617BB5654}"/>
+                <a16:creationId xmlns:a16="http://schemas.microsoft.com/office/drawing/2014/main" id="{01D7A509-875A-4FDD-AA0F-CCFDFFC38746}"/>
               </a:ext>
             </a:extLst>
           </p:cNvPr>
@@ -31998,7 +31998,7 @@
           <p:cNvPr id="5" name="TEACHING MODEL · BEAT-057 / 061 / 069 · CLM-0022 · DEC-0083">
             <a:extLst xmlns:a="http://schemas.openxmlformats.org/drawingml/2006/main">
               <a:ext uri="{FF2B5EF4-FFF2-40B4-BE49-F238E27FC236}">
-                <a16:creationId xmlns:a16="http://schemas.microsoft.com/office/drawing/2014/main" id="{9F548CFE-51F6-49CF-845A-0CDC92952C61}"/>
+                <a16:creationId xmlns:a16="http://schemas.microsoft.com/office/drawing/2014/main" id="{30C30CFB-0EB0-45FC-A21C-CE9956BD05C2}"/>
               </a:ext>
             </a:extLst>
           </p:cNvPr>
@@ -32156,7 +32156,7 @@
           <p:cNvPr id="6" name="통합·제거는 후보 판단 · 안전·권한·명세·검증 요구를 없애는 처방이 아님">
             <a:extLst xmlns:a="http://schemas.openxmlformats.org/drawingml/2006/main">
               <a:ext uri="{FF2B5EF4-FFF2-40B4-BE49-F238E27FC236}">
-                <a16:creationId xmlns:a16="http://schemas.microsoft.com/office/drawing/2014/main" id="{E65126F9-ACD6-408B-B3CA-6B5598B3B995}"/>
+                <a16:creationId xmlns:a16="http://schemas.microsoft.com/office/drawing/2014/main" id="{E441984D-2EE9-4369-A597-1FA8BADBC39F}"/>
               </a:ext>
             </a:extLst>
           </p:cNvPr>
@@ -32314,7 +32314,7 @@
           <p:cNvPr id="7" name="없애기 전에, 각 요소가 맡은 이유부터 확인한다">
             <a:extLst xmlns:a="http://schemas.openxmlformats.org/drawingml/2006/main">
               <a:ext uri="{FF2B5EF4-FFF2-40B4-BE49-F238E27FC236}">
-                <a16:creationId xmlns:a16="http://schemas.microsoft.com/office/drawing/2014/main" id="{1AC39EAD-46E9-498A-B13C-7B4E033EFD0F}"/>
+                <a16:creationId xmlns:a16="http://schemas.microsoft.com/office/drawing/2014/main" id="{1217A3D1-0C57-418A-BE2C-64B2A2AAA7E1}"/>
               </a:ext>
             </a:extLst>
           </p:cNvPr>
@@ -32472,7 +32472,7 @@
           <p:cNvPr id="8" name="">
             <a:extLst xmlns:a="http://schemas.openxmlformats.org/drawingml/2006/main">
               <a:ext uri="{FF2B5EF4-FFF2-40B4-BE49-F238E27FC236}">
-                <a16:creationId xmlns:a16="http://schemas.microsoft.com/office/drawing/2014/main" id="{EC3B7CEA-742A-40CF-B814-A74B555E07CE}"/>
+                <a16:creationId xmlns:a16="http://schemas.microsoft.com/office/drawing/2014/main" id="{C8B724B7-FDAE-4D36-9525-0F43D4BEA0F9}"/>
               </a:ext>
             </a:extLst>
           </p:cNvPr>
@@ -32503,7 +32503,7 @@
           <p:cNvPr id="9" name="유지">
             <a:extLst xmlns:a="http://schemas.openxmlformats.org/drawingml/2006/main">
               <a:ext uri="{FF2B5EF4-FFF2-40B4-BE49-F238E27FC236}">
-                <a16:creationId xmlns:a16="http://schemas.microsoft.com/office/drawing/2014/main" id="{75C3B4EC-CC90-44A4-A002-B3F95AC29E87}"/>
+                <a16:creationId xmlns:a16="http://schemas.microsoft.com/office/drawing/2014/main" id="{48487A4B-BAAC-4D9A-A8D5-8B7566F69503}"/>
               </a:ext>
             </a:extLst>
           </p:cNvPr>
@@ -32661,7 +32661,7 @@
           <p:cNvPr id="10" name="목표 · 명세&#10;검증 기준">
             <a:extLst xmlns:a="http://schemas.openxmlformats.org/drawingml/2006/main">
               <a:ext uri="{FF2B5EF4-FFF2-40B4-BE49-F238E27FC236}">
-                <a16:creationId xmlns:a16="http://schemas.microsoft.com/office/drawing/2014/main" id="{89D99C51-9AEE-4B5B-8056-58439D3AAAEA}"/>
+                <a16:creationId xmlns:a16="http://schemas.microsoft.com/office/drawing/2014/main" id="{84A4758F-DFC9-4257-890B-CFE25A664774}"/>
               </a:ext>
             </a:extLst>
           </p:cNvPr>
@@ -32842,7 +32842,7 @@
           <p:cNvPr id="11" name="필요한 요구는 계속 보존">
             <a:extLst xmlns:a="http://schemas.openxmlformats.org/drawingml/2006/main">
               <a:ext uri="{FF2B5EF4-FFF2-40B4-BE49-F238E27FC236}">
-                <a16:creationId xmlns:a16="http://schemas.microsoft.com/office/drawing/2014/main" id="{6925D9A8-0123-4068-B7DE-689E6B30E32E}"/>
+                <a16:creationId xmlns:a16="http://schemas.microsoft.com/office/drawing/2014/main" id="{D249BD41-516D-44EB-A7EC-4C0C4CFA743E}"/>
               </a:ext>
             </a:extLst>
           </p:cNvPr>
@@ -33000,7 +33000,7 @@
           <p:cNvPr id="12" name="">
             <a:extLst xmlns:a="http://schemas.openxmlformats.org/drawingml/2006/main">
               <a:ext uri="{FF2B5EF4-FFF2-40B4-BE49-F238E27FC236}">
-                <a16:creationId xmlns:a16="http://schemas.microsoft.com/office/drawing/2014/main" id="{DDEA3D1F-6EA5-41EB-8354-62239861A6E8}"/>
+                <a16:creationId xmlns:a16="http://schemas.microsoft.com/office/drawing/2014/main" id="{37504B4C-CFA1-414A-97A6-2B190F93E11A}"/>
               </a:ext>
             </a:extLst>
           </p:cNvPr>
@@ -33031,7 +33031,7 @@
           <p:cNvPr id="13" name="통합">
             <a:extLst xmlns:a="http://schemas.openxmlformats.org/drawingml/2006/main">
               <a:ext uri="{FF2B5EF4-FFF2-40B4-BE49-F238E27FC236}">
-                <a16:creationId xmlns:a16="http://schemas.microsoft.com/office/drawing/2014/main" id="{AFDD3D47-07F7-472D-AE22-C435371FE4EF}"/>
+                <a16:creationId xmlns:a16="http://schemas.microsoft.com/office/drawing/2014/main" id="{6B4BD405-4852-488A-932E-60A7D2BDEDFF}"/>
               </a:ext>
             </a:extLst>
           </p:cNvPr>
@@ -33189,7 +33189,7 @@
           <p:cNvPr id="14" name="겹치는 지침 · 역할">
             <a:extLst xmlns:a="http://schemas.openxmlformats.org/drawingml/2006/main">
               <a:ext uri="{FF2B5EF4-FFF2-40B4-BE49-F238E27FC236}">
-                <a16:creationId xmlns:a16="http://schemas.microsoft.com/office/drawing/2014/main" id="{F4EFA893-C425-4CFA-BFA8-AE6315757C7C}"/>
+                <a16:creationId xmlns:a16="http://schemas.microsoft.com/office/drawing/2014/main" id="{3D67FDB1-5715-41FB-9213-0EA6AD5D75CD}"/>
               </a:ext>
             </a:extLst>
           </p:cNvPr>
@@ -33347,7 +33347,7 @@
           <p:cNvPr id="15" name="한 출처 · 명확한 책임으로">
             <a:extLst xmlns:a="http://schemas.openxmlformats.org/drawingml/2006/main">
               <a:ext uri="{FF2B5EF4-FFF2-40B4-BE49-F238E27FC236}">
-                <a16:creationId xmlns:a16="http://schemas.microsoft.com/office/drawing/2014/main" id="{0DCD5343-946D-4E92-A396-49EF7A61ED05}"/>
+                <a16:creationId xmlns:a16="http://schemas.microsoft.com/office/drawing/2014/main" id="{86E1A775-6C7E-4D85-BA9D-A00D74493AE8}"/>
               </a:ext>
             </a:extLst>
           </p:cNvPr>
@@ -33505,7 +33505,7 @@
           <p:cNvPr id="16" name="">
             <a:extLst xmlns:a="http://schemas.openxmlformats.org/drawingml/2006/main">
               <a:ext uri="{FF2B5EF4-FFF2-40B4-BE49-F238E27FC236}">
-                <a16:creationId xmlns:a16="http://schemas.microsoft.com/office/drawing/2014/main" id="{50279528-D3B8-4BC5-A5DB-3EF7022E0438}"/>
+                <a16:creationId xmlns:a16="http://schemas.microsoft.com/office/drawing/2014/main" id="{0AFA062D-32E5-4E14-806B-4CEF2141C59B}"/>
               </a:ext>
             </a:extLst>
           </p:cNvPr>
@@ -33536,7 +33536,7 @@
           <p:cNvPr id="17" name="제거 후보">
             <a:extLst xmlns:a="http://schemas.openxmlformats.org/drawingml/2006/main">
               <a:ext uri="{FF2B5EF4-FFF2-40B4-BE49-F238E27FC236}">
-                <a16:creationId xmlns:a16="http://schemas.microsoft.com/office/drawing/2014/main" id="{6138C5A4-313B-447A-ABA5-A03DABAD206D}"/>
+                <a16:creationId xmlns:a16="http://schemas.microsoft.com/office/drawing/2014/main" id="{97CA90CE-E0FA-47DC-A825-AB8A18695CDD}"/>
               </a:ext>
             </a:extLst>
           </p:cNvPr>
@@ -33694,7 +33694,7 @@
           <p:cNvPr id="18" name="효용이 사라진&#10;우회 절차">
             <a:extLst xmlns:a="http://schemas.openxmlformats.org/drawingml/2006/main">
               <a:ext uri="{FF2B5EF4-FFF2-40B4-BE49-F238E27FC236}">
-                <a16:creationId xmlns:a16="http://schemas.microsoft.com/office/drawing/2014/main" id="{AC086EDC-0EFC-48D1-9C5E-206367258CA1}"/>
+                <a16:creationId xmlns:a16="http://schemas.microsoft.com/office/drawing/2014/main" id="{0F27B944-06CB-49C3-B414-3B9EF75D46C2}"/>
               </a:ext>
             </a:extLst>
           </p:cNvPr>
@@ -33875,7 +33875,7 @@
           <p:cNvPr id="19" name="현재도 필요한지 근거 확인">
             <a:extLst xmlns:a="http://schemas.openxmlformats.org/drawingml/2006/main">
               <a:ext uri="{FF2B5EF4-FFF2-40B4-BE49-F238E27FC236}">
-                <a16:creationId xmlns:a16="http://schemas.microsoft.com/office/drawing/2014/main" id="{05081543-C86F-45B3-A2BA-78C95437C88C}"/>
+                <a16:creationId xmlns:a16="http://schemas.microsoft.com/office/drawing/2014/main" id="{C7831B6D-D63F-47C5-AFF2-6C1602712A38}"/>
               </a:ext>
             </a:extLst>
           </p:cNvPr>
@@ -34033,7 +34033,7 @@
           <p:cNvPr id="20" name="독립 병렬 조사·권한 분리가 필요하다면, Subagent를 유지할 수 있다">
             <a:extLst xmlns:a="http://schemas.openxmlformats.org/drawingml/2006/main">
               <a:ext uri="{FF2B5EF4-FFF2-40B4-BE49-F238E27FC236}">
-                <a16:creationId xmlns:a16="http://schemas.microsoft.com/office/drawing/2014/main" id="{6C92696D-25C0-4B71-87A6-B3516BA0CD5A}"/>
+                <a16:creationId xmlns:a16="http://schemas.microsoft.com/office/drawing/2014/main" id="{CA6C2AE0-1E4C-4D28-B640-DDE731C684DD}"/>
               </a:ext>
             </a:extLst>
           </p:cNvPr>
@@ -34191,7 +34191,7 @@
           <p:cNvPr id="21" name="Legacy module connection">
             <a:extLst xmlns:a="http://schemas.openxmlformats.org/drawingml/2006/main">
               <a:ext uri="{FF2B5EF4-FFF2-40B4-BE49-F238E27FC236}">
-                <a16:creationId xmlns:a16="http://schemas.microsoft.com/office/drawing/2014/main" id="{2A181164-7EAB-489E-A2D4-1EF66A1FD25E}"/>
+                <a16:creationId xmlns:a16="http://schemas.microsoft.com/office/drawing/2014/main" id="{9341CFA2-C19B-49CC-8265-3E9EAB97DF25}"/>
               </a:ext>
             </a:extLst>
           </p:cNvPr>
@@ -34347,7 +34347,7 @@
     </p:spTree>
     <p:extLst>
       <p:ext uri="{BB962C8B-B14F-4D97-AF65-F5344CB8AC3E}">
-        <p14:creationId xmlns:p14="http://schemas.microsoft.com/office/powerpoint/2010/main" val="503135180"/>
+        <p14:creationId xmlns:p14="http://schemas.microsoft.com/office/powerpoint/2010/main" val="1421327561"/>
       </p:ext>
     </p:extLst>
   </p:cSld>
@@ -34378,7 +34378,7 @@
           <p:cNvPr id="35" name="ACT 5 · 재평가 3/3 · 평가 설계 / 실제 실행 결과 아님">
             <a:extLst xmlns:a="http://schemas.openxmlformats.org/drawingml/2006/main">
               <a:ext uri="{FF2B5EF4-FFF2-40B4-BE49-F238E27FC236}">
-                <a16:creationId xmlns:a16="http://schemas.microsoft.com/office/drawing/2014/main" id="{4F3B51E8-583C-4C06-AEE4-A9FA88BB7486}"/>
+                <a16:creationId xmlns:a16="http://schemas.microsoft.com/office/drawing/2014/main" id="{1E909397-5BF6-40AE-8051-7180DCF749CA}"/>
               </a:ext>
             </a:extLst>
           </p:cNvPr>
@@ -34533,10 +34533,10 @@
       </p:sp>
       <p:sp>
         <p:nvSpPr>
-          <p:cNvPr id="2" name="S93">
+          <p:cNvPr id="2" name="S96">
             <a:extLst xmlns:a="http://schemas.openxmlformats.org/drawingml/2006/main">
               <a:ext uri="{FF2B5EF4-FFF2-40B4-BE49-F238E27FC236}">
-                <a16:creationId xmlns:a16="http://schemas.microsoft.com/office/drawing/2014/main" id="{5D997E24-A085-4C22-864C-5CB91A29BB78}"/>
+                <a16:creationId xmlns:a16="http://schemas.microsoft.com/office/drawing/2014/main" id="{EE2CA027-DEB2-4C32-9466-5506A7E04358}"/>
               </a:ext>
             </a:extLst>
           </p:cNvPr>
@@ -34684,7 +34684,7 @@
                 <a:ea typeface="Malgun Gothic"/>
                 <a:cs typeface="Malgun Gothic"/>
               </a:rPr>
-              <a:t>S93</a:t>
+              <a:t>S96</a:t>
             </a:r>
           </a:p>
         </p:txBody>
@@ -34694,7 +34694,7 @@
           <p:cNvPr id="3" name="덜어낸 뒤에도 필요한 일을 하는가?">
             <a:extLst xmlns:a="http://schemas.openxmlformats.org/drawingml/2006/main">
               <a:ext uri="{FF2B5EF4-FFF2-40B4-BE49-F238E27FC236}">
-                <a16:creationId xmlns:a16="http://schemas.microsoft.com/office/drawing/2014/main" id="{C51D39AC-4FDC-4948-8C5D-68F962C57FB6}"/>
+                <a16:creationId xmlns:a16="http://schemas.microsoft.com/office/drawing/2014/main" id="{39B4DB0A-A608-4F69-8A55-6E7291F8E2A7}"/>
               </a:ext>
             </a:extLst>
           </p:cNvPr>
@@ -34852,7 +34852,7 @@
           <p:cNvPr id="4" name="">
             <a:extLst xmlns:a="http://schemas.openxmlformats.org/drawingml/2006/main">
               <a:ext uri="{FF2B5EF4-FFF2-40B4-BE49-F238E27FC236}">
-                <a16:creationId xmlns:a16="http://schemas.microsoft.com/office/drawing/2014/main" id="{DE3E7116-80DD-4FF4-9276-7109AD16A555}"/>
+                <a16:creationId xmlns:a16="http://schemas.microsoft.com/office/drawing/2014/main" id="{2E5E46AD-654A-458F-A7A7-BFAC883E4150}"/>
               </a:ext>
             </a:extLst>
           </p:cNvPr>
@@ -34883,7 +34883,7 @@
           <p:cNvPr id="5" name="TEACHING MODEL · SRC-0236의 평가 권고를 각색 · CLM-0040 · DEC-0083">
             <a:extLst xmlns:a="http://schemas.openxmlformats.org/drawingml/2006/main">
               <a:ext uri="{FF2B5EF4-FFF2-40B4-BE49-F238E27FC236}">
-                <a16:creationId xmlns:a16="http://schemas.microsoft.com/office/drawing/2014/main" id="{54BBBBF7-9D01-4D91-ACC7-4A897A84F5BC}"/>
+                <a16:creationId xmlns:a16="http://schemas.microsoft.com/office/drawing/2014/main" id="{AC0F0B39-C8DC-418E-8870-433097BB3B2B}"/>
               </a:ext>
             </a:extLst>
           </p:cNvPr>
@@ -35041,7 +35041,7 @@
           <p:cNvPr id="6" name="새 비교 실험·측정 결과 없음 · 시간·비용만으로 채택하지 않음">
             <a:extLst xmlns:a="http://schemas.openxmlformats.org/drawingml/2006/main">
               <a:ext uri="{FF2B5EF4-FFF2-40B4-BE49-F238E27FC236}">
-                <a16:creationId xmlns:a16="http://schemas.microsoft.com/office/drawing/2014/main" id="{8D966F73-8BB3-4896-867E-A45DB3FD296D}"/>
+                <a16:creationId xmlns:a16="http://schemas.microsoft.com/office/drawing/2014/main" id="{0FBCE280-478C-4E95-99CD-1337ACD45A71}"/>
               </a:ext>
             </a:extLst>
           </p:cNvPr>
@@ -35199,7 +35199,7 @@
           <p:cNvPr id="7" name="같은 대표 작업에서, 결과와 회귀부터 확인한다">
             <a:extLst xmlns:a="http://schemas.openxmlformats.org/drawingml/2006/main">
               <a:ext uri="{FF2B5EF4-FFF2-40B4-BE49-F238E27FC236}">
-                <a16:creationId xmlns:a16="http://schemas.microsoft.com/office/drawing/2014/main" id="{24E5C9C9-36E2-4854-80D6-7A6DBCA97BED}"/>
+                <a16:creationId xmlns:a16="http://schemas.microsoft.com/office/drawing/2014/main" id="{92E87E7A-3DA3-4BFF-998D-96B59CD66492}"/>
               </a:ext>
             </a:extLst>
           </p:cNvPr>
@@ -35357,7 +35357,7 @@
           <p:cNvPr id="8" name="">
             <a:extLst xmlns:a="http://schemas.openxmlformats.org/drawingml/2006/main">
               <a:ext uri="{FF2B5EF4-FFF2-40B4-BE49-F238E27FC236}">
-                <a16:creationId xmlns:a16="http://schemas.microsoft.com/office/drawing/2014/main" id="{291D2925-6EE3-46AF-B4F5-117E87423158}"/>
+                <a16:creationId xmlns:a16="http://schemas.microsoft.com/office/drawing/2014/main" id="{7F4EA02F-DC7C-4398-B451-74D8569D7DA0}"/>
               </a:ext>
             </a:extLst>
           </p:cNvPr>
@@ -35390,7 +35390,7 @@
           <p:cNvPr id="9" name="같은 대표&#10;작업·입력">
             <a:extLst xmlns:a="http://schemas.openxmlformats.org/drawingml/2006/main">
               <a:ext uri="{FF2B5EF4-FFF2-40B4-BE49-F238E27FC236}">
-                <a16:creationId xmlns:a16="http://schemas.microsoft.com/office/drawing/2014/main" id="{86E3C745-51AC-4D83-85F7-FAB50ABB4DBE}"/>
+                <a16:creationId xmlns:a16="http://schemas.microsoft.com/office/drawing/2014/main" id="{0908D13D-0AF8-4877-9FCA-7E6DF8E4F374}"/>
               </a:ext>
             </a:extLst>
           </p:cNvPr>
@@ -35571,7 +35571,7 @@
           <p:cNvPr id="10" name="">
             <a:extLst xmlns:a="http://schemas.openxmlformats.org/drawingml/2006/main">
               <a:ext uri="{FF2B5EF4-FFF2-40B4-BE49-F238E27FC236}">
-                <a16:creationId xmlns:a16="http://schemas.microsoft.com/office/drawing/2014/main" id="{36BAD08D-8F82-4CF5-9037-4A5A870CA3C4}"/>
+                <a16:creationId xmlns:a16="http://schemas.microsoft.com/office/drawing/2014/main" id="{5FB1CA51-E75D-433E-8D88-A785DF56D02A}"/>
               </a:ext>
             </a:extLst>
           </p:cNvPr>
@@ -35599,7 +35599,7 @@
           <p:cNvPr id="11" name="">
             <a:extLst xmlns:a="http://schemas.openxmlformats.org/drawingml/2006/main">
               <a:ext uri="{FF2B5EF4-FFF2-40B4-BE49-F238E27FC236}">
-                <a16:creationId xmlns:a16="http://schemas.microsoft.com/office/drawing/2014/main" id="{4B28E938-232C-4A21-9525-78B2944720F0}"/>
+                <a16:creationId xmlns:a16="http://schemas.microsoft.com/office/drawing/2014/main" id="{182CF57D-70E3-4A36-8800-42AAA88C99E5}"/>
               </a:ext>
             </a:extLst>
           </p:cNvPr>
@@ -35626,7 +35626,7 @@
           <p:cNvPr id="12" name="">
             <a:extLst xmlns:a="http://schemas.openxmlformats.org/drawingml/2006/main">
               <a:ext uri="{FF2B5EF4-FFF2-40B4-BE49-F238E27FC236}">
-                <a16:creationId xmlns:a16="http://schemas.microsoft.com/office/drawing/2014/main" id="{D3B051C3-30F8-4F6C-A84B-CE66AB241601}"/>
+                <a16:creationId xmlns:a16="http://schemas.microsoft.com/office/drawing/2014/main" id="{266BAB4E-30E2-40D0-8EDC-A3B4155F0B7A}"/>
               </a:ext>
             </a:extLst>
           </p:cNvPr>
@@ -35653,7 +35653,7 @@
           <p:cNvPr id="13" name="">
             <a:extLst xmlns:a="http://schemas.openxmlformats.org/drawingml/2006/main">
               <a:ext uri="{FF2B5EF4-FFF2-40B4-BE49-F238E27FC236}">
-                <a16:creationId xmlns:a16="http://schemas.microsoft.com/office/drawing/2014/main" id="{D85330A8-2AF4-4B6A-B2A8-A5C6D7AC315B}"/>
+                <a16:creationId xmlns:a16="http://schemas.microsoft.com/office/drawing/2014/main" id="{1BBAA4C4-0121-4285-9F2C-99D174F80711}"/>
               </a:ext>
             </a:extLst>
           </p:cNvPr>
@@ -35681,7 +35681,7 @@
           <p:cNvPr id="14" name="">
             <a:extLst xmlns:a="http://schemas.openxmlformats.org/drawingml/2006/main">
               <a:ext uri="{FF2B5EF4-FFF2-40B4-BE49-F238E27FC236}">
-                <a16:creationId xmlns:a16="http://schemas.microsoft.com/office/drawing/2014/main" id="{6DF7EC0B-0E2F-4A14-8F2D-50C6392BE10D}"/>
+                <a16:creationId xmlns:a16="http://schemas.microsoft.com/office/drawing/2014/main" id="{3CD35B09-E339-4E15-A2D6-4182ABC90326}"/>
               </a:ext>
             </a:extLst>
           </p:cNvPr>
@@ -35709,7 +35709,7 @@
           <p:cNvPr id="15" name="">
             <a:extLst xmlns:a="http://schemas.openxmlformats.org/drawingml/2006/main">
               <a:ext uri="{FF2B5EF4-FFF2-40B4-BE49-F238E27FC236}">
-                <a16:creationId xmlns:a16="http://schemas.microsoft.com/office/drawing/2014/main" id="{FBAF767B-D6F0-4080-AD12-F568FD41A7D9}"/>
+                <a16:creationId xmlns:a16="http://schemas.microsoft.com/office/drawing/2014/main" id="{CAADCEFD-8124-4860-81F7-ABE75721CA7D}"/>
               </a:ext>
             </a:extLst>
           </p:cNvPr>
@@ -35742,7 +35742,7 @@
           <p:cNvPr id="16" name="기존 구성">
             <a:extLst xmlns:a="http://schemas.openxmlformats.org/drawingml/2006/main">
               <a:ext uri="{FF2B5EF4-FFF2-40B4-BE49-F238E27FC236}">
-                <a16:creationId xmlns:a16="http://schemas.microsoft.com/office/drawing/2014/main" id="{7FBC9CF3-E7DD-4AEB-AB73-D9CB93F716AD}"/>
+                <a16:creationId xmlns:a16="http://schemas.microsoft.com/office/drawing/2014/main" id="{50283F44-5808-4FB9-9A09-87A27A3184AD}"/>
               </a:ext>
             </a:extLst>
           </p:cNvPr>
@@ -35900,7 +35900,7 @@
           <p:cNvPr id="17" name="">
             <a:extLst xmlns:a="http://schemas.openxmlformats.org/drawingml/2006/main">
               <a:ext uri="{FF2B5EF4-FFF2-40B4-BE49-F238E27FC236}">
-                <a16:creationId xmlns:a16="http://schemas.microsoft.com/office/drawing/2014/main" id="{C0A8E8C7-46F3-4167-9176-1BD82F40E13E}"/>
+                <a16:creationId xmlns:a16="http://schemas.microsoft.com/office/drawing/2014/main" id="{4C3D32B7-34C1-4875-9D70-2AD35C8605C3}"/>
               </a:ext>
             </a:extLst>
           </p:cNvPr>
@@ -35928,7 +35928,7 @@
           <p:cNvPr id="18" name="">
             <a:extLst xmlns:a="http://schemas.openxmlformats.org/drawingml/2006/main">
               <a:ext uri="{FF2B5EF4-FFF2-40B4-BE49-F238E27FC236}">
-                <a16:creationId xmlns:a16="http://schemas.microsoft.com/office/drawing/2014/main" id="{E03F28FF-B3A8-4673-8C89-398AD12E81F1}"/>
+                <a16:creationId xmlns:a16="http://schemas.microsoft.com/office/drawing/2014/main" id="{C99689C4-D3C3-42CC-9CCD-17BD2AC57840}"/>
               </a:ext>
             </a:extLst>
           </p:cNvPr>
@@ -35956,7 +35956,7 @@
           <p:cNvPr id="19" name="">
             <a:extLst xmlns:a="http://schemas.openxmlformats.org/drawingml/2006/main">
               <a:ext uri="{FF2B5EF4-FFF2-40B4-BE49-F238E27FC236}">
-                <a16:creationId xmlns:a16="http://schemas.microsoft.com/office/drawing/2014/main" id="{3E7D3429-51F1-4732-B1E3-DFCDB7D82F23}"/>
+                <a16:creationId xmlns:a16="http://schemas.microsoft.com/office/drawing/2014/main" id="{350F5790-FE18-4391-813D-5D47F6CE5637}"/>
               </a:ext>
             </a:extLst>
           </p:cNvPr>
@@ -35989,7 +35989,7 @@
           <p:cNvPr id="20" name="통합·제거 후보">
             <a:extLst xmlns:a="http://schemas.openxmlformats.org/drawingml/2006/main">
               <a:ext uri="{FF2B5EF4-FFF2-40B4-BE49-F238E27FC236}">
-                <a16:creationId xmlns:a16="http://schemas.microsoft.com/office/drawing/2014/main" id="{4C9B9610-D038-468F-81F7-E9FE0054E14F}"/>
+                <a16:creationId xmlns:a16="http://schemas.microsoft.com/office/drawing/2014/main" id="{0D56A6B7-AE3B-4CF0-8B49-661DB72546B5}"/>
               </a:ext>
             </a:extLst>
           </p:cNvPr>
@@ -36147,7 +36147,7 @@
           <p:cNvPr id="21" name="">
             <a:extLst xmlns:a="http://schemas.openxmlformats.org/drawingml/2006/main">
               <a:ext uri="{FF2B5EF4-FFF2-40B4-BE49-F238E27FC236}">
-                <a16:creationId xmlns:a16="http://schemas.microsoft.com/office/drawing/2014/main" id="{A54B8565-BD5F-4A8C-934D-B5C5E4950B85}"/>
+                <a16:creationId xmlns:a16="http://schemas.microsoft.com/office/drawing/2014/main" id="{2211AF1D-6061-4CCE-8045-AA05A07DAF3E}"/>
               </a:ext>
             </a:extLst>
           </p:cNvPr>
@@ -36175,7 +36175,7 @@
           <p:cNvPr id="22" name="같은 기준으로 비교">
             <a:extLst xmlns:a="http://schemas.openxmlformats.org/drawingml/2006/main">
               <a:ext uri="{FF2B5EF4-FFF2-40B4-BE49-F238E27FC236}">
-                <a16:creationId xmlns:a16="http://schemas.microsoft.com/office/drawing/2014/main" id="{65659A92-626F-40D0-B848-ADF72EE76186}"/>
+                <a16:creationId xmlns:a16="http://schemas.microsoft.com/office/drawing/2014/main" id="{1FE222C8-4614-4D47-96A4-7DD6C31799E6}"/>
               </a:ext>
             </a:extLst>
           </p:cNvPr>
@@ -36333,7 +36333,7 @@
           <p:cNvPr id="23" name="">
             <a:extLst xmlns:a="http://schemas.openxmlformats.org/drawingml/2006/main">
               <a:ext uri="{FF2B5EF4-FFF2-40B4-BE49-F238E27FC236}">
-                <a16:creationId xmlns:a16="http://schemas.microsoft.com/office/drawing/2014/main" id="{D68401D3-45BA-42D7-A586-0457A88D17FE}"/>
+                <a16:creationId xmlns:a16="http://schemas.microsoft.com/office/drawing/2014/main" id="{B84850F5-C7F7-4DFB-ACCF-2D11508A8DD6}"/>
               </a:ext>
             </a:extLst>
           </p:cNvPr>
@@ -36364,7 +36364,7 @@
           <p:cNvPr id="24" name="결과 · 회귀">
             <a:extLst xmlns:a="http://schemas.openxmlformats.org/drawingml/2006/main">
               <a:ext uri="{FF2B5EF4-FFF2-40B4-BE49-F238E27FC236}">
-                <a16:creationId xmlns:a16="http://schemas.microsoft.com/office/drawing/2014/main" id="{C0CA0072-B2E8-4C6B-982E-D2080E885160}"/>
+                <a16:creationId xmlns:a16="http://schemas.microsoft.com/office/drawing/2014/main" id="{D9871511-D3B6-436B-9A92-35FCB4E53CE5}"/>
               </a:ext>
             </a:extLst>
           </p:cNvPr>
@@ -36522,7 +36522,7 @@
           <p:cNvPr id="25" name="명세와 기존 동작을 지키나?">
             <a:extLst xmlns:a="http://schemas.openxmlformats.org/drawingml/2006/main">
               <a:ext uri="{FF2B5EF4-FFF2-40B4-BE49-F238E27FC236}">
-                <a16:creationId xmlns:a16="http://schemas.microsoft.com/office/drawing/2014/main" id="{1D3713A9-250D-47E9-B786-31DCC07B4FAA}"/>
+                <a16:creationId xmlns:a16="http://schemas.microsoft.com/office/drawing/2014/main" id="{F62D4BF1-AFED-4723-8094-DF57876ABBD9}"/>
               </a:ext>
             </a:extLst>
           </p:cNvPr>
@@ -36680,7 +36680,7 @@
           <p:cNvPr id="26" name="">
             <a:extLst xmlns:a="http://schemas.openxmlformats.org/drawingml/2006/main">
               <a:ext uri="{FF2B5EF4-FFF2-40B4-BE49-F238E27FC236}">
-                <a16:creationId xmlns:a16="http://schemas.microsoft.com/office/drawing/2014/main" id="{D51E23D7-D44E-410E-BF6C-3D223164A534}"/>
+                <a16:creationId xmlns:a16="http://schemas.microsoft.com/office/drawing/2014/main" id="{7D4AF856-FED7-4032-A46D-1D251D4E34EA}"/>
               </a:ext>
             </a:extLst>
           </p:cNvPr>
@@ -36711,7 +36711,7 @@
           <p:cNvPr id="27" name="시간 · 비용">
             <a:extLst xmlns:a="http://schemas.openxmlformats.org/drawingml/2006/main">
               <a:ext uri="{FF2B5EF4-FFF2-40B4-BE49-F238E27FC236}">
-                <a16:creationId xmlns:a16="http://schemas.microsoft.com/office/drawing/2014/main" id="{78D42D0F-42E5-4C8E-972C-55B6457FFBC7}"/>
+                <a16:creationId xmlns:a16="http://schemas.microsoft.com/office/drawing/2014/main" id="{6E15504E-A6BE-4131-BB4D-F02C2C107C5C}"/>
               </a:ext>
             </a:extLst>
           </p:cNvPr>
@@ -36869,7 +36869,7 @@
           <p:cNvPr id="28" name="기록으로 달라진 점을 보나?">
             <a:extLst xmlns:a="http://schemas.openxmlformats.org/drawingml/2006/main">
               <a:ext uri="{FF2B5EF4-FFF2-40B4-BE49-F238E27FC236}">
-                <a16:creationId xmlns:a16="http://schemas.microsoft.com/office/drawing/2014/main" id="{2D808129-167A-4C36-B433-58E0172BA781}"/>
+                <a16:creationId xmlns:a16="http://schemas.microsoft.com/office/drawing/2014/main" id="{B0F53922-D903-4504-9D1B-225E5228A9D5}"/>
               </a:ext>
             </a:extLst>
           </p:cNvPr>
@@ -37027,7 +37027,7 @@
           <p:cNvPr id="29" name="">
             <a:extLst xmlns:a="http://schemas.openxmlformats.org/drawingml/2006/main">
               <a:ext uri="{FF2B5EF4-FFF2-40B4-BE49-F238E27FC236}">
-                <a16:creationId xmlns:a16="http://schemas.microsoft.com/office/drawing/2014/main" id="{014EA8CC-E332-4E41-9175-3CFC5FF8BFEE}"/>
+                <a16:creationId xmlns:a16="http://schemas.microsoft.com/office/drawing/2014/main" id="{B3901255-6976-4C6D-ACAA-581AF171C3B6}"/>
               </a:ext>
             </a:extLst>
           </p:cNvPr>
@@ -37058,7 +37058,7 @@
           <p:cNvPr id="30" name="남은 위험">
             <a:extLst xmlns:a="http://schemas.openxmlformats.org/drawingml/2006/main">
               <a:ext uri="{FF2B5EF4-FFF2-40B4-BE49-F238E27FC236}">
-                <a16:creationId xmlns:a16="http://schemas.microsoft.com/office/drawing/2014/main" id="{43E98496-4F40-4FB8-977C-CEC46DAAFB2F}"/>
+                <a16:creationId xmlns:a16="http://schemas.microsoft.com/office/drawing/2014/main" id="{BC2842D8-817D-46E1-9317-646A2E98DCCD}"/>
               </a:ext>
             </a:extLst>
           </p:cNvPr>
@@ -37216,7 +37216,7 @@
           <p:cNvPr id="31" name="놓친 작업·권한 조건은 없나?">
             <a:extLst xmlns:a="http://schemas.openxmlformats.org/drawingml/2006/main">
               <a:ext uri="{FF2B5EF4-FFF2-40B4-BE49-F238E27FC236}">
-                <a16:creationId xmlns:a16="http://schemas.microsoft.com/office/drawing/2014/main" id="{E4F1CCD2-79E4-48D2-8353-7BDBE490B3D6}"/>
+                <a16:creationId xmlns:a16="http://schemas.microsoft.com/office/drawing/2014/main" id="{29EBBAC8-AFB5-45DE-8DD5-58EDACAE448E}"/>
               </a:ext>
             </a:extLst>
           </p:cNvPr>
@@ -37374,7 +37374,7 @@
           <p:cNvPr id="32" name="확인한 범위만 채택한다">
             <a:extLst xmlns:a="http://schemas.openxmlformats.org/drawingml/2006/main">
               <a:ext uri="{FF2B5EF4-FFF2-40B4-BE49-F238E27FC236}">
-                <a16:creationId xmlns:a16="http://schemas.microsoft.com/office/drawing/2014/main" id="{0CAB5C9E-1BD0-4654-9F73-80047B334DE5}"/>
+                <a16:creationId xmlns:a16="http://schemas.microsoft.com/office/drawing/2014/main" id="{2D176D6D-E9B5-4CFA-985F-CC4B9DAC0679}"/>
               </a:ext>
             </a:extLst>
           </p:cNvPr>
@@ -37532,7 +37532,7 @@
           <p:cNvPr id="33" name="나빠지면 되돌리고, 이유를 남긴다">
             <a:extLst xmlns:a="http://schemas.openxmlformats.org/drawingml/2006/main">
               <a:ext uri="{FF2B5EF4-FFF2-40B4-BE49-F238E27FC236}">
-                <a16:creationId xmlns:a16="http://schemas.microsoft.com/office/drawing/2014/main" id="{32FC3AB4-9186-4CB5-B93C-BBC7159EAF70}"/>
+                <a16:creationId xmlns:a16="http://schemas.microsoft.com/office/drawing/2014/main" id="{9DBAF835-C25F-4175-A03B-B03C5882C13D}"/>
               </a:ext>
             </a:extLst>
           </p:cNvPr>
@@ -37690,7 +37690,7 @@
           <p:cNvPr id="34" name="Legacy module connection">
             <a:extLst xmlns:a="http://schemas.openxmlformats.org/drawingml/2006/main">
               <a:ext uri="{FF2B5EF4-FFF2-40B4-BE49-F238E27FC236}">
-                <a16:creationId xmlns:a16="http://schemas.microsoft.com/office/drawing/2014/main" id="{E25305DD-9195-42A7-ADEF-EE85C45C7707}"/>
+                <a16:creationId xmlns:a16="http://schemas.microsoft.com/office/drawing/2014/main" id="{FB0CEAD5-C033-450A-AA5C-95DDC5F21772}"/>
               </a:ext>
             </a:extLst>
           </p:cNvPr>
@@ -37846,7 +37846,7 @@
     </p:spTree>
     <p:extLst>
       <p:ext uri="{BB962C8B-B14F-4D97-AF65-F5344CB8AC3E}">
-        <p14:creationId xmlns:p14="http://schemas.microsoft.com/office/powerpoint/2010/main" val="1432290739"/>
+        <p14:creationId xmlns:p14="http://schemas.microsoft.com/office/powerpoint/2010/main" val="1063366485"/>
       </p:ext>
     </p:extLst>
   </p:cSld>
@@ -37877,7 +37877,7 @@
           <p:cNvPr id="34" name="ACT 5 · C++ VISION / 문제 하나 고르기">
             <a:extLst xmlns:a="http://schemas.openxmlformats.org/drawingml/2006/main">
               <a:ext uri="{FF2B5EF4-FFF2-40B4-BE49-F238E27FC236}">
-                <a16:creationId xmlns:a16="http://schemas.microsoft.com/office/drawing/2014/main" id="{A56FE515-D66B-475D-87D3-4B2D45AD1B97}"/>
+                <a16:creationId xmlns:a16="http://schemas.microsoft.com/office/drawing/2014/main" id="{92E13783-EE59-4A51-95CC-62FF14D5F334}"/>
               </a:ext>
             </a:extLst>
           </p:cNvPr>
@@ -38032,10 +38032,10 @@
       </p:sp>
       <p:sp>
         <p:nvSpPr>
-          <p:cNvPr id="2" name="S94">
+          <p:cNvPr id="2" name="S97">
             <a:extLst xmlns:a="http://schemas.openxmlformats.org/drawingml/2006/main">
               <a:ext uri="{FF2B5EF4-FFF2-40B4-BE49-F238E27FC236}">
-                <a16:creationId xmlns:a16="http://schemas.microsoft.com/office/drawing/2014/main" id="{8FDCACE7-2DF7-417D-9294-AFFF62DF24C1}"/>
+                <a16:creationId xmlns:a16="http://schemas.microsoft.com/office/drawing/2014/main" id="{FC27A483-36E6-4DAB-9ACA-107AD4D6AFB9}"/>
               </a:ext>
             </a:extLst>
           </p:cNvPr>
@@ -38183,7 +38183,7 @@
                 <a:ea typeface="Malgun Gothic"/>
                 <a:cs typeface="Malgun Gothic"/>
               </a:rPr>
-              <a:t>S94</a:t>
+              <a:t>S97</a:t>
             </a:r>
           </a:p>
         </p:txBody>
@@ -38193,7 +38193,7 @@
           <p:cNvPr id="3" name="내 업무에서는 무엇이 반복해서 막힐까?">
             <a:extLst xmlns:a="http://schemas.openxmlformats.org/drawingml/2006/main">
               <a:ext uri="{FF2B5EF4-FFF2-40B4-BE49-F238E27FC236}">
-                <a16:creationId xmlns:a16="http://schemas.microsoft.com/office/drawing/2014/main" id="{9B46BB36-EA58-4B6A-919E-F2D76FAFBCC4}"/>
+                <a16:creationId xmlns:a16="http://schemas.microsoft.com/office/drawing/2014/main" id="{2490C452-D4F6-4664-981A-5BF4F3575D67}"/>
               </a:ext>
             </a:extLst>
           </p:cNvPr>
@@ -38351,7 +38351,7 @@
           <p:cNvPr id="4" name="">
             <a:extLst xmlns:a="http://schemas.openxmlformats.org/drawingml/2006/main">
               <a:ext uri="{FF2B5EF4-FFF2-40B4-BE49-F238E27FC236}">
-                <a16:creationId xmlns:a16="http://schemas.microsoft.com/office/drawing/2014/main" id="{2CA45EA7-EE1E-45A7-B6EF-BB4F1122ED9D}"/>
+                <a16:creationId xmlns:a16="http://schemas.microsoft.com/office/drawing/2014/main" id="{C919F4C8-173A-491E-8996-6A3A895976F7}"/>
               </a:ext>
             </a:extLst>
           </p:cNvPr>
@@ -38382,7 +38382,7 @@
           <p:cNvPr id="5" name="BEAT-068–069 · 업무 적용을 위한 교육용 질문">
             <a:extLst xmlns:a="http://schemas.openxmlformats.org/drawingml/2006/main">
               <a:ext uri="{FF2B5EF4-FFF2-40B4-BE49-F238E27FC236}">
-                <a16:creationId xmlns:a16="http://schemas.microsoft.com/office/drawing/2014/main" id="{1C6B6D08-4462-49DC-8C3B-ECFFF6173282}"/>
+                <a16:creationId xmlns:a16="http://schemas.microsoft.com/office/drawing/2014/main" id="{39449A9A-8089-43D7-A6A0-AD83F336132C}"/>
               </a:ext>
             </a:extLst>
           </p:cNvPr>
@@ -38540,7 +38540,7 @@
           <p:cNvPr id="6" name="A–E는 같은 수준의 선택지 · 필수 도입 순서나 검증된 C++ 프로젝트 절차가 아님">
             <a:extLst xmlns:a="http://schemas.openxmlformats.org/drawingml/2006/main">
               <a:ext uri="{FF2B5EF4-FFF2-40B4-BE49-F238E27FC236}">
-                <a16:creationId xmlns:a16="http://schemas.microsoft.com/office/drawing/2014/main" id="{12F00924-5C6C-4998-A0E0-CF2D92BDB52A}"/>
+                <a16:creationId xmlns:a16="http://schemas.microsoft.com/office/drawing/2014/main" id="{8FD00035-0111-4302-9295-6ED38251E48B}"/>
               </a:ext>
             </a:extLst>
           </p:cNvPr>
@@ -38698,7 +38698,7 @@
           <p:cNvPr id="7" name="부족한 기준과 겹쳐 쌓인 구성 중, 가까운 문제 하나만">
             <a:extLst xmlns:a="http://schemas.openxmlformats.org/drawingml/2006/main">
               <a:ext uri="{FF2B5EF4-FFF2-40B4-BE49-F238E27FC236}">
-                <a16:creationId xmlns:a16="http://schemas.microsoft.com/office/drawing/2014/main" id="{6FF7AD89-5224-487B-805E-DF8E8A89B2B9}"/>
+                <a16:creationId xmlns:a16="http://schemas.microsoft.com/office/drawing/2014/main" id="{ED360FF3-B8D1-44F7-8F89-A7FF9355C205}"/>
               </a:ext>
             </a:extLst>
           </p:cNvPr>
@@ -38856,7 +38856,7 @@
           <p:cNvPr id="8" name="">
             <a:extLst xmlns:a="http://schemas.openxmlformats.org/drawingml/2006/main">
               <a:ext uri="{FF2B5EF4-FFF2-40B4-BE49-F238E27FC236}">
-                <a16:creationId xmlns:a16="http://schemas.microsoft.com/office/drawing/2014/main" id="{0D7ADDB3-6A95-47EF-9D5D-D4454C4DCFBA}"/>
+                <a16:creationId xmlns:a16="http://schemas.microsoft.com/office/drawing/2014/main" id="{C6C321F5-770A-4957-AD28-6FEB3B29EFF8}"/>
               </a:ext>
             </a:extLst>
           </p:cNvPr>
@@ -38887,7 +38887,7 @@
           <p:cNvPr id="9" name="">
             <a:extLst xmlns:a="http://schemas.openxmlformats.org/drawingml/2006/main">
               <a:ext uri="{FF2B5EF4-FFF2-40B4-BE49-F238E27FC236}">
-                <a16:creationId xmlns:a16="http://schemas.microsoft.com/office/drawing/2014/main" id="{B1224F2A-E2C5-48AB-93AD-8A6F5C24B35A}"/>
+                <a16:creationId xmlns:a16="http://schemas.microsoft.com/office/drawing/2014/main" id="{BEE20C57-02F0-4359-BC2F-266E7FE5AB94}"/>
               </a:ext>
             </a:extLst>
           </p:cNvPr>
@@ -38918,7 +38918,7 @@
           <p:cNvPr id="10" name="A">
             <a:extLst xmlns:a="http://schemas.openxmlformats.org/drawingml/2006/main">
               <a:ext uri="{FF2B5EF4-FFF2-40B4-BE49-F238E27FC236}">
-                <a16:creationId xmlns:a16="http://schemas.microsoft.com/office/drawing/2014/main" id="{EEFD67CD-A9CB-4C68-BC95-8FF9ADBA0B0D}"/>
+                <a16:creationId xmlns:a16="http://schemas.microsoft.com/office/drawing/2014/main" id="{7CFFCD70-69B0-4E5D-8DF7-2A3FD52959B8}"/>
               </a:ext>
             </a:extLst>
           </p:cNvPr>
@@ -39076,7 +39076,7 @@
           <p:cNvPr id="11" name="성능 조사 범위가 모호하다">
             <a:extLst xmlns:a="http://schemas.openxmlformats.org/drawingml/2006/main">
               <a:ext uri="{FF2B5EF4-FFF2-40B4-BE49-F238E27FC236}">
-                <a16:creationId xmlns:a16="http://schemas.microsoft.com/office/drawing/2014/main" id="{63FF5FA9-C2DF-446F-AB66-F0C89860BC4C}"/>
+                <a16:creationId xmlns:a16="http://schemas.microsoft.com/office/drawing/2014/main" id="{52A2285E-99CC-4FC7-89AA-226B45878006}"/>
               </a:ext>
             </a:extLst>
           </p:cNvPr>
@@ -39234,7 +39234,7 @@
           <p:cNvPr id="12" name="요청 · Task">
             <a:extLst xmlns:a="http://schemas.openxmlformats.org/drawingml/2006/main">
               <a:ext uri="{FF2B5EF4-FFF2-40B4-BE49-F238E27FC236}">
-                <a16:creationId xmlns:a16="http://schemas.microsoft.com/office/drawing/2014/main" id="{4ACE06F0-430E-4163-8BF7-3071AA3D2C53}"/>
+                <a16:creationId xmlns:a16="http://schemas.microsoft.com/office/drawing/2014/main" id="{0D4121C5-592A-4C6E-9BBD-BBDF8A37C658}"/>
               </a:ext>
             </a:extLst>
           </p:cNvPr>
@@ -39392,7 +39392,7 @@
           <p:cNvPr id="13" name="">
             <a:extLst xmlns:a="http://schemas.openxmlformats.org/drawingml/2006/main">
               <a:ext uri="{FF2B5EF4-FFF2-40B4-BE49-F238E27FC236}">
-                <a16:creationId xmlns:a16="http://schemas.microsoft.com/office/drawing/2014/main" id="{AC7C5AC5-C66C-4056-84C9-08A72FDD53A1}"/>
+                <a16:creationId xmlns:a16="http://schemas.microsoft.com/office/drawing/2014/main" id="{3D541B14-4B7C-40F7-8343-9AB4BC774440}"/>
               </a:ext>
             </a:extLst>
           </p:cNvPr>
@@ -39423,7 +39423,7 @@
           <p:cNvPr id="14" name="">
             <a:extLst xmlns:a="http://schemas.openxmlformats.org/drawingml/2006/main">
               <a:ext uri="{FF2B5EF4-FFF2-40B4-BE49-F238E27FC236}">
-                <a16:creationId xmlns:a16="http://schemas.microsoft.com/office/drawing/2014/main" id="{0D24F83A-D4E2-40E6-AD6E-BAE8A68DBDCB}"/>
+                <a16:creationId xmlns:a16="http://schemas.microsoft.com/office/drawing/2014/main" id="{6DE2C0D0-B3C7-418B-B9FD-C9C77C6BBA70}"/>
               </a:ext>
             </a:extLst>
           </p:cNvPr>
@@ -39454,7 +39454,7 @@
           <p:cNvPr id="15" name="B">
             <a:extLst xmlns:a="http://schemas.openxmlformats.org/drawingml/2006/main">
               <a:ext uri="{FF2B5EF4-FFF2-40B4-BE49-F238E27FC236}">
-                <a16:creationId xmlns:a16="http://schemas.microsoft.com/office/drawing/2014/main" id="{0C42BD4E-4F24-4C87-9CEA-11B995FB3F1E}"/>
+                <a16:creationId xmlns:a16="http://schemas.microsoft.com/office/drawing/2014/main" id="{E78CE416-4EA9-44E6-864A-A1B2D7436E61}"/>
               </a:ext>
             </a:extLst>
           </p:cNvPr>
@@ -39612,7 +39612,7 @@
           <p:cNvPr id="16" name="조건 설명과 지침이 반복·중복된다">
             <a:extLst xmlns:a="http://schemas.openxmlformats.org/drawingml/2006/main">
               <a:ext uri="{FF2B5EF4-FFF2-40B4-BE49-F238E27FC236}">
-                <a16:creationId xmlns:a16="http://schemas.microsoft.com/office/drawing/2014/main" id="{BB0F0991-DEED-412E-8517-872941DBE9A5}"/>
+                <a16:creationId xmlns:a16="http://schemas.microsoft.com/office/drawing/2014/main" id="{57CDA66A-FD89-4BB0-BFEF-0363BC44C9A2}"/>
               </a:ext>
             </a:extLst>
           </p:cNvPr>
@@ -39770,7 +39770,7 @@
           <p:cNvPr id="17" name="지식 · Context">
             <a:extLst xmlns:a="http://schemas.openxmlformats.org/drawingml/2006/main">
               <a:ext uri="{FF2B5EF4-FFF2-40B4-BE49-F238E27FC236}">
-                <a16:creationId xmlns:a16="http://schemas.microsoft.com/office/drawing/2014/main" id="{F0BB1C40-B80F-4772-A16F-B4A2BB1BB1CC}"/>
+                <a16:creationId xmlns:a16="http://schemas.microsoft.com/office/drawing/2014/main" id="{E5678750-B121-4E8A-87E0-B015B47E5822}"/>
               </a:ext>
             </a:extLst>
           </p:cNvPr>
@@ -39928,7 +39928,7 @@
           <p:cNvPr id="18" name="">
             <a:extLst xmlns:a="http://schemas.openxmlformats.org/drawingml/2006/main">
               <a:ext uri="{FF2B5EF4-FFF2-40B4-BE49-F238E27FC236}">
-                <a16:creationId xmlns:a16="http://schemas.microsoft.com/office/drawing/2014/main" id="{EC3A1FD8-9671-41A9-9108-A0BEC801F641}"/>
+                <a16:creationId xmlns:a16="http://schemas.microsoft.com/office/drawing/2014/main" id="{3B283275-627D-40DA-96B4-6742E05CF582}"/>
               </a:ext>
             </a:extLst>
           </p:cNvPr>
@@ -39959,7 +39959,7 @@
           <p:cNvPr id="19" name="">
             <a:extLst xmlns:a="http://schemas.openxmlformats.org/drawingml/2006/main">
               <a:ext uri="{FF2B5EF4-FFF2-40B4-BE49-F238E27FC236}">
-                <a16:creationId xmlns:a16="http://schemas.microsoft.com/office/drawing/2014/main" id="{EB8766C2-2FB6-44E6-B211-252BCDBD913D}"/>
+                <a16:creationId xmlns:a16="http://schemas.microsoft.com/office/drawing/2014/main" id="{504E9724-BECF-4E4B-9DC1-B18F6F6EF8F9}"/>
               </a:ext>
             </a:extLst>
           </p:cNvPr>
@@ -39990,7 +39990,7 @@
           <p:cNvPr id="20" name="C">
             <a:extLst xmlns:a="http://schemas.openxmlformats.org/drawingml/2006/main">
               <a:ext uri="{FF2B5EF4-FFF2-40B4-BE49-F238E27FC236}">
-                <a16:creationId xmlns:a16="http://schemas.microsoft.com/office/drawing/2014/main" id="{5CDB1623-1912-4B2E-918F-EE7BDDA1D010}"/>
+                <a16:creationId xmlns:a16="http://schemas.microsoft.com/office/drawing/2014/main" id="{8B268AE8-F7CB-498C-B661-92EB3A00F499}"/>
               </a:ext>
             </a:extLst>
           </p:cNvPr>
@@ -40148,7 +40148,7 @@
           <p:cNvPr id="21" name="수행 절차·역할이 반복되거나 겹친다">
             <a:extLst xmlns:a="http://schemas.openxmlformats.org/drawingml/2006/main">
               <a:ext uri="{FF2B5EF4-FFF2-40B4-BE49-F238E27FC236}">
-                <a16:creationId xmlns:a16="http://schemas.microsoft.com/office/drawing/2014/main" id="{C909925B-29F1-476E-8EC3-7336314A5B3F}"/>
+                <a16:creationId xmlns:a16="http://schemas.microsoft.com/office/drawing/2014/main" id="{2FEBE6BF-8A1E-4BF8-9CD7-2C88111B8A6D}"/>
               </a:ext>
             </a:extLst>
           </p:cNvPr>
@@ -40306,7 +40306,7 @@
           <p:cNvPr id="22" name="수행 방법 · Workflow">
             <a:extLst xmlns:a="http://schemas.openxmlformats.org/drawingml/2006/main">
               <a:ext uri="{FF2B5EF4-FFF2-40B4-BE49-F238E27FC236}">
-                <a16:creationId xmlns:a16="http://schemas.microsoft.com/office/drawing/2014/main" id="{D9E0AFA4-82DF-4783-8C17-16F869208E0B}"/>
+                <a16:creationId xmlns:a16="http://schemas.microsoft.com/office/drawing/2014/main" id="{0B3DA473-CF68-4FA4-9946-F8FA9603CA0B}"/>
               </a:ext>
             </a:extLst>
           </p:cNvPr>
@@ -40464,7 +40464,7 @@
           <p:cNvPr id="23" name="">
             <a:extLst xmlns:a="http://schemas.openxmlformats.org/drawingml/2006/main">
               <a:ext uri="{FF2B5EF4-FFF2-40B4-BE49-F238E27FC236}">
-                <a16:creationId xmlns:a16="http://schemas.microsoft.com/office/drawing/2014/main" id="{34502491-3341-4E55-B270-117B31DF7F7F}"/>
+                <a16:creationId xmlns:a16="http://schemas.microsoft.com/office/drawing/2014/main" id="{F5B37E70-2640-41EB-9620-360DA6E1CA67}"/>
               </a:ext>
             </a:extLst>
           </p:cNvPr>
@@ -40495,7 +40495,7 @@
           <p:cNvPr id="24" name="">
             <a:extLst xmlns:a="http://schemas.openxmlformats.org/drawingml/2006/main">
               <a:ext uri="{FF2B5EF4-FFF2-40B4-BE49-F238E27FC236}">
-                <a16:creationId xmlns:a16="http://schemas.microsoft.com/office/drawing/2014/main" id="{FBA94E54-A38B-4EEB-B819-5A5C82190FF3}"/>
+                <a16:creationId xmlns:a16="http://schemas.microsoft.com/office/drawing/2014/main" id="{FA9E6DD0-F059-4CAF-8C54-4C6AFA81F542}"/>
               </a:ext>
             </a:extLst>
           </p:cNvPr>
@@ -40526,7 +40526,7 @@
           <p:cNvPr id="25" name="D">
             <a:extLst xmlns:a="http://schemas.openxmlformats.org/drawingml/2006/main">
               <a:ext uri="{FF2B5EF4-FFF2-40B4-BE49-F238E27FC236}">
-                <a16:creationId xmlns:a16="http://schemas.microsoft.com/office/drawing/2014/main" id="{9FC67FDC-8DD9-405C-A2BA-98FCE3F3C6DC}"/>
+                <a16:creationId xmlns:a16="http://schemas.microsoft.com/office/drawing/2014/main" id="{F722C7A2-CF6F-4711-88A0-5AA3DEFDAC23}"/>
               </a:ext>
             </a:extLst>
           </p:cNvPr>
@@ -40684,7 +40684,7 @@
           <p:cNvPr id="26" name="테스트·측정의 확인 기준이 모호하다">
             <a:extLst xmlns:a="http://schemas.openxmlformats.org/drawingml/2006/main">
               <a:ext uri="{FF2B5EF4-FFF2-40B4-BE49-F238E27FC236}">
-                <a16:creationId xmlns:a16="http://schemas.microsoft.com/office/drawing/2014/main" id="{CEB5AA41-7F41-4BE9-A004-18E04B80DFA3}"/>
+                <a16:creationId xmlns:a16="http://schemas.microsoft.com/office/drawing/2014/main" id="{42EE169D-96FD-43EE-A863-9B171729B7F3}"/>
               </a:ext>
             </a:extLst>
           </p:cNvPr>
@@ -40842,7 +40842,7 @@
           <p:cNvPr id="27" name="검증 · Verification">
             <a:extLst xmlns:a="http://schemas.openxmlformats.org/drawingml/2006/main">
               <a:ext uri="{FF2B5EF4-FFF2-40B4-BE49-F238E27FC236}">
-                <a16:creationId xmlns:a16="http://schemas.microsoft.com/office/drawing/2014/main" id="{891A27D8-77EB-4D72-8AF2-2A6552FCF4C6}"/>
+                <a16:creationId xmlns:a16="http://schemas.microsoft.com/office/drawing/2014/main" id="{FBC46BBB-464E-4F31-833B-3C4DD3B5FD95}"/>
               </a:ext>
             </a:extLst>
           </p:cNvPr>
@@ -41000,7 +41000,7 @@
           <p:cNvPr id="28" name="">
             <a:extLst xmlns:a="http://schemas.openxmlformats.org/drawingml/2006/main">
               <a:ext uri="{FF2B5EF4-FFF2-40B4-BE49-F238E27FC236}">
-                <a16:creationId xmlns:a16="http://schemas.microsoft.com/office/drawing/2014/main" id="{452DD22A-7B61-4348-84AE-3B183EB3035B}"/>
+                <a16:creationId xmlns:a16="http://schemas.microsoft.com/office/drawing/2014/main" id="{683D496C-FFF9-4013-ADDC-0A3B9ADE37FB}"/>
               </a:ext>
             </a:extLst>
           </p:cNvPr>
@@ -41031,7 +41031,7 @@
           <p:cNvPr id="29" name="">
             <a:extLst xmlns:a="http://schemas.openxmlformats.org/drawingml/2006/main">
               <a:ext uri="{FF2B5EF4-FFF2-40B4-BE49-F238E27FC236}">
-                <a16:creationId xmlns:a16="http://schemas.microsoft.com/office/drawing/2014/main" id="{7ABA02E7-0019-405F-886E-5CAD3A6A7981}"/>
+                <a16:creationId xmlns:a16="http://schemas.microsoft.com/office/drawing/2014/main" id="{534E4DCC-B06D-49B8-B948-D0A3FDD01171}"/>
               </a:ext>
             </a:extLst>
           </p:cNvPr>
@@ -41062,7 +41062,7 @@
           <p:cNvPr id="30" name="E">
             <a:extLst xmlns:a="http://schemas.openxmlformats.org/drawingml/2006/main">
               <a:ext uri="{FF2B5EF4-FFF2-40B4-BE49-F238E27FC236}">
-                <a16:creationId xmlns:a16="http://schemas.microsoft.com/office/drawing/2014/main" id="{56D00D85-D8FB-4828-81C1-D45359D77751}"/>
+                <a16:creationId xmlns:a16="http://schemas.microsoft.com/office/drawing/2014/main" id="{AFFD7BF7-7B63-4E13-A413-1CBD1AFB32B6}"/>
               </a:ext>
             </a:extLst>
           </p:cNvPr>
@@ -41220,7 +41220,7 @@
           <p:cNvPr id="31" name="같은 실패 뒤에도 원인·기준을 다시 안 본다">
             <a:extLst xmlns:a="http://schemas.openxmlformats.org/drawingml/2006/main">
               <a:ext uri="{FF2B5EF4-FFF2-40B4-BE49-F238E27FC236}">
-                <a16:creationId xmlns:a16="http://schemas.microsoft.com/office/drawing/2014/main" id="{CEC46391-CD05-4D6E-AD7D-B590AFACB215}"/>
+                <a16:creationId xmlns:a16="http://schemas.microsoft.com/office/drawing/2014/main" id="{3A345CC7-2BBF-4AE3-8945-87FE4D36B287}"/>
               </a:ext>
             </a:extLst>
           </p:cNvPr>
@@ -41378,7 +41378,7 @@
           <p:cNvPr id="32" name="개선 · Feedback Loop">
             <a:extLst xmlns:a="http://schemas.openxmlformats.org/drawingml/2006/main">
               <a:ext uri="{FF2B5EF4-FFF2-40B4-BE49-F238E27FC236}">
-                <a16:creationId xmlns:a16="http://schemas.microsoft.com/office/drawing/2014/main" id="{D841FC6F-9B5F-4F50-B3BB-7B454F6412E0}"/>
+                <a16:creationId xmlns:a16="http://schemas.microsoft.com/office/drawing/2014/main" id="{8B74B000-4017-4BFB-AEFD-5A329D309694}"/>
               </a:ext>
             </a:extLst>
           </p:cNvPr>
@@ -41536,7 +41536,7 @@
           <p:cNvPr id="33" name="Legacy module connection">
             <a:extLst xmlns:a="http://schemas.openxmlformats.org/drawingml/2006/main">
               <a:ext uri="{FF2B5EF4-FFF2-40B4-BE49-F238E27FC236}">
-                <a16:creationId xmlns:a16="http://schemas.microsoft.com/office/drawing/2014/main" id="{077A1174-5EDA-4151-B0D4-888453475F45}"/>
+                <a16:creationId xmlns:a16="http://schemas.microsoft.com/office/drawing/2014/main" id="{B862B9E2-3301-4B7F-B01B-CFA40B58137A}"/>
               </a:ext>
             </a:extLst>
           </p:cNvPr>
@@ -41692,7 +41692,7 @@
     </p:spTree>
     <p:extLst>
       <p:ext uri="{BB962C8B-B14F-4D97-AF65-F5344CB8AC3E}">
-        <p14:creationId xmlns:p14="http://schemas.microsoft.com/office/powerpoint/2010/main" val="2086797672"/>
+        <p14:creationId xmlns:p14="http://schemas.microsoft.com/office/powerpoint/2010/main" val="1863053832"/>
       </p:ext>
     </p:extLst>
   </p:cSld>

</xml_diff>